<commit_message>
Improve deck flow arrows
</commit_message>
<xml_diff>
--- a/Distributed_Search_Engine_FA1_Technical_Presentation.pptx
+++ b/Distributed_Search_Engine_FA1_Technical_Presentation.pptx
@@ -2,27 +2,27 @@
 <file path=ppt/presentation.xml><?xml version="1.0" encoding="utf-8"?>
 <p:presentation xmlns:p="http://schemas.openxmlformats.org/presentationml/2006/main">
   <p:sldMasterIdLst>
-    <p:sldMasterId xmlns:r="http://schemas.openxmlformats.org/officeDocument/2006/relationships" id="2147483648" r:id="R158b4374a5cf40f4"/>
+    <p:sldMasterId xmlns:r="http://schemas.openxmlformats.org/officeDocument/2006/relationships" id="2147483648" r:id="Rc68d838e2f7840c8"/>
   </p:sldMasterIdLst>
   <p:notesMasterIdLst>
-    <p:notesMasterId xmlns:r="http://schemas.openxmlformats.org/officeDocument/2006/relationships" r:id="Re9c52047ab324ed7"/>
+    <p:notesMasterId xmlns:r="http://schemas.openxmlformats.org/officeDocument/2006/relationships" r:id="R6c1c3242cc5140dd"/>
   </p:notesMasterIdLst>
   <p:sldIdLst>
-    <p:sldId xmlns:r="http://schemas.openxmlformats.org/officeDocument/2006/relationships" id="256" r:id="R4f8b5a4715e146fe"/>
-    <p:sldId xmlns:r="http://schemas.openxmlformats.org/officeDocument/2006/relationships" id="257" r:id="Re7bf61bb5ac34dc0"/>
-    <p:sldId xmlns:r="http://schemas.openxmlformats.org/officeDocument/2006/relationships" id="258" r:id="R838659909fda4e04"/>
-    <p:sldId xmlns:r="http://schemas.openxmlformats.org/officeDocument/2006/relationships" id="259" r:id="Rc7e4ce34762d4e4e"/>
-    <p:sldId xmlns:r="http://schemas.openxmlformats.org/officeDocument/2006/relationships" id="260" r:id="R723bdbe8c8634e2a"/>
-    <p:sldId xmlns:r="http://schemas.openxmlformats.org/officeDocument/2006/relationships" id="261" r:id="R2471c013513748c1"/>
-    <p:sldId xmlns:r="http://schemas.openxmlformats.org/officeDocument/2006/relationships" id="262" r:id="R5f260d11c02a4ad4"/>
-    <p:sldId xmlns:r="http://schemas.openxmlformats.org/officeDocument/2006/relationships" id="263" r:id="R3ef439abf06a4908"/>
-    <p:sldId xmlns:r="http://schemas.openxmlformats.org/officeDocument/2006/relationships" id="264" r:id="R119a02fc6a4f4f82"/>
-    <p:sldId xmlns:r="http://schemas.openxmlformats.org/officeDocument/2006/relationships" id="265" r:id="Rea56aeeee4dc4dda"/>
-    <p:sldId xmlns:r="http://schemas.openxmlformats.org/officeDocument/2006/relationships" id="266" r:id="R57420a0af0624a34"/>
-    <p:sldId xmlns:r="http://schemas.openxmlformats.org/officeDocument/2006/relationships" id="267" r:id="R5800d3141e8a437d"/>
-    <p:sldId xmlns:r="http://schemas.openxmlformats.org/officeDocument/2006/relationships" id="268" r:id="R06b7ec533fc548e6"/>
-    <p:sldId xmlns:r="http://schemas.openxmlformats.org/officeDocument/2006/relationships" id="269" r:id="R6e98a1a42d1947b5"/>
-    <p:sldId xmlns:r="http://schemas.openxmlformats.org/officeDocument/2006/relationships" id="270" r:id="Rb48dde27d66b4fea"/>
+    <p:sldId xmlns:r="http://schemas.openxmlformats.org/officeDocument/2006/relationships" id="256" r:id="R0100e04f50e84b04"/>
+    <p:sldId xmlns:r="http://schemas.openxmlformats.org/officeDocument/2006/relationships" id="257" r:id="R1b1c73e1530f4d26"/>
+    <p:sldId xmlns:r="http://schemas.openxmlformats.org/officeDocument/2006/relationships" id="258" r:id="R5d23890b310f4608"/>
+    <p:sldId xmlns:r="http://schemas.openxmlformats.org/officeDocument/2006/relationships" id="259" r:id="R8297283e4e034b94"/>
+    <p:sldId xmlns:r="http://schemas.openxmlformats.org/officeDocument/2006/relationships" id="260" r:id="R27736720c082410b"/>
+    <p:sldId xmlns:r="http://schemas.openxmlformats.org/officeDocument/2006/relationships" id="261" r:id="Rd695b5064c424303"/>
+    <p:sldId xmlns:r="http://schemas.openxmlformats.org/officeDocument/2006/relationships" id="262" r:id="R0f692e466e054d71"/>
+    <p:sldId xmlns:r="http://schemas.openxmlformats.org/officeDocument/2006/relationships" id="263" r:id="R3911283c57ca4476"/>
+    <p:sldId xmlns:r="http://schemas.openxmlformats.org/officeDocument/2006/relationships" id="264" r:id="R81a0d3d688274f69"/>
+    <p:sldId xmlns:r="http://schemas.openxmlformats.org/officeDocument/2006/relationships" id="265" r:id="R969682a89c7e4f93"/>
+    <p:sldId xmlns:r="http://schemas.openxmlformats.org/officeDocument/2006/relationships" id="266" r:id="R724dfe9c21214f7d"/>
+    <p:sldId xmlns:r="http://schemas.openxmlformats.org/officeDocument/2006/relationships" id="267" r:id="Rd5da06258baf4390"/>
+    <p:sldId xmlns:r="http://schemas.openxmlformats.org/officeDocument/2006/relationships" id="268" r:id="Rd0db07cde9b6419e"/>
+    <p:sldId xmlns:r="http://schemas.openxmlformats.org/officeDocument/2006/relationships" id="269" r:id="R340728f93833401a"/>
+    <p:sldId xmlns:r="http://schemas.openxmlformats.org/officeDocument/2006/relationships" id="270" r:id="Rab2ca8def0844595"/>
   </p:sldIdLst>
   <p:sldSz cx="12192000" cy="6858000"/>
   <p:notesSz cx="6858000" cy="9144000"/>
@@ -2254,7 +2254,7 @@
   </p:cSld>
   <p:clrMap bg1="lt1" tx1="dk1" bg2="lt2" tx2="dk2" accent1="accent1" accent2="accent2" accent3="accent3" accent4="accent4" accent5="accent5" accent6="accent6" hlink="hlink" folHlink="folHlink"/>
   <p:sldLayoutIdLst>
-    <p:sldLayoutId xmlns:r="http://schemas.openxmlformats.org/officeDocument/2006/relationships" id="2147483649" r:id="R7b2a9259b2174a08"/>
+    <p:sldLayoutId xmlns:r="http://schemas.openxmlformats.org/officeDocument/2006/relationships" id="2147483649" r:id="Ree4027c42c414bda"/>
   </p:sldLayoutIdLst>
   <p:txStyles>
     <p:titleStyle>
@@ -2805,7 +2805,7 @@
           <p:cNvPr id="13" name="">
             <a:extLst xmlns:a="http://schemas.openxmlformats.org/drawingml/2006/main">
               <a:ext uri="{FF2B5EF4-FFF2-40B4-BE49-F238E27FC236}">
-                <a16:creationId xmlns:a16="http://schemas.microsoft.com/office/drawing/2014/main" id="{9A31797D-56A2-4950-A842-CC69764304A1}"/>
+                <a16:creationId xmlns:a16="http://schemas.microsoft.com/office/drawing/2014/main" id="{92C06559-2254-4DC9-B947-312D30C06259}"/>
               </a:ext>
             </a:extLst>
           </p:cNvPr>
@@ -2836,7 +2836,7 @@
           <p:cNvPr id="2" name="">
             <a:extLst xmlns:a="http://schemas.openxmlformats.org/drawingml/2006/main">
               <a:ext uri="{FF2B5EF4-FFF2-40B4-BE49-F238E27FC236}">
-                <a16:creationId xmlns:a16="http://schemas.microsoft.com/office/drawing/2014/main" id="{B83EB7E5-AC82-4EB5-929F-BE95C4E91144}"/>
+                <a16:creationId xmlns:a16="http://schemas.microsoft.com/office/drawing/2014/main" id="{A2DB04DA-6AAB-42F6-ACFD-3B4F2B0DD90A}"/>
               </a:ext>
             </a:extLst>
           </p:cNvPr>
@@ -2886,7 +2886,7 @@
           <p:cNvPr id="3" name="">
             <a:extLst xmlns:a="http://schemas.openxmlformats.org/drawingml/2006/main">
               <a:ext uri="{FF2B5EF4-FFF2-40B4-BE49-F238E27FC236}">
-                <a16:creationId xmlns:a16="http://schemas.microsoft.com/office/drawing/2014/main" id="{467465F0-6853-45BD-8E87-1B17FD8760F1}"/>
+                <a16:creationId xmlns:a16="http://schemas.microsoft.com/office/drawing/2014/main" id="{0FE40164-683F-4618-AA53-94DF56C08F5E}"/>
               </a:ext>
             </a:extLst>
           </p:cNvPr>
@@ -2936,7 +2936,7 @@
           <p:cNvPr id="4" name="">
             <a:extLst xmlns:a="http://schemas.openxmlformats.org/drawingml/2006/main">
               <a:ext uri="{FF2B5EF4-FFF2-40B4-BE49-F238E27FC236}">
-                <a16:creationId xmlns:a16="http://schemas.microsoft.com/office/drawing/2014/main" id="{AE75BD9D-831E-4B3F-A191-B01ECFA32919}"/>
+                <a16:creationId xmlns:a16="http://schemas.microsoft.com/office/drawing/2014/main" id="{4948CEC7-BC0E-4640-A381-2E02F3419A0B}"/>
               </a:ext>
             </a:extLst>
           </p:cNvPr>
@@ -2986,7 +2986,7 @@
           <p:cNvPr id="5" name="">
             <a:extLst xmlns:a="http://schemas.openxmlformats.org/drawingml/2006/main">
               <a:ext uri="{FF2B5EF4-FFF2-40B4-BE49-F238E27FC236}">
-                <a16:creationId xmlns:a16="http://schemas.microsoft.com/office/drawing/2014/main" id="{C2D458F4-93A5-47B2-92B8-817C057B309B}"/>
+                <a16:creationId xmlns:a16="http://schemas.microsoft.com/office/drawing/2014/main" id="{CDF9552E-DF88-4A36-AA8A-3F12E1B3476A}"/>
               </a:ext>
             </a:extLst>
           </p:cNvPr>
@@ -3021,7 +3021,7 @@
           <p:cNvPr id="6" name="">
             <a:extLst xmlns:a="http://schemas.openxmlformats.org/drawingml/2006/main">
               <a:ext uri="{FF2B5EF4-FFF2-40B4-BE49-F238E27FC236}">
-                <a16:creationId xmlns:a16="http://schemas.microsoft.com/office/drawing/2014/main" id="{038E5404-BDEE-4CDD-8F70-EE66B616C17B}"/>
+                <a16:creationId xmlns:a16="http://schemas.microsoft.com/office/drawing/2014/main" id="{141F158C-C2F4-4AB9-8CB5-CC9906B2DD62}"/>
               </a:ext>
             </a:extLst>
           </p:cNvPr>
@@ -3071,7 +3071,7 @@
           <p:cNvPr id="7" name="">
             <a:extLst xmlns:a="http://schemas.openxmlformats.org/drawingml/2006/main">
               <a:ext uri="{FF2B5EF4-FFF2-40B4-BE49-F238E27FC236}">
-                <a16:creationId xmlns:a16="http://schemas.microsoft.com/office/drawing/2014/main" id="{A04D5F2A-7A0F-415C-87B1-67A8F59FE7AD}"/>
+                <a16:creationId xmlns:a16="http://schemas.microsoft.com/office/drawing/2014/main" id="{197501D5-FD15-4773-A35F-ED6185EC30C0}"/>
               </a:ext>
             </a:extLst>
           </p:cNvPr>
@@ -3102,7 +3102,7 @@
           <p:cNvPr id="8" name="">
             <a:extLst xmlns:a="http://schemas.openxmlformats.org/drawingml/2006/main">
               <a:ext uri="{FF2B5EF4-FFF2-40B4-BE49-F238E27FC236}">
-                <a16:creationId xmlns:a16="http://schemas.microsoft.com/office/drawing/2014/main" id="{EF89E63D-E949-4626-B7C7-3CB1AF59C2B3}"/>
+                <a16:creationId xmlns:a16="http://schemas.microsoft.com/office/drawing/2014/main" id="{ECDAB09F-3603-44B3-892F-36F6454B2CC3}"/>
               </a:ext>
             </a:extLst>
           </p:cNvPr>
@@ -3152,7 +3152,7 @@
           <p:cNvPr id="9" name="">
             <a:extLst xmlns:a="http://schemas.openxmlformats.org/drawingml/2006/main">
               <a:ext uri="{FF2B5EF4-FFF2-40B4-BE49-F238E27FC236}">
-                <a16:creationId xmlns:a16="http://schemas.microsoft.com/office/drawing/2014/main" id="{421F1042-C9CF-4DBD-94B8-7026E760E9DD}"/>
+                <a16:creationId xmlns:a16="http://schemas.microsoft.com/office/drawing/2014/main" id="{AE9C3418-2380-480D-8502-7F0EB5C4ABAD}"/>
               </a:ext>
             </a:extLst>
           </p:cNvPr>
@@ -3183,7 +3183,7 @@
           <p:cNvPr id="10" name="">
             <a:extLst xmlns:a="http://schemas.openxmlformats.org/drawingml/2006/main">
               <a:ext uri="{FF2B5EF4-FFF2-40B4-BE49-F238E27FC236}">
-                <a16:creationId xmlns:a16="http://schemas.microsoft.com/office/drawing/2014/main" id="{4B355150-BF0C-4135-B1A7-4055E1590145}"/>
+                <a16:creationId xmlns:a16="http://schemas.microsoft.com/office/drawing/2014/main" id="{B292A4A4-B065-4502-80BD-94A6DDB87CB9}"/>
               </a:ext>
             </a:extLst>
           </p:cNvPr>
@@ -3233,7 +3233,7 @@
           <p:cNvPr id="11" name="">
             <a:extLst xmlns:a="http://schemas.openxmlformats.org/drawingml/2006/main">
               <a:ext uri="{FF2B5EF4-FFF2-40B4-BE49-F238E27FC236}">
-                <a16:creationId xmlns:a16="http://schemas.microsoft.com/office/drawing/2014/main" id="{2D4F8A2A-410A-460A-97FE-00998179BF1C}"/>
+                <a16:creationId xmlns:a16="http://schemas.microsoft.com/office/drawing/2014/main" id="{5F98F5B0-1CCB-4702-8C2C-4CEDE91C83D1}"/>
               </a:ext>
             </a:extLst>
           </p:cNvPr>
@@ -3283,7 +3283,7 @@
           <p:cNvPr id="12" name="">
             <a:extLst xmlns:a="http://schemas.openxmlformats.org/drawingml/2006/main">
               <a:ext uri="{FF2B5EF4-FFF2-40B4-BE49-F238E27FC236}">
-                <a16:creationId xmlns:a16="http://schemas.microsoft.com/office/drawing/2014/main" id="{15DB6C1E-7598-495B-9C15-29659BC0C01B}"/>
+                <a16:creationId xmlns:a16="http://schemas.microsoft.com/office/drawing/2014/main" id="{A623DA61-671C-4134-B369-3929878FBD46}"/>
               </a:ext>
             </a:extLst>
           </p:cNvPr>
@@ -3331,7 +3331,7 @@
     </p:spTree>
     <p:extLst>
       <p:ext uri="{BB962C8B-B14F-4D97-AF65-F5344CB8AC3E}">
-        <p14:creationId xmlns:p14="http://schemas.microsoft.com/office/powerpoint/2010/main" val="609707621"/>
+        <p14:creationId xmlns:p14="http://schemas.microsoft.com/office/powerpoint/2010/main" val="1473241297"/>
       </p:ext>
     </p:extLst>
   </p:cSld>
@@ -3362,7 +3362,7 @@
           <p:cNvPr id="13" name="">
             <a:extLst xmlns:a="http://schemas.openxmlformats.org/drawingml/2006/main">
               <a:ext uri="{FF2B5EF4-FFF2-40B4-BE49-F238E27FC236}">
-                <a16:creationId xmlns:a16="http://schemas.microsoft.com/office/drawing/2014/main" id="{977A71C3-3378-4F77-A0D5-4E1EE964E6EC}"/>
+                <a16:creationId xmlns:a16="http://schemas.microsoft.com/office/drawing/2014/main" id="{B02EADF1-9130-4396-ADFC-0DE96D8759BC}"/>
               </a:ext>
             </a:extLst>
           </p:cNvPr>
@@ -3412,7 +3412,7 @@
           <p:cNvPr id="2" name="">
             <a:extLst xmlns:a="http://schemas.openxmlformats.org/drawingml/2006/main">
               <a:ext uri="{FF2B5EF4-FFF2-40B4-BE49-F238E27FC236}">
-                <a16:creationId xmlns:a16="http://schemas.microsoft.com/office/drawing/2014/main" id="{AA8648E0-B5D5-4593-9E46-9E55E4744AF3}"/>
+                <a16:creationId xmlns:a16="http://schemas.microsoft.com/office/drawing/2014/main" id="{6DC3748D-44EB-421C-9AFC-8C30889A5736}"/>
               </a:ext>
             </a:extLst>
           </p:cNvPr>
@@ -3462,7 +3462,7 @@
           <p:cNvPr id="3" name="">
             <a:extLst xmlns:a="http://schemas.openxmlformats.org/drawingml/2006/main">
               <a:ext uri="{FF2B5EF4-FFF2-40B4-BE49-F238E27FC236}">
-                <a16:creationId xmlns:a16="http://schemas.microsoft.com/office/drawing/2014/main" id="{7EE8BE81-1EB1-43CE-A52A-80076BE2B0DA}"/>
+                <a16:creationId xmlns:a16="http://schemas.microsoft.com/office/drawing/2014/main" id="{10E38671-CB56-40EB-B7F1-F9C89EEC18F0}"/>
               </a:ext>
             </a:extLst>
           </p:cNvPr>
@@ -3493,7 +3493,7 @@
           <p:cNvPr id="4" name="">
             <a:extLst xmlns:a="http://schemas.openxmlformats.org/drawingml/2006/main">
               <a:ext uri="{FF2B5EF4-FFF2-40B4-BE49-F238E27FC236}">
-                <a16:creationId xmlns:a16="http://schemas.microsoft.com/office/drawing/2014/main" id="{C58D4A5E-C04B-494F-A6AB-63C01305B615}"/>
+                <a16:creationId xmlns:a16="http://schemas.microsoft.com/office/drawing/2014/main" id="{3248E3CA-74C2-4781-8C8C-CF8DD8AB17C8}"/>
               </a:ext>
             </a:extLst>
           </p:cNvPr>
@@ -3543,7 +3543,7 @@
           <p:cNvPr id="5" name="">
             <a:extLst xmlns:a="http://schemas.openxmlformats.org/drawingml/2006/main">
               <a:ext uri="{FF2B5EF4-FFF2-40B4-BE49-F238E27FC236}">
-                <a16:creationId xmlns:a16="http://schemas.microsoft.com/office/drawing/2014/main" id="{10524FA8-594C-4ED9-8DF4-61A9E3758C86}"/>
+                <a16:creationId xmlns:a16="http://schemas.microsoft.com/office/drawing/2014/main" id="{E67534D7-5C89-46E6-8C70-14E816752EF6}"/>
               </a:ext>
             </a:extLst>
           </p:cNvPr>
@@ -3593,7 +3593,7 @@
           <p:cNvPr id="6" name="">
             <a:extLst xmlns:a="http://schemas.openxmlformats.org/drawingml/2006/main">
               <a:ext uri="{FF2B5EF4-FFF2-40B4-BE49-F238E27FC236}">
-                <a16:creationId xmlns:a16="http://schemas.microsoft.com/office/drawing/2014/main" id="{99FB769D-B199-4B49-A30D-D2B32EA6BDAF}"/>
+                <a16:creationId xmlns:a16="http://schemas.microsoft.com/office/drawing/2014/main" id="{8AA41C19-A577-45F3-B9B6-EFBD16D4FC9C}"/>
               </a:ext>
             </a:extLst>
           </p:cNvPr>
@@ -3628,7 +3628,7 @@
           <p:cNvPr id="7" name="">
             <a:extLst xmlns:a="http://schemas.openxmlformats.org/drawingml/2006/main">
               <a:ext uri="{FF2B5EF4-FFF2-40B4-BE49-F238E27FC236}">
-                <a16:creationId xmlns:a16="http://schemas.microsoft.com/office/drawing/2014/main" id="{A47F6C79-14A6-4F9F-A4FA-7A01A0513026}"/>
+                <a16:creationId xmlns:a16="http://schemas.microsoft.com/office/drawing/2014/main" id="{1809265F-8A36-42DF-885F-59B17D5AACB7}"/>
               </a:ext>
             </a:extLst>
           </p:cNvPr>
@@ -3678,7 +3678,7 @@
           <p:cNvPr id="8" name="">
             <a:extLst xmlns:a="http://schemas.openxmlformats.org/drawingml/2006/main">
               <a:ext uri="{FF2B5EF4-FFF2-40B4-BE49-F238E27FC236}">
-                <a16:creationId xmlns:a16="http://schemas.microsoft.com/office/drawing/2014/main" id="{782F577E-0FEE-49A3-A352-E956C1CBD3C2}"/>
+                <a16:creationId xmlns:a16="http://schemas.microsoft.com/office/drawing/2014/main" id="{6881939C-B353-43BB-84CB-A185D9DAB05A}"/>
               </a:ext>
             </a:extLst>
           </p:cNvPr>
@@ -3794,7 +3794,7 @@
           <p:cNvPr id="9" name="">
             <a:extLst xmlns:a="http://schemas.openxmlformats.org/drawingml/2006/main">
               <a:ext uri="{FF2B5EF4-FFF2-40B4-BE49-F238E27FC236}">
-                <a16:creationId xmlns:a16="http://schemas.microsoft.com/office/drawing/2014/main" id="{044429CD-D237-4C49-9A6B-2383CA0C61B8}"/>
+                <a16:creationId xmlns:a16="http://schemas.microsoft.com/office/drawing/2014/main" id="{DC730CBF-13F4-44A8-A6BA-377B448F8EE8}"/>
               </a:ext>
             </a:extLst>
           </p:cNvPr>
@@ -3829,7 +3829,7 @@
           <p:cNvPr id="10" name="">
             <a:extLst xmlns:a="http://schemas.openxmlformats.org/drawingml/2006/main">
               <a:ext uri="{FF2B5EF4-FFF2-40B4-BE49-F238E27FC236}">
-                <a16:creationId xmlns:a16="http://schemas.microsoft.com/office/drawing/2014/main" id="{C2B83F4B-8DE7-49A2-987E-329E97B1FB2F}"/>
+                <a16:creationId xmlns:a16="http://schemas.microsoft.com/office/drawing/2014/main" id="{C825BF37-E0EA-42A9-B02C-340DB9E52CA4}"/>
               </a:ext>
             </a:extLst>
           </p:cNvPr>
@@ -3879,7 +3879,7 @@
           <p:cNvPr id="11" name="">
             <a:extLst xmlns:a="http://schemas.openxmlformats.org/drawingml/2006/main">
               <a:ext uri="{FF2B5EF4-FFF2-40B4-BE49-F238E27FC236}">
-                <a16:creationId xmlns:a16="http://schemas.microsoft.com/office/drawing/2014/main" id="{44239933-2351-4F5D-83A5-B68F3E8881AB}"/>
+                <a16:creationId xmlns:a16="http://schemas.microsoft.com/office/drawing/2014/main" id="{4C19CE0C-6839-486F-8379-67E89F85FD3F}"/>
               </a:ext>
             </a:extLst>
           </p:cNvPr>
@@ -3995,7 +3995,7 @@
           <p:cNvPr id="12" name="">
             <a:extLst xmlns:a="http://schemas.openxmlformats.org/drawingml/2006/main">
               <a:ext uri="{FF2B5EF4-FFF2-40B4-BE49-F238E27FC236}">
-                <a16:creationId xmlns:a16="http://schemas.microsoft.com/office/drawing/2014/main" id="{59381817-295A-4745-8BC2-EE14D78BBA1F}"/>
+                <a16:creationId xmlns:a16="http://schemas.microsoft.com/office/drawing/2014/main" id="{D2F7A18C-0613-4B65-B694-68DE0AC2D4C0}"/>
               </a:ext>
             </a:extLst>
           </p:cNvPr>
@@ -4024,7 +4024,7 @@
     </p:spTree>
     <p:extLst>
       <p:ext uri="{BB962C8B-B14F-4D97-AF65-F5344CB8AC3E}">
-        <p14:creationId xmlns:p14="http://schemas.microsoft.com/office/powerpoint/2010/main" val="1207433851"/>
+        <p14:creationId xmlns:p14="http://schemas.microsoft.com/office/powerpoint/2010/main" val="281603726"/>
       </p:ext>
     </p:extLst>
   </p:cSld>
@@ -4055,7 +4055,7 @@
           <p:cNvPr id="19" name="">
             <a:extLst xmlns:a="http://schemas.openxmlformats.org/drawingml/2006/main">
               <a:ext uri="{FF2B5EF4-FFF2-40B4-BE49-F238E27FC236}">
-                <a16:creationId xmlns:a16="http://schemas.microsoft.com/office/drawing/2014/main" id="{6FD35E08-C96A-4B10-B7F0-BC2B176A55FC}"/>
+                <a16:creationId xmlns:a16="http://schemas.microsoft.com/office/drawing/2014/main" id="{AFA85BAF-DAB6-4683-A843-EFED930B8BE5}"/>
               </a:ext>
             </a:extLst>
           </p:cNvPr>
@@ -4105,7 +4105,7 @@
           <p:cNvPr id="2" name="">
             <a:extLst xmlns:a="http://schemas.openxmlformats.org/drawingml/2006/main">
               <a:ext uri="{FF2B5EF4-FFF2-40B4-BE49-F238E27FC236}">
-                <a16:creationId xmlns:a16="http://schemas.microsoft.com/office/drawing/2014/main" id="{400EEB69-F800-49C6-9E3E-7F065FE80E7F}"/>
+                <a16:creationId xmlns:a16="http://schemas.microsoft.com/office/drawing/2014/main" id="{E1EA9DA7-B34B-4035-A9D0-0A18E44D94D0}"/>
               </a:ext>
             </a:extLst>
           </p:cNvPr>
@@ -4155,7 +4155,7 @@
           <p:cNvPr id="3" name="">
             <a:extLst xmlns:a="http://schemas.openxmlformats.org/drawingml/2006/main">
               <a:ext uri="{FF2B5EF4-FFF2-40B4-BE49-F238E27FC236}">
-                <a16:creationId xmlns:a16="http://schemas.microsoft.com/office/drawing/2014/main" id="{48F6BE53-C559-4A64-9227-92189FA044E5}"/>
+                <a16:creationId xmlns:a16="http://schemas.microsoft.com/office/drawing/2014/main" id="{48B29E40-16ED-4231-B11B-BDB6CFBFC670}"/>
               </a:ext>
             </a:extLst>
           </p:cNvPr>
@@ -4186,7 +4186,7 @@
           <p:cNvPr id="4" name="">
             <a:extLst xmlns:a="http://schemas.openxmlformats.org/drawingml/2006/main">
               <a:ext uri="{FF2B5EF4-FFF2-40B4-BE49-F238E27FC236}">
-                <a16:creationId xmlns:a16="http://schemas.microsoft.com/office/drawing/2014/main" id="{BE9AE700-09D6-4619-BD89-17013C9FD508}"/>
+                <a16:creationId xmlns:a16="http://schemas.microsoft.com/office/drawing/2014/main" id="{AF34CB1A-7C81-494D-81BC-E5D3EA95EE90}"/>
               </a:ext>
             </a:extLst>
           </p:cNvPr>
@@ -4236,7 +4236,7 @@
           <p:cNvPr id="5" name="">
             <a:extLst xmlns:a="http://schemas.openxmlformats.org/drawingml/2006/main">
               <a:ext uri="{FF2B5EF4-FFF2-40B4-BE49-F238E27FC236}">
-                <a16:creationId xmlns:a16="http://schemas.microsoft.com/office/drawing/2014/main" id="{52AAFA9D-8B2A-4211-BDE2-92996496B469}"/>
+                <a16:creationId xmlns:a16="http://schemas.microsoft.com/office/drawing/2014/main" id="{74AC3EA4-1D8F-4B99-8F0D-FD10B54B00CE}"/>
               </a:ext>
             </a:extLst>
           </p:cNvPr>
@@ -4286,7 +4286,7 @@
           <p:cNvPr id="6" name="">
             <a:extLst xmlns:a="http://schemas.openxmlformats.org/drawingml/2006/main">
               <a:ext uri="{FF2B5EF4-FFF2-40B4-BE49-F238E27FC236}">
-                <a16:creationId xmlns:a16="http://schemas.microsoft.com/office/drawing/2014/main" id="{5F06B101-CB1A-4FBC-9469-406DBD85ACFB}"/>
+                <a16:creationId xmlns:a16="http://schemas.microsoft.com/office/drawing/2014/main" id="{497491C8-5B95-481B-8D38-D96B2C3EA1FD}"/>
               </a:ext>
             </a:extLst>
           </p:cNvPr>
@@ -4340,7 +4340,7 @@
           <p:cNvPr id="7" name="">
             <a:extLst xmlns:a="http://schemas.openxmlformats.org/drawingml/2006/main">
               <a:ext uri="{FF2B5EF4-FFF2-40B4-BE49-F238E27FC236}">
-                <a16:creationId xmlns:a16="http://schemas.microsoft.com/office/drawing/2014/main" id="{BAB16F7F-7AA9-4301-9D1D-2380407BDBF0}"/>
+                <a16:creationId xmlns:a16="http://schemas.microsoft.com/office/drawing/2014/main" id="{6D09D8B0-AB3B-48B7-AACF-470ABAECF819}"/>
               </a:ext>
             </a:extLst>
           </p:cNvPr>
@@ -4390,7 +4390,7 @@
           <p:cNvPr id="8" name="">
             <a:extLst xmlns:a="http://schemas.openxmlformats.org/drawingml/2006/main">
               <a:ext uri="{FF2B5EF4-FFF2-40B4-BE49-F238E27FC236}">
-                <a16:creationId xmlns:a16="http://schemas.microsoft.com/office/drawing/2014/main" id="{49E1C9E2-3B2F-46B8-8DC8-46E840A9E927}"/>
+                <a16:creationId xmlns:a16="http://schemas.microsoft.com/office/drawing/2014/main" id="{ACA6F3EA-CE7D-4D0E-B2FE-9420E6A4EF53}"/>
               </a:ext>
             </a:extLst>
           </p:cNvPr>
@@ -4444,7 +4444,7 @@
           <p:cNvPr id="9" name="">
             <a:extLst xmlns:a="http://schemas.openxmlformats.org/drawingml/2006/main">
               <a:ext uri="{FF2B5EF4-FFF2-40B4-BE49-F238E27FC236}">
-                <a16:creationId xmlns:a16="http://schemas.microsoft.com/office/drawing/2014/main" id="{1BB628E2-BB4F-4A2E-A0DF-911E2A36AA36}"/>
+                <a16:creationId xmlns:a16="http://schemas.microsoft.com/office/drawing/2014/main" id="{DC7CE212-284E-41AC-AB15-9FE2AE22461D}"/>
               </a:ext>
             </a:extLst>
           </p:cNvPr>
@@ -4494,7 +4494,7 @@
           <p:cNvPr id="10" name="">
             <a:extLst xmlns:a="http://schemas.openxmlformats.org/drawingml/2006/main">
               <a:ext uri="{FF2B5EF4-FFF2-40B4-BE49-F238E27FC236}">
-                <a16:creationId xmlns:a16="http://schemas.microsoft.com/office/drawing/2014/main" id="{60225E71-3BA6-46C4-AE31-92060C4671CC}"/>
+                <a16:creationId xmlns:a16="http://schemas.microsoft.com/office/drawing/2014/main" id="{21FDF136-0384-463F-969A-F1F19C13D5B3}"/>
               </a:ext>
             </a:extLst>
           </p:cNvPr>
@@ -4548,7 +4548,7 @@
           <p:cNvPr id="11" name="">
             <a:extLst xmlns:a="http://schemas.openxmlformats.org/drawingml/2006/main">
               <a:ext uri="{FF2B5EF4-FFF2-40B4-BE49-F238E27FC236}">
-                <a16:creationId xmlns:a16="http://schemas.microsoft.com/office/drawing/2014/main" id="{F20ED076-CCD3-49D7-AB64-AAF81144B4F6}"/>
+                <a16:creationId xmlns:a16="http://schemas.microsoft.com/office/drawing/2014/main" id="{32C0E8FE-2FD4-4D20-A6E8-2F4797BD1BF9}"/>
               </a:ext>
             </a:extLst>
           </p:cNvPr>
@@ -4598,7 +4598,7 @@
           <p:cNvPr id="12" name="">
             <a:extLst xmlns:a="http://schemas.openxmlformats.org/drawingml/2006/main">
               <a:ext uri="{FF2B5EF4-FFF2-40B4-BE49-F238E27FC236}">
-                <a16:creationId xmlns:a16="http://schemas.microsoft.com/office/drawing/2014/main" id="{96A8DEB1-ED8F-4C7A-90C3-A769B0F766CE}"/>
+                <a16:creationId xmlns:a16="http://schemas.microsoft.com/office/drawing/2014/main" id="{F72FA87B-799F-47B5-A53C-835AC8C5AD40}"/>
               </a:ext>
             </a:extLst>
           </p:cNvPr>
@@ -4652,7 +4652,7 @@
           <p:cNvPr id="13" name="">
             <a:extLst xmlns:a="http://schemas.openxmlformats.org/drawingml/2006/main">
               <a:ext uri="{FF2B5EF4-FFF2-40B4-BE49-F238E27FC236}">
-                <a16:creationId xmlns:a16="http://schemas.microsoft.com/office/drawing/2014/main" id="{E501A792-0850-4A76-B063-6551BE3052D9}"/>
+                <a16:creationId xmlns:a16="http://schemas.microsoft.com/office/drawing/2014/main" id="{22B3036B-A88A-4BA9-8A1E-54A22A2AB19A}"/>
               </a:ext>
             </a:extLst>
           </p:cNvPr>
@@ -4702,7 +4702,7 @@
           <p:cNvPr id="14" name="">
             <a:extLst xmlns:a="http://schemas.openxmlformats.org/drawingml/2006/main">
               <a:ext uri="{FF2B5EF4-FFF2-40B4-BE49-F238E27FC236}">
-                <a16:creationId xmlns:a16="http://schemas.microsoft.com/office/drawing/2014/main" id="{6957C0AD-2591-4C2C-B2F6-79947177E1C1}"/>
+                <a16:creationId xmlns:a16="http://schemas.microsoft.com/office/drawing/2014/main" id="{50601092-7AE1-49A2-AD40-54B41B22D60C}"/>
               </a:ext>
             </a:extLst>
           </p:cNvPr>
@@ -4756,7 +4756,7 @@
           <p:cNvPr id="15" name="">
             <a:extLst xmlns:a="http://schemas.openxmlformats.org/drawingml/2006/main">
               <a:ext uri="{FF2B5EF4-FFF2-40B4-BE49-F238E27FC236}">
-                <a16:creationId xmlns:a16="http://schemas.microsoft.com/office/drawing/2014/main" id="{0F40B2CC-2CF8-4945-A13E-A6D9D62F1176}"/>
+                <a16:creationId xmlns:a16="http://schemas.microsoft.com/office/drawing/2014/main" id="{E32BEB6F-7A86-47A2-B7E7-8A86B28C2AC6}"/>
               </a:ext>
             </a:extLst>
           </p:cNvPr>
@@ -4806,7 +4806,7 @@
           <p:cNvPr id="16" name="">
             <a:extLst xmlns:a="http://schemas.openxmlformats.org/drawingml/2006/main">
               <a:ext uri="{FF2B5EF4-FFF2-40B4-BE49-F238E27FC236}">
-                <a16:creationId xmlns:a16="http://schemas.microsoft.com/office/drawing/2014/main" id="{EA33E145-ACC6-43CB-8B6D-2A823E258D82}"/>
+                <a16:creationId xmlns:a16="http://schemas.microsoft.com/office/drawing/2014/main" id="{0AE3D597-CDC3-4BF0-B829-F4724178BA15}"/>
               </a:ext>
             </a:extLst>
           </p:cNvPr>
@@ -4841,7 +4841,7 @@
           <p:cNvPr id="17" name="">
             <a:extLst xmlns:a="http://schemas.openxmlformats.org/drawingml/2006/main">
               <a:ext uri="{FF2B5EF4-FFF2-40B4-BE49-F238E27FC236}">
-                <a16:creationId xmlns:a16="http://schemas.microsoft.com/office/drawing/2014/main" id="{6966B488-FA1B-4475-97BD-F5A94E22BA7A}"/>
+                <a16:creationId xmlns:a16="http://schemas.microsoft.com/office/drawing/2014/main" id="{95DB9850-8A7C-4539-BA10-9AE43C76C64D}"/>
               </a:ext>
             </a:extLst>
           </p:cNvPr>
@@ -4891,7 +4891,7 @@
           <p:cNvPr id="18" name="">
             <a:extLst xmlns:a="http://schemas.openxmlformats.org/drawingml/2006/main">
               <a:ext uri="{FF2B5EF4-FFF2-40B4-BE49-F238E27FC236}">
-                <a16:creationId xmlns:a16="http://schemas.microsoft.com/office/drawing/2014/main" id="{9851B0D1-A901-40A0-B2E4-466C7463F480}"/>
+                <a16:creationId xmlns:a16="http://schemas.microsoft.com/office/drawing/2014/main" id="{7B11F788-29D3-4F31-A150-FC328F11EFF2}"/>
               </a:ext>
             </a:extLst>
           </p:cNvPr>
@@ -5007,7 +5007,7 @@
     </p:spTree>
     <p:extLst>
       <p:ext uri="{BB962C8B-B14F-4D97-AF65-F5344CB8AC3E}">
-        <p14:creationId xmlns:p14="http://schemas.microsoft.com/office/powerpoint/2010/main" val="1644644966"/>
+        <p14:creationId xmlns:p14="http://schemas.microsoft.com/office/powerpoint/2010/main" val="2046498720"/>
       </p:ext>
     </p:extLst>
   </p:cSld>
@@ -5038,7 +5038,7 @@
           <p:cNvPr id="22" name="">
             <a:extLst xmlns:a="http://schemas.openxmlformats.org/drawingml/2006/main">
               <a:ext uri="{FF2B5EF4-FFF2-40B4-BE49-F238E27FC236}">
-                <a16:creationId xmlns:a16="http://schemas.microsoft.com/office/drawing/2014/main" id="{0AFC2A95-3007-4C2F-81AD-1B44E00C0B3B}"/>
+                <a16:creationId xmlns:a16="http://schemas.microsoft.com/office/drawing/2014/main" id="{8DC71BA3-BABE-49FD-8267-3586A7D48CDE}"/>
               </a:ext>
             </a:extLst>
           </p:cNvPr>
@@ -5088,7 +5088,7 @@
           <p:cNvPr id="2" name="">
             <a:extLst xmlns:a="http://schemas.openxmlformats.org/drawingml/2006/main">
               <a:ext uri="{FF2B5EF4-FFF2-40B4-BE49-F238E27FC236}">
-                <a16:creationId xmlns:a16="http://schemas.microsoft.com/office/drawing/2014/main" id="{819BC047-38FD-4BF7-B1FE-52B4CCA98CFD}"/>
+                <a16:creationId xmlns:a16="http://schemas.microsoft.com/office/drawing/2014/main" id="{AFDEFAB3-85BB-4B49-AFEB-05CB1717BD0A}"/>
               </a:ext>
             </a:extLst>
           </p:cNvPr>
@@ -5138,7 +5138,7 @@
           <p:cNvPr id="3" name="">
             <a:extLst xmlns:a="http://schemas.openxmlformats.org/drawingml/2006/main">
               <a:ext uri="{FF2B5EF4-FFF2-40B4-BE49-F238E27FC236}">
-                <a16:creationId xmlns:a16="http://schemas.microsoft.com/office/drawing/2014/main" id="{78A5F027-69B3-4B87-9511-01BCA1A39FE9}"/>
+                <a16:creationId xmlns:a16="http://schemas.microsoft.com/office/drawing/2014/main" id="{A59D10B1-F17A-4966-BBBC-9DB08F18F493}"/>
               </a:ext>
             </a:extLst>
           </p:cNvPr>
@@ -5169,7 +5169,7 @@
           <p:cNvPr id="4" name="">
             <a:extLst xmlns:a="http://schemas.openxmlformats.org/drawingml/2006/main">
               <a:ext uri="{FF2B5EF4-FFF2-40B4-BE49-F238E27FC236}">
-                <a16:creationId xmlns:a16="http://schemas.microsoft.com/office/drawing/2014/main" id="{B5674D10-4EBD-4DDD-9A62-3D2F7AF879E9}"/>
+                <a16:creationId xmlns:a16="http://schemas.microsoft.com/office/drawing/2014/main" id="{4AA253FC-AB70-43B1-9A8F-00C521C7BB56}"/>
               </a:ext>
             </a:extLst>
           </p:cNvPr>
@@ -5219,7 +5219,7 @@
           <p:cNvPr id="5" name="">
             <a:extLst xmlns:a="http://schemas.openxmlformats.org/drawingml/2006/main">
               <a:ext uri="{FF2B5EF4-FFF2-40B4-BE49-F238E27FC236}">
-                <a16:creationId xmlns:a16="http://schemas.microsoft.com/office/drawing/2014/main" id="{AD4ED36B-3B54-4AB2-9B75-93EA06581CF2}"/>
+                <a16:creationId xmlns:a16="http://schemas.microsoft.com/office/drawing/2014/main" id="{F51371B3-DDE1-418C-89B6-1DAC835E1A10}"/>
               </a:ext>
             </a:extLst>
           </p:cNvPr>
@@ -5269,7 +5269,7 @@
           <p:cNvPr id="6" name="">
             <a:extLst xmlns:a="http://schemas.openxmlformats.org/drawingml/2006/main">
               <a:ext uri="{FF2B5EF4-FFF2-40B4-BE49-F238E27FC236}">
-                <a16:creationId xmlns:a16="http://schemas.microsoft.com/office/drawing/2014/main" id="{E8C49491-CBBA-498E-A211-18FD43A417F5}"/>
+                <a16:creationId xmlns:a16="http://schemas.microsoft.com/office/drawing/2014/main" id="{63B3B433-F8C3-4A7E-B763-81A615DEC690}"/>
               </a:ext>
             </a:extLst>
           </p:cNvPr>
@@ -5319,7 +5319,7 @@
           <p:cNvPr id="7" name="">
             <a:extLst xmlns:a="http://schemas.openxmlformats.org/drawingml/2006/main">
               <a:ext uri="{FF2B5EF4-FFF2-40B4-BE49-F238E27FC236}">
-                <a16:creationId xmlns:a16="http://schemas.microsoft.com/office/drawing/2014/main" id="{60611E4C-53D3-4098-AD4A-468243BDF22C}"/>
+                <a16:creationId xmlns:a16="http://schemas.microsoft.com/office/drawing/2014/main" id="{0D9FC47C-1B2F-44D7-A3A8-B1C8BEE5788A}"/>
               </a:ext>
             </a:extLst>
           </p:cNvPr>
@@ -5350,7 +5350,7 @@
           <p:cNvPr id="8" name="">
             <a:extLst xmlns:a="http://schemas.openxmlformats.org/drawingml/2006/main">
               <a:ext uri="{FF2B5EF4-FFF2-40B4-BE49-F238E27FC236}">
-                <a16:creationId xmlns:a16="http://schemas.microsoft.com/office/drawing/2014/main" id="{828C4849-981E-4749-912B-F52A3B0DAFC2}"/>
+                <a16:creationId xmlns:a16="http://schemas.microsoft.com/office/drawing/2014/main" id="{6DA37944-8264-47F3-89F2-37CC00D04112}"/>
               </a:ext>
             </a:extLst>
           </p:cNvPr>
@@ -5400,7 +5400,7 @@
           <p:cNvPr id="9" name="">
             <a:extLst xmlns:a="http://schemas.openxmlformats.org/drawingml/2006/main">
               <a:ext uri="{FF2B5EF4-FFF2-40B4-BE49-F238E27FC236}">
-                <a16:creationId xmlns:a16="http://schemas.microsoft.com/office/drawing/2014/main" id="{9D159E20-FDA9-4F10-8F75-201F2EE1D331}"/>
+                <a16:creationId xmlns:a16="http://schemas.microsoft.com/office/drawing/2014/main" id="{F31556B4-4F51-44F9-94CE-68C9150EF132}"/>
               </a:ext>
             </a:extLst>
           </p:cNvPr>
@@ -5431,7 +5431,7 @@
           <p:cNvPr id="10" name="">
             <a:extLst xmlns:a="http://schemas.openxmlformats.org/drawingml/2006/main">
               <a:ext uri="{FF2B5EF4-FFF2-40B4-BE49-F238E27FC236}">
-                <a16:creationId xmlns:a16="http://schemas.microsoft.com/office/drawing/2014/main" id="{4583B2EA-8801-415E-AA66-28B3D2E2F0AD}"/>
+                <a16:creationId xmlns:a16="http://schemas.microsoft.com/office/drawing/2014/main" id="{3EB4883A-A880-49B5-81E5-57223035D220}"/>
               </a:ext>
             </a:extLst>
           </p:cNvPr>
@@ -5481,7 +5481,7 @@
           <p:cNvPr id="11" name="">
             <a:extLst xmlns:a="http://schemas.openxmlformats.org/drawingml/2006/main">
               <a:ext uri="{FF2B5EF4-FFF2-40B4-BE49-F238E27FC236}">
-                <a16:creationId xmlns:a16="http://schemas.microsoft.com/office/drawing/2014/main" id="{FC07AD4A-63F1-4DED-8DAE-354B4815B31F}"/>
+                <a16:creationId xmlns:a16="http://schemas.microsoft.com/office/drawing/2014/main" id="{26B9982E-104C-41CD-A5DF-A9106FA05761}"/>
               </a:ext>
             </a:extLst>
           </p:cNvPr>
@@ -5512,7 +5512,7 @@
           <p:cNvPr id="12" name="">
             <a:extLst xmlns:a="http://schemas.openxmlformats.org/drawingml/2006/main">
               <a:ext uri="{FF2B5EF4-FFF2-40B4-BE49-F238E27FC236}">
-                <a16:creationId xmlns:a16="http://schemas.microsoft.com/office/drawing/2014/main" id="{35487C96-DED8-4959-AAF3-EB389EB23693}"/>
+                <a16:creationId xmlns:a16="http://schemas.microsoft.com/office/drawing/2014/main" id="{5525A7C9-E9AF-467E-A64F-C3638E99215F}"/>
               </a:ext>
             </a:extLst>
           </p:cNvPr>
@@ -5562,7 +5562,7 @@
           <p:cNvPr id="13" name="">
             <a:extLst xmlns:a="http://schemas.openxmlformats.org/drawingml/2006/main">
               <a:ext uri="{FF2B5EF4-FFF2-40B4-BE49-F238E27FC236}">
-                <a16:creationId xmlns:a16="http://schemas.microsoft.com/office/drawing/2014/main" id="{3AF0442E-5D88-4019-B7B5-41488B8634A1}"/>
+                <a16:creationId xmlns:a16="http://schemas.microsoft.com/office/drawing/2014/main" id="{DBCF6853-1BB9-4009-BBB1-97A8404CA5FC}"/>
               </a:ext>
             </a:extLst>
           </p:cNvPr>
@@ -5612,7 +5612,7 @@
           <p:cNvPr id="14" name="">
             <a:extLst xmlns:a="http://schemas.openxmlformats.org/drawingml/2006/main">
               <a:ext uri="{FF2B5EF4-FFF2-40B4-BE49-F238E27FC236}">
-                <a16:creationId xmlns:a16="http://schemas.microsoft.com/office/drawing/2014/main" id="{8DDB3BDE-6D59-4F88-9509-174629033E0B}"/>
+                <a16:creationId xmlns:a16="http://schemas.microsoft.com/office/drawing/2014/main" id="{6D1675B1-8E68-4C42-81DF-36A6F1FC7E7A}"/>
               </a:ext>
             </a:extLst>
           </p:cNvPr>
@@ -5643,7 +5643,7 @@
           <p:cNvPr id="15" name="">
             <a:extLst xmlns:a="http://schemas.openxmlformats.org/drawingml/2006/main">
               <a:ext uri="{FF2B5EF4-FFF2-40B4-BE49-F238E27FC236}">
-                <a16:creationId xmlns:a16="http://schemas.microsoft.com/office/drawing/2014/main" id="{99B0BCCA-EF12-4975-B9D1-28EB6C80D333}"/>
+                <a16:creationId xmlns:a16="http://schemas.microsoft.com/office/drawing/2014/main" id="{759D7EBC-5C26-4AC8-9D75-14AF2F9905D2}"/>
               </a:ext>
             </a:extLst>
           </p:cNvPr>
@@ -5693,7 +5693,7 @@
           <p:cNvPr id="16" name="">
             <a:extLst xmlns:a="http://schemas.openxmlformats.org/drawingml/2006/main">
               <a:ext uri="{FF2B5EF4-FFF2-40B4-BE49-F238E27FC236}">
-                <a16:creationId xmlns:a16="http://schemas.microsoft.com/office/drawing/2014/main" id="{A48AAFDF-7824-4F60-8EBC-898F8C3AC0D9}"/>
+                <a16:creationId xmlns:a16="http://schemas.microsoft.com/office/drawing/2014/main" id="{0E13E1AC-AA88-449B-B52C-C45A1F631EBE}"/>
               </a:ext>
             </a:extLst>
           </p:cNvPr>
@@ -5724,7 +5724,7 @@
           <p:cNvPr id="17" name="">
             <a:extLst xmlns:a="http://schemas.openxmlformats.org/drawingml/2006/main">
               <a:ext uri="{FF2B5EF4-FFF2-40B4-BE49-F238E27FC236}">
-                <a16:creationId xmlns:a16="http://schemas.microsoft.com/office/drawing/2014/main" id="{3723C9C9-5167-4313-AB88-E9ECF98DBE2E}"/>
+                <a16:creationId xmlns:a16="http://schemas.microsoft.com/office/drawing/2014/main" id="{D7402148-7512-4CAC-85D4-1C7DB5B11965}"/>
               </a:ext>
             </a:extLst>
           </p:cNvPr>
@@ -5774,7 +5774,7 @@
           <p:cNvPr id="18" name="">
             <a:extLst xmlns:a="http://schemas.openxmlformats.org/drawingml/2006/main">
               <a:ext uri="{FF2B5EF4-FFF2-40B4-BE49-F238E27FC236}">
-                <a16:creationId xmlns:a16="http://schemas.microsoft.com/office/drawing/2014/main" id="{6B167DC4-3760-4F20-9422-88EA986D8A88}"/>
+                <a16:creationId xmlns:a16="http://schemas.microsoft.com/office/drawing/2014/main" id="{8704FA87-0899-4B20-A305-9D82EB5DDE63}"/>
               </a:ext>
             </a:extLst>
           </p:cNvPr>
@@ -5805,7 +5805,7 @@
           <p:cNvPr id="19" name="">
             <a:extLst xmlns:a="http://schemas.openxmlformats.org/drawingml/2006/main">
               <a:ext uri="{FF2B5EF4-FFF2-40B4-BE49-F238E27FC236}">
-                <a16:creationId xmlns:a16="http://schemas.microsoft.com/office/drawing/2014/main" id="{1D94BC1D-25A7-439D-9941-3F9499B572D6}"/>
+                <a16:creationId xmlns:a16="http://schemas.microsoft.com/office/drawing/2014/main" id="{7530A3EC-2F0C-47AA-871E-257245EA7432}"/>
               </a:ext>
             </a:extLst>
           </p:cNvPr>
@@ -5855,7 +5855,7 @@
           <p:cNvPr id="20" name="">
             <a:extLst xmlns:a="http://schemas.openxmlformats.org/drawingml/2006/main">
               <a:ext uri="{FF2B5EF4-FFF2-40B4-BE49-F238E27FC236}">
-                <a16:creationId xmlns:a16="http://schemas.microsoft.com/office/drawing/2014/main" id="{64B136A0-B2D2-4A30-B07F-B4E2E2BCF294}"/>
+                <a16:creationId xmlns:a16="http://schemas.microsoft.com/office/drawing/2014/main" id="{10A0BA28-5CD4-42EE-9C56-BFFF877BD192}"/>
               </a:ext>
             </a:extLst>
           </p:cNvPr>
@@ -5890,7 +5890,7 @@
           <p:cNvPr id="21" name="">
             <a:extLst xmlns:a="http://schemas.openxmlformats.org/drawingml/2006/main">
               <a:ext uri="{FF2B5EF4-FFF2-40B4-BE49-F238E27FC236}">
-                <a16:creationId xmlns:a16="http://schemas.microsoft.com/office/drawing/2014/main" id="{9ACF628F-DE63-4360-A86D-9E56282E93D8}"/>
+                <a16:creationId xmlns:a16="http://schemas.microsoft.com/office/drawing/2014/main" id="{D03CA90D-5D74-47FA-8664-F1AD4413CDE1}"/>
               </a:ext>
             </a:extLst>
           </p:cNvPr>
@@ -5938,7 +5938,7 @@
     </p:spTree>
     <p:extLst>
       <p:ext uri="{BB962C8B-B14F-4D97-AF65-F5344CB8AC3E}">
-        <p14:creationId xmlns:p14="http://schemas.microsoft.com/office/powerpoint/2010/main" val="916089894"/>
+        <p14:creationId xmlns:p14="http://schemas.microsoft.com/office/powerpoint/2010/main" val="1753689858"/>
       </p:ext>
     </p:extLst>
   </p:cSld>
@@ -5969,7 +5969,7 @@
           <p:cNvPr id="24" name="">
             <a:extLst xmlns:a="http://schemas.openxmlformats.org/drawingml/2006/main">
               <a:ext uri="{FF2B5EF4-FFF2-40B4-BE49-F238E27FC236}">
-                <a16:creationId xmlns:a16="http://schemas.microsoft.com/office/drawing/2014/main" id="{F735F525-8D7B-4BEE-B110-F7518D7CB543}"/>
+                <a16:creationId xmlns:a16="http://schemas.microsoft.com/office/drawing/2014/main" id="{B9745CFB-499E-4FF2-B34D-8C7039C91FA4}"/>
               </a:ext>
             </a:extLst>
           </p:cNvPr>
@@ -6019,7 +6019,7 @@
           <p:cNvPr id="2" name="">
             <a:extLst xmlns:a="http://schemas.openxmlformats.org/drawingml/2006/main">
               <a:ext uri="{FF2B5EF4-FFF2-40B4-BE49-F238E27FC236}">
-                <a16:creationId xmlns:a16="http://schemas.microsoft.com/office/drawing/2014/main" id="{FA4CB068-DAF1-4622-9BFE-9D789AC2B0A8}"/>
+                <a16:creationId xmlns:a16="http://schemas.microsoft.com/office/drawing/2014/main" id="{2123A18D-AD25-441B-B1A3-168A7E048C38}"/>
               </a:ext>
             </a:extLst>
           </p:cNvPr>
@@ -6069,7 +6069,7 @@
           <p:cNvPr id="3" name="">
             <a:extLst xmlns:a="http://schemas.openxmlformats.org/drawingml/2006/main">
               <a:ext uri="{FF2B5EF4-FFF2-40B4-BE49-F238E27FC236}">
-                <a16:creationId xmlns:a16="http://schemas.microsoft.com/office/drawing/2014/main" id="{9E370631-96F1-4434-96DB-FBD8FB991BB4}"/>
+                <a16:creationId xmlns:a16="http://schemas.microsoft.com/office/drawing/2014/main" id="{04BC8943-9D01-46B1-8B3A-2E1EB7402641}"/>
               </a:ext>
             </a:extLst>
           </p:cNvPr>
@@ -6100,7 +6100,7 @@
           <p:cNvPr id="4" name="">
             <a:extLst xmlns:a="http://schemas.openxmlformats.org/drawingml/2006/main">
               <a:ext uri="{FF2B5EF4-FFF2-40B4-BE49-F238E27FC236}">
-                <a16:creationId xmlns:a16="http://schemas.microsoft.com/office/drawing/2014/main" id="{8779D0DF-6D52-4276-8DD7-1B65571D2BD6}"/>
+                <a16:creationId xmlns:a16="http://schemas.microsoft.com/office/drawing/2014/main" id="{7198E421-8415-49E2-A89F-52E062DC5802}"/>
               </a:ext>
             </a:extLst>
           </p:cNvPr>
@@ -6150,7 +6150,7 @@
           <p:cNvPr id="5" name="">
             <a:extLst xmlns:a="http://schemas.openxmlformats.org/drawingml/2006/main">
               <a:ext uri="{FF2B5EF4-FFF2-40B4-BE49-F238E27FC236}">
-                <a16:creationId xmlns:a16="http://schemas.microsoft.com/office/drawing/2014/main" id="{34D90E0E-A25D-48FB-9877-BDE9CB71AC58}"/>
+                <a16:creationId xmlns:a16="http://schemas.microsoft.com/office/drawing/2014/main" id="{4898B702-6F13-4D9F-950F-A86347962E82}"/>
               </a:ext>
             </a:extLst>
           </p:cNvPr>
@@ -6200,7 +6200,7 @@
           <p:cNvPr id="6" name="">
             <a:extLst xmlns:a="http://schemas.openxmlformats.org/drawingml/2006/main">
               <a:ext uri="{FF2B5EF4-FFF2-40B4-BE49-F238E27FC236}">
-                <a16:creationId xmlns:a16="http://schemas.microsoft.com/office/drawing/2014/main" id="{27405012-6175-4E48-9B91-FAF03F3D72FF}"/>
+                <a16:creationId xmlns:a16="http://schemas.microsoft.com/office/drawing/2014/main" id="{B6E840E6-AB3C-46E0-BD36-2FE8D58DE886}"/>
               </a:ext>
             </a:extLst>
           </p:cNvPr>
@@ -6250,7 +6250,7 @@
           <p:cNvPr id="7" name="">
             <a:extLst xmlns:a="http://schemas.openxmlformats.org/drawingml/2006/main">
               <a:ext uri="{FF2B5EF4-FFF2-40B4-BE49-F238E27FC236}">
-                <a16:creationId xmlns:a16="http://schemas.microsoft.com/office/drawing/2014/main" id="{A198C54A-66D2-4195-9178-2017AC0B4110}"/>
+                <a16:creationId xmlns:a16="http://schemas.microsoft.com/office/drawing/2014/main" id="{2A2FB707-FE39-422F-8FB7-4330F06E6D44}"/>
               </a:ext>
             </a:extLst>
           </p:cNvPr>
@@ -6281,7 +6281,7 @@
           <p:cNvPr id="8" name="">
             <a:extLst xmlns:a="http://schemas.openxmlformats.org/drawingml/2006/main">
               <a:ext uri="{FF2B5EF4-FFF2-40B4-BE49-F238E27FC236}">
-                <a16:creationId xmlns:a16="http://schemas.microsoft.com/office/drawing/2014/main" id="{1C290F9C-3BD5-4036-8B7C-3B0983EF5B2F}"/>
+                <a16:creationId xmlns:a16="http://schemas.microsoft.com/office/drawing/2014/main" id="{42246D3F-6F82-4194-B808-C972F78A1F73}"/>
               </a:ext>
             </a:extLst>
           </p:cNvPr>
@@ -6331,7 +6331,7 @@
           <p:cNvPr id="9" name="">
             <a:extLst xmlns:a="http://schemas.openxmlformats.org/drawingml/2006/main">
               <a:ext uri="{FF2B5EF4-FFF2-40B4-BE49-F238E27FC236}">
-                <a16:creationId xmlns:a16="http://schemas.microsoft.com/office/drawing/2014/main" id="{3B3DAEC5-DEF1-4F42-8BF2-CBAADA43BD7D}"/>
+                <a16:creationId xmlns:a16="http://schemas.microsoft.com/office/drawing/2014/main" id="{8772739E-E5B7-45BA-A47A-8ADD6BDD8EE5}"/>
               </a:ext>
             </a:extLst>
           </p:cNvPr>
@@ -6362,7 +6362,7 @@
           <p:cNvPr id="10" name="">
             <a:extLst xmlns:a="http://schemas.openxmlformats.org/drawingml/2006/main">
               <a:ext uri="{FF2B5EF4-FFF2-40B4-BE49-F238E27FC236}">
-                <a16:creationId xmlns:a16="http://schemas.microsoft.com/office/drawing/2014/main" id="{CE42FEFB-C01E-4801-9BE1-6BFFB4382F28}"/>
+                <a16:creationId xmlns:a16="http://schemas.microsoft.com/office/drawing/2014/main" id="{E376BB26-F84A-45B6-8352-E30557D90B5E}"/>
               </a:ext>
             </a:extLst>
           </p:cNvPr>
@@ -6412,7 +6412,7 @@
           <p:cNvPr id="11" name="">
             <a:extLst xmlns:a="http://schemas.openxmlformats.org/drawingml/2006/main">
               <a:ext uri="{FF2B5EF4-FFF2-40B4-BE49-F238E27FC236}">
-                <a16:creationId xmlns:a16="http://schemas.microsoft.com/office/drawing/2014/main" id="{AFAABF7A-5CA2-4D0C-9C0C-23846ABCA62A}"/>
+                <a16:creationId xmlns:a16="http://schemas.microsoft.com/office/drawing/2014/main" id="{8485790C-D3D5-4B27-98C8-FE86606C032C}"/>
               </a:ext>
             </a:extLst>
           </p:cNvPr>
@@ -6443,7 +6443,7 @@
           <p:cNvPr id="12" name="">
             <a:extLst xmlns:a="http://schemas.openxmlformats.org/drawingml/2006/main">
               <a:ext uri="{FF2B5EF4-FFF2-40B4-BE49-F238E27FC236}">
-                <a16:creationId xmlns:a16="http://schemas.microsoft.com/office/drawing/2014/main" id="{567C923B-1081-4298-96FF-66D14146F74E}"/>
+                <a16:creationId xmlns:a16="http://schemas.microsoft.com/office/drawing/2014/main" id="{8FCE8963-FDCE-4DED-AEAE-3AFBEFBC6AD6}"/>
               </a:ext>
             </a:extLst>
           </p:cNvPr>
@@ -6493,7 +6493,7 @@
           <p:cNvPr id="13" name="">
             <a:extLst xmlns:a="http://schemas.openxmlformats.org/drawingml/2006/main">
               <a:ext uri="{FF2B5EF4-FFF2-40B4-BE49-F238E27FC236}">
-                <a16:creationId xmlns:a16="http://schemas.microsoft.com/office/drawing/2014/main" id="{F161C78B-4669-43E1-8BC4-8E7E8B4BB8E2}"/>
+                <a16:creationId xmlns:a16="http://schemas.microsoft.com/office/drawing/2014/main" id="{B1854766-FFAD-40B4-B5E0-95118E83D1FE}"/>
               </a:ext>
             </a:extLst>
           </p:cNvPr>
@@ -6524,7 +6524,7 @@
           <p:cNvPr id="14" name="">
             <a:extLst xmlns:a="http://schemas.openxmlformats.org/drawingml/2006/main">
               <a:ext uri="{FF2B5EF4-FFF2-40B4-BE49-F238E27FC236}">
-                <a16:creationId xmlns:a16="http://schemas.microsoft.com/office/drawing/2014/main" id="{2A0BEEDE-34A4-45A6-AFD1-F1E38DDFD54B}"/>
+                <a16:creationId xmlns:a16="http://schemas.microsoft.com/office/drawing/2014/main" id="{8523232C-E234-4753-BB09-2D5239BBD69E}"/>
               </a:ext>
             </a:extLst>
           </p:cNvPr>
@@ -6574,7 +6574,7 @@
           <p:cNvPr id="15" name="">
             <a:extLst xmlns:a="http://schemas.openxmlformats.org/drawingml/2006/main">
               <a:ext uri="{FF2B5EF4-FFF2-40B4-BE49-F238E27FC236}">
-                <a16:creationId xmlns:a16="http://schemas.microsoft.com/office/drawing/2014/main" id="{6D5C8C6D-E403-4299-8BFE-13710555DD8E}"/>
+                <a16:creationId xmlns:a16="http://schemas.microsoft.com/office/drawing/2014/main" id="{CFAE7343-95C4-46A6-B7CA-48B819E92D94}"/>
               </a:ext>
             </a:extLst>
           </p:cNvPr>
@@ -6624,7 +6624,7 @@
           <p:cNvPr id="16" name="">
             <a:extLst xmlns:a="http://schemas.openxmlformats.org/drawingml/2006/main">
               <a:ext uri="{FF2B5EF4-FFF2-40B4-BE49-F238E27FC236}">
-                <a16:creationId xmlns:a16="http://schemas.microsoft.com/office/drawing/2014/main" id="{77CA9861-E357-4C62-A96F-D9DDA7D3A9A0}"/>
+                <a16:creationId xmlns:a16="http://schemas.microsoft.com/office/drawing/2014/main" id="{61529C79-9173-444A-9465-C735FA59A84A}"/>
               </a:ext>
             </a:extLst>
           </p:cNvPr>
@@ -6655,7 +6655,7 @@
           <p:cNvPr id="17" name="">
             <a:extLst xmlns:a="http://schemas.openxmlformats.org/drawingml/2006/main">
               <a:ext uri="{FF2B5EF4-FFF2-40B4-BE49-F238E27FC236}">
-                <a16:creationId xmlns:a16="http://schemas.microsoft.com/office/drawing/2014/main" id="{16CE6864-6D15-49A5-ADC3-1669D5C4EAB8}"/>
+                <a16:creationId xmlns:a16="http://schemas.microsoft.com/office/drawing/2014/main" id="{19553A68-021F-448D-80CF-5EB43A65BD15}"/>
               </a:ext>
             </a:extLst>
           </p:cNvPr>
@@ -6705,7 +6705,7 @@
           <p:cNvPr id="18" name="">
             <a:extLst xmlns:a="http://schemas.openxmlformats.org/drawingml/2006/main">
               <a:ext uri="{FF2B5EF4-FFF2-40B4-BE49-F238E27FC236}">
-                <a16:creationId xmlns:a16="http://schemas.microsoft.com/office/drawing/2014/main" id="{FF29563C-69D2-4D88-B351-62F346EE6759}"/>
+                <a16:creationId xmlns:a16="http://schemas.microsoft.com/office/drawing/2014/main" id="{ABA05AFB-D5D7-4AFB-BC5E-EE0D015F8A73}"/>
               </a:ext>
             </a:extLst>
           </p:cNvPr>
@@ -6736,7 +6736,7 @@
           <p:cNvPr id="19" name="">
             <a:extLst xmlns:a="http://schemas.openxmlformats.org/drawingml/2006/main">
               <a:ext uri="{FF2B5EF4-FFF2-40B4-BE49-F238E27FC236}">
-                <a16:creationId xmlns:a16="http://schemas.microsoft.com/office/drawing/2014/main" id="{17C45DC8-FD2B-41A0-A93F-098030D26DF7}"/>
+                <a16:creationId xmlns:a16="http://schemas.microsoft.com/office/drawing/2014/main" id="{750A13E4-06DB-46BA-8534-FF1A0A91D3C5}"/>
               </a:ext>
             </a:extLst>
           </p:cNvPr>
@@ -6786,7 +6786,7 @@
           <p:cNvPr id="20" name="">
             <a:extLst xmlns:a="http://schemas.openxmlformats.org/drawingml/2006/main">
               <a:ext uri="{FF2B5EF4-FFF2-40B4-BE49-F238E27FC236}">
-                <a16:creationId xmlns:a16="http://schemas.microsoft.com/office/drawing/2014/main" id="{4AB61393-9810-4502-8E02-0EED3827AAF2}"/>
+                <a16:creationId xmlns:a16="http://schemas.microsoft.com/office/drawing/2014/main" id="{217C4AB9-06C7-4433-A53D-C8756EBE6290}"/>
               </a:ext>
             </a:extLst>
           </p:cNvPr>
@@ -6817,7 +6817,7 @@
           <p:cNvPr id="21" name="">
             <a:extLst xmlns:a="http://schemas.openxmlformats.org/drawingml/2006/main">
               <a:ext uri="{FF2B5EF4-FFF2-40B4-BE49-F238E27FC236}">
-                <a16:creationId xmlns:a16="http://schemas.microsoft.com/office/drawing/2014/main" id="{2FF6D143-7977-4EDA-9D67-7D728B471694}"/>
+                <a16:creationId xmlns:a16="http://schemas.microsoft.com/office/drawing/2014/main" id="{EDC411F5-D1FD-45DA-BD12-C10B5C922AC5}"/>
               </a:ext>
             </a:extLst>
           </p:cNvPr>
@@ -6867,7 +6867,7 @@
           <p:cNvPr id="22" name="">
             <a:extLst xmlns:a="http://schemas.openxmlformats.org/drawingml/2006/main">
               <a:ext uri="{FF2B5EF4-FFF2-40B4-BE49-F238E27FC236}">
-                <a16:creationId xmlns:a16="http://schemas.microsoft.com/office/drawing/2014/main" id="{9B23B9E9-C55A-48AE-B274-F27EC77CBB47}"/>
+                <a16:creationId xmlns:a16="http://schemas.microsoft.com/office/drawing/2014/main" id="{3F649D4A-EF69-49EA-A4E9-F78FE134BC43}"/>
               </a:ext>
             </a:extLst>
           </p:cNvPr>
@@ -6898,7 +6898,7 @@
           <p:cNvPr id="23" name="">
             <a:extLst xmlns:a="http://schemas.openxmlformats.org/drawingml/2006/main">
               <a:ext uri="{FF2B5EF4-FFF2-40B4-BE49-F238E27FC236}">
-                <a16:creationId xmlns:a16="http://schemas.microsoft.com/office/drawing/2014/main" id="{1E5FB9CE-7ADE-487C-A0B8-7755BA7C0F9D}"/>
+                <a16:creationId xmlns:a16="http://schemas.microsoft.com/office/drawing/2014/main" id="{30206F1A-5695-4267-8475-C2571DA9E24E}"/>
               </a:ext>
             </a:extLst>
           </p:cNvPr>
@@ -6946,7 +6946,7 @@
     </p:spTree>
     <p:extLst>
       <p:ext uri="{BB962C8B-B14F-4D97-AF65-F5344CB8AC3E}">
-        <p14:creationId xmlns:p14="http://schemas.microsoft.com/office/powerpoint/2010/main" val="1302819889"/>
+        <p14:creationId xmlns:p14="http://schemas.microsoft.com/office/powerpoint/2010/main" val="1370534528"/>
       </p:ext>
     </p:extLst>
   </p:cSld>
@@ -6977,7 +6977,7 @@
           <p:cNvPr id="24" name="">
             <a:extLst xmlns:a="http://schemas.openxmlformats.org/drawingml/2006/main">
               <a:ext uri="{FF2B5EF4-FFF2-40B4-BE49-F238E27FC236}">
-                <a16:creationId xmlns:a16="http://schemas.microsoft.com/office/drawing/2014/main" id="{A7D0150F-CE5B-4274-8B6C-30E552916E01}"/>
+                <a16:creationId xmlns:a16="http://schemas.microsoft.com/office/drawing/2014/main" id="{0C1EAE1B-3E60-4CF4-B983-E255C001016E}"/>
               </a:ext>
             </a:extLst>
           </p:cNvPr>
@@ -7027,7 +7027,7 @@
           <p:cNvPr id="2" name="">
             <a:extLst xmlns:a="http://schemas.openxmlformats.org/drawingml/2006/main">
               <a:ext uri="{FF2B5EF4-FFF2-40B4-BE49-F238E27FC236}">
-                <a16:creationId xmlns:a16="http://schemas.microsoft.com/office/drawing/2014/main" id="{CB83E6B9-B424-423C-808F-BB80FCD13D1A}"/>
+                <a16:creationId xmlns:a16="http://schemas.microsoft.com/office/drawing/2014/main" id="{CBD952C5-17E4-42E8-A164-7DBA865810D9}"/>
               </a:ext>
             </a:extLst>
           </p:cNvPr>
@@ -7077,7 +7077,7 @@
           <p:cNvPr id="3" name="">
             <a:extLst xmlns:a="http://schemas.openxmlformats.org/drawingml/2006/main">
               <a:ext uri="{FF2B5EF4-FFF2-40B4-BE49-F238E27FC236}">
-                <a16:creationId xmlns:a16="http://schemas.microsoft.com/office/drawing/2014/main" id="{0BAE131E-8445-4150-8821-A0D0B164F9B2}"/>
+                <a16:creationId xmlns:a16="http://schemas.microsoft.com/office/drawing/2014/main" id="{14C35E77-2884-4B15-84F8-9BAE2E3F6B28}"/>
               </a:ext>
             </a:extLst>
           </p:cNvPr>
@@ -7108,7 +7108,7 @@
           <p:cNvPr id="4" name="">
             <a:extLst xmlns:a="http://schemas.openxmlformats.org/drawingml/2006/main">
               <a:ext uri="{FF2B5EF4-FFF2-40B4-BE49-F238E27FC236}">
-                <a16:creationId xmlns:a16="http://schemas.microsoft.com/office/drawing/2014/main" id="{220BD4A3-C85C-4F5D-97D4-0CE84917FEBA}"/>
+                <a16:creationId xmlns:a16="http://schemas.microsoft.com/office/drawing/2014/main" id="{DB857B75-8FEE-451D-B9E6-2118E1D834AC}"/>
               </a:ext>
             </a:extLst>
           </p:cNvPr>
@@ -7158,7 +7158,7 @@
           <p:cNvPr id="5" name="">
             <a:extLst xmlns:a="http://schemas.openxmlformats.org/drawingml/2006/main">
               <a:ext uri="{FF2B5EF4-FFF2-40B4-BE49-F238E27FC236}">
-                <a16:creationId xmlns:a16="http://schemas.microsoft.com/office/drawing/2014/main" id="{C3A73705-158F-47E7-9F43-2D212CADCB30}"/>
+                <a16:creationId xmlns:a16="http://schemas.microsoft.com/office/drawing/2014/main" id="{2330B428-85DE-43BC-9C03-93196ECFEFB1}"/>
               </a:ext>
             </a:extLst>
           </p:cNvPr>
@@ -7208,7 +7208,7 @@
           <p:cNvPr id="6" name="">
             <a:extLst xmlns:a="http://schemas.openxmlformats.org/drawingml/2006/main">
               <a:ext uri="{FF2B5EF4-FFF2-40B4-BE49-F238E27FC236}">
-                <a16:creationId xmlns:a16="http://schemas.microsoft.com/office/drawing/2014/main" id="{B240D46D-A6BE-467C-925F-8169171CFCDC}"/>
+                <a16:creationId xmlns:a16="http://schemas.microsoft.com/office/drawing/2014/main" id="{2131EC86-3A3A-43E8-886D-C2CD57E25F03}"/>
               </a:ext>
             </a:extLst>
           </p:cNvPr>
@@ -7258,7 +7258,7 @@
           <p:cNvPr id="7" name="">
             <a:extLst xmlns:a="http://schemas.openxmlformats.org/drawingml/2006/main">
               <a:ext uri="{FF2B5EF4-FFF2-40B4-BE49-F238E27FC236}">
-                <a16:creationId xmlns:a16="http://schemas.microsoft.com/office/drawing/2014/main" id="{A2FF6E5B-446A-4D68-BA19-1C4C932BB562}"/>
+                <a16:creationId xmlns:a16="http://schemas.microsoft.com/office/drawing/2014/main" id="{D202F92D-8AE8-4690-8C00-A159BD602C9D}"/>
               </a:ext>
             </a:extLst>
           </p:cNvPr>
@@ -7289,7 +7289,7 @@
           <p:cNvPr id="8" name="">
             <a:extLst xmlns:a="http://schemas.openxmlformats.org/drawingml/2006/main">
               <a:ext uri="{FF2B5EF4-FFF2-40B4-BE49-F238E27FC236}">
-                <a16:creationId xmlns:a16="http://schemas.microsoft.com/office/drawing/2014/main" id="{4F6C1CB2-72D1-478E-959D-9D2C4480AB35}"/>
+                <a16:creationId xmlns:a16="http://schemas.microsoft.com/office/drawing/2014/main" id="{4ABA7E49-A900-4DEA-B797-A2EF0DC064F7}"/>
               </a:ext>
             </a:extLst>
           </p:cNvPr>
@@ -7339,7 +7339,7 @@
           <p:cNvPr id="9" name="">
             <a:extLst xmlns:a="http://schemas.openxmlformats.org/drawingml/2006/main">
               <a:ext uri="{FF2B5EF4-FFF2-40B4-BE49-F238E27FC236}">
-                <a16:creationId xmlns:a16="http://schemas.microsoft.com/office/drawing/2014/main" id="{46828DCE-0F5E-48F6-9DE8-A7FDD52C48C2}"/>
+                <a16:creationId xmlns:a16="http://schemas.microsoft.com/office/drawing/2014/main" id="{B0261559-7CF2-4624-B07F-DEA7D014F5C7}"/>
               </a:ext>
             </a:extLst>
           </p:cNvPr>
@@ -7370,7 +7370,7 @@
           <p:cNvPr id="10" name="">
             <a:extLst xmlns:a="http://schemas.openxmlformats.org/drawingml/2006/main">
               <a:ext uri="{FF2B5EF4-FFF2-40B4-BE49-F238E27FC236}">
-                <a16:creationId xmlns:a16="http://schemas.microsoft.com/office/drawing/2014/main" id="{900BDF9D-5195-4BB3-BD47-BE5DC6E2D55B}"/>
+                <a16:creationId xmlns:a16="http://schemas.microsoft.com/office/drawing/2014/main" id="{CC37975B-70DE-4562-A8A7-43C04AEF5588}"/>
               </a:ext>
             </a:extLst>
           </p:cNvPr>
@@ -7420,7 +7420,7 @@
           <p:cNvPr id="11" name="">
             <a:extLst xmlns:a="http://schemas.openxmlformats.org/drawingml/2006/main">
               <a:ext uri="{FF2B5EF4-FFF2-40B4-BE49-F238E27FC236}">
-                <a16:creationId xmlns:a16="http://schemas.microsoft.com/office/drawing/2014/main" id="{CE9C5C0C-E70B-4608-9B52-67027A3C2EB5}"/>
+                <a16:creationId xmlns:a16="http://schemas.microsoft.com/office/drawing/2014/main" id="{2C39B6CE-63A0-489A-BBE4-D3CD9C81D3C7}"/>
               </a:ext>
             </a:extLst>
           </p:cNvPr>
@@ -7451,7 +7451,7 @@
           <p:cNvPr id="12" name="">
             <a:extLst xmlns:a="http://schemas.openxmlformats.org/drawingml/2006/main">
               <a:ext uri="{FF2B5EF4-FFF2-40B4-BE49-F238E27FC236}">
-                <a16:creationId xmlns:a16="http://schemas.microsoft.com/office/drawing/2014/main" id="{61C36004-4FA2-41A9-A47C-98797CBD899B}"/>
+                <a16:creationId xmlns:a16="http://schemas.microsoft.com/office/drawing/2014/main" id="{7A3662C9-CD84-4408-8212-BD2A50746D5C}"/>
               </a:ext>
             </a:extLst>
           </p:cNvPr>
@@ -7501,7 +7501,7 @@
           <p:cNvPr id="13" name="">
             <a:extLst xmlns:a="http://schemas.openxmlformats.org/drawingml/2006/main">
               <a:ext uri="{FF2B5EF4-FFF2-40B4-BE49-F238E27FC236}">
-                <a16:creationId xmlns:a16="http://schemas.microsoft.com/office/drawing/2014/main" id="{93C3F734-EAD5-4605-B2FA-FA3293D17B0B}"/>
+                <a16:creationId xmlns:a16="http://schemas.microsoft.com/office/drawing/2014/main" id="{224029BC-86DC-49C5-B0A6-2683027E7491}"/>
               </a:ext>
             </a:extLst>
           </p:cNvPr>
@@ -7532,7 +7532,7 @@
           <p:cNvPr id="14" name="">
             <a:extLst xmlns:a="http://schemas.openxmlformats.org/drawingml/2006/main">
               <a:ext uri="{FF2B5EF4-FFF2-40B4-BE49-F238E27FC236}">
-                <a16:creationId xmlns:a16="http://schemas.microsoft.com/office/drawing/2014/main" id="{A38E54DA-BF67-4609-9AE0-82F77A926085}"/>
+                <a16:creationId xmlns:a16="http://schemas.microsoft.com/office/drawing/2014/main" id="{764FB0EB-DA56-4B4C-9BB2-E4BE313D14ED}"/>
               </a:ext>
             </a:extLst>
           </p:cNvPr>
@@ -7582,7 +7582,7 @@
           <p:cNvPr id="15" name="">
             <a:extLst xmlns:a="http://schemas.openxmlformats.org/drawingml/2006/main">
               <a:ext uri="{FF2B5EF4-FFF2-40B4-BE49-F238E27FC236}">
-                <a16:creationId xmlns:a16="http://schemas.microsoft.com/office/drawing/2014/main" id="{C39E3D0E-91A7-4CDB-8CB2-5063FA1D24EF}"/>
+                <a16:creationId xmlns:a16="http://schemas.microsoft.com/office/drawing/2014/main" id="{0A1AFBF4-F5EF-4527-AC73-82B3CE6B7EFE}"/>
               </a:ext>
             </a:extLst>
           </p:cNvPr>
@@ -7632,7 +7632,7 @@
           <p:cNvPr id="16" name="">
             <a:extLst xmlns:a="http://schemas.openxmlformats.org/drawingml/2006/main">
               <a:ext uri="{FF2B5EF4-FFF2-40B4-BE49-F238E27FC236}">
-                <a16:creationId xmlns:a16="http://schemas.microsoft.com/office/drawing/2014/main" id="{8841E298-13A2-4D20-818C-302C365A8582}"/>
+                <a16:creationId xmlns:a16="http://schemas.microsoft.com/office/drawing/2014/main" id="{04548AE7-F280-45B0-AEAF-02B2CDD4009B}"/>
               </a:ext>
             </a:extLst>
           </p:cNvPr>
@@ -7663,7 +7663,7 @@
           <p:cNvPr id="17" name="">
             <a:extLst xmlns:a="http://schemas.openxmlformats.org/drawingml/2006/main">
               <a:ext uri="{FF2B5EF4-FFF2-40B4-BE49-F238E27FC236}">
-                <a16:creationId xmlns:a16="http://schemas.microsoft.com/office/drawing/2014/main" id="{FA12342B-75A5-43DB-BA6F-52EBC55568A9}"/>
+                <a16:creationId xmlns:a16="http://schemas.microsoft.com/office/drawing/2014/main" id="{73251A63-5037-42B8-B942-209B3D694AB5}"/>
               </a:ext>
             </a:extLst>
           </p:cNvPr>
@@ -7713,7 +7713,7 @@
           <p:cNvPr id="18" name="">
             <a:extLst xmlns:a="http://schemas.openxmlformats.org/drawingml/2006/main">
               <a:ext uri="{FF2B5EF4-FFF2-40B4-BE49-F238E27FC236}">
-                <a16:creationId xmlns:a16="http://schemas.microsoft.com/office/drawing/2014/main" id="{912F3026-D2EE-4250-A6C5-24B79B0C581B}"/>
+                <a16:creationId xmlns:a16="http://schemas.microsoft.com/office/drawing/2014/main" id="{B884B3DA-0AF3-4DF0-8D37-A580DF6013EC}"/>
               </a:ext>
             </a:extLst>
           </p:cNvPr>
@@ -7744,7 +7744,7 @@
           <p:cNvPr id="19" name="">
             <a:extLst xmlns:a="http://schemas.openxmlformats.org/drawingml/2006/main">
               <a:ext uri="{FF2B5EF4-FFF2-40B4-BE49-F238E27FC236}">
-                <a16:creationId xmlns:a16="http://schemas.microsoft.com/office/drawing/2014/main" id="{D60D05A4-2398-4015-A869-1850AA6F603D}"/>
+                <a16:creationId xmlns:a16="http://schemas.microsoft.com/office/drawing/2014/main" id="{5C48A51C-3423-44D6-8376-5F54CDB7B16A}"/>
               </a:ext>
             </a:extLst>
           </p:cNvPr>
@@ -7794,7 +7794,7 @@
           <p:cNvPr id="20" name="">
             <a:extLst xmlns:a="http://schemas.openxmlformats.org/drawingml/2006/main">
               <a:ext uri="{FF2B5EF4-FFF2-40B4-BE49-F238E27FC236}">
-                <a16:creationId xmlns:a16="http://schemas.microsoft.com/office/drawing/2014/main" id="{4634E881-29F6-422B-8827-871DC61DA85F}"/>
+                <a16:creationId xmlns:a16="http://schemas.microsoft.com/office/drawing/2014/main" id="{E70FCC04-3280-4706-95B8-5279DA7FA25C}"/>
               </a:ext>
             </a:extLst>
           </p:cNvPr>
@@ -7825,7 +7825,7 @@
           <p:cNvPr id="21" name="">
             <a:extLst xmlns:a="http://schemas.openxmlformats.org/drawingml/2006/main">
               <a:ext uri="{FF2B5EF4-FFF2-40B4-BE49-F238E27FC236}">
-                <a16:creationId xmlns:a16="http://schemas.microsoft.com/office/drawing/2014/main" id="{64FEE5A7-A782-4C3F-ABC4-E6C5F595EDFF}"/>
+                <a16:creationId xmlns:a16="http://schemas.microsoft.com/office/drawing/2014/main" id="{66E2AA9C-FE77-4F93-8000-0A21E30611FB}"/>
               </a:ext>
             </a:extLst>
           </p:cNvPr>
@@ -7875,7 +7875,7 @@
           <p:cNvPr id="22" name="">
             <a:extLst xmlns:a="http://schemas.openxmlformats.org/drawingml/2006/main">
               <a:ext uri="{FF2B5EF4-FFF2-40B4-BE49-F238E27FC236}">
-                <a16:creationId xmlns:a16="http://schemas.microsoft.com/office/drawing/2014/main" id="{6C370E1D-A628-4F99-A945-587FD67681A0}"/>
+                <a16:creationId xmlns:a16="http://schemas.microsoft.com/office/drawing/2014/main" id="{A399829D-C853-4AE1-BFB4-B02227E55A5C}"/>
               </a:ext>
             </a:extLst>
           </p:cNvPr>
@@ -7906,7 +7906,7 @@
           <p:cNvPr id="23" name="">
             <a:extLst xmlns:a="http://schemas.openxmlformats.org/drawingml/2006/main">
               <a:ext uri="{FF2B5EF4-FFF2-40B4-BE49-F238E27FC236}">
-                <a16:creationId xmlns:a16="http://schemas.microsoft.com/office/drawing/2014/main" id="{F5820E0B-1992-47BC-BA1B-4E7B39191663}"/>
+                <a16:creationId xmlns:a16="http://schemas.microsoft.com/office/drawing/2014/main" id="{CD5EFDBA-B272-4F09-A19F-8B99277C2039}"/>
               </a:ext>
             </a:extLst>
           </p:cNvPr>
@@ -7954,7 +7954,7 @@
     </p:spTree>
     <p:extLst>
       <p:ext uri="{BB962C8B-B14F-4D97-AF65-F5344CB8AC3E}">
-        <p14:creationId xmlns:p14="http://schemas.microsoft.com/office/powerpoint/2010/main" val="718863267"/>
+        <p14:creationId xmlns:p14="http://schemas.microsoft.com/office/powerpoint/2010/main" val="711652390"/>
       </p:ext>
     </p:extLst>
   </p:cSld>
@@ -7985,7 +7985,7 @@
           <p:cNvPr id="21" name="">
             <a:extLst xmlns:a="http://schemas.openxmlformats.org/drawingml/2006/main">
               <a:ext uri="{FF2B5EF4-FFF2-40B4-BE49-F238E27FC236}">
-                <a16:creationId xmlns:a16="http://schemas.microsoft.com/office/drawing/2014/main" id="{BA3CA1DA-7763-471F-9013-F4369741C0AD}"/>
+                <a16:creationId xmlns:a16="http://schemas.microsoft.com/office/drawing/2014/main" id="{9371343E-AA66-4221-B3B8-1CE3750616F1}"/>
               </a:ext>
             </a:extLst>
           </p:cNvPr>
@@ -8035,7 +8035,7 @@
           <p:cNvPr id="2" name="">
             <a:extLst xmlns:a="http://schemas.openxmlformats.org/drawingml/2006/main">
               <a:ext uri="{FF2B5EF4-FFF2-40B4-BE49-F238E27FC236}">
-                <a16:creationId xmlns:a16="http://schemas.microsoft.com/office/drawing/2014/main" id="{145A6220-81B4-4F9C-8319-5F44EC7C36FB}"/>
+                <a16:creationId xmlns:a16="http://schemas.microsoft.com/office/drawing/2014/main" id="{236C92F1-081A-4BA7-BC62-D360FB5B866F}"/>
               </a:ext>
             </a:extLst>
           </p:cNvPr>
@@ -8085,7 +8085,7 @@
           <p:cNvPr id="3" name="">
             <a:extLst xmlns:a="http://schemas.openxmlformats.org/drawingml/2006/main">
               <a:ext uri="{FF2B5EF4-FFF2-40B4-BE49-F238E27FC236}">
-                <a16:creationId xmlns:a16="http://schemas.microsoft.com/office/drawing/2014/main" id="{B26A2760-025B-4151-8607-228AE2E496AA}"/>
+                <a16:creationId xmlns:a16="http://schemas.microsoft.com/office/drawing/2014/main" id="{BB3F1875-64A9-4700-8E3A-57278238E933}"/>
               </a:ext>
             </a:extLst>
           </p:cNvPr>
@@ -8116,7 +8116,7 @@
           <p:cNvPr id="4" name="">
             <a:extLst xmlns:a="http://schemas.openxmlformats.org/drawingml/2006/main">
               <a:ext uri="{FF2B5EF4-FFF2-40B4-BE49-F238E27FC236}">
-                <a16:creationId xmlns:a16="http://schemas.microsoft.com/office/drawing/2014/main" id="{8CB3D163-8275-48DB-9CCA-8DA181D8C326}"/>
+                <a16:creationId xmlns:a16="http://schemas.microsoft.com/office/drawing/2014/main" id="{17CB3E11-F123-4592-B475-CDCA17A69D50}"/>
               </a:ext>
             </a:extLst>
           </p:cNvPr>
@@ -8166,7 +8166,7 @@
           <p:cNvPr id="5" name="">
             <a:extLst xmlns:a="http://schemas.openxmlformats.org/drawingml/2006/main">
               <a:ext uri="{FF2B5EF4-FFF2-40B4-BE49-F238E27FC236}">
-                <a16:creationId xmlns:a16="http://schemas.microsoft.com/office/drawing/2014/main" id="{A181F38F-567B-4977-A812-F6E1A5655008}"/>
+                <a16:creationId xmlns:a16="http://schemas.microsoft.com/office/drawing/2014/main" id="{93255DE4-0D00-455D-B597-5426FC8191AB}"/>
               </a:ext>
             </a:extLst>
           </p:cNvPr>
@@ -8216,7 +8216,7 @@
           <p:cNvPr id="6" name="">
             <a:extLst xmlns:a="http://schemas.openxmlformats.org/drawingml/2006/main">
               <a:ext uri="{FF2B5EF4-FFF2-40B4-BE49-F238E27FC236}">
-                <a16:creationId xmlns:a16="http://schemas.microsoft.com/office/drawing/2014/main" id="{1D6A0D94-BF10-4898-B53B-EBF82C24E602}"/>
+                <a16:creationId xmlns:a16="http://schemas.microsoft.com/office/drawing/2014/main" id="{5F798788-2A68-4465-B0BA-FA5DCAB05733}"/>
               </a:ext>
             </a:extLst>
           </p:cNvPr>
@@ -8270,7 +8270,7 @@
           <p:cNvPr id="7" name="">
             <a:extLst xmlns:a="http://schemas.openxmlformats.org/drawingml/2006/main">
               <a:ext uri="{FF2B5EF4-FFF2-40B4-BE49-F238E27FC236}">
-                <a16:creationId xmlns:a16="http://schemas.microsoft.com/office/drawing/2014/main" id="{4C707DE9-6315-4072-A8D8-C77037F425FF}"/>
+                <a16:creationId xmlns:a16="http://schemas.microsoft.com/office/drawing/2014/main" id="{A455ECF7-E90C-4B26-8AF0-676322D0160B}"/>
               </a:ext>
             </a:extLst>
           </p:cNvPr>
@@ -8320,7 +8320,7 @@
           <p:cNvPr id="8" name="">
             <a:extLst xmlns:a="http://schemas.openxmlformats.org/drawingml/2006/main">
               <a:ext uri="{FF2B5EF4-FFF2-40B4-BE49-F238E27FC236}">
-                <a16:creationId xmlns:a16="http://schemas.microsoft.com/office/drawing/2014/main" id="{B306839E-B3AF-489A-9327-11F1AD10BFBC}"/>
+                <a16:creationId xmlns:a16="http://schemas.microsoft.com/office/drawing/2014/main" id="{13011794-1A74-42DC-B132-339AAF9AB788}"/>
               </a:ext>
             </a:extLst>
           </p:cNvPr>
@@ -8370,7 +8370,7 @@
           <p:cNvPr id="9" name="">
             <a:extLst xmlns:a="http://schemas.openxmlformats.org/drawingml/2006/main">
               <a:ext uri="{FF2B5EF4-FFF2-40B4-BE49-F238E27FC236}">
-                <a16:creationId xmlns:a16="http://schemas.microsoft.com/office/drawing/2014/main" id="{6F96D775-DDBA-4FA8-A54B-76120F92E019}"/>
+                <a16:creationId xmlns:a16="http://schemas.microsoft.com/office/drawing/2014/main" id="{9E9363C3-B926-4A35-8314-0885C9AF2B26}"/>
               </a:ext>
             </a:extLst>
           </p:cNvPr>
@@ -8424,7 +8424,7 @@
           <p:cNvPr id="10" name="">
             <a:extLst xmlns:a="http://schemas.openxmlformats.org/drawingml/2006/main">
               <a:ext uri="{FF2B5EF4-FFF2-40B4-BE49-F238E27FC236}">
-                <a16:creationId xmlns:a16="http://schemas.microsoft.com/office/drawing/2014/main" id="{A28F480B-077F-4C3B-9A9B-1D9C4FBAEC3F}"/>
+                <a16:creationId xmlns:a16="http://schemas.microsoft.com/office/drawing/2014/main" id="{F0568359-0505-4B97-8FCB-10624085BB45}"/>
               </a:ext>
             </a:extLst>
           </p:cNvPr>
@@ -8474,7 +8474,7 @@
           <p:cNvPr id="11" name="">
             <a:extLst xmlns:a="http://schemas.openxmlformats.org/drawingml/2006/main">
               <a:ext uri="{FF2B5EF4-FFF2-40B4-BE49-F238E27FC236}">
-                <a16:creationId xmlns:a16="http://schemas.microsoft.com/office/drawing/2014/main" id="{4CDD719D-EA9D-4588-9060-93B25E57090F}"/>
+                <a16:creationId xmlns:a16="http://schemas.microsoft.com/office/drawing/2014/main" id="{5AA18CB5-111C-4B89-84A5-5867D36D46E9}"/>
               </a:ext>
             </a:extLst>
           </p:cNvPr>
@@ -8524,7 +8524,7 @@
           <p:cNvPr id="12" name="">
             <a:extLst xmlns:a="http://schemas.openxmlformats.org/drawingml/2006/main">
               <a:ext uri="{FF2B5EF4-FFF2-40B4-BE49-F238E27FC236}">
-                <a16:creationId xmlns:a16="http://schemas.microsoft.com/office/drawing/2014/main" id="{57BBCE3A-D163-4244-B280-C44D2BF06CBA}"/>
+                <a16:creationId xmlns:a16="http://schemas.microsoft.com/office/drawing/2014/main" id="{4AD405F2-2214-42ED-80F7-32DD8EB62606}"/>
               </a:ext>
             </a:extLst>
           </p:cNvPr>
@@ -8578,7 +8578,7 @@
           <p:cNvPr id="13" name="">
             <a:extLst xmlns:a="http://schemas.openxmlformats.org/drawingml/2006/main">
               <a:ext uri="{FF2B5EF4-FFF2-40B4-BE49-F238E27FC236}">
-                <a16:creationId xmlns:a16="http://schemas.microsoft.com/office/drawing/2014/main" id="{E4A2AD4F-F71D-4EDB-B0B5-663A6644ED83}"/>
+                <a16:creationId xmlns:a16="http://schemas.microsoft.com/office/drawing/2014/main" id="{1F3924F8-56F0-4D91-8846-9D0D52223360}"/>
               </a:ext>
             </a:extLst>
           </p:cNvPr>
@@ -8628,7 +8628,7 @@
           <p:cNvPr id="14" name="">
             <a:extLst xmlns:a="http://schemas.openxmlformats.org/drawingml/2006/main">
               <a:ext uri="{FF2B5EF4-FFF2-40B4-BE49-F238E27FC236}">
-                <a16:creationId xmlns:a16="http://schemas.microsoft.com/office/drawing/2014/main" id="{3B53FB89-67AE-4B3C-B53B-0E6772112F20}"/>
+                <a16:creationId xmlns:a16="http://schemas.microsoft.com/office/drawing/2014/main" id="{B0367BAE-36ED-434E-B903-B70152E6AA19}"/>
               </a:ext>
             </a:extLst>
           </p:cNvPr>
@@ -8678,7 +8678,7 @@
           <p:cNvPr id="15" name="">
             <a:extLst xmlns:a="http://schemas.openxmlformats.org/drawingml/2006/main">
               <a:ext uri="{FF2B5EF4-FFF2-40B4-BE49-F238E27FC236}">
-                <a16:creationId xmlns:a16="http://schemas.microsoft.com/office/drawing/2014/main" id="{ED3F6111-4A49-4746-BA92-24985E9DFEAB}"/>
+                <a16:creationId xmlns:a16="http://schemas.microsoft.com/office/drawing/2014/main" id="{05A3B9F4-B2A6-40CA-A946-30BED127878C}"/>
               </a:ext>
             </a:extLst>
           </p:cNvPr>
@@ -8732,7 +8732,7 @@
           <p:cNvPr id="16" name="">
             <a:extLst xmlns:a="http://schemas.openxmlformats.org/drawingml/2006/main">
               <a:ext uri="{FF2B5EF4-FFF2-40B4-BE49-F238E27FC236}">
-                <a16:creationId xmlns:a16="http://schemas.microsoft.com/office/drawing/2014/main" id="{915F20BF-E0E6-4323-B728-E0B810D858FE}"/>
+                <a16:creationId xmlns:a16="http://schemas.microsoft.com/office/drawing/2014/main" id="{0A306119-52C1-4CF5-A303-6BDD368A3D35}"/>
               </a:ext>
             </a:extLst>
           </p:cNvPr>
@@ -8782,7 +8782,7 @@
           <p:cNvPr id="17" name="">
             <a:extLst xmlns:a="http://schemas.openxmlformats.org/drawingml/2006/main">
               <a:ext uri="{FF2B5EF4-FFF2-40B4-BE49-F238E27FC236}">
-                <a16:creationId xmlns:a16="http://schemas.microsoft.com/office/drawing/2014/main" id="{90595D28-005C-4228-9FE8-75BB6781DD0D}"/>
+                <a16:creationId xmlns:a16="http://schemas.microsoft.com/office/drawing/2014/main" id="{26769871-CB5C-4EE0-A7AD-7B05D8C93A07}"/>
               </a:ext>
             </a:extLst>
           </p:cNvPr>
@@ -8832,7 +8832,7 @@
           <p:cNvPr id="18" name="">
             <a:extLst xmlns:a="http://schemas.openxmlformats.org/drawingml/2006/main">
               <a:ext uri="{FF2B5EF4-FFF2-40B4-BE49-F238E27FC236}">
-                <a16:creationId xmlns:a16="http://schemas.microsoft.com/office/drawing/2014/main" id="{536C99C3-42EB-4B86-B69A-4C98E554459E}"/>
+                <a16:creationId xmlns:a16="http://schemas.microsoft.com/office/drawing/2014/main" id="{48054B2D-15AF-4E8F-8CB3-88D8ED4C3DA4}"/>
               </a:ext>
             </a:extLst>
           </p:cNvPr>
@@ -8886,7 +8886,7 @@
           <p:cNvPr id="19" name="">
             <a:extLst xmlns:a="http://schemas.openxmlformats.org/drawingml/2006/main">
               <a:ext uri="{FF2B5EF4-FFF2-40B4-BE49-F238E27FC236}">
-                <a16:creationId xmlns:a16="http://schemas.microsoft.com/office/drawing/2014/main" id="{AADAC61A-9FDE-4AA1-8898-BF6FFA754C2F}"/>
+                <a16:creationId xmlns:a16="http://schemas.microsoft.com/office/drawing/2014/main" id="{9289E95F-EE35-4D07-B01F-DB0E3151D1B3}"/>
               </a:ext>
             </a:extLst>
           </p:cNvPr>
@@ -8936,7 +8936,7 @@
           <p:cNvPr id="20" name="">
             <a:extLst xmlns:a="http://schemas.openxmlformats.org/drawingml/2006/main">
               <a:ext uri="{FF2B5EF4-FFF2-40B4-BE49-F238E27FC236}">
-                <a16:creationId xmlns:a16="http://schemas.microsoft.com/office/drawing/2014/main" id="{10DDD665-CBF6-4FE1-B83C-1A55E7FE8C91}"/>
+                <a16:creationId xmlns:a16="http://schemas.microsoft.com/office/drawing/2014/main" id="{9D9E194A-869A-4EBC-B27B-B83DC30027C1}"/>
               </a:ext>
             </a:extLst>
           </p:cNvPr>
@@ -8984,7 +8984,7 @@
     </p:spTree>
     <p:extLst>
       <p:ext uri="{BB962C8B-B14F-4D97-AF65-F5344CB8AC3E}">
-        <p14:creationId xmlns:p14="http://schemas.microsoft.com/office/powerpoint/2010/main" val="1345924205"/>
+        <p14:creationId xmlns:p14="http://schemas.microsoft.com/office/powerpoint/2010/main" val="1595253320"/>
       </p:ext>
     </p:extLst>
   </p:cSld>
@@ -9012,10 +9012,10 @@
       </p:grpSpPr>
       <p:sp>
         <p:nvSpPr>
-          <p:cNvPr id="15" name="">
-            <a:extLst xmlns:a="http://schemas.openxmlformats.org/drawingml/2006/main">
-              <a:ext uri="{FF2B5EF4-FFF2-40B4-BE49-F238E27FC236}">
-                <a16:creationId xmlns:a16="http://schemas.microsoft.com/office/drawing/2014/main" id="{C9265F72-CEEA-414B-9ECA-B69EA926884A}"/>
+          <p:cNvPr id="21" name="">
+            <a:extLst xmlns:a="http://schemas.openxmlformats.org/drawingml/2006/main">
+              <a:ext uri="{FF2B5EF4-FFF2-40B4-BE49-F238E27FC236}">
+                <a16:creationId xmlns:a16="http://schemas.microsoft.com/office/drawing/2014/main" id="{78AD0888-79BF-4733-B783-B603DA703C20}"/>
               </a:ext>
             </a:extLst>
           </p:cNvPr>
@@ -9065,7 +9065,7 @@
           <p:cNvPr id="2" name="">
             <a:extLst xmlns:a="http://schemas.openxmlformats.org/drawingml/2006/main">
               <a:ext uri="{FF2B5EF4-FFF2-40B4-BE49-F238E27FC236}">
-                <a16:creationId xmlns:a16="http://schemas.microsoft.com/office/drawing/2014/main" id="{37C9C013-0AAF-4F5F-92EB-5F44AA80D2F4}"/>
+                <a16:creationId xmlns:a16="http://schemas.microsoft.com/office/drawing/2014/main" id="{F60D6D7E-B999-43BF-B52E-75C125D47924}"/>
               </a:ext>
             </a:extLst>
           </p:cNvPr>
@@ -9115,7 +9115,7 @@
           <p:cNvPr id="3" name="">
             <a:extLst xmlns:a="http://schemas.openxmlformats.org/drawingml/2006/main">
               <a:ext uri="{FF2B5EF4-FFF2-40B4-BE49-F238E27FC236}">
-                <a16:creationId xmlns:a16="http://schemas.microsoft.com/office/drawing/2014/main" id="{D964ED58-638E-4EB3-96F5-3535F3F2FAD6}"/>
+                <a16:creationId xmlns:a16="http://schemas.microsoft.com/office/drawing/2014/main" id="{B790DCBC-0F09-4451-BC8D-4BDD8E00D40B}"/>
               </a:ext>
             </a:extLst>
           </p:cNvPr>
@@ -9146,7 +9146,7 @@
           <p:cNvPr id="4" name="">
             <a:extLst xmlns:a="http://schemas.openxmlformats.org/drawingml/2006/main">
               <a:ext uri="{FF2B5EF4-FFF2-40B4-BE49-F238E27FC236}">
-                <a16:creationId xmlns:a16="http://schemas.microsoft.com/office/drawing/2014/main" id="{C92627CD-F41A-4348-85A6-A2B5BED40876}"/>
+                <a16:creationId xmlns:a16="http://schemas.microsoft.com/office/drawing/2014/main" id="{A09B0C2E-157E-4457-A78E-A58DB5B0A127}"/>
               </a:ext>
             </a:extLst>
           </p:cNvPr>
@@ -9196,7 +9196,7 @@
           <p:cNvPr id="5" name="">
             <a:extLst xmlns:a="http://schemas.openxmlformats.org/drawingml/2006/main">
               <a:ext uri="{FF2B5EF4-FFF2-40B4-BE49-F238E27FC236}">
-                <a16:creationId xmlns:a16="http://schemas.microsoft.com/office/drawing/2014/main" id="{CB195F58-284C-4E82-B0BF-5AC0856A16A0}"/>
+                <a16:creationId xmlns:a16="http://schemas.microsoft.com/office/drawing/2014/main" id="{7D70778C-6696-4D88-A805-E141AD994DBE}"/>
               </a:ext>
             </a:extLst>
           </p:cNvPr>
@@ -9246,7 +9246,7 @@
           <p:cNvPr id="6" name="">
             <a:extLst xmlns:a="http://schemas.openxmlformats.org/drawingml/2006/main">
               <a:ext uri="{FF2B5EF4-FFF2-40B4-BE49-F238E27FC236}">
-                <a16:creationId xmlns:a16="http://schemas.microsoft.com/office/drawing/2014/main" id="{F9096119-CE46-466C-B393-313DB0951203}"/>
+                <a16:creationId xmlns:a16="http://schemas.microsoft.com/office/drawing/2014/main" id="{C0EC8F47-F2ED-4294-AAC0-ACC10B0AA5DF}"/>
               </a:ext>
             </a:extLst>
           </p:cNvPr>
@@ -9296,23 +9296,108 @@
           <p:cNvPr id="7" name="">
             <a:extLst xmlns:a="http://schemas.openxmlformats.org/drawingml/2006/main">
               <a:ext uri="{FF2B5EF4-FFF2-40B4-BE49-F238E27FC236}">
-                <a16:creationId xmlns:a16="http://schemas.microsoft.com/office/drawing/2014/main" id="{90D3332D-E419-4A85-9BDA-746F92B128FA}"/>
-              </a:ext>
-            </a:extLst>
-          </p:cNvPr>
-          <p:cNvSpPr>
-            <a:spLocks xmlns:a="http://schemas.openxmlformats.org/drawingml/2006/main" noGrp="1"/>
-          </p:cNvSpPr>
-          <p:nvPr/>
-        </p:nvSpPr>
-        <p:spPr>
-          <a:xfrm xmlns:a="http://schemas.openxmlformats.org/drawingml/2006/main">
-            <a:off x="1352550" y="2895600"/>
-            <a:ext cx="2190750" cy="914400"/>
+                <a16:creationId xmlns:a16="http://schemas.microsoft.com/office/drawing/2014/main" id="{737FB207-30B6-4851-A877-151D3DE890E8}"/>
+              </a:ext>
+            </a:extLst>
+          </p:cNvPr>
+          <p:cNvSpPr>
+            <a:spLocks xmlns:a="http://schemas.openxmlformats.org/drawingml/2006/main" noGrp="1"/>
+          </p:cNvSpPr>
+          <p:nvPr/>
+        </p:nvSpPr>
+        <p:spPr>
+          <a:xfrm xmlns:a="http://schemas.openxmlformats.org/drawingml/2006/main">
+            <a:off x="1123950" y="2781300"/>
+            <a:ext cx="1428750" cy="514350"/>
           </a:xfrm>
           <a:prstGeom xmlns:a="http://schemas.openxmlformats.org/drawingml/2006/main" prst="roundRect">
             <a:avLst>
-              <a:gd name="adj" fmla="val 8333"/>
+              <a:gd name="adj" fmla="val 14815"/>
+            </a:avLst>
+          </a:prstGeom>
+          <a:solidFill xmlns:a="http://schemas.openxmlformats.org/drawingml/2006/main">
+            <a:srgbClr val="5D6B78"/>
+          </a:solidFill>
+          <a:ln xmlns:a="http://schemas.openxmlformats.org/drawingml/2006/main" w="0">
+            <a:noFill/>
+            <a:prstDash val="solid"/>
+          </a:ln>
+        </p:spPr>
+        <p:txBody>
+          <a:bodyPr xmlns:a="http://schemas.openxmlformats.org/drawingml/2006/main"/>
+          <a:lstStyle xmlns:a="http://schemas.openxmlformats.org/drawingml/2006/main"/>
+          <a:p xmlns:a="http://schemas.openxmlformats.org/drawingml/2006/main">
+            <a:pPr algn="ctr">
+              <a:defRPr sz="1275" b="1">
+                <a:solidFill>
+                  <a:srgbClr val="FFFFFF"/>
+                </a:solidFill>
+              </a:defRPr>
+            </a:pPr>
+            <a:r>
+              <a:rPr sz="1275" b="1">
+                <a:solidFill>
+                  <a:srgbClr val="FFFFFF"/>
+                </a:solidFill>
+              </a:rPr>
+              <a:t>all documents</a:t>
+            </a:r>
+          </a:p>
+        </p:txBody>
+      </p:sp>
+      <p:sp>
+        <p:nvSpPr>
+          <p:cNvPr id="8" name="">
+            <a:extLst xmlns:a="http://schemas.openxmlformats.org/drawingml/2006/main">
+              <a:ext uri="{FF2B5EF4-FFF2-40B4-BE49-F238E27FC236}">
+                <a16:creationId xmlns:a16="http://schemas.microsoft.com/office/drawing/2014/main" id="{5C74C108-CF59-465F-9118-F84C271B29B4}"/>
+              </a:ext>
+            </a:extLst>
+          </p:cNvPr>
+          <p:cNvSpPr>
+            <a:spLocks xmlns:a="http://schemas.openxmlformats.org/drawingml/2006/main" noGrp="1"/>
+          </p:cNvSpPr>
+          <p:nvPr/>
+        </p:nvSpPr>
+        <p:spPr>
+          <a:xfrm xmlns:a="http://schemas.openxmlformats.org/drawingml/2006/main">
+            <a:off x="2781300" y="2905125"/>
+            <a:ext cx="533400" cy="266700"/>
+          </a:xfrm>
+          <a:prstGeom xmlns:a="http://schemas.openxmlformats.org/drawingml/2006/main" prst="rightArrow">
+            <a:avLst/>
+          </a:prstGeom>
+          <a:solidFill xmlns:a="http://schemas.openxmlformats.org/drawingml/2006/main">
+            <a:srgbClr val="C2413A"/>
+          </a:solidFill>
+          <a:ln xmlns:a="http://schemas.openxmlformats.org/drawingml/2006/main" w="0">
+            <a:noFill/>
+            <a:prstDash val="solid"/>
+          </a:ln>
+        </p:spPr>
+      </p:sp>
+      <p:sp>
+        <p:nvSpPr>
+          <p:cNvPr id="9" name="">
+            <a:extLst xmlns:a="http://schemas.openxmlformats.org/drawingml/2006/main">
+              <a:ext uri="{FF2B5EF4-FFF2-40B4-BE49-F238E27FC236}">
+                <a16:creationId xmlns:a16="http://schemas.microsoft.com/office/drawing/2014/main" id="{E124E673-5FC2-492B-B790-7EDF500788D1}"/>
+              </a:ext>
+            </a:extLst>
+          </p:cNvPr>
+          <p:cNvSpPr>
+            <a:spLocks xmlns:a="http://schemas.openxmlformats.org/drawingml/2006/main" noGrp="1"/>
+          </p:cNvSpPr>
+          <p:nvPr/>
+        </p:nvSpPr>
+        <p:spPr>
+          <a:xfrm xmlns:a="http://schemas.openxmlformats.org/drawingml/2006/main">
+            <a:off x="3600450" y="2628900"/>
+            <a:ext cx="2000250" cy="819150"/>
+          </a:xfrm>
+          <a:prstGeom xmlns:a="http://schemas.openxmlformats.org/drawingml/2006/main" prst="roundRect">
+            <a:avLst>
+              <a:gd name="adj" fmla="val 9302"/>
             </a:avLst>
           </a:prstGeom>
           <a:solidFill xmlns:a="http://schemas.openxmlformats.org/drawingml/2006/main">
@@ -9328,14 +9413,14 @@
           <a:lstStyle xmlns:a="http://schemas.openxmlformats.org/drawingml/2006/main"/>
           <a:p xmlns:a="http://schemas.openxmlformats.org/drawingml/2006/main">
             <a:pPr algn="ctr">
-              <a:defRPr sz="1425" b="1">
+              <a:defRPr sz="1350" b="1">
                 <a:solidFill>
                   <a:srgbClr val="FFFFFF"/>
                 </a:solidFill>
               </a:defRPr>
             </a:pPr>
             <a:r>
-              <a:rPr sz="1425" b="1">
+              <a:rPr sz="1350" b="1">
                 <a:solidFill>
                   <a:srgbClr val="FFFFFF"/>
                 </a:solidFill>
@@ -9345,14 +9430,14 @@
           </a:p>
           <a:p xmlns:a="http://schemas.openxmlformats.org/drawingml/2006/main">
             <a:pPr algn="ctr">
-              <a:defRPr sz="1425" b="1">
+              <a:defRPr sz="1350" b="1">
                 <a:solidFill>
                   <a:srgbClr val="FFFFFF"/>
                 </a:solidFill>
               </a:defRPr>
             </a:pPr>
             <a:r>
-              <a:rPr sz="1425" b="1">
+              <a:rPr sz="1350" b="1">
                 <a:solidFill>
                   <a:srgbClr val="FFFFFF"/>
                 </a:solidFill>
@@ -9364,126 +9449,22 @@
       </p:sp>
       <p:sp>
         <p:nvSpPr>
-          <p:cNvPr id="8" name="">
-            <a:extLst xmlns:a="http://schemas.openxmlformats.org/drawingml/2006/main">
-              <a:ext uri="{FF2B5EF4-FFF2-40B4-BE49-F238E27FC236}">
-                <a16:creationId xmlns:a16="http://schemas.microsoft.com/office/drawing/2014/main" id="{5C832BED-0AD2-4AB2-ACE1-2621129048DA}"/>
-              </a:ext>
-            </a:extLst>
-          </p:cNvPr>
-          <p:cNvSpPr>
-            <a:spLocks xmlns:a="http://schemas.openxmlformats.org/drawingml/2006/main" noGrp="1"/>
-          </p:cNvSpPr>
-          <p:nvPr/>
-        </p:nvSpPr>
-        <p:spPr>
-          <a:xfrm xmlns:a="http://schemas.openxmlformats.org/drawingml/2006/main">
-            <a:off x="1123950" y="4514850"/>
-            <a:ext cx="2667000" cy="495300"/>
-          </a:xfrm>
-          <a:prstGeom xmlns:a="http://schemas.openxmlformats.org/drawingml/2006/main" prst="roundRect">
-            <a:avLst>
-              <a:gd name="adj" fmla="val 15385"/>
-            </a:avLst>
-          </a:prstGeom>
-          <a:solidFill xmlns:a="http://schemas.openxmlformats.org/drawingml/2006/main">
-            <a:srgbClr val="C2413A"/>
-          </a:solidFill>
-          <a:ln xmlns:a="http://schemas.openxmlformats.org/drawingml/2006/main" w="0">
-            <a:noFill/>
-            <a:prstDash val="solid"/>
-          </a:ln>
-        </p:spPr>
-        <p:txBody>
-          <a:bodyPr xmlns:a="http://schemas.openxmlformats.org/drawingml/2006/main"/>
-          <a:lstStyle xmlns:a="http://schemas.openxmlformats.org/drawingml/2006/main"/>
-          <a:p xmlns:a="http://schemas.openxmlformats.org/drawingml/2006/main">
-            <a:pPr algn="ctr">
-              <a:defRPr sz="1275" b="1">
-                <a:solidFill>
-                  <a:srgbClr val="FFFFFF"/>
-                </a:solidFill>
-              </a:defRPr>
-            </a:pPr>
-            <a:r>
-              <a:rPr sz="1275" b="1">
-                <a:solidFill>
-                  <a:srgbClr val="FFFFFF"/>
-                </a:solidFill>
-              </a:rPr>
-              <a:t>bottleneck / single failure point</a:t>
-            </a:r>
-          </a:p>
-        </p:txBody>
-      </p:sp>
-      <p:sp>
-        <p:nvSpPr>
-          <p:cNvPr id="9" name="">
-            <a:extLst xmlns:a="http://schemas.openxmlformats.org/drawingml/2006/main">
-              <a:ext uri="{FF2B5EF4-FFF2-40B4-BE49-F238E27FC236}">
-                <a16:creationId xmlns:a16="http://schemas.microsoft.com/office/drawing/2014/main" id="{46C1169A-B8F5-48FA-9C73-51821C615E74}"/>
-              </a:ext>
-            </a:extLst>
-          </p:cNvPr>
-          <p:cNvSpPr>
-            <a:spLocks xmlns:a="http://schemas.openxmlformats.org/drawingml/2006/main" noGrp="1"/>
-          </p:cNvSpPr>
-          <p:nvPr/>
-        </p:nvSpPr>
-        <p:spPr>
-          <a:xfrm xmlns:a="http://schemas.openxmlformats.org/drawingml/2006/main">
-            <a:off x="7067550" y="2000250"/>
-            <a:ext cx="2857500" cy="304800"/>
-          </a:xfrm>
-          <a:prstGeom xmlns:a="http://schemas.openxmlformats.org/drawingml/2006/main" prst="rect">
-            <a:avLst/>
-          </a:prstGeom>
-          <a:noFill xmlns:a="http://schemas.openxmlformats.org/drawingml/2006/main"/>
-          <a:ln xmlns:a="http://schemas.openxmlformats.org/drawingml/2006/main" w="0">
-            <a:noFill/>
-            <a:prstDash val="solid"/>
-          </a:ln>
-        </p:spPr>
-        <p:txBody>
-          <a:bodyPr xmlns:a="http://schemas.openxmlformats.org/drawingml/2006/main"/>
-          <a:lstStyle xmlns:a="http://schemas.openxmlformats.org/drawingml/2006/main"/>
-          <a:p xmlns:a="http://schemas.openxmlformats.org/drawingml/2006/main">
-            <a:pPr algn="l">
-              <a:defRPr sz="1875" b="1">
-                <a:solidFill>
-                  <a:srgbClr val="102A43"/>
-                </a:solidFill>
-              </a:defRPr>
-            </a:pPr>
-            <a:r>
-              <a:rPr sz="1875" b="1">
-                <a:solidFill>
-                  <a:srgbClr val="102A43"/>
-                </a:solidFill>
-              </a:rPr>
-              <a:t>Distributed search</a:t>
-            </a:r>
-          </a:p>
-        </p:txBody>
-      </p:sp>
-      <p:sp>
-        <p:nvSpPr>
           <p:cNvPr id="10" name="">
             <a:extLst xmlns:a="http://schemas.openxmlformats.org/drawingml/2006/main">
               <a:ext uri="{FF2B5EF4-FFF2-40B4-BE49-F238E27FC236}">
-                <a16:creationId xmlns:a16="http://schemas.microsoft.com/office/drawing/2014/main" id="{F2095A4D-B90E-4EDF-BFF0-6FEDDEEF6A70}"/>
-              </a:ext>
-            </a:extLst>
-          </p:cNvPr>
-          <p:cNvSpPr>
-            <a:spLocks xmlns:a="http://schemas.openxmlformats.org/drawingml/2006/main" noGrp="1"/>
-          </p:cNvSpPr>
-          <p:nvPr/>
-        </p:nvSpPr>
-        <p:spPr>
-          <a:xfrm xmlns:a="http://schemas.openxmlformats.org/drawingml/2006/main">
-            <a:off x="8420100" y="2724150"/>
-            <a:ext cx="1619250" cy="533400"/>
+                <a16:creationId xmlns:a16="http://schemas.microsoft.com/office/drawing/2014/main" id="{A7A1AC0B-2348-45E5-964F-985CEF1977D1}"/>
+              </a:ext>
+            </a:extLst>
+          </p:cNvPr>
+          <p:cNvSpPr>
+            <a:spLocks xmlns:a="http://schemas.openxmlformats.org/drawingml/2006/main" noGrp="1"/>
+          </p:cNvSpPr>
+          <p:nvPr/>
+        </p:nvSpPr>
+        <p:spPr>
+          <a:xfrm xmlns:a="http://schemas.openxmlformats.org/drawingml/2006/main">
+            <a:off x="1714500" y="4343400"/>
+            <a:ext cx="2857500" cy="533400"/>
           </a:xfrm>
           <a:prstGeom xmlns:a="http://schemas.openxmlformats.org/drawingml/2006/main" prst="roundRect">
             <a:avLst>
@@ -9491,6 +9472,160 @@
             </a:avLst>
           </a:prstGeom>
           <a:solidFill xmlns:a="http://schemas.openxmlformats.org/drawingml/2006/main">
+            <a:srgbClr val="C2413A"/>
+          </a:solidFill>
+          <a:ln xmlns:a="http://schemas.openxmlformats.org/drawingml/2006/main" w="0">
+            <a:noFill/>
+            <a:prstDash val="solid"/>
+          </a:ln>
+        </p:spPr>
+        <p:txBody>
+          <a:bodyPr xmlns:a="http://schemas.openxmlformats.org/drawingml/2006/main"/>
+          <a:lstStyle xmlns:a="http://schemas.openxmlformats.org/drawingml/2006/main"/>
+          <a:p xmlns:a="http://schemas.openxmlformats.org/drawingml/2006/main">
+            <a:pPr algn="ctr">
+              <a:defRPr sz="1275" b="1">
+                <a:solidFill>
+                  <a:srgbClr val="FFFFFF"/>
+                </a:solidFill>
+              </a:defRPr>
+            </a:pPr>
+            <a:r>
+              <a:rPr sz="1275" b="1">
+                <a:solidFill>
+                  <a:srgbClr val="FFFFFF"/>
+                </a:solidFill>
+              </a:rPr>
+              <a:t>bottleneck / single failure point</a:t>
+            </a:r>
+          </a:p>
+        </p:txBody>
+      </p:sp>
+      <p:sp>
+        <p:nvSpPr>
+          <p:cNvPr id="11" name="">
+            <a:extLst xmlns:a="http://schemas.openxmlformats.org/drawingml/2006/main">
+              <a:ext uri="{FF2B5EF4-FFF2-40B4-BE49-F238E27FC236}">
+                <a16:creationId xmlns:a16="http://schemas.microsoft.com/office/drawing/2014/main" id="{1D48DB77-6F27-434E-8D3D-FCE52EC5EEE9}"/>
+              </a:ext>
+            </a:extLst>
+          </p:cNvPr>
+          <p:cNvSpPr>
+            <a:spLocks xmlns:a="http://schemas.openxmlformats.org/drawingml/2006/main" noGrp="1"/>
+          </p:cNvSpPr>
+          <p:nvPr/>
+        </p:nvSpPr>
+        <p:spPr>
+          <a:xfrm xmlns:a="http://schemas.openxmlformats.org/drawingml/2006/main">
+            <a:off x="1485900" y="5105400"/>
+            <a:ext cx="3429000" cy="323850"/>
+          </a:xfrm>
+          <a:prstGeom xmlns:a="http://schemas.openxmlformats.org/drawingml/2006/main" prst="rect">
+            <a:avLst/>
+          </a:prstGeom>
+          <a:noFill xmlns:a="http://schemas.openxmlformats.org/drawingml/2006/main"/>
+          <a:ln xmlns:a="http://schemas.openxmlformats.org/drawingml/2006/main" w="0">
+            <a:noFill/>
+            <a:prstDash val="solid"/>
+          </a:ln>
+        </p:spPr>
+        <p:txBody>
+          <a:bodyPr xmlns:a="http://schemas.openxmlformats.org/drawingml/2006/main"/>
+          <a:lstStyle xmlns:a="http://schemas.openxmlformats.org/drawingml/2006/main"/>
+          <a:p xmlns:a="http://schemas.openxmlformats.org/drawingml/2006/main">
+            <a:pPr algn="ctr">
+              <a:defRPr sz="1350" b="0">
+                <a:solidFill>
+                  <a:srgbClr val="5D6B78"/>
+                </a:solidFill>
+              </a:defRPr>
+            </a:pPr>
+            <a:r>
+              <a:rPr sz="1350" b="0">
+                <a:solidFill>
+                  <a:srgbClr val="5D6B78"/>
+                </a:solidFill>
+              </a:rPr>
+              <a:t>one machine handles indexing and queries</a:t>
+            </a:r>
+          </a:p>
+        </p:txBody>
+      </p:sp>
+      <p:sp>
+        <p:nvSpPr>
+          <p:cNvPr id="12" name="">
+            <a:extLst xmlns:a="http://schemas.openxmlformats.org/drawingml/2006/main">
+              <a:ext uri="{FF2B5EF4-FFF2-40B4-BE49-F238E27FC236}">
+                <a16:creationId xmlns:a16="http://schemas.microsoft.com/office/drawing/2014/main" id="{011FFFFD-3699-4C2D-A56D-770F2FE8EA71}"/>
+              </a:ext>
+            </a:extLst>
+          </p:cNvPr>
+          <p:cNvSpPr>
+            <a:spLocks xmlns:a="http://schemas.openxmlformats.org/drawingml/2006/main" noGrp="1"/>
+          </p:cNvSpPr>
+          <p:nvPr/>
+        </p:nvSpPr>
+        <p:spPr>
+          <a:xfrm xmlns:a="http://schemas.openxmlformats.org/drawingml/2006/main">
+            <a:off x="7067550" y="2000250"/>
+            <a:ext cx="2857500" cy="304800"/>
+          </a:xfrm>
+          <a:prstGeom xmlns:a="http://schemas.openxmlformats.org/drawingml/2006/main" prst="rect">
+            <a:avLst/>
+          </a:prstGeom>
+          <a:noFill xmlns:a="http://schemas.openxmlformats.org/drawingml/2006/main"/>
+          <a:ln xmlns:a="http://schemas.openxmlformats.org/drawingml/2006/main" w="0">
+            <a:noFill/>
+            <a:prstDash val="solid"/>
+          </a:ln>
+        </p:spPr>
+        <p:txBody>
+          <a:bodyPr xmlns:a="http://schemas.openxmlformats.org/drawingml/2006/main"/>
+          <a:lstStyle xmlns:a="http://schemas.openxmlformats.org/drawingml/2006/main"/>
+          <a:p xmlns:a="http://schemas.openxmlformats.org/drawingml/2006/main">
+            <a:pPr algn="l">
+              <a:defRPr sz="1875" b="1">
+                <a:solidFill>
+                  <a:srgbClr val="102A43"/>
+                </a:solidFill>
+              </a:defRPr>
+            </a:pPr>
+            <a:r>
+              <a:rPr sz="1875" b="1">
+                <a:solidFill>
+                  <a:srgbClr val="102A43"/>
+                </a:solidFill>
+              </a:rPr>
+              <a:t>Distributed search</a:t>
+            </a:r>
+          </a:p>
+        </p:txBody>
+      </p:sp>
+      <p:sp>
+        <p:nvSpPr>
+          <p:cNvPr id="13" name="">
+            <a:extLst xmlns:a="http://schemas.openxmlformats.org/drawingml/2006/main">
+              <a:ext uri="{FF2B5EF4-FFF2-40B4-BE49-F238E27FC236}">
+                <a16:creationId xmlns:a16="http://schemas.microsoft.com/office/drawing/2014/main" id="{3AA13146-1335-45F0-82D3-6F8615A66FAE}"/>
+              </a:ext>
+            </a:extLst>
+          </p:cNvPr>
+          <p:cNvSpPr>
+            <a:spLocks xmlns:a="http://schemas.openxmlformats.org/drawingml/2006/main" noGrp="1"/>
+          </p:cNvSpPr>
+          <p:nvPr/>
+        </p:nvSpPr>
+        <p:spPr>
+          <a:xfrm xmlns:a="http://schemas.openxmlformats.org/drawingml/2006/main">
+            <a:off x="6762750" y="3219450"/>
+            <a:ext cx="1619250" cy="552450"/>
+          </a:xfrm>
+          <a:prstGeom xmlns:a="http://schemas.openxmlformats.org/drawingml/2006/main" prst="roundRect">
+            <a:avLst>
+              <a:gd name="adj" fmla="val 13793"/>
+            </a:avLst>
+          </a:prstGeom>
+          <a:solidFill xmlns:a="http://schemas.openxmlformats.org/drawingml/2006/main">
             <a:srgbClr val="102A43"/>
           </a:solidFill>
           <a:ln xmlns:a="http://schemas.openxmlformats.org/drawingml/2006/main" w="0">
@@ -9522,26 +9657,107 @@
       </p:sp>
       <p:sp>
         <p:nvSpPr>
-          <p:cNvPr id="11" name="">
-            <a:extLst xmlns:a="http://schemas.openxmlformats.org/drawingml/2006/main">
-              <a:ext uri="{FF2B5EF4-FFF2-40B4-BE49-F238E27FC236}">
-                <a16:creationId xmlns:a16="http://schemas.microsoft.com/office/drawing/2014/main" id="{F83DE384-A2ED-4DBF-8C48-304FC5AA9E3C}"/>
-              </a:ext>
-            </a:extLst>
-          </p:cNvPr>
-          <p:cNvSpPr>
-            <a:spLocks xmlns:a="http://schemas.openxmlformats.org/drawingml/2006/main" noGrp="1"/>
-          </p:cNvSpPr>
-          <p:nvPr/>
-        </p:nvSpPr>
-        <p:spPr>
-          <a:xfrm xmlns:a="http://schemas.openxmlformats.org/drawingml/2006/main">
-            <a:off x="6667500" y="4171950"/>
-            <a:ext cx="1257300" cy="495300"/>
+          <p:cNvPr id="14" name="">
+            <a:extLst xmlns:a="http://schemas.openxmlformats.org/drawingml/2006/main">
+              <a:ext uri="{FF2B5EF4-FFF2-40B4-BE49-F238E27FC236}">
+                <a16:creationId xmlns:a16="http://schemas.microsoft.com/office/drawing/2014/main" id="{ABA22349-832D-49C8-ADB2-FAFB01E794E1}"/>
+              </a:ext>
+            </a:extLst>
+          </p:cNvPr>
+          <p:cNvSpPr>
+            <a:spLocks xmlns:a="http://schemas.openxmlformats.org/drawingml/2006/main" noGrp="1"/>
+          </p:cNvSpPr>
+          <p:nvPr/>
+        </p:nvSpPr>
+        <p:spPr>
+          <a:xfrm xmlns:a="http://schemas.openxmlformats.org/drawingml/2006/main">
+            <a:off x="8686800" y="2971800"/>
+            <a:ext cx="1143000" cy="247650"/>
+          </a:xfrm>
+          <a:prstGeom xmlns:a="http://schemas.openxmlformats.org/drawingml/2006/main" prst="rect">
+            <a:avLst/>
+          </a:prstGeom>
+          <a:noFill xmlns:a="http://schemas.openxmlformats.org/drawingml/2006/main"/>
+          <a:ln xmlns:a="http://schemas.openxmlformats.org/drawingml/2006/main" w="0">
+            <a:noFill/>
+            <a:prstDash val="solid"/>
+          </a:ln>
+        </p:spPr>
+        <p:txBody>
+          <a:bodyPr xmlns:a="http://schemas.openxmlformats.org/drawingml/2006/main"/>
+          <a:lstStyle xmlns:a="http://schemas.openxmlformats.org/drawingml/2006/main"/>
+          <a:p xmlns:a="http://schemas.openxmlformats.org/drawingml/2006/main">
+            <a:pPr algn="ctr">
+              <a:defRPr sz="1200" b="1">
+                <a:solidFill>
+                  <a:srgbClr val="102A43"/>
+                </a:solidFill>
+              </a:defRPr>
+            </a:pPr>
+            <a:r>
+              <a:rPr sz="1200" b="1">
+                <a:solidFill>
+                  <a:srgbClr val="102A43"/>
+                </a:solidFill>
+              </a:rPr>
+              <a:t>fan-out query</a:t>
+            </a:r>
+          </a:p>
+        </p:txBody>
+      </p:sp>
+      <p:sp>
+        <p:nvSpPr>
+          <p:cNvPr id="15" name="">
+            <a:extLst xmlns:a="http://schemas.openxmlformats.org/drawingml/2006/main">
+              <a:ext uri="{FF2B5EF4-FFF2-40B4-BE49-F238E27FC236}">
+                <a16:creationId xmlns:a16="http://schemas.microsoft.com/office/drawing/2014/main" id="{8D706D56-5D74-461C-A871-779DC3348444}"/>
+              </a:ext>
+            </a:extLst>
+          </p:cNvPr>
+          <p:cNvSpPr>
+            <a:spLocks xmlns:a="http://schemas.openxmlformats.org/drawingml/2006/main" noGrp="1"/>
+          </p:cNvSpPr>
+          <p:nvPr/>
+        </p:nvSpPr>
+        <p:spPr>
+          <a:xfrm xmlns:a="http://schemas.openxmlformats.org/drawingml/2006/main">
+            <a:off x="8705850" y="3352800"/>
+            <a:ext cx="628650" cy="285750"/>
+          </a:xfrm>
+          <a:prstGeom xmlns:a="http://schemas.openxmlformats.org/drawingml/2006/main" prst="rightArrow">
+            <a:avLst/>
+          </a:prstGeom>
+          <a:solidFill xmlns:a="http://schemas.openxmlformats.org/drawingml/2006/main">
+            <a:srgbClr val="102A43"/>
+          </a:solidFill>
+          <a:ln xmlns:a="http://schemas.openxmlformats.org/drawingml/2006/main" w="0">
+            <a:noFill/>
+            <a:prstDash val="solid"/>
+          </a:ln>
+        </p:spPr>
+      </p:sp>
+      <p:sp>
+        <p:nvSpPr>
+          <p:cNvPr id="16" name="">
+            <a:extLst xmlns:a="http://schemas.openxmlformats.org/drawingml/2006/main">
+              <a:ext uri="{FF2B5EF4-FFF2-40B4-BE49-F238E27FC236}">
+                <a16:creationId xmlns:a16="http://schemas.microsoft.com/office/drawing/2014/main" id="{E1D586AA-1704-4EE2-B390-134BE62887A1}"/>
+              </a:ext>
+            </a:extLst>
+          </p:cNvPr>
+          <p:cNvSpPr>
+            <a:spLocks xmlns:a="http://schemas.openxmlformats.org/drawingml/2006/main" noGrp="1"/>
+          </p:cNvSpPr>
+          <p:nvPr/>
+        </p:nvSpPr>
+        <p:spPr>
+          <a:xfrm xmlns:a="http://schemas.openxmlformats.org/drawingml/2006/main">
+            <a:off x="9753600" y="2628900"/>
+            <a:ext cx="1314450" cy="476250"/>
           </a:xfrm>
           <a:prstGeom xmlns:a="http://schemas.openxmlformats.org/drawingml/2006/main" prst="roundRect">
             <a:avLst>
-              <a:gd name="adj" fmla="val 15385"/>
+              <a:gd name="adj" fmla="val 16000"/>
             </a:avLst>
           </a:prstGeom>
           <a:solidFill xmlns:a="http://schemas.openxmlformats.org/drawingml/2006/main">
@@ -9576,26 +9792,26 @@
       </p:sp>
       <p:sp>
         <p:nvSpPr>
-          <p:cNvPr id="12" name="">
-            <a:extLst xmlns:a="http://schemas.openxmlformats.org/drawingml/2006/main">
-              <a:ext uri="{FF2B5EF4-FFF2-40B4-BE49-F238E27FC236}">
-                <a16:creationId xmlns:a16="http://schemas.microsoft.com/office/drawing/2014/main" id="{9739AFFA-A368-41D1-9C8A-F56C0D63D6CC}"/>
-              </a:ext>
-            </a:extLst>
-          </p:cNvPr>
-          <p:cNvSpPr>
-            <a:spLocks xmlns:a="http://schemas.openxmlformats.org/drawingml/2006/main" noGrp="1"/>
-          </p:cNvSpPr>
-          <p:nvPr/>
-        </p:nvSpPr>
-        <p:spPr>
-          <a:xfrm xmlns:a="http://schemas.openxmlformats.org/drawingml/2006/main">
-            <a:off x="8591550" y="4171950"/>
-            <a:ext cx="1257300" cy="495300"/>
+          <p:cNvPr id="17" name="">
+            <a:extLst xmlns:a="http://schemas.openxmlformats.org/drawingml/2006/main">
+              <a:ext uri="{FF2B5EF4-FFF2-40B4-BE49-F238E27FC236}">
+                <a16:creationId xmlns:a16="http://schemas.microsoft.com/office/drawing/2014/main" id="{0CA9E2A8-4729-4CD1-96F3-B6C6908127A9}"/>
+              </a:ext>
+            </a:extLst>
+          </p:cNvPr>
+          <p:cNvSpPr>
+            <a:spLocks xmlns:a="http://schemas.openxmlformats.org/drawingml/2006/main" noGrp="1"/>
+          </p:cNvSpPr>
+          <p:nvPr/>
+        </p:nvSpPr>
+        <p:spPr>
+          <a:xfrm xmlns:a="http://schemas.openxmlformats.org/drawingml/2006/main">
+            <a:off x="9753600" y="3371850"/>
+            <a:ext cx="1314450" cy="476250"/>
           </a:xfrm>
           <a:prstGeom xmlns:a="http://schemas.openxmlformats.org/drawingml/2006/main" prst="roundRect">
             <a:avLst>
-              <a:gd name="adj" fmla="val 15385"/>
+              <a:gd name="adj" fmla="val 16000"/>
             </a:avLst>
           </a:prstGeom>
           <a:solidFill xmlns:a="http://schemas.openxmlformats.org/drawingml/2006/main">
@@ -9630,26 +9846,26 @@
       </p:sp>
       <p:sp>
         <p:nvSpPr>
-          <p:cNvPr id="13" name="">
-            <a:extLst xmlns:a="http://schemas.openxmlformats.org/drawingml/2006/main">
-              <a:ext uri="{FF2B5EF4-FFF2-40B4-BE49-F238E27FC236}">
-                <a16:creationId xmlns:a16="http://schemas.microsoft.com/office/drawing/2014/main" id="{992BDB9D-AD00-467B-AC7C-817DAC956493}"/>
-              </a:ext>
-            </a:extLst>
-          </p:cNvPr>
-          <p:cNvSpPr>
-            <a:spLocks xmlns:a="http://schemas.openxmlformats.org/drawingml/2006/main" noGrp="1"/>
-          </p:cNvSpPr>
-          <p:nvPr/>
-        </p:nvSpPr>
-        <p:spPr>
-          <a:xfrm xmlns:a="http://schemas.openxmlformats.org/drawingml/2006/main">
-            <a:off x="10515600" y="4171950"/>
-            <a:ext cx="1257300" cy="495300"/>
+          <p:cNvPr id="18" name="">
+            <a:extLst xmlns:a="http://schemas.openxmlformats.org/drawingml/2006/main">
+              <a:ext uri="{FF2B5EF4-FFF2-40B4-BE49-F238E27FC236}">
+                <a16:creationId xmlns:a16="http://schemas.microsoft.com/office/drawing/2014/main" id="{B4139F25-2C7B-466E-9AB0-CAC5530EAE09}"/>
+              </a:ext>
+            </a:extLst>
+          </p:cNvPr>
+          <p:cNvSpPr>
+            <a:spLocks xmlns:a="http://schemas.openxmlformats.org/drawingml/2006/main" noGrp="1"/>
+          </p:cNvSpPr>
+          <p:nvPr/>
+        </p:nvSpPr>
+        <p:spPr>
+          <a:xfrm xmlns:a="http://schemas.openxmlformats.org/drawingml/2006/main">
+            <a:off x="9753600" y="4114800"/>
+            <a:ext cx="1314450" cy="476250"/>
           </a:xfrm>
           <a:prstGeom xmlns:a="http://schemas.openxmlformats.org/drawingml/2006/main" prst="roundRect">
             <a:avLst>
-              <a:gd name="adj" fmla="val 15385"/>
+              <a:gd name="adj" fmla="val 16000"/>
             </a:avLst>
           </a:prstGeom>
           <a:solidFill xmlns:a="http://schemas.openxmlformats.org/drawingml/2006/main">
@@ -9684,21 +9900,71 @@
       </p:sp>
       <p:sp>
         <p:nvSpPr>
-          <p:cNvPr id="14" name="">
-            <a:extLst xmlns:a="http://schemas.openxmlformats.org/drawingml/2006/main">
-              <a:ext uri="{FF2B5EF4-FFF2-40B4-BE49-F238E27FC236}">
-                <a16:creationId xmlns:a16="http://schemas.microsoft.com/office/drawing/2014/main" id="{5E60B8CB-22BA-4087-8E94-EB1CC168DCC0}"/>
-              </a:ext>
-            </a:extLst>
-          </p:cNvPr>
-          <p:cNvSpPr>
-            <a:spLocks xmlns:a="http://schemas.openxmlformats.org/drawingml/2006/main" noGrp="1"/>
-          </p:cNvSpPr>
-          <p:nvPr/>
-        </p:nvSpPr>
-        <p:spPr>
-          <a:xfrm xmlns:a="http://schemas.openxmlformats.org/drawingml/2006/main">
-            <a:off x="6667500" y="5200650"/>
+          <p:cNvPr id="19" name="">
+            <a:extLst xmlns:a="http://schemas.openxmlformats.org/drawingml/2006/main">
+              <a:ext uri="{FF2B5EF4-FFF2-40B4-BE49-F238E27FC236}">
+                <a16:creationId xmlns:a16="http://schemas.microsoft.com/office/drawing/2014/main" id="{45ACA8E6-04A9-4C36-9704-188D1F27ECFA}"/>
+              </a:ext>
+            </a:extLst>
+          </p:cNvPr>
+          <p:cNvSpPr>
+            <a:spLocks xmlns:a="http://schemas.openxmlformats.org/drawingml/2006/main" noGrp="1"/>
+          </p:cNvSpPr>
+          <p:nvPr/>
+        </p:nvSpPr>
+        <p:spPr>
+          <a:xfrm xmlns:a="http://schemas.openxmlformats.org/drawingml/2006/main">
+            <a:off x="9505950" y="4838700"/>
+            <a:ext cx="1809750" cy="247650"/>
+          </a:xfrm>
+          <a:prstGeom xmlns:a="http://schemas.openxmlformats.org/drawingml/2006/main" prst="rect">
+            <a:avLst/>
+          </a:prstGeom>
+          <a:noFill xmlns:a="http://schemas.openxmlformats.org/drawingml/2006/main"/>
+          <a:ln xmlns:a="http://schemas.openxmlformats.org/drawingml/2006/main" w="0">
+            <a:noFill/>
+            <a:prstDash val="solid"/>
+          </a:ln>
+        </p:spPr>
+        <p:txBody>
+          <a:bodyPr xmlns:a="http://schemas.openxmlformats.org/drawingml/2006/main"/>
+          <a:lstStyle xmlns:a="http://schemas.openxmlformats.org/drawingml/2006/main"/>
+          <a:p xmlns:a="http://schemas.openxmlformats.org/drawingml/2006/main">
+            <a:pPr algn="ctr">
+              <a:defRPr sz="1350" b="1">
+                <a:solidFill>
+                  <a:srgbClr val="0E7C7B"/>
+                </a:solidFill>
+              </a:defRPr>
+            </a:pPr>
+            <a:r>
+              <a:rPr sz="1350" b="1">
+                <a:solidFill>
+                  <a:srgbClr val="0E7C7B"/>
+                </a:solidFill>
+              </a:rPr>
+              <a:t>parallel local search</a:t>
+            </a:r>
+          </a:p>
+        </p:txBody>
+      </p:sp>
+      <p:sp>
+        <p:nvSpPr>
+          <p:cNvPr id="20" name="">
+            <a:extLst xmlns:a="http://schemas.openxmlformats.org/drawingml/2006/main">
+              <a:ext uri="{FF2B5EF4-FFF2-40B4-BE49-F238E27FC236}">
+                <a16:creationId xmlns:a16="http://schemas.microsoft.com/office/drawing/2014/main" id="{A9380311-7CFC-4021-A0F6-60171CBDA1C0}"/>
+              </a:ext>
+            </a:extLst>
+          </p:cNvPr>
+          <p:cNvSpPr>
+            <a:spLocks xmlns:a="http://schemas.openxmlformats.org/drawingml/2006/main" noGrp="1"/>
+          </p:cNvSpPr>
+          <p:nvPr/>
+        </p:nvSpPr>
+        <p:spPr>
+          <a:xfrm xmlns:a="http://schemas.openxmlformats.org/drawingml/2006/main">
+            <a:off x="6858000" y="5257800"/>
             <a:ext cx="4762500" cy="476250"/>
           </a:xfrm>
           <a:prstGeom xmlns:a="http://schemas.openxmlformats.org/drawingml/2006/main" prst="rect">
@@ -9735,7 +10001,7 @@
     </p:spTree>
     <p:extLst>
       <p:ext uri="{BB962C8B-B14F-4D97-AF65-F5344CB8AC3E}">
-        <p14:creationId xmlns:p14="http://schemas.microsoft.com/office/powerpoint/2010/main" val="1107735397"/>
+        <p14:creationId xmlns:p14="http://schemas.microsoft.com/office/powerpoint/2010/main" val="63869787"/>
       </p:ext>
     </p:extLst>
   </p:cSld>
@@ -9766,7 +10032,7 @@
           <p:cNvPr id="25" name="">
             <a:extLst xmlns:a="http://schemas.openxmlformats.org/drawingml/2006/main">
               <a:ext uri="{FF2B5EF4-FFF2-40B4-BE49-F238E27FC236}">
-                <a16:creationId xmlns:a16="http://schemas.microsoft.com/office/drawing/2014/main" id="{CDC2C253-4BC9-4810-89FA-90FA20DA67B5}"/>
+                <a16:creationId xmlns:a16="http://schemas.microsoft.com/office/drawing/2014/main" id="{48C8363E-8CF7-4A60-A1EE-DE3B13995C87}"/>
               </a:ext>
             </a:extLst>
           </p:cNvPr>
@@ -9816,7 +10082,7 @@
           <p:cNvPr id="2" name="">
             <a:extLst xmlns:a="http://schemas.openxmlformats.org/drawingml/2006/main">
               <a:ext uri="{FF2B5EF4-FFF2-40B4-BE49-F238E27FC236}">
-                <a16:creationId xmlns:a16="http://schemas.microsoft.com/office/drawing/2014/main" id="{1A11E456-BB00-4CB6-B307-5BC33D8D10FD}"/>
+                <a16:creationId xmlns:a16="http://schemas.microsoft.com/office/drawing/2014/main" id="{C4336F4A-50BD-44CB-A914-4AC2E644672F}"/>
               </a:ext>
             </a:extLst>
           </p:cNvPr>
@@ -9866,7 +10132,7 @@
           <p:cNvPr id="3" name="">
             <a:extLst xmlns:a="http://schemas.openxmlformats.org/drawingml/2006/main">
               <a:ext uri="{FF2B5EF4-FFF2-40B4-BE49-F238E27FC236}">
-                <a16:creationId xmlns:a16="http://schemas.microsoft.com/office/drawing/2014/main" id="{DF1DA408-E287-485A-B459-0114429C1169}"/>
+                <a16:creationId xmlns:a16="http://schemas.microsoft.com/office/drawing/2014/main" id="{B5C69484-F877-4751-8E5D-F4B37AFB92FA}"/>
               </a:ext>
             </a:extLst>
           </p:cNvPr>
@@ -9897,7 +10163,7 @@
           <p:cNvPr id="4" name="">
             <a:extLst xmlns:a="http://schemas.openxmlformats.org/drawingml/2006/main">
               <a:ext uri="{FF2B5EF4-FFF2-40B4-BE49-F238E27FC236}">
-                <a16:creationId xmlns:a16="http://schemas.microsoft.com/office/drawing/2014/main" id="{602B3828-B6FE-4DD9-BCAA-153870E8AB95}"/>
+                <a16:creationId xmlns:a16="http://schemas.microsoft.com/office/drawing/2014/main" id="{96E9F69B-5376-4333-8415-C064510D8B1C}"/>
               </a:ext>
             </a:extLst>
           </p:cNvPr>
@@ -9947,7 +10213,7 @@
           <p:cNvPr id="5" name="">
             <a:extLst xmlns:a="http://schemas.openxmlformats.org/drawingml/2006/main">
               <a:ext uri="{FF2B5EF4-FFF2-40B4-BE49-F238E27FC236}">
-                <a16:creationId xmlns:a16="http://schemas.microsoft.com/office/drawing/2014/main" id="{1FDE723F-E0C1-41DF-87E6-B1549898D827}"/>
+                <a16:creationId xmlns:a16="http://schemas.microsoft.com/office/drawing/2014/main" id="{2283CEB9-7D38-43D7-84FB-BA4BB2BAC246}"/>
               </a:ext>
             </a:extLst>
           </p:cNvPr>
@@ -9997,7 +10263,7 @@
           <p:cNvPr id="6" name="">
             <a:extLst xmlns:a="http://schemas.openxmlformats.org/drawingml/2006/main">
               <a:ext uri="{FF2B5EF4-FFF2-40B4-BE49-F238E27FC236}">
-                <a16:creationId xmlns:a16="http://schemas.microsoft.com/office/drawing/2014/main" id="{69B18728-5F05-432C-B0E3-5E83DB7E2B78}"/>
+                <a16:creationId xmlns:a16="http://schemas.microsoft.com/office/drawing/2014/main" id="{70215DE0-D9C3-4687-A652-136020698BC4}"/>
               </a:ext>
             </a:extLst>
           </p:cNvPr>
@@ -10051,25 +10317,25 @@
           <p:cNvPr id="7" name="">
             <a:extLst xmlns:a="http://schemas.openxmlformats.org/drawingml/2006/main">
               <a:ext uri="{FF2B5EF4-FFF2-40B4-BE49-F238E27FC236}">
-                <a16:creationId xmlns:a16="http://schemas.microsoft.com/office/drawing/2014/main" id="{EDC13FFA-0BC8-4717-A3CB-5E160056B9BF}"/>
-              </a:ext>
-            </a:extLst>
-          </p:cNvPr>
-          <p:cNvSpPr>
-            <a:spLocks xmlns:a="http://schemas.openxmlformats.org/drawingml/2006/main" noGrp="1"/>
-          </p:cNvSpPr>
-          <p:nvPr/>
-        </p:nvSpPr>
-        <p:spPr>
-          <a:xfrm xmlns:a="http://schemas.openxmlformats.org/drawingml/2006/main">
-            <a:off x="1943100" y="3028950"/>
-            <a:ext cx="323850" cy="209550"/>
+                <a16:creationId xmlns:a16="http://schemas.microsoft.com/office/drawing/2014/main" id="{33884CC2-95AA-4812-85E6-CEB5F9137C21}"/>
+              </a:ext>
+            </a:extLst>
+          </p:cNvPr>
+          <p:cNvSpPr>
+            <a:spLocks xmlns:a="http://schemas.openxmlformats.org/drawingml/2006/main" noGrp="1"/>
+          </p:cNvSpPr>
+          <p:nvPr/>
+        </p:nvSpPr>
+        <p:spPr>
+          <a:xfrm xmlns:a="http://schemas.openxmlformats.org/drawingml/2006/main">
+            <a:off x="1885950" y="3009900"/>
+            <a:ext cx="381000" cy="247650"/>
           </a:xfrm>
           <a:prstGeom xmlns:a="http://schemas.openxmlformats.org/drawingml/2006/main" prst="rightArrow">
             <a:avLst/>
           </a:prstGeom>
           <a:solidFill xmlns:a="http://schemas.openxmlformats.org/drawingml/2006/main">
-            <a:srgbClr val="5D6B78"/>
+            <a:srgbClr val="0E7C7B"/>
           </a:solidFill>
           <a:ln xmlns:a="http://schemas.openxmlformats.org/drawingml/2006/main" w="0">
             <a:noFill/>
@@ -10082,7 +10348,7 @@
           <p:cNvPr id="8" name="">
             <a:extLst xmlns:a="http://schemas.openxmlformats.org/drawingml/2006/main">
               <a:ext uri="{FF2B5EF4-FFF2-40B4-BE49-F238E27FC236}">
-                <a16:creationId xmlns:a16="http://schemas.microsoft.com/office/drawing/2014/main" id="{9567A0F5-85B2-4534-AF77-7B7B275AEE64}"/>
+                <a16:creationId xmlns:a16="http://schemas.microsoft.com/office/drawing/2014/main" id="{8470A9E7-4D62-4957-AA97-1CE9B3E23605}"/>
               </a:ext>
             </a:extLst>
           </p:cNvPr>
@@ -10136,25 +10402,25 @@
           <p:cNvPr id="9" name="">
             <a:extLst xmlns:a="http://schemas.openxmlformats.org/drawingml/2006/main">
               <a:ext uri="{FF2B5EF4-FFF2-40B4-BE49-F238E27FC236}">
-                <a16:creationId xmlns:a16="http://schemas.microsoft.com/office/drawing/2014/main" id="{16E344BD-E8D8-49FE-8878-1E3828CA4C36}"/>
-              </a:ext>
-            </a:extLst>
-          </p:cNvPr>
-          <p:cNvSpPr>
-            <a:spLocks xmlns:a="http://schemas.openxmlformats.org/drawingml/2006/main" noGrp="1"/>
-          </p:cNvSpPr>
-          <p:nvPr/>
-        </p:nvSpPr>
-        <p:spPr>
-          <a:xfrm xmlns:a="http://schemas.openxmlformats.org/drawingml/2006/main">
-            <a:off x="3524250" y="3028950"/>
-            <a:ext cx="323850" cy="209550"/>
+                <a16:creationId xmlns:a16="http://schemas.microsoft.com/office/drawing/2014/main" id="{8E7E2B39-9A3A-4EF0-8390-91CAFB8B0142}"/>
+              </a:ext>
+            </a:extLst>
+          </p:cNvPr>
+          <p:cNvSpPr>
+            <a:spLocks xmlns:a="http://schemas.openxmlformats.org/drawingml/2006/main" noGrp="1"/>
+          </p:cNvSpPr>
+          <p:nvPr/>
+        </p:nvSpPr>
+        <p:spPr>
+          <a:xfrm xmlns:a="http://schemas.openxmlformats.org/drawingml/2006/main">
+            <a:off x="3467100" y="3009900"/>
+            <a:ext cx="381000" cy="247650"/>
           </a:xfrm>
           <a:prstGeom xmlns:a="http://schemas.openxmlformats.org/drawingml/2006/main" prst="rightArrow">
             <a:avLst/>
           </a:prstGeom>
           <a:solidFill xmlns:a="http://schemas.openxmlformats.org/drawingml/2006/main">
-            <a:srgbClr val="5D6B78"/>
+            <a:srgbClr val="0E7C7B"/>
           </a:solidFill>
           <a:ln xmlns:a="http://schemas.openxmlformats.org/drawingml/2006/main" w="0">
             <a:noFill/>
@@ -10167,7 +10433,7 @@
           <p:cNvPr id="10" name="">
             <a:extLst xmlns:a="http://schemas.openxmlformats.org/drawingml/2006/main">
               <a:ext uri="{FF2B5EF4-FFF2-40B4-BE49-F238E27FC236}">
-                <a16:creationId xmlns:a16="http://schemas.microsoft.com/office/drawing/2014/main" id="{66143566-0304-4FC6-809A-4B4530A292A5}"/>
+                <a16:creationId xmlns:a16="http://schemas.microsoft.com/office/drawing/2014/main" id="{A7EE8CD0-3677-40BC-BA3F-E7734D27130B}"/>
               </a:ext>
             </a:extLst>
           </p:cNvPr>
@@ -10221,25 +10487,25 @@
           <p:cNvPr id="11" name="">
             <a:extLst xmlns:a="http://schemas.openxmlformats.org/drawingml/2006/main">
               <a:ext uri="{FF2B5EF4-FFF2-40B4-BE49-F238E27FC236}">
-                <a16:creationId xmlns:a16="http://schemas.microsoft.com/office/drawing/2014/main" id="{05546826-B654-4768-82E1-009FD82BF50C}"/>
-              </a:ext>
-            </a:extLst>
-          </p:cNvPr>
-          <p:cNvSpPr>
-            <a:spLocks xmlns:a="http://schemas.openxmlformats.org/drawingml/2006/main" noGrp="1"/>
-          </p:cNvSpPr>
-          <p:nvPr/>
-        </p:nvSpPr>
-        <p:spPr>
-          <a:xfrm xmlns:a="http://schemas.openxmlformats.org/drawingml/2006/main">
-            <a:off x="5105400" y="3028950"/>
-            <a:ext cx="323850" cy="209550"/>
+                <a16:creationId xmlns:a16="http://schemas.microsoft.com/office/drawing/2014/main" id="{98906C16-6933-43E2-AAE9-9D7BC757A169}"/>
+              </a:ext>
+            </a:extLst>
+          </p:cNvPr>
+          <p:cNvSpPr>
+            <a:spLocks xmlns:a="http://schemas.openxmlformats.org/drawingml/2006/main" noGrp="1"/>
+          </p:cNvSpPr>
+          <p:nvPr/>
+        </p:nvSpPr>
+        <p:spPr>
+          <a:xfrm xmlns:a="http://schemas.openxmlformats.org/drawingml/2006/main">
+            <a:off x="5048250" y="3009900"/>
+            <a:ext cx="381000" cy="247650"/>
           </a:xfrm>
           <a:prstGeom xmlns:a="http://schemas.openxmlformats.org/drawingml/2006/main" prst="rightArrow">
             <a:avLst/>
           </a:prstGeom>
           <a:solidFill xmlns:a="http://schemas.openxmlformats.org/drawingml/2006/main">
-            <a:srgbClr val="5D6B78"/>
+            <a:srgbClr val="0E7C7B"/>
           </a:solidFill>
           <a:ln xmlns:a="http://schemas.openxmlformats.org/drawingml/2006/main" w="0">
             <a:noFill/>
@@ -10252,7 +10518,7 @@
           <p:cNvPr id="12" name="">
             <a:extLst xmlns:a="http://schemas.openxmlformats.org/drawingml/2006/main">
               <a:ext uri="{FF2B5EF4-FFF2-40B4-BE49-F238E27FC236}">
-                <a16:creationId xmlns:a16="http://schemas.microsoft.com/office/drawing/2014/main" id="{1D07B736-F86E-4192-8791-EE0F3CE2384C}"/>
+                <a16:creationId xmlns:a16="http://schemas.microsoft.com/office/drawing/2014/main" id="{6625B56D-C37F-4A0B-A82F-7059DAFFC3A7}"/>
               </a:ext>
             </a:extLst>
           </p:cNvPr>
@@ -10306,25 +10572,25 @@
           <p:cNvPr id="13" name="">
             <a:extLst xmlns:a="http://schemas.openxmlformats.org/drawingml/2006/main">
               <a:ext uri="{FF2B5EF4-FFF2-40B4-BE49-F238E27FC236}">
-                <a16:creationId xmlns:a16="http://schemas.microsoft.com/office/drawing/2014/main" id="{C81F2613-2BDB-4BCE-9F89-DCE4F8927E28}"/>
-              </a:ext>
-            </a:extLst>
-          </p:cNvPr>
-          <p:cNvSpPr>
-            <a:spLocks xmlns:a="http://schemas.openxmlformats.org/drawingml/2006/main" noGrp="1"/>
-          </p:cNvSpPr>
-          <p:nvPr/>
-        </p:nvSpPr>
-        <p:spPr>
-          <a:xfrm xmlns:a="http://schemas.openxmlformats.org/drawingml/2006/main">
-            <a:off x="6686550" y="3028950"/>
-            <a:ext cx="323850" cy="209550"/>
+                <a16:creationId xmlns:a16="http://schemas.microsoft.com/office/drawing/2014/main" id="{437221FB-917D-44E2-B6FE-619455217B67}"/>
+              </a:ext>
+            </a:extLst>
+          </p:cNvPr>
+          <p:cNvSpPr>
+            <a:spLocks xmlns:a="http://schemas.openxmlformats.org/drawingml/2006/main" noGrp="1"/>
+          </p:cNvSpPr>
+          <p:nvPr/>
+        </p:nvSpPr>
+        <p:spPr>
+          <a:xfrm xmlns:a="http://schemas.openxmlformats.org/drawingml/2006/main">
+            <a:off x="6629400" y="3009900"/>
+            <a:ext cx="381000" cy="247650"/>
           </a:xfrm>
           <a:prstGeom xmlns:a="http://schemas.openxmlformats.org/drawingml/2006/main" prst="rightArrow">
             <a:avLst/>
           </a:prstGeom>
           <a:solidFill xmlns:a="http://schemas.openxmlformats.org/drawingml/2006/main">
-            <a:srgbClr val="5D6B78"/>
+            <a:srgbClr val="3267B1"/>
           </a:solidFill>
           <a:ln xmlns:a="http://schemas.openxmlformats.org/drawingml/2006/main" w="0">
             <a:noFill/>
@@ -10337,7 +10603,7 @@
           <p:cNvPr id="14" name="">
             <a:extLst xmlns:a="http://schemas.openxmlformats.org/drawingml/2006/main">
               <a:ext uri="{FF2B5EF4-FFF2-40B4-BE49-F238E27FC236}">
-                <a16:creationId xmlns:a16="http://schemas.microsoft.com/office/drawing/2014/main" id="{9A53570C-B889-44A0-A021-320F40E4B66E}"/>
+                <a16:creationId xmlns:a16="http://schemas.microsoft.com/office/drawing/2014/main" id="{643BE777-6C89-4057-A86D-E6D23D424752}"/>
               </a:ext>
             </a:extLst>
           </p:cNvPr>
@@ -10391,25 +10657,25 @@
           <p:cNvPr id="15" name="">
             <a:extLst xmlns:a="http://schemas.openxmlformats.org/drawingml/2006/main">
               <a:ext uri="{FF2B5EF4-FFF2-40B4-BE49-F238E27FC236}">
-                <a16:creationId xmlns:a16="http://schemas.microsoft.com/office/drawing/2014/main" id="{5754D445-528B-41CC-9513-B101C293EF01}"/>
-              </a:ext>
-            </a:extLst>
-          </p:cNvPr>
-          <p:cNvSpPr>
-            <a:spLocks xmlns:a="http://schemas.openxmlformats.org/drawingml/2006/main" noGrp="1"/>
-          </p:cNvSpPr>
-          <p:nvPr/>
-        </p:nvSpPr>
-        <p:spPr>
-          <a:xfrm xmlns:a="http://schemas.openxmlformats.org/drawingml/2006/main">
-            <a:off x="8267700" y="3028950"/>
-            <a:ext cx="323850" cy="209550"/>
+                <a16:creationId xmlns:a16="http://schemas.microsoft.com/office/drawing/2014/main" id="{1C7EF1B2-A63A-4D8C-B5AE-52A5C08EFD9F}"/>
+              </a:ext>
+            </a:extLst>
+          </p:cNvPr>
+          <p:cNvSpPr>
+            <a:spLocks xmlns:a="http://schemas.openxmlformats.org/drawingml/2006/main" noGrp="1"/>
+          </p:cNvSpPr>
+          <p:nvPr/>
+        </p:nvSpPr>
+        <p:spPr>
+          <a:xfrm xmlns:a="http://schemas.openxmlformats.org/drawingml/2006/main">
+            <a:off x="8210550" y="3009900"/>
+            <a:ext cx="381000" cy="247650"/>
           </a:xfrm>
           <a:prstGeom xmlns:a="http://schemas.openxmlformats.org/drawingml/2006/main" prst="rightArrow">
             <a:avLst/>
           </a:prstGeom>
           <a:solidFill xmlns:a="http://schemas.openxmlformats.org/drawingml/2006/main">
-            <a:srgbClr val="5D6B78"/>
+            <a:srgbClr val="3267B1"/>
           </a:solidFill>
           <a:ln xmlns:a="http://schemas.openxmlformats.org/drawingml/2006/main" w="0">
             <a:noFill/>
@@ -10422,7 +10688,7 @@
           <p:cNvPr id="16" name="">
             <a:extLst xmlns:a="http://schemas.openxmlformats.org/drawingml/2006/main">
               <a:ext uri="{FF2B5EF4-FFF2-40B4-BE49-F238E27FC236}">
-                <a16:creationId xmlns:a16="http://schemas.microsoft.com/office/drawing/2014/main" id="{3B3AA349-6D5E-45C8-A670-74A85FAA7A42}"/>
+                <a16:creationId xmlns:a16="http://schemas.microsoft.com/office/drawing/2014/main" id="{41203313-ECF2-40B4-96B8-B910BD9A5F91}"/>
               </a:ext>
             </a:extLst>
           </p:cNvPr>
@@ -10476,25 +10742,25 @@
           <p:cNvPr id="17" name="">
             <a:extLst xmlns:a="http://schemas.openxmlformats.org/drawingml/2006/main">
               <a:ext uri="{FF2B5EF4-FFF2-40B4-BE49-F238E27FC236}">
-                <a16:creationId xmlns:a16="http://schemas.microsoft.com/office/drawing/2014/main" id="{811B56A5-45D7-42B6-AFCF-5FE99110C92E}"/>
-              </a:ext>
-            </a:extLst>
-          </p:cNvPr>
-          <p:cNvSpPr>
-            <a:spLocks xmlns:a="http://schemas.openxmlformats.org/drawingml/2006/main" noGrp="1"/>
-          </p:cNvSpPr>
-          <p:nvPr/>
-        </p:nvSpPr>
-        <p:spPr>
-          <a:xfrm xmlns:a="http://schemas.openxmlformats.org/drawingml/2006/main">
-            <a:off x="9848850" y="3028950"/>
-            <a:ext cx="323850" cy="209550"/>
+                <a16:creationId xmlns:a16="http://schemas.microsoft.com/office/drawing/2014/main" id="{8105887F-4444-4C40-BEB5-CF352B4CCA67}"/>
+              </a:ext>
+            </a:extLst>
+          </p:cNvPr>
+          <p:cNvSpPr>
+            <a:spLocks xmlns:a="http://schemas.openxmlformats.org/drawingml/2006/main" noGrp="1"/>
+          </p:cNvSpPr>
+          <p:nvPr/>
+        </p:nvSpPr>
+        <p:spPr>
+          <a:xfrm xmlns:a="http://schemas.openxmlformats.org/drawingml/2006/main">
+            <a:off x="9791700" y="3009900"/>
+            <a:ext cx="381000" cy="247650"/>
           </a:xfrm>
           <a:prstGeom xmlns:a="http://schemas.openxmlformats.org/drawingml/2006/main" prst="rightArrow">
             <a:avLst/>
           </a:prstGeom>
           <a:solidFill xmlns:a="http://schemas.openxmlformats.org/drawingml/2006/main">
-            <a:srgbClr val="5D6B78"/>
+            <a:srgbClr val="3267B1"/>
           </a:solidFill>
           <a:ln xmlns:a="http://schemas.openxmlformats.org/drawingml/2006/main" w="0">
             <a:noFill/>
@@ -10507,7 +10773,7 @@
           <p:cNvPr id="18" name="">
             <a:extLst xmlns:a="http://schemas.openxmlformats.org/drawingml/2006/main">
               <a:ext uri="{FF2B5EF4-FFF2-40B4-BE49-F238E27FC236}">
-                <a16:creationId xmlns:a16="http://schemas.microsoft.com/office/drawing/2014/main" id="{BD9148F8-E8FB-4572-8C18-3F722C3C11B7}"/>
+                <a16:creationId xmlns:a16="http://schemas.microsoft.com/office/drawing/2014/main" id="{BD631DFC-F31C-440F-A0DE-64967E54F838}"/>
               </a:ext>
             </a:extLst>
           </p:cNvPr>
@@ -10561,7 +10827,7 @@
           <p:cNvPr id="19" name="">
             <a:extLst xmlns:a="http://schemas.openxmlformats.org/drawingml/2006/main">
               <a:ext uri="{FF2B5EF4-FFF2-40B4-BE49-F238E27FC236}">
-                <a16:creationId xmlns:a16="http://schemas.microsoft.com/office/drawing/2014/main" id="{2BA3A693-0A5E-4E85-B21C-79E231DE1E88}"/>
+                <a16:creationId xmlns:a16="http://schemas.microsoft.com/office/drawing/2014/main" id="{B33407CB-DFAB-43E0-A91E-32EDE4C9ABB1}"/>
               </a:ext>
             </a:extLst>
           </p:cNvPr>
@@ -10611,7 +10877,7 @@
           <p:cNvPr id="20" name="">
             <a:extLst xmlns:a="http://schemas.openxmlformats.org/drawingml/2006/main">
               <a:ext uri="{FF2B5EF4-FFF2-40B4-BE49-F238E27FC236}">
-                <a16:creationId xmlns:a16="http://schemas.microsoft.com/office/drawing/2014/main" id="{46BE2090-67D6-419F-AED2-6EFCCCE4A32A}"/>
+                <a16:creationId xmlns:a16="http://schemas.microsoft.com/office/drawing/2014/main" id="{0B6807B8-AAD2-4381-8E1F-A064DCC6B50A}"/>
               </a:ext>
             </a:extLst>
           </p:cNvPr>
@@ -10661,7 +10927,7 @@
           <p:cNvPr id="21" name="">
             <a:extLst xmlns:a="http://schemas.openxmlformats.org/drawingml/2006/main">
               <a:ext uri="{FF2B5EF4-FFF2-40B4-BE49-F238E27FC236}">
-                <a16:creationId xmlns:a16="http://schemas.microsoft.com/office/drawing/2014/main" id="{76FBD944-E359-40B2-9D9F-7B2B14DD9068}"/>
+                <a16:creationId xmlns:a16="http://schemas.microsoft.com/office/drawing/2014/main" id="{BA1D6FC7-2693-4603-94A3-673B4DFE4E76}"/>
               </a:ext>
             </a:extLst>
           </p:cNvPr>
@@ -10696,7 +10962,7 @@
           <p:cNvPr id="22" name="">
             <a:extLst xmlns:a="http://schemas.openxmlformats.org/drawingml/2006/main">
               <a:ext uri="{FF2B5EF4-FFF2-40B4-BE49-F238E27FC236}">
-                <a16:creationId xmlns:a16="http://schemas.microsoft.com/office/drawing/2014/main" id="{C8A40B07-8071-4A80-BCE6-8302777DCD83}"/>
+                <a16:creationId xmlns:a16="http://schemas.microsoft.com/office/drawing/2014/main" id="{B8CD45B8-4382-49B0-B8ED-2A91DDD4CC26}"/>
               </a:ext>
             </a:extLst>
           </p:cNvPr>
@@ -10746,7 +11012,7 @@
           <p:cNvPr id="23" name="">
             <a:extLst xmlns:a="http://schemas.openxmlformats.org/drawingml/2006/main">
               <a:ext uri="{FF2B5EF4-FFF2-40B4-BE49-F238E27FC236}">
-                <a16:creationId xmlns:a16="http://schemas.microsoft.com/office/drawing/2014/main" id="{488ACBCB-89F3-444F-9E53-21F7B937DA43}"/>
+                <a16:creationId xmlns:a16="http://schemas.microsoft.com/office/drawing/2014/main" id="{0B75A471-4F4E-4E51-A013-A986612C52C3}"/>
               </a:ext>
             </a:extLst>
           </p:cNvPr>
@@ -10781,7 +11047,7 @@
           <p:cNvPr id="24" name="">
             <a:extLst xmlns:a="http://schemas.openxmlformats.org/drawingml/2006/main">
               <a:ext uri="{FF2B5EF4-FFF2-40B4-BE49-F238E27FC236}">
-                <a16:creationId xmlns:a16="http://schemas.microsoft.com/office/drawing/2014/main" id="{96233D05-45BB-4246-9896-94D5A61346C7}"/>
+                <a16:creationId xmlns:a16="http://schemas.microsoft.com/office/drawing/2014/main" id="{8DCF058D-6C23-4BC8-A8D8-A8A7F964BA78}"/>
               </a:ext>
             </a:extLst>
           </p:cNvPr>
@@ -10829,7 +11095,7 @@
     </p:spTree>
     <p:extLst>
       <p:ext uri="{BB962C8B-B14F-4D97-AF65-F5344CB8AC3E}">
-        <p14:creationId xmlns:p14="http://schemas.microsoft.com/office/powerpoint/2010/main" val="1554661749"/>
+        <p14:creationId xmlns:p14="http://schemas.microsoft.com/office/powerpoint/2010/main" val="526636182"/>
       </p:ext>
     </p:extLst>
   </p:cSld>
@@ -10860,7 +11126,7 @@
           <p:cNvPr id="26" name="">
             <a:extLst xmlns:a="http://schemas.openxmlformats.org/drawingml/2006/main">
               <a:ext uri="{FF2B5EF4-FFF2-40B4-BE49-F238E27FC236}">
-                <a16:creationId xmlns:a16="http://schemas.microsoft.com/office/drawing/2014/main" id="{3E59DBC3-47FF-4BC8-BA37-EBFAB162AB4A}"/>
+                <a16:creationId xmlns:a16="http://schemas.microsoft.com/office/drawing/2014/main" id="{419199C4-7FFE-4641-8198-9B19287391BD}"/>
               </a:ext>
             </a:extLst>
           </p:cNvPr>
@@ -10910,7 +11176,7 @@
           <p:cNvPr id="2" name="">
             <a:extLst xmlns:a="http://schemas.openxmlformats.org/drawingml/2006/main">
               <a:ext uri="{FF2B5EF4-FFF2-40B4-BE49-F238E27FC236}">
-                <a16:creationId xmlns:a16="http://schemas.microsoft.com/office/drawing/2014/main" id="{0960DAD7-A564-48E8-A481-B0C85D216110}"/>
+                <a16:creationId xmlns:a16="http://schemas.microsoft.com/office/drawing/2014/main" id="{F75A2BFD-D3F6-4065-A6D4-430C171E96FA}"/>
               </a:ext>
             </a:extLst>
           </p:cNvPr>
@@ -10960,7 +11226,7 @@
           <p:cNvPr id="3" name="">
             <a:extLst xmlns:a="http://schemas.openxmlformats.org/drawingml/2006/main">
               <a:ext uri="{FF2B5EF4-FFF2-40B4-BE49-F238E27FC236}">
-                <a16:creationId xmlns:a16="http://schemas.microsoft.com/office/drawing/2014/main" id="{099FF3EB-F2FD-4DBF-B3D6-F1DFC571CDAD}"/>
+                <a16:creationId xmlns:a16="http://schemas.microsoft.com/office/drawing/2014/main" id="{DCAF9F1F-0025-4264-961F-45DA1588E271}"/>
               </a:ext>
             </a:extLst>
           </p:cNvPr>
@@ -10991,7 +11257,7 @@
           <p:cNvPr id="4" name="">
             <a:extLst xmlns:a="http://schemas.openxmlformats.org/drawingml/2006/main">
               <a:ext uri="{FF2B5EF4-FFF2-40B4-BE49-F238E27FC236}">
-                <a16:creationId xmlns:a16="http://schemas.microsoft.com/office/drawing/2014/main" id="{2C58D41E-110C-45F9-9ED0-E308AC595C18}"/>
+                <a16:creationId xmlns:a16="http://schemas.microsoft.com/office/drawing/2014/main" id="{F51EE3BD-EE3D-4AC5-B26F-21D4049AB685}"/>
               </a:ext>
             </a:extLst>
           </p:cNvPr>
@@ -11041,7 +11307,7 @@
           <p:cNvPr id="5" name="">
             <a:extLst xmlns:a="http://schemas.openxmlformats.org/drawingml/2006/main">
               <a:ext uri="{FF2B5EF4-FFF2-40B4-BE49-F238E27FC236}">
-                <a16:creationId xmlns:a16="http://schemas.microsoft.com/office/drawing/2014/main" id="{41858EBD-04AA-4ADE-A492-A662537A7BEF}"/>
+                <a16:creationId xmlns:a16="http://schemas.microsoft.com/office/drawing/2014/main" id="{BEAAF4C7-7D30-4997-8E77-026561288779}"/>
               </a:ext>
             </a:extLst>
           </p:cNvPr>
@@ -11091,7 +11357,7 @@
           <p:cNvPr id="6" name="">
             <a:extLst xmlns:a="http://schemas.openxmlformats.org/drawingml/2006/main">
               <a:ext uri="{FF2B5EF4-FFF2-40B4-BE49-F238E27FC236}">
-                <a16:creationId xmlns:a16="http://schemas.microsoft.com/office/drawing/2014/main" id="{F7BD0C78-9566-4388-BDCE-90A55503D850}"/>
+                <a16:creationId xmlns:a16="http://schemas.microsoft.com/office/drawing/2014/main" id="{77F1DB85-013B-4756-91A1-6AD02FC266BD}"/>
               </a:ext>
             </a:extLst>
           </p:cNvPr>
@@ -11141,7 +11407,7 @@
           <p:cNvPr id="7" name="">
             <a:extLst xmlns:a="http://schemas.openxmlformats.org/drawingml/2006/main">
               <a:ext uri="{FF2B5EF4-FFF2-40B4-BE49-F238E27FC236}">
-                <a16:creationId xmlns:a16="http://schemas.microsoft.com/office/drawing/2014/main" id="{A9D29215-BF9A-48D7-B0FB-D6160A3F3A5E}"/>
+                <a16:creationId xmlns:a16="http://schemas.microsoft.com/office/drawing/2014/main" id="{3730BEFD-148E-44AF-97DC-1DBF6BF1BE56}"/>
               </a:ext>
             </a:extLst>
           </p:cNvPr>
@@ -11172,7 +11438,7 @@
           <p:cNvPr id="8" name="">
             <a:extLst xmlns:a="http://schemas.openxmlformats.org/drawingml/2006/main">
               <a:ext uri="{FF2B5EF4-FFF2-40B4-BE49-F238E27FC236}">
-                <a16:creationId xmlns:a16="http://schemas.microsoft.com/office/drawing/2014/main" id="{702D8FCE-3F25-4F74-B3A8-2A718A417945}"/>
+                <a16:creationId xmlns:a16="http://schemas.microsoft.com/office/drawing/2014/main" id="{7DD141AE-2B6E-4DA2-815D-5E4A4DC961A9}"/>
               </a:ext>
             </a:extLst>
           </p:cNvPr>
@@ -11222,7 +11488,7 @@
           <p:cNvPr id="9" name="">
             <a:extLst xmlns:a="http://schemas.openxmlformats.org/drawingml/2006/main">
               <a:ext uri="{FF2B5EF4-FFF2-40B4-BE49-F238E27FC236}">
-                <a16:creationId xmlns:a16="http://schemas.microsoft.com/office/drawing/2014/main" id="{45B3E917-D341-492C-A9FF-7CB5C6E63E4E}"/>
+                <a16:creationId xmlns:a16="http://schemas.microsoft.com/office/drawing/2014/main" id="{128C47A7-303E-4E99-AB40-27C76FC04878}"/>
               </a:ext>
             </a:extLst>
           </p:cNvPr>
@@ -11253,7 +11519,7 @@
           <p:cNvPr id="10" name="">
             <a:extLst xmlns:a="http://schemas.openxmlformats.org/drawingml/2006/main">
               <a:ext uri="{FF2B5EF4-FFF2-40B4-BE49-F238E27FC236}">
-                <a16:creationId xmlns:a16="http://schemas.microsoft.com/office/drawing/2014/main" id="{CB476E09-4251-4966-802F-EBD291B0EF46}"/>
+                <a16:creationId xmlns:a16="http://schemas.microsoft.com/office/drawing/2014/main" id="{0D33DDDA-0709-4C92-9776-453FBA92D3B8}"/>
               </a:ext>
             </a:extLst>
           </p:cNvPr>
@@ -11303,7 +11569,7 @@
           <p:cNvPr id="11" name="">
             <a:extLst xmlns:a="http://schemas.openxmlformats.org/drawingml/2006/main">
               <a:ext uri="{FF2B5EF4-FFF2-40B4-BE49-F238E27FC236}">
-                <a16:creationId xmlns:a16="http://schemas.microsoft.com/office/drawing/2014/main" id="{09E0D6C3-434E-4236-BA4F-00E9A8B59EED}"/>
+                <a16:creationId xmlns:a16="http://schemas.microsoft.com/office/drawing/2014/main" id="{359BE8A5-6547-4FE4-BE5D-155FC5EA2AB4}"/>
               </a:ext>
             </a:extLst>
           </p:cNvPr>
@@ -11334,7 +11600,7 @@
           <p:cNvPr id="12" name="">
             <a:extLst xmlns:a="http://schemas.openxmlformats.org/drawingml/2006/main">
               <a:ext uri="{FF2B5EF4-FFF2-40B4-BE49-F238E27FC236}">
-                <a16:creationId xmlns:a16="http://schemas.microsoft.com/office/drawing/2014/main" id="{C5B2F777-D6D6-480A-BD11-38436E01AF2A}"/>
+                <a16:creationId xmlns:a16="http://schemas.microsoft.com/office/drawing/2014/main" id="{AA5BBD69-543E-4363-960D-597E2E7EF457}"/>
               </a:ext>
             </a:extLst>
           </p:cNvPr>
@@ -11384,7 +11650,7 @@
           <p:cNvPr id="13" name="">
             <a:extLst xmlns:a="http://schemas.openxmlformats.org/drawingml/2006/main">
               <a:ext uri="{FF2B5EF4-FFF2-40B4-BE49-F238E27FC236}">
-                <a16:creationId xmlns:a16="http://schemas.microsoft.com/office/drawing/2014/main" id="{3C003392-CA3D-4248-9428-FFDDCDDAD153}"/>
+                <a16:creationId xmlns:a16="http://schemas.microsoft.com/office/drawing/2014/main" id="{2BFEDDD8-8441-473D-B826-E43A7AEC8B45}"/>
               </a:ext>
             </a:extLst>
           </p:cNvPr>
@@ -11415,7 +11681,7 @@
           <p:cNvPr id="14" name="">
             <a:extLst xmlns:a="http://schemas.openxmlformats.org/drawingml/2006/main">
               <a:ext uri="{FF2B5EF4-FFF2-40B4-BE49-F238E27FC236}">
-                <a16:creationId xmlns:a16="http://schemas.microsoft.com/office/drawing/2014/main" id="{C6763E9C-2D36-44F6-8A9F-CB5F6A0BF972}"/>
+                <a16:creationId xmlns:a16="http://schemas.microsoft.com/office/drawing/2014/main" id="{F2B25C54-8E50-41B4-ACE0-5CA0D18FC050}"/>
               </a:ext>
             </a:extLst>
           </p:cNvPr>
@@ -11465,7 +11731,7 @@
           <p:cNvPr id="15" name="">
             <a:extLst xmlns:a="http://schemas.openxmlformats.org/drawingml/2006/main">
               <a:ext uri="{FF2B5EF4-FFF2-40B4-BE49-F238E27FC236}">
-                <a16:creationId xmlns:a16="http://schemas.microsoft.com/office/drawing/2014/main" id="{330F669E-EABB-40F3-9E1F-9D9E4C326734}"/>
+                <a16:creationId xmlns:a16="http://schemas.microsoft.com/office/drawing/2014/main" id="{E873D5FB-8F4F-43AF-8F71-5CE8F0490CCA}"/>
               </a:ext>
             </a:extLst>
           </p:cNvPr>
@@ -11515,7 +11781,7 @@
           <p:cNvPr id="16" name="">
             <a:extLst xmlns:a="http://schemas.openxmlformats.org/drawingml/2006/main">
               <a:ext uri="{FF2B5EF4-FFF2-40B4-BE49-F238E27FC236}">
-                <a16:creationId xmlns:a16="http://schemas.microsoft.com/office/drawing/2014/main" id="{FE986D7E-C8CE-4347-8936-590473EBBCBF}"/>
+                <a16:creationId xmlns:a16="http://schemas.microsoft.com/office/drawing/2014/main" id="{349792D5-86EF-4D24-9BF8-FB3E9077A4B2}"/>
               </a:ext>
             </a:extLst>
           </p:cNvPr>
@@ -11546,7 +11812,7 @@
           <p:cNvPr id="17" name="">
             <a:extLst xmlns:a="http://schemas.openxmlformats.org/drawingml/2006/main">
               <a:ext uri="{FF2B5EF4-FFF2-40B4-BE49-F238E27FC236}">
-                <a16:creationId xmlns:a16="http://schemas.microsoft.com/office/drawing/2014/main" id="{90303169-25C3-470D-BCF4-D9D818892245}"/>
+                <a16:creationId xmlns:a16="http://schemas.microsoft.com/office/drawing/2014/main" id="{7718E2AC-4422-4176-B9F8-FF4A57B8D50C}"/>
               </a:ext>
             </a:extLst>
           </p:cNvPr>
@@ -11596,7 +11862,7 @@
           <p:cNvPr id="18" name="">
             <a:extLst xmlns:a="http://schemas.openxmlformats.org/drawingml/2006/main">
               <a:ext uri="{FF2B5EF4-FFF2-40B4-BE49-F238E27FC236}">
-                <a16:creationId xmlns:a16="http://schemas.microsoft.com/office/drawing/2014/main" id="{87CF7475-35A4-496E-9CB9-F624DF2DDB83}"/>
+                <a16:creationId xmlns:a16="http://schemas.microsoft.com/office/drawing/2014/main" id="{78265526-EA35-4DD1-AF61-472DEB5BD9B1}"/>
               </a:ext>
             </a:extLst>
           </p:cNvPr>
@@ -11627,7 +11893,7 @@
           <p:cNvPr id="19" name="">
             <a:extLst xmlns:a="http://schemas.openxmlformats.org/drawingml/2006/main">
               <a:ext uri="{FF2B5EF4-FFF2-40B4-BE49-F238E27FC236}">
-                <a16:creationId xmlns:a16="http://schemas.microsoft.com/office/drawing/2014/main" id="{86591F7B-72F9-443A-9C10-608B1A43B27F}"/>
+                <a16:creationId xmlns:a16="http://schemas.microsoft.com/office/drawing/2014/main" id="{E7AC612B-D477-4B1F-9698-32E0BC2EFFC6}"/>
               </a:ext>
             </a:extLst>
           </p:cNvPr>
@@ -11677,7 +11943,7 @@
           <p:cNvPr id="20" name="">
             <a:extLst xmlns:a="http://schemas.openxmlformats.org/drawingml/2006/main">
               <a:ext uri="{FF2B5EF4-FFF2-40B4-BE49-F238E27FC236}">
-                <a16:creationId xmlns:a16="http://schemas.microsoft.com/office/drawing/2014/main" id="{630C1B45-7279-45F6-B5E3-6D338C99C2B3}"/>
+                <a16:creationId xmlns:a16="http://schemas.microsoft.com/office/drawing/2014/main" id="{4E46CFF3-E927-41D5-B9A2-03BF9F9EBC9F}"/>
               </a:ext>
             </a:extLst>
           </p:cNvPr>
@@ -11708,7 +11974,7 @@
           <p:cNvPr id="21" name="">
             <a:extLst xmlns:a="http://schemas.openxmlformats.org/drawingml/2006/main">
               <a:ext uri="{FF2B5EF4-FFF2-40B4-BE49-F238E27FC236}">
-                <a16:creationId xmlns:a16="http://schemas.microsoft.com/office/drawing/2014/main" id="{96911E3B-2736-4DFC-AACC-C3EB5B93A916}"/>
+                <a16:creationId xmlns:a16="http://schemas.microsoft.com/office/drawing/2014/main" id="{632B98D7-AB01-440C-B5C2-09B161F0FE29}"/>
               </a:ext>
             </a:extLst>
           </p:cNvPr>
@@ -11758,7 +12024,7 @@
           <p:cNvPr id="22" name="">
             <a:extLst xmlns:a="http://schemas.openxmlformats.org/drawingml/2006/main">
               <a:ext uri="{FF2B5EF4-FFF2-40B4-BE49-F238E27FC236}">
-                <a16:creationId xmlns:a16="http://schemas.microsoft.com/office/drawing/2014/main" id="{9DC3763E-10F4-46CE-80B9-0F323070FF53}"/>
+                <a16:creationId xmlns:a16="http://schemas.microsoft.com/office/drawing/2014/main" id="{A496EC80-0277-4F90-82C3-03CA8BF4CCE9}"/>
               </a:ext>
             </a:extLst>
           </p:cNvPr>
@@ -11789,7 +12055,7 @@
           <p:cNvPr id="23" name="">
             <a:extLst xmlns:a="http://schemas.openxmlformats.org/drawingml/2006/main">
               <a:ext uri="{FF2B5EF4-FFF2-40B4-BE49-F238E27FC236}">
-                <a16:creationId xmlns:a16="http://schemas.microsoft.com/office/drawing/2014/main" id="{63D5704D-A98F-4E8F-AC29-451AF2F04036}"/>
+                <a16:creationId xmlns:a16="http://schemas.microsoft.com/office/drawing/2014/main" id="{3839CFFD-0062-4E5A-ACC1-0B34D5FFA062}"/>
               </a:ext>
             </a:extLst>
           </p:cNvPr>
@@ -11839,7 +12105,7 @@
           <p:cNvPr id="24" name="">
             <a:extLst xmlns:a="http://schemas.openxmlformats.org/drawingml/2006/main">
               <a:ext uri="{FF2B5EF4-FFF2-40B4-BE49-F238E27FC236}">
-                <a16:creationId xmlns:a16="http://schemas.microsoft.com/office/drawing/2014/main" id="{EDCB568D-655F-43A9-BBBE-5441C1EBD24D}"/>
+                <a16:creationId xmlns:a16="http://schemas.microsoft.com/office/drawing/2014/main" id="{B8C0EBCD-E060-42AE-A684-D89E7070973A}"/>
               </a:ext>
             </a:extLst>
           </p:cNvPr>
@@ -11874,7 +12140,7 @@
           <p:cNvPr id="25" name="">
             <a:extLst xmlns:a="http://schemas.openxmlformats.org/drawingml/2006/main">
               <a:ext uri="{FF2B5EF4-FFF2-40B4-BE49-F238E27FC236}">
-                <a16:creationId xmlns:a16="http://schemas.microsoft.com/office/drawing/2014/main" id="{4ED187BA-76D5-4070-9E6F-0FDBC65E7F70}"/>
+                <a16:creationId xmlns:a16="http://schemas.microsoft.com/office/drawing/2014/main" id="{9312DF48-F744-4B9A-BC81-13F5B3F63C67}"/>
               </a:ext>
             </a:extLst>
           </p:cNvPr>
@@ -11922,7 +12188,7 @@
     </p:spTree>
     <p:extLst>
       <p:ext uri="{BB962C8B-B14F-4D97-AF65-F5344CB8AC3E}">
-        <p14:creationId xmlns:p14="http://schemas.microsoft.com/office/powerpoint/2010/main" val="218499111"/>
+        <p14:creationId xmlns:p14="http://schemas.microsoft.com/office/powerpoint/2010/main" val="1148806321"/>
       </p:ext>
     </p:extLst>
   </p:cSld>
@@ -11953,7 +12219,7 @@
           <p:cNvPr id="18" name="">
             <a:extLst xmlns:a="http://schemas.openxmlformats.org/drawingml/2006/main">
               <a:ext uri="{FF2B5EF4-FFF2-40B4-BE49-F238E27FC236}">
-                <a16:creationId xmlns:a16="http://schemas.microsoft.com/office/drawing/2014/main" id="{69D3E25D-51B9-4127-9662-3FFAFCB809D6}"/>
+                <a16:creationId xmlns:a16="http://schemas.microsoft.com/office/drawing/2014/main" id="{C3B9C0B5-713F-4FBF-A946-1580C7DC5742}"/>
               </a:ext>
             </a:extLst>
           </p:cNvPr>
@@ -12003,7 +12269,7 @@
           <p:cNvPr id="2" name="">
             <a:extLst xmlns:a="http://schemas.openxmlformats.org/drawingml/2006/main">
               <a:ext uri="{FF2B5EF4-FFF2-40B4-BE49-F238E27FC236}">
-                <a16:creationId xmlns:a16="http://schemas.microsoft.com/office/drawing/2014/main" id="{D00B7EE0-FBB8-4626-9726-C643A042C3D8}"/>
+                <a16:creationId xmlns:a16="http://schemas.microsoft.com/office/drawing/2014/main" id="{3A49300F-7A0C-4C87-ABD0-9D9BFDE9D3C5}"/>
               </a:ext>
             </a:extLst>
           </p:cNvPr>
@@ -12053,7 +12319,7 @@
           <p:cNvPr id="3" name="">
             <a:extLst xmlns:a="http://schemas.openxmlformats.org/drawingml/2006/main">
               <a:ext uri="{FF2B5EF4-FFF2-40B4-BE49-F238E27FC236}">
-                <a16:creationId xmlns:a16="http://schemas.microsoft.com/office/drawing/2014/main" id="{F0FBE2C1-E5D9-48B8-90AD-CDD983B52BDB}"/>
+                <a16:creationId xmlns:a16="http://schemas.microsoft.com/office/drawing/2014/main" id="{01B17906-786A-432D-A227-5DB7F7D6FDC5}"/>
               </a:ext>
             </a:extLst>
           </p:cNvPr>
@@ -12084,7 +12350,7 @@
           <p:cNvPr id="4" name="">
             <a:extLst xmlns:a="http://schemas.openxmlformats.org/drawingml/2006/main">
               <a:ext uri="{FF2B5EF4-FFF2-40B4-BE49-F238E27FC236}">
-                <a16:creationId xmlns:a16="http://schemas.microsoft.com/office/drawing/2014/main" id="{1299B0FD-3227-4EC8-BD4B-A5AAFB51558D}"/>
+                <a16:creationId xmlns:a16="http://schemas.microsoft.com/office/drawing/2014/main" id="{2BD2B426-7EB2-47AF-8B3C-54D12F997B08}"/>
               </a:ext>
             </a:extLst>
           </p:cNvPr>
@@ -12134,7 +12400,7 @@
           <p:cNvPr id="5" name="">
             <a:extLst xmlns:a="http://schemas.openxmlformats.org/drawingml/2006/main">
               <a:ext uri="{FF2B5EF4-FFF2-40B4-BE49-F238E27FC236}">
-                <a16:creationId xmlns:a16="http://schemas.microsoft.com/office/drawing/2014/main" id="{B562F4D1-C7DB-4133-B452-B31DDFD684AB}"/>
+                <a16:creationId xmlns:a16="http://schemas.microsoft.com/office/drawing/2014/main" id="{EBAD7733-1A9B-47F3-8A8A-63DCF33D4368}"/>
               </a:ext>
             </a:extLst>
           </p:cNvPr>
@@ -12184,7 +12450,7 @@
           <p:cNvPr id="6" name="">
             <a:extLst xmlns:a="http://schemas.openxmlformats.org/drawingml/2006/main">
               <a:ext uri="{FF2B5EF4-FFF2-40B4-BE49-F238E27FC236}">
-                <a16:creationId xmlns:a16="http://schemas.microsoft.com/office/drawing/2014/main" id="{63244FCE-01F4-4CA7-ADA4-808DAB5B9F1A}"/>
+                <a16:creationId xmlns:a16="http://schemas.microsoft.com/office/drawing/2014/main" id="{6E90121A-C27D-4A8D-AE1F-31CDB268D983}"/>
               </a:ext>
             </a:extLst>
           </p:cNvPr>
@@ -12234,7 +12500,7 @@
           <p:cNvPr id="7" name="">
             <a:extLst xmlns:a="http://schemas.openxmlformats.org/drawingml/2006/main">
               <a:ext uri="{FF2B5EF4-FFF2-40B4-BE49-F238E27FC236}">
-                <a16:creationId xmlns:a16="http://schemas.microsoft.com/office/drawing/2014/main" id="{0CD36CF1-FDA3-457F-8323-86DA0240D40B}"/>
+                <a16:creationId xmlns:a16="http://schemas.microsoft.com/office/drawing/2014/main" id="{B1D8515E-2E38-4BEF-901E-2DBC9E1E9DEA}"/>
               </a:ext>
             </a:extLst>
           </p:cNvPr>
@@ -12284,7 +12550,7 @@
           <p:cNvPr id="8" name="">
             <a:extLst xmlns:a="http://schemas.openxmlformats.org/drawingml/2006/main">
               <a:ext uri="{FF2B5EF4-FFF2-40B4-BE49-F238E27FC236}">
-                <a16:creationId xmlns:a16="http://schemas.microsoft.com/office/drawing/2014/main" id="{9C7AF606-A426-441A-A9D3-97920FDA834F}"/>
+                <a16:creationId xmlns:a16="http://schemas.microsoft.com/office/drawing/2014/main" id="{424B6891-B3C3-49B0-A211-770B17770391}"/>
               </a:ext>
             </a:extLst>
           </p:cNvPr>
@@ -12315,7 +12581,7 @@
           <p:cNvPr id="9" name="">
             <a:extLst xmlns:a="http://schemas.openxmlformats.org/drawingml/2006/main">
               <a:ext uri="{FF2B5EF4-FFF2-40B4-BE49-F238E27FC236}">
-                <a16:creationId xmlns:a16="http://schemas.microsoft.com/office/drawing/2014/main" id="{61B297DC-10BC-4DDF-9F61-36E0DB433CCD}"/>
+                <a16:creationId xmlns:a16="http://schemas.microsoft.com/office/drawing/2014/main" id="{34F3E75D-31E3-45F9-811C-449A0C2A65D9}"/>
               </a:ext>
             </a:extLst>
           </p:cNvPr>
@@ -12365,7 +12631,7 @@
           <p:cNvPr id="10" name="">
             <a:extLst xmlns:a="http://schemas.openxmlformats.org/drawingml/2006/main">
               <a:ext uri="{FF2B5EF4-FFF2-40B4-BE49-F238E27FC236}">
-                <a16:creationId xmlns:a16="http://schemas.microsoft.com/office/drawing/2014/main" id="{43EFD2F6-9683-4EA5-B596-298912255C40}"/>
+                <a16:creationId xmlns:a16="http://schemas.microsoft.com/office/drawing/2014/main" id="{DD01963D-73ED-43EF-89F9-0740ED3963C4}"/>
               </a:ext>
             </a:extLst>
           </p:cNvPr>
@@ -12415,7 +12681,7 @@
           <p:cNvPr id="11" name="">
             <a:extLst xmlns:a="http://schemas.openxmlformats.org/drawingml/2006/main">
               <a:ext uri="{FF2B5EF4-FFF2-40B4-BE49-F238E27FC236}">
-                <a16:creationId xmlns:a16="http://schemas.microsoft.com/office/drawing/2014/main" id="{4670923D-B1BA-4334-98B2-80370BDF2F70}"/>
+                <a16:creationId xmlns:a16="http://schemas.microsoft.com/office/drawing/2014/main" id="{23BAE2B5-1AEF-480F-B13A-C63B1657CDE6}"/>
               </a:ext>
             </a:extLst>
           </p:cNvPr>
@@ -12446,7 +12712,7 @@
           <p:cNvPr id="12" name="">
             <a:extLst xmlns:a="http://schemas.openxmlformats.org/drawingml/2006/main">
               <a:ext uri="{FF2B5EF4-FFF2-40B4-BE49-F238E27FC236}">
-                <a16:creationId xmlns:a16="http://schemas.microsoft.com/office/drawing/2014/main" id="{042C497B-6810-4339-A13D-AB9FB5B7BF00}"/>
+                <a16:creationId xmlns:a16="http://schemas.microsoft.com/office/drawing/2014/main" id="{6DB49798-8C06-4D3D-960E-C38AD02186B8}"/>
               </a:ext>
             </a:extLst>
           </p:cNvPr>
@@ -12496,7 +12762,7 @@
           <p:cNvPr id="13" name="">
             <a:extLst xmlns:a="http://schemas.openxmlformats.org/drawingml/2006/main">
               <a:ext uri="{FF2B5EF4-FFF2-40B4-BE49-F238E27FC236}">
-                <a16:creationId xmlns:a16="http://schemas.microsoft.com/office/drawing/2014/main" id="{6006259B-25F6-4FF2-AFBA-BA5B25ED542A}"/>
+                <a16:creationId xmlns:a16="http://schemas.microsoft.com/office/drawing/2014/main" id="{A053A99C-88F7-49A3-A86B-65DECDE6338E}"/>
               </a:ext>
             </a:extLst>
           </p:cNvPr>
@@ -12546,7 +12812,7 @@
           <p:cNvPr id="14" name="">
             <a:extLst xmlns:a="http://schemas.openxmlformats.org/drawingml/2006/main">
               <a:ext uri="{FF2B5EF4-FFF2-40B4-BE49-F238E27FC236}">
-                <a16:creationId xmlns:a16="http://schemas.microsoft.com/office/drawing/2014/main" id="{E0297FEA-AC49-4392-9AE6-08E0D6632DF8}"/>
+                <a16:creationId xmlns:a16="http://schemas.microsoft.com/office/drawing/2014/main" id="{79FB7CB5-90B9-4F38-8E4A-C6E7C3ACD238}"/>
               </a:ext>
             </a:extLst>
           </p:cNvPr>
@@ -12577,7 +12843,7 @@
           <p:cNvPr id="15" name="">
             <a:extLst xmlns:a="http://schemas.openxmlformats.org/drawingml/2006/main">
               <a:ext uri="{FF2B5EF4-FFF2-40B4-BE49-F238E27FC236}">
-                <a16:creationId xmlns:a16="http://schemas.microsoft.com/office/drawing/2014/main" id="{5CD174ED-05F7-4E49-AD27-D1982DCD9550}"/>
+                <a16:creationId xmlns:a16="http://schemas.microsoft.com/office/drawing/2014/main" id="{1A8A2D35-604F-42D7-B0C6-85BC31F842EC}"/>
               </a:ext>
             </a:extLst>
           </p:cNvPr>
@@ -12627,7 +12893,7 @@
           <p:cNvPr id="16" name="">
             <a:extLst xmlns:a="http://schemas.openxmlformats.org/drawingml/2006/main">
               <a:ext uri="{FF2B5EF4-FFF2-40B4-BE49-F238E27FC236}">
-                <a16:creationId xmlns:a16="http://schemas.microsoft.com/office/drawing/2014/main" id="{6808901D-D9B6-43FF-88DC-9775463BBB81}"/>
+                <a16:creationId xmlns:a16="http://schemas.microsoft.com/office/drawing/2014/main" id="{BB82BB1E-23A8-4956-8B84-090EBF43F378}"/>
               </a:ext>
             </a:extLst>
           </p:cNvPr>
@@ -12677,7 +12943,7 @@
           <p:cNvPr id="17" name="">
             <a:extLst xmlns:a="http://schemas.openxmlformats.org/drawingml/2006/main">
               <a:ext uri="{FF2B5EF4-FFF2-40B4-BE49-F238E27FC236}">
-                <a16:creationId xmlns:a16="http://schemas.microsoft.com/office/drawing/2014/main" id="{6C82481E-BD72-4698-A253-8CA92B24FE7F}"/>
+                <a16:creationId xmlns:a16="http://schemas.microsoft.com/office/drawing/2014/main" id="{E65CD9B0-3284-414F-AF35-122A45B7BDA2}"/>
               </a:ext>
             </a:extLst>
           </p:cNvPr>
@@ -12706,7 +12972,7 @@
     </p:spTree>
     <p:extLst>
       <p:ext uri="{BB962C8B-B14F-4D97-AF65-F5344CB8AC3E}">
-        <p14:creationId xmlns:p14="http://schemas.microsoft.com/office/powerpoint/2010/main" val="2005111627"/>
+        <p14:creationId xmlns:p14="http://schemas.microsoft.com/office/powerpoint/2010/main" val="858152912"/>
       </p:ext>
     </p:extLst>
   </p:cSld>
@@ -12737,7 +13003,7 @@
           <p:cNvPr id="15" name="">
             <a:extLst xmlns:a="http://schemas.openxmlformats.org/drawingml/2006/main">
               <a:ext uri="{FF2B5EF4-FFF2-40B4-BE49-F238E27FC236}">
-                <a16:creationId xmlns:a16="http://schemas.microsoft.com/office/drawing/2014/main" id="{28A4AAA5-CA8D-4E48-AB49-70004CCA23BF}"/>
+                <a16:creationId xmlns:a16="http://schemas.microsoft.com/office/drawing/2014/main" id="{23F595BB-A53B-46F3-8F72-089B73B7E725}"/>
               </a:ext>
             </a:extLst>
           </p:cNvPr>
@@ -12787,7 +13053,7 @@
           <p:cNvPr id="2" name="">
             <a:extLst xmlns:a="http://schemas.openxmlformats.org/drawingml/2006/main">
               <a:ext uri="{FF2B5EF4-FFF2-40B4-BE49-F238E27FC236}">
-                <a16:creationId xmlns:a16="http://schemas.microsoft.com/office/drawing/2014/main" id="{51D6B1FE-4195-407D-AA40-DB401CE20052}"/>
+                <a16:creationId xmlns:a16="http://schemas.microsoft.com/office/drawing/2014/main" id="{C2B60E09-DBE5-40C7-9FC9-20DC7B76961D}"/>
               </a:ext>
             </a:extLst>
           </p:cNvPr>
@@ -12837,7 +13103,7 @@
           <p:cNvPr id="3" name="">
             <a:extLst xmlns:a="http://schemas.openxmlformats.org/drawingml/2006/main">
               <a:ext uri="{FF2B5EF4-FFF2-40B4-BE49-F238E27FC236}">
-                <a16:creationId xmlns:a16="http://schemas.microsoft.com/office/drawing/2014/main" id="{5B849BD1-9881-47C1-B5DD-7BF1E8B13269}"/>
+                <a16:creationId xmlns:a16="http://schemas.microsoft.com/office/drawing/2014/main" id="{D1E35042-2083-4618-AD73-C16871D524D9}"/>
               </a:ext>
             </a:extLst>
           </p:cNvPr>
@@ -12868,7 +13134,7 @@
           <p:cNvPr id="4" name="">
             <a:extLst xmlns:a="http://schemas.openxmlformats.org/drawingml/2006/main">
               <a:ext uri="{FF2B5EF4-FFF2-40B4-BE49-F238E27FC236}">
-                <a16:creationId xmlns:a16="http://schemas.microsoft.com/office/drawing/2014/main" id="{1884C881-8569-4A65-839C-93428331DDEA}"/>
+                <a16:creationId xmlns:a16="http://schemas.microsoft.com/office/drawing/2014/main" id="{9F201EFC-203C-44A5-96B5-863A9BC737FC}"/>
               </a:ext>
             </a:extLst>
           </p:cNvPr>
@@ -12918,7 +13184,7 @@
           <p:cNvPr id="5" name="">
             <a:extLst xmlns:a="http://schemas.openxmlformats.org/drawingml/2006/main">
               <a:ext uri="{FF2B5EF4-FFF2-40B4-BE49-F238E27FC236}">
-                <a16:creationId xmlns:a16="http://schemas.microsoft.com/office/drawing/2014/main" id="{49586DB3-1AFE-4CCF-9C7E-6BF8C1AC2992}"/>
+                <a16:creationId xmlns:a16="http://schemas.microsoft.com/office/drawing/2014/main" id="{08410B61-8E77-4AD3-ABAE-B11D96790514}"/>
               </a:ext>
             </a:extLst>
           </p:cNvPr>
@@ -12968,7 +13234,7 @@
           <p:cNvPr id="6" name="">
             <a:extLst xmlns:a="http://schemas.openxmlformats.org/drawingml/2006/main">
               <a:ext uri="{FF2B5EF4-FFF2-40B4-BE49-F238E27FC236}">
-                <a16:creationId xmlns:a16="http://schemas.microsoft.com/office/drawing/2014/main" id="{7646F675-786E-49A3-8328-C57727CB77FC}"/>
+                <a16:creationId xmlns:a16="http://schemas.microsoft.com/office/drawing/2014/main" id="{53EAD7AC-F8BE-4094-B8C3-98249385DAF3}"/>
               </a:ext>
             </a:extLst>
           </p:cNvPr>
@@ -13022,25 +13288,25 @@
           <p:cNvPr id="7" name="">
             <a:extLst xmlns:a="http://schemas.openxmlformats.org/drawingml/2006/main">
               <a:ext uri="{FF2B5EF4-FFF2-40B4-BE49-F238E27FC236}">
-                <a16:creationId xmlns:a16="http://schemas.microsoft.com/office/drawing/2014/main" id="{B5A50C1F-AFC2-41CD-B4EF-C29AFE2B8211}"/>
-              </a:ext>
-            </a:extLst>
-          </p:cNvPr>
-          <p:cNvSpPr>
-            <a:spLocks xmlns:a="http://schemas.openxmlformats.org/drawingml/2006/main" noGrp="1"/>
-          </p:cNvSpPr>
-          <p:nvPr/>
-        </p:nvSpPr>
-        <p:spPr>
-          <a:xfrm xmlns:a="http://schemas.openxmlformats.org/drawingml/2006/main">
-            <a:off x="3086100" y="2876550"/>
-            <a:ext cx="419100" cy="209550"/>
+                <a16:creationId xmlns:a16="http://schemas.microsoft.com/office/drawing/2014/main" id="{2AB287B2-2DED-4C43-86DC-8AB5834250A4}"/>
+              </a:ext>
+            </a:extLst>
+          </p:cNvPr>
+          <p:cNvSpPr>
+            <a:spLocks xmlns:a="http://schemas.openxmlformats.org/drawingml/2006/main" noGrp="1"/>
+          </p:cNvSpPr>
+          <p:nvPr/>
+        </p:nvSpPr>
+        <p:spPr>
+          <a:xfrm xmlns:a="http://schemas.openxmlformats.org/drawingml/2006/main">
+            <a:off x="3067050" y="2828925"/>
+            <a:ext cx="609600" cy="323850"/>
           </a:xfrm>
           <a:prstGeom xmlns:a="http://schemas.openxmlformats.org/drawingml/2006/main" prst="rightArrow">
             <a:avLst/>
           </a:prstGeom>
           <a:solidFill xmlns:a="http://schemas.openxmlformats.org/drawingml/2006/main">
-            <a:srgbClr val="5D6B78"/>
+            <a:srgbClr val="102A43"/>
           </a:solidFill>
           <a:ln xmlns:a="http://schemas.openxmlformats.org/drawingml/2006/main" w="0">
             <a:noFill/>
@@ -13053,7 +13319,7 @@
           <p:cNvPr id="8" name="">
             <a:extLst xmlns:a="http://schemas.openxmlformats.org/drawingml/2006/main">
               <a:ext uri="{FF2B5EF4-FFF2-40B4-BE49-F238E27FC236}">
-                <a16:creationId xmlns:a16="http://schemas.microsoft.com/office/drawing/2014/main" id="{729D798E-F02A-468A-A5AB-541FBA23092C}"/>
+                <a16:creationId xmlns:a16="http://schemas.microsoft.com/office/drawing/2014/main" id="{4C796B3C-DDD6-4F53-96C2-56D4613E1D6B}"/>
               </a:ext>
             </a:extLst>
           </p:cNvPr>
@@ -13107,7 +13373,7 @@
           <p:cNvPr id="9" name="">
             <a:extLst xmlns:a="http://schemas.openxmlformats.org/drawingml/2006/main">
               <a:ext uri="{FF2B5EF4-FFF2-40B4-BE49-F238E27FC236}">
-                <a16:creationId xmlns:a16="http://schemas.microsoft.com/office/drawing/2014/main" id="{9145F335-B2C2-4E70-BA5A-7961A55CB055}"/>
+                <a16:creationId xmlns:a16="http://schemas.microsoft.com/office/drawing/2014/main" id="{62DB0356-FD73-4BBD-9ED5-BB91EBB63B8E}"/>
               </a:ext>
             </a:extLst>
           </p:cNvPr>
@@ -13161,7 +13427,7 @@
           <p:cNvPr id="10" name="">
             <a:extLst xmlns:a="http://schemas.openxmlformats.org/drawingml/2006/main">
               <a:ext uri="{FF2B5EF4-FFF2-40B4-BE49-F238E27FC236}">
-                <a16:creationId xmlns:a16="http://schemas.microsoft.com/office/drawing/2014/main" id="{D1EEC720-DD7E-4AF3-A170-86A49F4B22D0}"/>
+                <a16:creationId xmlns:a16="http://schemas.microsoft.com/office/drawing/2014/main" id="{5870D470-6A04-4774-86A2-A23449618EA5}"/>
               </a:ext>
             </a:extLst>
           </p:cNvPr>
@@ -13215,7 +13481,7 @@
           <p:cNvPr id="11" name="">
             <a:extLst xmlns:a="http://schemas.openxmlformats.org/drawingml/2006/main">
               <a:ext uri="{FF2B5EF4-FFF2-40B4-BE49-F238E27FC236}">
-                <a16:creationId xmlns:a16="http://schemas.microsoft.com/office/drawing/2014/main" id="{51257220-80D4-4F6D-A2A1-829A6F5A205C}"/>
+                <a16:creationId xmlns:a16="http://schemas.microsoft.com/office/drawing/2014/main" id="{210FE21D-FE3C-439A-966F-CC30526212E9}"/>
               </a:ext>
             </a:extLst>
           </p:cNvPr>
@@ -13265,7 +13531,7 @@
           <p:cNvPr id="12" name="">
             <a:extLst xmlns:a="http://schemas.openxmlformats.org/drawingml/2006/main">
               <a:ext uri="{FF2B5EF4-FFF2-40B4-BE49-F238E27FC236}">
-                <a16:creationId xmlns:a16="http://schemas.microsoft.com/office/drawing/2014/main" id="{31717984-1C9E-4751-AE0A-BFC53535CAA3}"/>
+                <a16:creationId xmlns:a16="http://schemas.microsoft.com/office/drawing/2014/main" id="{3B23E334-D0F3-4B72-B6E9-DBF82B4B7DB1}"/>
               </a:ext>
             </a:extLst>
           </p:cNvPr>
@@ -13300,7 +13566,7 @@
           <p:cNvPr id="13" name="">
             <a:extLst xmlns:a="http://schemas.openxmlformats.org/drawingml/2006/main">
               <a:ext uri="{FF2B5EF4-FFF2-40B4-BE49-F238E27FC236}">
-                <a16:creationId xmlns:a16="http://schemas.microsoft.com/office/drawing/2014/main" id="{C388001F-0359-4020-A205-9AA92B064CA3}"/>
+                <a16:creationId xmlns:a16="http://schemas.microsoft.com/office/drawing/2014/main" id="{36FB7415-A66E-472F-AAB2-5420B9364C31}"/>
               </a:ext>
             </a:extLst>
           </p:cNvPr>
@@ -13350,7 +13616,7 @@
           <p:cNvPr id="14" name="">
             <a:extLst xmlns:a="http://schemas.openxmlformats.org/drawingml/2006/main">
               <a:ext uri="{FF2B5EF4-FFF2-40B4-BE49-F238E27FC236}">
-                <a16:creationId xmlns:a16="http://schemas.microsoft.com/office/drawing/2014/main" id="{1E969EA1-6014-4797-A7B1-BFFA10F5B8CA}"/>
+                <a16:creationId xmlns:a16="http://schemas.microsoft.com/office/drawing/2014/main" id="{2D69BC38-CA78-4CC5-9CAA-CA41E14DCB55}"/>
               </a:ext>
             </a:extLst>
           </p:cNvPr>
@@ -13442,7 +13708,7 @@
     </p:spTree>
     <p:extLst>
       <p:ext uri="{BB962C8B-B14F-4D97-AF65-F5344CB8AC3E}">
-        <p14:creationId xmlns:p14="http://schemas.microsoft.com/office/powerpoint/2010/main" val="206225133"/>
+        <p14:creationId xmlns:p14="http://schemas.microsoft.com/office/powerpoint/2010/main" val="453276888"/>
       </p:ext>
     </p:extLst>
   </p:cSld>
@@ -13473,7 +13739,7 @@
           <p:cNvPr id="15" name="">
             <a:extLst xmlns:a="http://schemas.openxmlformats.org/drawingml/2006/main">
               <a:ext uri="{FF2B5EF4-FFF2-40B4-BE49-F238E27FC236}">
-                <a16:creationId xmlns:a16="http://schemas.microsoft.com/office/drawing/2014/main" id="{126B7810-FDCA-4C1A-9310-D1CE7906C2BA}"/>
+                <a16:creationId xmlns:a16="http://schemas.microsoft.com/office/drawing/2014/main" id="{87AE4038-A33E-4076-B9F4-5A21FC1F37BE}"/>
               </a:ext>
             </a:extLst>
           </p:cNvPr>
@@ -13523,7 +13789,7 @@
           <p:cNvPr id="2" name="">
             <a:extLst xmlns:a="http://schemas.openxmlformats.org/drawingml/2006/main">
               <a:ext uri="{FF2B5EF4-FFF2-40B4-BE49-F238E27FC236}">
-                <a16:creationId xmlns:a16="http://schemas.microsoft.com/office/drawing/2014/main" id="{68317D33-1E71-4301-AD0C-3D4611C4926D}"/>
+                <a16:creationId xmlns:a16="http://schemas.microsoft.com/office/drawing/2014/main" id="{CBE9F4B2-8622-4501-A520-7948E909C08A}"/>
               </a:ext>
             </a:extLst>
           </p:cNvPr>
@@ -13573,7 +13839,7 @@
           <p:cNvPr id="3" name="">
             <a:extLst xmlns:a="http://schemas.openxmlformats.org/drawingml/2006/main">
               <a:ext uri="{FF2B5EF4-FFF2-40B4-BE49-F238E27FC236}">
-                <a16:creationId xmlns:a16="http://schemas.microsoft.com/office/drawing/2014/main" id="{D9BE7C06-FAA4-4216-A2C6-93747891AB9C}"/>
+                <a16:creationId xmlns:a16="http://schemas.microsoft.com/office/drawing/2014/main" id="{57DBA9D2-D5C5-4A4D-8ECD-45230F3372C9}"/>
               </a:ext>
             </a:extLst>
           </p:cNvPr>
@@ -13604,7 +13870,7 @@
           <p:cNvPr id="4" name="">
             <a:extLst xmlns:a="http://schemas.openxmlformats.org/drawingml/2006/main">
               <a:ext uri="{FF2B5EF4-FFF2-40B4-BE49-F238E27FC236}">
-                <a16:creationId xmlns:a16="http://schemas.microsoft.com/office/drawing/2014/main" id="{0004CA5C-1626-4C6A-9591-FF58F2CB8322}"/>
+                <a16:creationId xmlns:a16="http://schemas.microsoft.com/office/drawing/2014/main" id="{78631725-CD8C-49A7-8A46-99BC8E98E703}"/>
               </a:ext>
             </a:extLst>
           </p:cNvPr>
@@ -13654,7 +13920,7 @@
           <p:cNvPr id="5" name="">
             <a:extLst xmlns:a="http://schemas.openxmlformats.org/drawingml/2006/main">
               <a:ext uri="{FF2B5EF4-FFF2-40B4-BE49-F238E27FC236}">
-                <a16:creationId xmlns:a16="http://schemas.microsoft.com/office/drawing/2014/main" id="{960B7C98-1A31-431A-BD99-62CFF8E9D8E8}"/>
+                <a16:creationId xmlns:a16="http://schemas.microsoft.com/office/drawing/2014/main" id="{766735E4-B755-4CE9-AF6E-432CE042EBCE}"/>
               </a:ext>
             </a:extLst>
           </p:cNvPr>
@@ -13704,7 +13970,7 @@
           <p:cNvPr id="6" name="">
             <a:extLst xmlns:a="http://schemas.openxmlformats.org/drawingml/2006/main">
               <a:ext uri="{FF2B5EF4-FFF2-40B4-BE49-F238E27FC236}">
-                <a16:creationId xmlns:a16="http://schemas.microsoft.com/office/drawing/2014/main" id="{38091259-242E-402F-A25B-49F77888F528}"/>
+                <a16:creationId xmlns:a16="http://schemas.microsoft.com/office/drawing/2014/main" id="{C3DC0C40-A5F4-4607-8154-9E6E5E5270DE}"/>
               </a:ext>
             </a:extLst>
           </p:cNvPr>
@@ -13739,7 +14005,7 @@
           <p:cNvPr id="7" name="">
             <a:extLst xmlns:a="http://schemas.openxmlformats.org/drawingml/2006/main">
               <a:ext uri="{FF2B5EF4-FFF2-40B4-BE49-F238E27FC236}">
-                <a16:creationId xmlns:a16="http://schemas.microsoft.com/office/drawing/2014/main" id="{0434BDA6-7193-44AB-8E37-9251B456951E}"/>
+                <a16:creationId xmlns:a16="http://schemas.microsoft.com/office/drawing/2014/main" id="{DFF5DB53-B582-41ED-B05F-C933C08507D2}"/>
               </a:ext>
             </a:extLst>
           </p:cNvPr>
@@ -13789,7 +14055,7 @@
           <p:cNvPr id="8" name="">
             <a:extLst xmlns:a="http://schemas.openxmlformats.org/drawingml/2006/main">
               <a:ext uri="{FF2B5EF4-FFF2-40B4-BE49-F238E27FC236}">
-                <a16:creationId xmlns:a16="http://schemas.microsoft.com/office/drawing/2014/main" id="{79FF1344-4940-4932-B995-D9E47C24616D}"/>
+                <a16:creationId xmlns:a16="http://schemas.microsoft.com/office/drawing/2014/main" id="{867DD451-E4C4-40BE-933D-4734C2E0E78C}"/>
               </a:ext>
             </a:extLst>
           </p:cNvPr>
@@ -13907,7 +14173,7 @@
           <p:cNvPr id="9" name="">
             <a:extLst xmlns:a="http://schemas.openxmlformats.org/drawingml/2006/main">
               <a:ext uri="{FF2B5EF4-FFF2-40B4-BE49-F238E27FC236}">
-                <a16:creationId xmlns:a16="http://schemas.microsoft.com/office/drawing/2014/main" id="{D67B73FE-075F-4D8D-93BA-F60327550E99}"/>
+                <a16:creationId xmlns:a16="http://schemas.microsoft.com/office/drawing/2014/main" id="{8779E068-D984-4DE4-A2E4-A680206D6505}"/>
               </a:ext>
             </a:extLst>
           </p:cNvPr>
@@ -13957,7 +14223,7 @@
           <p:cNvPr id="10" name="">
             <a:extLst xmlns:a="http://schemas.openxmlformats.org/drawingml/2006/main">
               <a:ext uri="{FF2B5EF4-FFF2-40B4-BE49-F238E27FC236}">
-                <a16:creationId xmlns:a16="http://schemas.microsoft.com/office/drawing/2014/main" id="{25BDE01D-4F2B-4E2D-A335-542754EC5661}"/>
+                <a16:creationId xmlns:a16="http://schemas.microsoft.com/office/drawing/2014/main" id="{64609797-23D2-43F8-9324-D95695453E60}"/>
               </a:ext>
             </a:extLst>
           </p:cNvPr>
@@ -14007,7 +14273,7 @@
           <p:cNvPr id="11" name="">
             <a:extLst xmlns:a="http://schemas.openxmlformats.org/drawingml/2006/main">
               <a:ext uri="{FF2B5EF4-FFF2-40B4-BE49-F238E27FC236}">
-                <a16:creationId xmlns:a16="http://schemas.microsoft.com/office/drawing/2014/main" id="{C3B922E4-9F32-4008-9A6E-F5603E304910}"/>
+                <a16:creationId xmlns:a16="http://schemas.microsoft.com/office/drawing/2014/main" id="{ABB2F454-5BE7-45FD-8AB0-E8FEA9F6A556}"/>
               </a:ext>
             </a:extLst>
           </p:cNvPr>
@@ -14042,7 +14308,7 @@
           <p:cNvPr id="12" name="">
             <a:extLst xmlns:a="http://schemas.openxmlformats.org/drawingml/2006/main">
               <a:ext uri="{FF2B5EF4-FFF2-40B4-BE49-F238E27FC236}">
-                <a16:creationId xmlns:a16="http://schemas.microsoft.com/office/drawing/2014/main" id="{7638F7F7-BA70-404F-B52A-7FE4680390DB}"/>
+                <a16:creationId xmlns:a16="http://schemas.microsoft.com/office/drawing/2014/main" id="{FBA2C02D-3119-40B4-A15E-CB625A0AF34A}"/>
               </a:ext>
             </a:extLst>
           </p:cNvPr>
@@ -14092,7 +14358,7 @@
           <p:cNvPr id="13" name="">
             <a:extLst xmlns:a="http://schemas.openxmlformats.org/drawingml/2006/main">
               <a:ext uri="{FF2B5EF4-FFF2-40B4-BE49-F238E27FC236}">
-                <a16:creationId xmlns:a16="http://schemas.microsoft.com/office/drawing/2014/main" id="{F12E5054-419B-4F4F-A474-E6D4747BF388}"/>
+                <a16:creationId xmlns:a16="http://schemas.microsoft.com/office/drawing/2014/main" id="{0F852CCB-D8F3-4CDA-85A0-9685F557A92D}"/>
               </a:ext>
             </a:extLst>
           </p:cNvPr>
@@ -14278,7 +14544,7 @@
           <p:cNvPr id="14" name="">
             <a:extLst xmlns:a="http://schemas.openxmlformats.org/drawingml/2006/main">
               <a:ext uri="{FF2B5EF4-FFF2-40B4-BE49-F238E27FC236}">
-                <a16:creationId xmlns:a16="http://schemas.microsoft.com/office/drawing/2014/main" id="{21D77BB7-DC0A-44A1-9371-FC4A96E095ED}"/>
+                <a16:creationId xmlns:a16="http://schemas.microsoft.com/office/drawing/2014/main" id="{131A92D9-2769-4A7A-B74C-72BFF86C8F37}"/>
               </a:ext>
             </a:extLst>
           </p:cNvPr>
@@ -14326,7 +14592,7 @@
     </p:spTree>
     <p:extLst>
       <p:ext uri="{BB962C8B-B14F-4D97-AF65-F5344CB8AC3E}">
-        <p14:creationId xmlns:p14="http://schemas.microsoft.com/office/powerpoint/2010/main" val="1950596126"/>
+        <p14:creationId xmlns:p14="http://schemas.microsoft.com/office/powerpoint/2010/main" val="816521264"/>
       </p:ext>
     </p:extLst>
   </p:cSld>
@@ -14357,7 +14623,7 @@
           <p:cNvPr id="13" name="">
             <a:extLst xmlns:a="http://schemas.openxmlformats.org/drawingml/2006/main">
               <a:ext uri="{FF2B5EF4-FFF2-40B4-BE49-F238E27FC236}">
-                <a16:creationId xmlns:a16="http://schemas.microsoft.com/office/drawing/2014/main" id="{1F362EC7-4AF8-4F02-8664-4924AEDB9165}"/>
+                <a16:creationId xmlns:a16="http://schemas.microsoft.com/office/drawing/2014/main" id="{22DF3215-05DF-403F-ABFF-2A26D26081A8}"/>
               </a:ext>
             </a:extLst>
           </p:cNvPr>
@@ -14407,7 +14673,7 @@
           <p:cNvPr id="2" name="">
             <a:extLst xmlns:a="http://schemas.openxmlformats.org/drawingml/2006/main">
               <a:ext uri="{FF2B5EF4-FFF2-40B4-BE49-F238E27FC236}">
-                <a16:creationId xmlns:a16="http://schemas.microsoft.com/office/drawing/2014/main" id="{005366F4-FA38-4968-9FAF-140CAC42EFE7}"/>
+                <a16:creationId xmlns:a16="http://schemas.microsoft.com/office/drawing/2014/main" id="{C109D836-A6D9-46B2-BAA5-E366A0A818B1}"/>
               </a:ext>
             </a:extLst>
           </p:cNvPr>
@@ -14457,7 +14723,7 @@
           <p:cNvPr id="3" name="">
             <a:extLst xmlns:a="http://schemas.openxmlformats.org/drawingml/2006/main">
               <a:ext uri="{FF2B5EF4-FFF2-40B4-BE49-F238E27FC236}">
-                <a16:creationId xmlns:a16="http://schemas.microsoft.com/office/drawing/2014/main" id="{2E24D7BC-5FE5-403F-A920-F1365568458F}"/>
+                <a16:creationId xmlns:a16="http://schemas.microsoft.com/office/drawing/2014/main" id="{9A522A39-52EC-487A-B44A-A6C6B6C48DF5}"/>
               </a:ext>
             </a:extLst>
           </p:cNvPr>
@@ -14488,7 +14754,7 @@
           <p:cNvPr id="4" name="">
             <a:extLst xmlns:a="http://schemas.openxmlformats.org/drawingml/2006/main">
               <a:ext uri="{FF2B5EF4-FFF2-40B4-BE49-F238E27FC236}">
-                <a16:creationId xmlns:a16="http://schemas.microsoft.com/office/drawing/2014/main" id="{FA17919F-B93F-449C-83A5-C54811E323D4}"/>
+                <a16:creationId xmlns:a16="http://schemas.microsoft.com/office/drawing/2014/main" id="{C821B674-2A41-43D1-B202-1048ACF2DC7B}"/>
               </a:ext>
             </a:extLst>
           </p:cNvPr>
@@ -14538,7 +14804,7 @@
           <p:cNvPr id="5" name="">
             <a:extLst xmlns:a="http://schemas.openxmlformats.org/drawingml/2006/main">
               <a:ext uri="{FF2B5EF4-FFF2-40B4-BE49-F238E27FC236}">
-                <a16:creationId xmlns:a16="http://schemas.microsoft.com/office/drawing/2014/main" id="{FDF692AE-D9C4-42D0-B948-3029B44646EC}"/>
+                <a16:creationId xmlns:a16="http://schemas.microsoft.com/office/drawing/2014/main" id="{08FCEBA2-9B12-437B-B6E4-36F2F2F10250}"/>
               </a:ext>
             </a:extLst>
           </p:cNvPr>
@@ -14588,7 +14854,7 @@
           <p:cNvPr id="6" name="">
             <a:extLst xmlns:a="http://schemas.openxmlformats.org/drawingml/2006/main">
               <a:ext uri="{FF2B5EF4-FFF2-40B4-BE49-F238E27FC236}">
-                <a16:creationId xmlns:a16="http://schemas.microsoft.com/office/drawing/2014/main" id="{59B21C86-62BB-408D-9828-972FF18796F5}"/>
+                <a16:creationId xmlns:a16="http://schemas.microsoft.com/office/drawing/2014/main" id="{874CEE97-7E01-4573-A066-5D33ABC1DAA3}"/>
               </a:ext>
             </a:extLst>
           </p:cNvPr>
@@ -14623,7 +14889,7 @@
           <p:cNvPr id="7" name="">
             <a:extLst xmlns:a="http://schemas.openxmlformats.org/drawingml/2006/main">
               <a:ext uri="{FF2B5EF4-FFF2-40B4-BE49-F238E27FC236}">
-                <a16:creationId xmlns:a16="http://schemas.microsoft.com/office/drawing/2014/main" id="{1B1462A5-6708-4868-9E78-014D49BF2F33}"/>
+                <a16:creationId xmlns:a16="http://schemas.microsoft.com/office/drawing/2014/main" id="{A11DF0F8-0789-4D78-9E4D-24084F8C1BFA}"/>
               </a:ext>
             </a:extLst>
           </p:cNvPr>
@@ -14673,7 +14939,7 @@
           <p:cNvPr id="8" name="">
             <a:extLst xmlns:a="http://schemas.openxmlformats.org/drawingml/2006/main">
               <a:ext uri="{FF2B5EF4-FFF2-40B4-BE49-F238E27FC236}">
-                <a16:creationId xmlns:a16="http://schemas.microsoft.com/office/drawing/2014/main" id="{73CA4524-79CC-446E-BE1A-E26F587E444E}"/>
+                <a16:creationId xmlns:a16="http://schemas.microsoft.com/office/drawing/2014/main" id="{104A31BA-5D55-4628-A391-EB548B39FC7F}"/>
               </a:ext>
             </a:extLst>
           </p:cNvPr>
@@ -14825,7 +15091,7 @@
           <p:cNvPr id="9" name="">
             <a:extLst xmlns:a="http://schemas.openxmlformats.org/drawingml/2006/main">
               <a:ext uri="{FF2B5EF4-FFF2-40B4-BE49-F238E27FC236}">
-                <a16:creationId xmlns:a16="http://schemas.microsoft.com/office/drawing/2014/main" id="{DC07DB4C-A73C-4DEF-91F4-A531E508E252}"/>
+                <a16:creationId xmlns:a16="http://schemas.microsoft.com/office/drawing/2014/main" id="{98FFED1A-6AEA-43FF-B696-FD29953FA21E}"/>
               </a:ext>
             </a:extLst>
           </p:cNvPr>
@@ -14860,7 +15126,7 @@
           <p:cNvPr id="10" name="">
             <a:extLst xmlns:a="http://schemas.openxmlformats.org/drawingml/2006/main">
               <a:ext uri="{FF2B5EF4-FFF2-40B4-BE49-F238E27FC236}">
-                <a16:creationId xmlns:a16="http://schemas.microsoft.com/office/drawing/2014/main" id="{EC06546C-EE79-46FC-A1CD-CC9DCB3AE8DA}"/>
+                <a16:creationId xmlns:a16="http://schemas.microsoft.com/office/drawing/2014/main" id="{C20EFA78-0573-45E0-91F5-A67A8AAC95DD}"/>
               </a:ext>
             </a:extLst>
           </p:cNvPr>
@@ -14910,7 +15176,7 @@
           <p:cNvPr id="11" name="">
             <a:extLst xmlns:a="http://schemas.openxmlformats.org/drawingml/2006/main">
               <a:ext uri="{FF2B5EF4-FFF2-40B4-BE49-F238E27FC236}">
-                <a16:creationId xmlns:a16="http://schemas.microsoft.com/office/drawing/2014/main" id="{1434012C-C4DD-463F-8A6F-E46009013232}"/>
+                <a16:creationId xmlns:a16="http://schemas.microsoft.com/office/drawing/2014/main" id="{C1F8FFD6-4C94-4E0D-9319-2A15AD9B8120}"/>
               </a:ext>
             </a:extLst>
           </p:cNvPr>
@@ -15055,7 +15321,7 @@
           <p:cNvPr id="12" name="">
             <a:extLst xmlns:a="http://schemas.openxmlformats.org/drawingml/2006/main">
               <a:ext uri="{FF2B5EF4-FFF2-40B4-BE49-F238E27FC236}">
-                <a16:creationId xmlns:a16="http://schemas.microsoft.com/office/drawing/2014/main" id="{A515B844-2392-4675-8E05-07518C27DC2E}"/>
+                <a16:creationId xmlns:a16="http://schemas.microsoft.com/office/drawing/2014/main" id="{6B0D9CA0-445D-4AFB-AB09-17C0C81FC22E}"/>
               </a:ext>
             </a:extLst>
           </p:cNvPr>
@@ -15103,7 +15369,7 @@
     </p:spTree>
     <p:extLst>
       <p:ext uri="{BB962C8B-B14F-4D97-AF65-F5344CB8AC3E}">
-        <p14:creationId xmlns:p14="http://schemas.microsoft.com/office/powerpoint/2010/main" val="1821411112"/>
+        <p14:creationId xmlns:p14="http://schemas.microsoft.com/office/powerpoint/2010/main" val="1852785290"/>
       </p:ext>
     </p:extLst>
   </p:cSld>
@@ -15134,7 +15400,7 @@
           <p:cNvPr id="18" name="">
             <a:extLst xmlns:a="http://schemas.openxmlformats.org/drawingml/2006/main">
               <a:ext uri="{FF2B5EF4-FFF2-40B4-BE49-F238E27FC236}">
-                <a16:creationId xmlns:a16="http://schemas.microsoft.com/office/drawing/2014/main" id="{1AB4B7DF-8E0F-423D-A9B2-A48A3165C5A6}"/>
+                <a16:creationId xmlns:a16="http://schemas.microsoft.com/office/drawing/2014/main" id="{E1DB65D3-6BE7-4AF5-BDCD-A85DBA4C2779}"/>
               </a:ext>
             </a:extLst>
           </p:cNvPr>
@@ -15184,7 +15450,7 @@
           <p:cNvPr id="2" name="">
             <a:extLst xmlns:a="http://schemas.openxmlformats.org/drawingml/2006/main">
               <a:ext uri="{FF2B5EF4-FFF2-40B4-BE49-F238E27FC236}">
-                <a16:creationId xmlns:a16="http://schemas.microsoft.com/office/drawing/2014/main" id="{1F7E7CFC-E146-4F8F-BE8C-46F98A3E151A}"/>
+                <a16:creationId xmlns:a16="http://schemas.microsoft.com/office/drawing/2014/main" id="{A0C01F30-9F0D-4922-BE4E-CC5C1A6E87AB}"/>
               </a:ext>
             </a:extLst>
           </p:cNvPr>
@@ -15234,7 +15500,7 @@
           <p:cNvPr id="3" name="">
             <a:extLst xmlns:a="http://schemas.openxmlformats.org/drawingml/2006/main">
               <a:ext uri="{FF2B5EF4-FFF2-40B4-BE49-F238E27FC236}">
-                <a16:creationId xmlns:a16="http://schemas.microsoft.com/office/drawing/2014/main" id="{B5234C8E-5020-4FDF-8B5D-6F74F62AEDB3}"/>
+                <a16:creationId xmlns:a16="http://schemas.microsoft.com/office/drawing/2014/main" id="{7A74605B-B262-4C7C-8557-E1FDE024244A}"/>
               </a:ext>
             </a:extLst>
           </p:cNvPr>
@@ -15265,7 +15531,7 @@
           <p:cNvPr id="4" name="">
             <a:extLst xmlns:a="http://schemas.openxmlformats.org/drawingml/2006/main">
               <a:ext uri="{FF2B5EF4-FFF2-40B4-BE49-F238E27FC236}">
-                <a16:creationId xmlns:a16="http://schemas.microsoft.com/office/drawing/2014/main" id="{B4D0A2E9-09F2-47E6-BC49-61893DF3B22D}"/>
+                <a16:creationId xmlns:a16="http://schemas.microsoft.com/office/drawing/2014/main" id="{5B683007-2ADF-4DBE-B030-AB3D968CE68A}"/>
               </a:ext>
             </a:extLst>
           </p:cNvPr>
@@ -15315,7 +15581,7 @@
           <p:cNvPr id="5" name="">
             <a:extLst xmlns:a="http://schemas.openxmlformats.org/drawingml/2006/main">
               <a:ext uri="{FF2B5EF4-FFF2-40B4-BE49-F238E27FC236}">
-                <a16:creationId xmlns:a16="http://schemas.microsoft.com/office/drawing/2014/main" id="{1330E21C-61AC-4C81-80C5-CE6F869C66A0}"/>
+                <a16:creationId xmlns:a16="http://schemas.microsoft.com/office/drawing/2014/main" id="{47B17408-6E2D-4B4E-8514-35190C31804B}"/>
               </a:ext>
             </a:extLst>
           </p:cNvPr>
@@ -15365,7 +15631,7 @@
           <p:cNvPr id="6" name="">
             <a:extLst xmlns:a="http://schemas.openxmlformats.org/drawingml/2006/main">
               <a:ext uri="{FF2B5EF4-FFF2-40B4-BE49-F238E27FC236}">
-                <a16:creationId xmlns:a16="http://schemas.microsoft.com/office/drawing/2014/main" id="{5C6C91DB-1310-48B9-8640-70D0A996987B}"/>
+                <a16:creationId xmlns:a16="http://schemas.microsoft.com/office/drawing/2014/main" id="{B2AA53BC-450F-494C-AFFE-EA440F1177C5}"/>
               </a:ext>
             </a:extLst>
           </p:cNvPr>
@@ -15400,7 +15666,7 @@
           <p:cNvPr id="7" name="">
             <a:extLst xmlns:a="http://schemas.openxmlformats.org/drawingml/2006/main">
               <a:ext uri="{FF2B5EF4-FFF2-40B4-BE49-F238E27FC236}">
-                <a16:creationId xmlns:a16="http://schemas.microsoft.com/office/drawing/2014/main" id="{7E12CB01-1DF8-499D-A327-20491F37092B}"/>
+                <a16:creationId xmlns:a16="http://schemas.microsoft.com/office/drawing/2014/main" id="{AF76F643-3DA1-4B42-AD4A-218027AA1B48}"/>
               </a:ext>
             </a:extLst>
           </p:cNvPr>
@@ -15450,7 +15716,7 @@
           <p:cNvPr id="8" name="">
             <a:extLst xmlns:a="http://schemas.openxmlformats.org/drawingml/2006/main">
               <a:ext uri="{FF2B5EF4-FFF2-40B4-BE49-F238E27FC236}">
-                <a16:creationId xmlns:a16="http://schemas.microsoft.com/office/drawing/2014/main" id="{B0D21E44-9A82-45B6-90EB-0F7DDA9A766F}"/>
+                <a16:creationId xmlns:a16="http://schemas.microsoft.com/office/drawing/2014/main" id="{39F3CEC0-D988-40C0-AA4B-A7BEAEC239C1}"/>
               </a:ext>
             </a:extLst>
           </p:cNvPr>
@@ -15500,7 +15766,7 @@
           <p:cNvPr id="9" name="">
             <a:extLst xmlns:a="http://schemas.openxmlformats.org/drawingml/2006/main">
               <a:ext uri="{FF2B5EF4-FFF2-40B4-BE49-F238E27FC236}">
-                <a16:creationId xmlns:a16="http://schemas.microsoft.com/office/drawing/2014/main" id="{3A119C88-E985-43A9-A2F1-4A5CFEAA5D2D}"/>
+                <a16:creationId xmlns:a16="http://schemas.microsoft.com/office/drawing/2014/main" id="{1DB7F1E0-727A-4CD3-AE63-21FA2FFB8408}"/>
               </a:ext>
             </a:extLst>
           </p:cNvPr>
@@ -15535,7 +15801,7 @@
           <p:cNvPr id="10" name="">
             <a:extLst xmlns:a="http://schemas.openxmlformats.org/drawingml/2006/main">
               <a:ext uri="{FF2B5EF4-FFF2-40B4-BE49-F238E27FC236}">
-                <a16:creationId xmlns:a16="http://schemas.microsoft.com/office/drawing/2014/main" id="{5CCF0572-B06A-4AE1-82C9-8F6CF2E0853B}"/>
+                <a16:creationId xmlns:a16="http://schemas.microsoft.com/office/drawing/2014/main" id="{88320B9A-96EA-4F77-9A5B-594F7B639962}"/>
               </a:ext>
             </a:extLst>
           </p:cNvPr>
@@ -15585,7 +15851,7 @@
           <p:cNvPr id="11" name="">
             <a:extLst xmlns:a="http://schemas.openxmlformats.org/drawingml/2006/main">
               <a:ext uri="{FF2B5EF4-FFF2-40B4-BE49-F238E27FC236}">
-                <a16:creationId xmlns:a16="http://schemas.microsoft.com/office/drawing/2014/main" id="{F46C482A-0400-486B-ABA0-20B180127452}"/>
+                <a16:creationId xmlns:a16="http://schemas.microsoft.com/office/drawing/2014/main" id="{32C74E3F-0F74-453A-AF97-64335F319E27}"/>
               </a:ext>
             </a:extLst>
           </p:cNvPr>
@@ -15635,7 +15901,7 @@
           <p:cNvPr id="12" name="">
             <a:extLst xmlns:a="http://schemas.openxmlformats.org/drawingml/2006/main">
               <a:ext uri="{FF2B5EF4-FFF2-40B4-BE49-F238E27FC236}">
-                <a16:creationId xmlns:a16="http://schemas.microsoft.com/office/drawing/2014/main" id="{DDA084D6-E044-4527-BFCD-5237EB6ED97E}"/>
+                <a16:creationId xmlns:a16="http://schemas.microsoft.com/office/drawing/2014/main" id="{D20940C0-E141-49C6-B111-7B0EEECEC1EA}"/>
               </a:ext>
             </a:extLst>
           </p:cNvPr>
@@ -15670,7 +15936,7 @@
           <p:cNvPr id="13" name="">
             <a:extLst xmlns:a="http://schemas.openxmlformats.org/drawingml/2006/main">
               <a:ext uri="{FF2B5EF4-FFF2-40B4-BE49-F238E27FC236}">
-                <a16:creationId xmlns:a16="http://schemas.microsoft.com/office/drawing/2014/main" id="{7C70EB2F-5F5C-4927-99DF-F49ED4069CEC}"/>
+                <a16:creationId xmlns:a16="http://schemas.microsoft.com/office/drawing/2014/main" id="{74E2ABE4-6286-4537-B5B4-A84BE28FD68B}"/>
               </a:ext>
             </a:extLst>
           </p:cNvPr>
@@ -15720,7 +15986,7 @@
           <p:cNvPr id="14" name="">
             <a:extLst xmlns:a="http://schemas.openxmlformats.org/drawingml/2006/main">
               <a:ext uri="{FF2B5EF4-FFF2-40B4-BE49-F238E27FC236}">
-                <a16:creationId xmlns:a16="http://schemas.microsoft.com/office/drawing/2014/main" id="{FEB9010A-AA3F-448B-A760-7C2EF5B9F261}"/>
+                <a16:creationId xmlns:a16="http://schemas.microsoft.com/office/drawing/2014/main" id="{2885447F-8DC5-4B14-B1C6-46DB7C2E4F0B}"/>
               </a:ext>
             </a:extLst>
           </p:cNvPr>
@@ -15770,7 +16036,7 @@
           <p:cNvPr id="15" name="">
             <a:extLst xmlns:a="http://schemas.openxmlformats.org/drawingml/2006/main">
               <a:ext uri="{FF2B5EF4-FFF2-40B4-BE49-F238E27FC236}">
-                <a16:creationId xmlns:a16="http://schemas.microsoft.com/office/drawing/2014/main" id="{ADA9E420-3EE7-451E-8A69-1946B791791B}"/>
+                <a16:creationId xmlns:a16="http://schemas.microsoft.com/office/drawing/2014/main" id="{9AF2E414-15F3-4F23-88E7-860544AD6D3A}"/>
               </a:ext>
             </a:extLst>
           </p:cNvPr>
@@ -15805,7 +16071,7 @@
           <p:cNvPr id="16" name="">
             <a:extLst xmlns:a="http://schemas.openxmlformats.org/drawingml/2006/main">
               <a:ext uri="{FF2B5EF4-FFF2-40B4-BE49-F238E27FC236}">
-                <a16:creationId xmlns:a16="http://schemas.microsoft.com/office/drawing/2014/main" id="{4B41C34A-A7BD-465A-939A-A9B4A67A494F}"/>
+                <a16:creationId xmlns:a16="http://schemas.microsoft.com/office/drawing/2014/main" id="{F808A3BD-976D-49D0-A928-3E1F3E3280AF}"/>
               </a:ext>
             </a:extLst>
           </p:cNvPr>
@@ -15855,7 +16121,7 @@
           <p:cNvPr id="17" name="">
             <a:extLst xmlns:a="http://schemas.openxmlformats.org/drawingml/2006/main">
               <a:ext uri="{FF2B5EF4-FFF2-40B4-BE49-F238E27FC236}">
-                <a16:creationId xmlns:a16="http://schemas.microsoft.com/office/drawing/2014/main" id="{865CFF61-F019-4C4A-891B-A90A5E5AB272}"/>
+                <a16:creationId xmlns:a16="http://schemas.microsoft.com/office/drawing/2014/main" id="{2AAD1BF2-E82B-49FE-97A0-CF85662FEFFF}"/>
               </a:ext>
             </a:extLst>
           </p:cNvPr>
@@ -15903,7 +16169,7 @@
     </p:spTree>
     <p:extLst>
       <p:ext uri="{BB962C8B-B14F-4D97-AF65-F5344CB8AC3E}">
-        <p14:creationId xmlns:p14="http://schemas.microsoft.com/office/powerpoint/2010/main" val="377815836"/>
+        <p14:creationId xmlns:p14="http://schemas.microsoft.com/office/powerpoint/2010/main" val="970746317"/>
       </p:ext>
     </p:extLst>
   </p:cSld>

</xml_diff>

<commit_message>
Clarify two-repository integration in deck
</commit_message>
<xml_diff>
--- a/Distributed_Search_Engine_FA1_Technical_Presentation.pptx
+++ b/Distributed_Search_Engine_FA1_Technical_Presentation.pptx
@@ -2,27 +2,27 @@
 <file path=ppt/presentation.xml><?xml version="1.0" encoding="utf-8"?>
 <p:presentation xmlns:p="http://schemas.openxmlformats.org/presentationml/2006/main">
   <p:sldMasterIdLst>
-    <p:sldMasterId xmlns:r="http://schemas.openxmlformats.org/officeDocument/2006/relationships" id="2147483648" r:id="Rc68d838e2f7840c8"/>
+    <p:sldMasterId xmlns:r="http://schemas.openxmlformats.org/officeDocument/2006/relationships" id="2147483648" r:id="Rc0807b14650d469d"/>
   </p:sldMasterIdLst>
   <p:notesMasterIdLst>
-    <p:notesMasterId xmlns:r="http://schemas.openxmlformats.org/officeDocument/2006/relationships" r:id="R6c1c3242cc5140dd"/>
+    <p:notesMasterId xmlns:r="http://schemas.openxmlformats.org/officeDocument/2006/relationships" r:id="R6ad1c22f67c945c2"/>
   </p:notesMasterIdLst>
   <p:sldIdLst>
-    <p:sldId xmlns:r="http://schemas.openxmlformats.org/officeDocument/2006/relationships" id="256" r:id="R0100e04f50e84b04"/>
-    <p:sldId xmlns:r="http://schemas.openxmlformats.org/officeDocument/2006/relationships" id="257" r:id="R1b1c73e1530f4d26"/>
-    <p:sldId xmlns:r="http://schemas.openxmlformats.org/officeDocument/2006/relationships" id="258" r:id="R5d23890b310f4608"/>
-    <p:sldId xmlns:r="http://schemas.openxmlformats.org/officeDocument/2006/relationships" id="259" r:id="R8297283e4e034b94"/>
-    <p:sldId xmlns:r="http://schemas.openxmlformats.org/officeDocument/2006/relationships" id="260" r:id="R27736720c082410b"/>
-    <p:sldId xmlns:r="http://schemas.openxmlformats.org/officeDocument/2006/relationships" id="261" r:id="Rd695b5064c424303"/>
-    <p:sldId xmlns:r="http://schemas.openxmlformats.org/officeDocument/2006/relationships" id="262" r:id="R0f692e466e054d71"/>
-    <p:sldId xmlns:r="http://schemas.openxmlformats.org/officeDocument/2006/relationships" id="263" r:id="R3911283c57ca4476"/>
-    <p:sldId xmlns:r="http://schemas.openxmlformats.org/officeDocument/2006/relationships" id="264" r:id="R81a0d3d688274f69"/>
-    <p:sldId xmlns:r="http://schemas.openxmlformats.org/officeDocument/2006/relationships" id="265" r:id="R969682a89c7e4f93"/>
-    <p:sldId xmlns:r="http://schemas.openxmlformats.org/officeDocument/2006/relationships" id="266" r:id="R724dfe9c21214f7d"/>
-    <p:sldId xmlns:r="http://schemas.openxmlformats.org/officeDocument/2006/relationships" id="267" r:id="Rd5da06258baf4390"/>
-    <p:sldId xmlns:r="http://schemas.openxmlformats.org/officeDocument/2006/relationships" id="268" r:id="Rd0db07cde9b6419e"/>
-    <p:sldId xmlns:r="http://schemas.openxmlformats.org/officeDocument/2006/relationships" id="269" r:id="R340728f93833401a"/>
-    <p:sldId xmlns:r="http://schemas.openxmlformats.org/officeDocument/2006/relationships" id="270" r:id="Rab2ca8def0844595"/>
+    <p:sldId xmlns:r="http://schemas.openxmlformats.org/officeDocument/2006/relationships" id="256" r:id="R1964ffa22ab44d88"/>
+    <p:sldId xmlns:r="http://schemas.openxmlformats.org/officeDocument/2006/relationships" id="257" r:id="Rcbd0dfd172174a64"/>
+    <p:sldId xmlns:r="http://schemas.openxmlformats.org/officeDocument/2006/relationships" id="258" r:id="R2dc401371a2d49f5"/>
+    <p:sldId xmlns:r="http://schemas.openxmlformats.org/officeDocument/2006/relationships" id="259" r:id="Rd0e388f9d4714175"/>
+    <p:sldId xmlns:r="http://schemas.openxmlformats.org/officeDocument/2006/relationships" id="260" r:id="Rd9e1d00370d443e1"/>
+    <p:sldId xmlns:r="http://schemas.openxmlformats.org/officeDocument/2006/relationships" id="261" r:id="R4a0f30c9e5fa4995"/>
+    <p:sldId xmlns:r="http://schemas.openxmlformats.org/officeDocument/2006/relationships" id="262" r:id="Re1181825c27b4df1"/>
+    <p:sldId xmlns:r="http://schemas.openxmlformats.org/officeDocument/2006/relationships" id="263" r:id="R6f92070000d54b7f"/>
+    <p:sldId xmlns:r="http://schemas.openxmlformats.org/officeDocument/2006/relationships" id="264" r:id="R76261e63c52746b0"/>
+    <p:sldId xmlns:r="http://schemas.openxmlformats.org/officeDocument/2006/relationships" id="265" r:id="R76d74e422a554a83"/>
+    <p:sldId xmlns:r="http://schemas.openxmlformats.org/officeDocument/2006/relationships" id="266" r:id="R20627bdb17c1429a"/>
+    <p:sldId xmlns:r="http://schemas.openxmlformats.org/officeDocument/2006/relationships" id="267" r:id="Rac492dea374a4988"/>
+    <p:sldId xmlns:r="http://schemas.openxmlformats.org/officeDocument/2006/relationships" id="268" r:id="R811c9e38ae8c4f08"/>
+    <p:sldId xmlns:r="http://schemas.openxmlformats.org/officeDocument/2006/relationships" id="269" r:id="R3b64f24acd5f42a0"/>
+    <p:sldId xmlns:r="http://schemas.openxmlformats.org/officeDocument/2006/relationships" id="270" r:id="R3a199f9526c94267"/>
   </p:sldIdLst>
   <p:sldSz cx="12192000" cy="6858000"/>
   <p:notesSz cx="6858000" cy="9144000"/>
@@ -1176,7 +1176,7 @@
           <a:lstStyle xmlns:a="http://schemas.openxmlformats.org/drawingml/2006/main"/>
           <a:p xmlns:a="http://schemas.openxmlformats.org/drawingml/2006/main">
             <a:r>
-              <a:t>Close with the exact demonstration plan. It covers offline artifacts and online runtime behavior.</a:t>
+              <a:t>Close with the exact demonstration plan. It shows two separate repositories connected by copied/generated artifacts and then demonstrates degraded-mode query behavior.</a:t>
             </a:r>
           </a:p>
           <a:p xmlns:a="http://schemas.openxmlformats.org/drawingml/2006/main">
@@ -1536,7 +1536,7 @@
           <a:lstStyle xmlns:a="http://schemas.openxmlformats.org/drawingml/2006/main"/>
           <a:p xmlns:a="http://schemas.openxmlformats.org/drawingml/2006/main">
             <a:r>
-              <a:t>Explain this as a system decomposition rather than a person-wise split. The important point is the contract between offline artifacts and runtime services.</a:t>
+              <a:t>Explain this as a codebase decomposition. The important point is that the online runtime depends on the offline artifact contract, not on rerunning a separate crawl.</a:t>
             </a:r>
           </a:p>
           <a:p xmlns:a="http://schemas.openxmlformats.org/drawingml/2006/main">
@@ -2254,7 +2254,7 @@
   </p:cSld>
   <p:clrMap bg1="lt1" tx1="dk1" bg2="lt2" tx2="dk2" accent1="accent1" accent2="accent2" accent3="accent3" accent4="accent4" accent5="accent5" accent6="accent6" hlink="hlink" folHlink="folHlink"/>
   <p:sldLayoutIdLst>
-    <p:sldLayoutId xmlns:r="http://schemas.openxmlformats.org/officeDocument/2006/relationships" id="2147483649" r:id="Ree4027c42c414bda"/>
+    <p:sldLayoutId xmlns:r="http://schemas.openxmlformats.org/officeDocument/2006/relationships" id="2147483649" r:id="R5dbad5382e754a14"/>
   </p:sldLayoutIdLst>
   <p:txStyles>
     <p:titleStyle>
@@ -2805,7 +2805,7 @@
           <p:cNvPr id="13" name="">
             <a:extLst xmlns:a="http://schemas.openxmlformats.org/drawingml/2006/main">
               <a:ext uri="{FF2B5EF4-FFF2-40B4-BE49-F238E27FC236}">
-                <a16:creationId xmlns:a16="http://schemas.microsoft.com/office/drawing/2014/main" id="{92C06559-2254-4DC9-B947-312D30C06259}"/>
+                <a16:creationId xmlns:a16="http://schemas.microsoft.com/office/drawing/2014/main" id="{9656D427-0D54-456E-A557-B017D8B6DCC1}"/>
               </a:ext>
             </a:extLst>
           </p:cNvPr>
@@ -2836,7 +2836,7 @@
           <p:cNvPr id="2" name="">
             <a:extLst xmlns:a="http://schemas.openxmlformats.org/drawingml/2006/main">
               <a:ext uri="{FF2B5EF4-FFF2-40B4-BE49-F238E27FC236}">
-                <a16:creationId xmlns:a16="http://schemas.microsoft.com/office/drawing/2014/main" id="{A2DB04DA-6AAB-42F6-ACFD-3B4F2B0DD90A}"/>
+                <a16:creationId xmlns:a16="http://schemas.microsoft.com/office/drawing/2014/main" id="{44484C8C-60C4-4829-A65F-AAB975C6A2A9}"/>
               </a:ext>
             </a:extLst>
           </p:cNvPr>
@@ -2886,7 +2886,7 @@
           <p:cNvPr id="3" name="">
             <a:extLst xmlns:a="http://schemas.openxmlformats.org/drawingml/2006/main">
               <a:ext uri="{FF2B5EF4-FFF2-40B4-BE49-F238E27FC236}">
-                <a16:creationId xmlns:a16="http://schemas.microsoft.com/office/drawing/2014/main" id="{0FE40164-683F-4618-AA53-94DF56C08F5E}"/>
+                <a16:creationId xmlns:a16="http://schemas.microsoft.com/office/drawing/2014/main" id="{5ACB46F8-63A4-4461-8B97-39924D67D4BC}"/>
               </a:ext>
             </a:extLst>
           </p:cNvPr>
@@ -2936,7 +2936,7 @@
           <p:cNvPr id="4" name="">
             <a:extLst xmlns:a="http://schemas.openxmlformats.org/drawingml/2006/main">
               <a:ext uri="{FF2B5EF4-FFF2-40B4-BE49-F238E27FC236}">
-                <a16:creationId xmlns:a16="http://schemas.microsoft.com/office/drawing/2014/main" id="{4948CEC7-BC0E-4640-A381-2E02F3419A0B}"/>
+                <a16:creationId xmlns:a16="http://schemas.microsoft.com/office/drawing/2014/main" id="{9F3C411B-9F20-477A-9132-1032A736FBB3}"/>
               </a:ext>
             </a:extLst>
           </p:cNvPr>
@@ -2986,7 +2986,7 @@
           <p:cNvPr id="5" name="">
             <a:extLst xmlns:a="http://schemas.openxmlformats.org/drawingml/2006/main">
               <a:ext uri="{FF2B5EF4-FFF2-40B4-BE49-F238E27FC236}">
-                <a16:creationId xmlns:a16="http://schemas.microsoft.com/office/drawing/2014/main" id="{CDF9552E-DF88-4A36-AA8A-3F12E1B3476A}"/>
+                <a16:creationId xmlns:a16="http://schemas.microsoft.com/office/drawing/2014/main" id="{7CF3F1C0-623D-4876-9642-702671ABBF7C}"/>
               </a:ext>
             </a:extLst>
           </p:cNvPr>
@@ -3021,7 +3021,7 @@
           <p:cNvPr id="6" name="">
             <a:extLst xmlns:a="http://schemas.openxmlformats.org/drawingml/2006/main">
               <a:ext uri="{FF2B5EF4-FFF2-40B4-BE49-F238E27FC236}">
-                <a16:creationId xmlns:a16="http://schemas.microsoft.com/office/drawing/2014/main" id="{141F158C-C2F4-4AB9-8CB5-CC9906B2DD62}"/>
+                <a16:creationId xmlns:a16="http://schemas.microsoft.com/office/drawing/2014/main" id="{AF9D872B-729A-47D7-AF45-A85E8F69F57A}"/>
               </a:ext>
             </a:extLst>
           </p:cNvPr>
@@ -3071,7 +3071,7 @@
           <p:cNvPr id="7" name="">
             <a:extLst xmlns:a="http://schemas.openxmlformats.org/drawingml/2006/main">
               <a:ext uri="{FF2B5EF4-FFF2-40B4-BE49-F238E27FC236}">
-                <a16:creationId xmlns:a16="http://schemas.microsoft.com/office/drawing/2014/main" id="{197501D5-FD15-4773-A35F-ED6185EC30C0}"/>
+                <a16:creationId xmlns:a16="http://schemas.microsoft.com/office/drawing/2014/main" id="{73D59542-FDBE-46C8-A55D-EF55D067F018}"/>
               </a:ext>
             </a:extLst>
           </p:cNvPr>
@@ -3102,7 +3102,7 @@
           <p:cNvPr id="8" name="">
             <a:extLst xmlns:a="http://schemas.openxmlformats.org/drawingml/2006/main">
               <a:ext uri="{FF2B5EF4-FFF2-40B4-BE49-F238E27FC236}">
-                <a16:creationId xmlns:a16="http://schemas.microsoft.com/office/drawing/2014/main" id="{ECDAB09F-3603-44B3-892F-36F6454B2CC3}"/>
+                <a16:creationId xmlns:a16="http://schemas.microsoft.com/office/drawing/2014/main" id="{A1527F6B-A1E1-459E-868B-A1D3080B0B5A}"/>
               </a:ext>
             </a:extLst>
           </p:cNvPr>
@@ -3152,7 +3152,7 @@
           <p:cNvPr id="9" name="">
             <a:extLst xmlns:a="http://schemas.openxmlformats.org/drawingml/2006/main">
               <a:ext uri="{FF2B5EF4-FFF2-40B4-BE49-F238E27FC236}">
-                <a16:creationId xmlns:a16="http://schemas.microsoft.com/office/drawing/2014/main" id="{AE9C3418-2380-480D-8502-7F0EB5C4ABAD}"/>
+                <a16:creationId xmlns:a16="http://schemas.microsoft.com/office/drawing/2014/main" id="{FB6D81F3-FAC3-4602-8D8F-D79F31818279}"/>
               </a:ext>
             </a:extLst>
           </p:cNvPr>
@@ -3183,7 +3183,7 @@
           <p:cNvPr id="10" name="">
             <a:extLst xmlns:a="http://schemas.openxmlformats.org/drawingml/2006/main">
               <a:ext uri="{FF2B5EF4-FFF2-40B4-BE49-F238E27FC236}">
-                <a16:creationId xmlns:a16="http://schemas.microsoft.com/office/drawing/2014/main" id="{B292A4A4-B065-4502-80BD-94A6DDB87CB9}"/>
+                <a16:creationId xmlns:a16="http://schemas.microsoft.com/office/drawing/2014/main" id="{3DEA9E8F-7769-45C2-849E-960D23B65DE9}"/>
               </a:ext>
             </a:extLst>
           </p:cNvPr>
@@ -3233,7 +3233,7 @@
           <p:cNvPr id="11" name="">
             <a:extLst xmlns:a="http://schemas.openxmlformats.org/drawingml/2006/main">
               <a:ext uri="{FF2B5EF4-FFF2-40B4-BE49-F238E27FC236}">
-                <a16:creationId xmlns:a16="http://schemas.microsoft.com/office/drawing/2014/main" id="{5F98F5B0-1CCB-4702-8C2C-4CEDE91C83D1}"/>
+                <a16:creationId xmlns:a16="http://schemas.microsoft.com/office/drawing/2014/main" id="{AAF61B99-7F7B-4C23-B5BD-9074EEAB2177}"/>
               </a:ext>
             </a:extLst>
           </p:cNvPr>
@@ -3283,7 +3283,7 @@
           <p:cNvPr id="12" name="">
             <a:extLst xmlns:a="http://schemas.openxmlformats.org/drawingml/2006/main">
               <a:ext uri="{FF2B5EF4-FFF2-40B4-BE49-F238E27FC236}">
-                <a16:creationId xmlns:a16="http://schemas.microsoft.com/office/drawing/2014/main" id="{A623DA61-671C-4134-B369-3929878FBD46}"/>
+                <a16:creationId xmlns:a16="http://schemas.microsoft.com/office/drawing/2014/main" id="{C081EA4B-ABDB-4B6D-9198-5F4D8D33B90A}"/>
               </a:ext>
             </a:extLst>
           </p:cNvPr>
@@ -3331,7 +3331,7 @@
     </p:spTree>
     <p:extLst>
       <p:ext uri="{BB962C8B-B14F-4D97-AF65-F5344CB8AC3E}">
-        <p14:creationId xmlns:p14="http://schemas.microsoft.com/office/powerpoint/2010/main" val="1473241297"/>
+        <p14:creationId xmlns:p14="http://schemas.microsoft.com/office/powerpoint/2010/main" val="1426566713"/>
       </p:ext>
     </p:extLst>
   </p:cSld>
@@ -3362,7 +3362,7 @@
           <p:cNvPr id="13" name="">
             <a:extLst xmlns:a="http://schemas.openxmlformats.org/drawingml/2006/main">
               <a:ext uri="{FF2B5EF4-FFF2-40B4-BE49-F238E27FC236}">
-                <a16:creationId xmlns:a16="http://schemas.microsoft.com/office/drawing/2014/main" id="{B02EADF1-9130-4396-ADFC-0DE96D8759BC}"/>
+                <a16:creationId xmlns:a16="http://schemas.microsoft.com/office/drawing/2014/main" id="{05D537F6-1D2E-4FD2-9C0C-2B335C790771}"/>
               </a:ext>
             </a:extLst>
           </p:cNvPr>
@@ -3412,7 +3412,7 @@
           <p:cNvPr id="2" name="">
             <a:extLst xmlns:a="http://schemas.openxmlformats.org/drawingml/2006/main">
               <a:ext uri="{FF2B5EF4-FFF2-40B4-BE49-F238E27FC236}">
-                <a16:creationId xmlns:a16="http://schemas.microsoft.com/office/drawing/2014/main" id="{6DC3748D-44EB-421C-9AFC-8C30889A5736}"/>
+                <a16:creationId xmlns:a16="http://schemas.microsoft.com/office/drawing/2014/main" id="{2B938599-4EAB-43EA-8ECA-9B17D234C222}"/>
               </a:ext>
             </a:extLst>
           </p:cNvPr>
@@ -3462,7 +3462,7 @@
           <p:cNvPr id="3" name="">
             <a:extLst xmlns:a="http://schemas.openxmlformats.org/drawingml/2006/main">
               <a:ext uri="{FF2B5EF4-FFF2-40B4-BE49-F238E27FC236}">
-                <a16:creationId xmlns:a16="http://schemas.microsoft.com/office/drawing/2014/main" id="{10E38671-CB56-40EB-B7F1-F9C89EEC18F0}"/>
+                <a16:creationId xmlns:a16="http://schemas.microsoft.com/office/drawing/2014/main" id="{2731255A-70CA-4CA9-BDE4-798FE938413F}"/>
               </a:ext>
             </a:extLst>
           </p:cNvPr>
@@ -3493,7 +3493,7 @@
           <p:cNvPr id="4" name="">
             <a:extLst xmlns:a="http://schemas.openxmlformats.org/drawingml/2006/main">
               <a:ext uri="{FF2B5EF4-FFF2-40B4-BE49-F238E27FC236}">
-                <a16:creationId xmlns:a16="http://schemas.microsoft.com/office/drawing/2014/main" id="{3248E3CA-74C2-4781-8C8C-CF8DD8AB17C8}"/>
+                <a16:creationId xmlns:a16="http://schemas.microsoft.com/office/drawing/2014/main" id="{05E0C84E-7AB9-49B0-897F-F430B513430D}"/>
               </a:ext>
             </a:extLst>
           </p:cNvPr>
@@ -3543,7 +3543,7 @@
           <p:cNvPr id="5" name="">
             <a:extLst xmlns:a="http://schemas.openxmlformats.org/drawingml/2006/main">
               <a:ext uri="{FF2B5EF4-FFF2-40B4-BE49-F238E27FC236}">
-                <a16:creationId xmlns:a16="http://schemas.microsoft.com/office/drawing/2014/main" id="{E67534D7-5C89-46E6-8C70-14E816752EF6}"/>
+                <a16:creationId xmlns:a16="http://schemas.microsoft.com/office/drawing/2014/main" id="{D5964A19-5979-4125-9CE2-38C7C52139E4}"/>
               </a:ext>
             </a:extLst>
           </p:cNvPr>
@@ -3593,7 +3593,7 @@
           <p:cNvPr id="6" name="">
             <a:extLst xmlns:a="http://schemas.openxmlformats.org/drawingml/2006/main">
               <a:ext uri="{FF2B5EF4-FFF2-40B4-BE49-F238E27FC236}">
-                <a16:creationId xmlns:a16="http://schemas.microsoft.com/office/drawing/2014/main" id="{8AA41C19-A577-45F3-B9B6-EFBD16D4FC9C}"/>
+                <a16:creationId xmlns:a16="http://schemas.microsoft.com/office/drawing/2014/main" id="{84AE8DBB-E164-41A3-A0AD-BA1843C4AD1A}"/>
               </a:ext>
             </a:extLst>
           </p:cNvPr>
@@ -3628,7 +3628,7 @@
           <p:cNvPr id="7" name="">
             <a:extLst xmlns:a="http://schemas.openxmlformats.org/drawingml/2006/main">
               <a:ext uri="{FF2B5EF4-FFF2-40B4-BE49-F238E27FC236}">
-                <a16:creationId xmlns:a16="http://schemas.microsoft.com/office/drawing/2014/main" id="{1809265F-8A36-42DF-885F-59B17D5AACB7}"/>
+                <a16:creationId xmlns:a16="http://schemas.microsoft.com/office/drawing/2014/main" id="{EF0A4F43-3734-4700-BA9B-3082DB86A093}"/>
               </a:ext>
             </a:extLst>
           </p:cNvPr>
@@ -3678,7 +3678,7 @@
           <p:cNvPr id="8" name="">
             <a:extLst xmlns:a="http://schemas.openxmlformats.org/drawingml/2006/main">
               <a:ext uri="{FF2B5EF4-FFF2-40B4-BE49-F238E27FC236}">
-                <a16:creationId xmlns:a16="http://schemas.microsoft.com/office/drawing/2014/main" id="{6881939C-B353-43BB-84CB-A185D9DAB05A}"/>
+                <a16:creationId xmlns:a16="http://schemas.microsoft.com/office/drawing/2014/main" id="{7E302E63-AF08-49D1-974E-247D6040670A}"/>
               </a:ext>
             </a:extLst>
           </p:cNvPr>
@@ -3794,7 +3794,7 @@
           <p:cNvPr id="9" name="">
             <a:extLst xmlns:a="http://schemas.openxmlformats.org/drawingml/2006/main">
               <a:ext uri="{FF2B5EF4-FFF2-40B4-BE49-F238E27FC236}">
-                <a16:creationId xmlns:a16="http://schemas.microsoft.com/office/drawing/2014/main" id="{DC730CBF-13F4-44A8-A6BA-377B448F8EE8}"/>
+                <a16:creationId xmlns:a16="http://schemas.microsoft.com/office/drawing/2014/main" id="{00533E13-BFDA-44D1-B0CC-FC2021793B20}"/>
               </a:ext>
             </a:extLst>
           </p:cNvPr>
@@ -3829,7 +3829,7 @@
           <p:cNvPr id="10" name="">
             <a:extLst xmlns:a="http://schemas.openxmlformats.org/drawingml/2006/main">
               <a:ext uri="{FF2B5EF4-FFF2-40B4-BE49-F238E27FC236}">
-                <a16:creationId xmlns:a16="http://schemas.microsoft.com/office/drawing/2014/main" id="{C825BF37-E0EA-42A9-B02C-340DB9E52CA4}"/>
+                <a16:creationId xmlns:a16="http://schemas.microsoft.com/office/drawing/2014/main" id="{35FB6070-EC02-491C-8806-DF0CEBF85FE4}"/>
               </a:ext>
             </a:extLst>
           </p:cNvPr>
@@ -3879,7 +3879,7 @@
           <p:cNvPr id="11" name="">
             <a:extLst xmlns:a="http://schemas.openxmlformats.org/drawingml/2006/main">
               <a:ext uri="{FF2B5EF4-FFF2-40B4-BE49-F238E27FC236}">
-                <a16:creationId xmlns:a16="http://schemas.microsoft.com/office/drawing/2014/main" id="{4C19CE0C-6839-486F-8379-67E89F85FD3F}"/>
+                <a16:creationId xmlns:a16="http://schemas.microsoft.com/office/drawing/2014/main" id="{7251D682-34D0-4614-959E-69B0513104E0}"/>
               </a:ext>
             </a:extLst>
           </p:cNvPr>
@@ -3995,7 +3995,7 @@
           <p:cNvPr id="12" name="">
             <a:extLst xmlns:a="http://schemas.openxmlformats.org/drawingml/2006/main">
               <a:ext uri="{FF2B5EF4-FFF2-40B4-BE49-F238E27FC236}">
-                <a16:creationId xmlns:a16="http://schemas.microsoft.com/office/drawing/2014/main" id="{D2F7A18C-0613-4B65-B694-68DE0AC2D4C0}"/>
+                <a16:creationId xmlns:a16="http://schemas.microsoft.com/office/drawing/2014/main" id="{17AA35D1-E68A-40BC-B52B-3A943C034AA7}"/>
               </a:ext>
             </a:extLst>
           </p:cNvPr>
@@ -4024,7 +4024,7 @@
     </p:spTree>
     <p:extLst>
       <p:ext uri="{BB962C8B-B14F-4D97-AF65-F5344CB8AC3E}">
-        <p14:creationId xmlns:p14="http://schemas.microsoft.com/office/powerpoint/2010/main" val="281603726"/>
+        <p14:creationId xmlns:p14="http://schemas.microsoft.com/office/powerpoint/2010/main" val="1261324308"/>
       </p:ext>
     </p:extLst>
   </p:cSld>
@@ -4055,7 +4055,7 @@
           <p:cNvPr id="19" name="">
             <a:extLst xmlns:a="http://schemas.openxmlformats.org/drawingml/2006/main">
               <a:ext uri="{FF2B5EF4-FFF2-40B4-BE49-F238E27FC236}">
-                <a16:creationId xmlns:a16="http://schemas.microsoft.com/office/drawing/2014/main" id="{AFA85BAF-DAB6-4683-A843-EFED930B8BE5}"/>
+                <a16:creationId xmlns:a16="http://schemas.microsoft.com/office/drawing/2014/main" id="{F773E2E6-5029-4161-AFA7-830FAE0D4C13}"/>
               </a:ext>
             </a:extLst>
           </p:cNvPr>
@@ -4105,7 +4105,7 @@
           <p:cNvPr id="2" name="">
             <a:extLst xmlns:a="http://schemas.openxmlformats.org/drawingml/2006/main">
               <a:ext uri="{FF2B5EF4-FFF2-40B4-BE49-F238E27FC236}">
-                <a16:creationId xmlns:a16="http://schemas.microsoft.com/office/drawing/2014/main" id="{E1EA9DA7-B34B-4035-A9D0-0A18E44D94D0}"/>
+                <a16:creationId xmlns:a16="http://schemas.microsoft.com/office/drawing/2014/main" id="{9894DF38-4449-41EF-AB08-5163B4161098}"/>
               </a:ext>
             </a:extLst>
           </p:cNvPr>
@@ -4155,7 +4155,7 @@
           <p:cNvPr id="3" name="">
             <a:extLst xmlns:a="http://schemas.openxmlformats.org/drawingml/2006/main">
               <a:ext uri="{FF2B5EF4-FFF2-40B4-BE49-F238E27FC236}">
-                <a16:creationId xmlns:a16="http://schemas.microsoft.com/office/drawing/2014/main" id="{48B29E40-16ED-4231-B11B-BDB6CFBFC670}"/>
+                <a16:creationId xmlns:a16="http://schemas.microsoft.com/office/drawing/2014/main" id="{669E9E2C-FC3B-4E91-A40B-4CD289A73B48}"/>
               </a:ext>
             </a:extLst>
           </p:cNvPr>
@@ -4186,7 +4186,7 @@
           <p:cNvPr id="4" name="">
             <a:extLst xmlns:a="http://schemas.openxmlformats.org/drawingml/2006/main">
               <a:ext uri="{FF2B5EF4-FFF2-40B4-BE49-F238E27FC236}">
-                <a16:creationId xmlns:a16="http://schemas.microsoft.com/office/drawing/2014/main" id="{AF34CB1A-7C81-494D-81BC-E5D3EA95EE90}"/>
+                <a16:creationId xmlns:a16="http://schemas.microsoft.com/office/drawing/2014/main" id="{B5C655FE-671C-4681-A7B8-C2AC02E6AE58}"/>
               </a:ext>
             </a:extLst>
           </p:cNvPr>
@@ -4236,7 +4236,7 @@
           <p:cNvPr id="5" name="">
             <a:extLst xmlns:a="http://schemas.openxmlformats.org/drawingml/2006/main">
               <a:ext uri="{FF2B5EF4-FFF2-40B4-BE49-F238E27FC236}">
-                <a16:creationId xmlns:a16="http://schemas.microsoft.com/office/drawing/2014/main" id="{74AC3EA4-1D8F-4B99-8F0D-FD10B54B00CE}"/>
+                <a16:creationId xmlns:a16="http://schemas.microsoft.com/office/drawing/2014/main" id="{F30D8CE3-26A2-46EE-AB40-D9BDA3059582}"/>
               </a:ext>
             </a:extLst>
           </p:cNvPr>
@@ -4286,7 +4286,7 @@
           <p:cNvPr id="6" name="">
             <a:extLst xmlns:a="http://schemas.openxmlformats.org/drawingml/2006/main">
               <a:ext uri="{FF2B5EF4-FFF2-40B4-BE49-F238E27FC236}">
-                <a16:creationId xmlns:a16="http://schemas.microsoft.com/office/drawing/2014/main" id="{497491C8-5B95-481B-8D38-D96B2C3EA1FD}"/>
+                <a16:creationId xmlns:a16="http://schemas.microsoft.com/office/drawing/2014/main" id="{B509FB15-CCAA-4799-905A-207128E55C24}"/>
               </a:ext>
             </a:extLst>
           </p:cNvPr>
@@ -4340,7 +4340,7 @@
           <p:cNvPr id="7" name="">
             <a:extLst xmlns:a="http://schemas.openxmlformats.org/drawingml/2006/main">
               <a:ext uri="{FF2B5EF4-FFF2-40B4-BE49-F238E27FC236}">
-                <a16:creationId xmlns:a16="http://schemas.microsoft.com/office/drawing/2014/main" id="{6D09D8B0-AB3B-48B7-AACF-470ABAECF819}"/>
+                <a16:creationId xmlns:a16="http://schemas.microsoft.com/office/drawing/2014/main" id="{C7FECFFD-27A5-4FED-A1B0-01D97D8D1240}"/>
               </a:ext>
             </a:extLst>
           </p:cNvPr>
@@ -4390,7 +4390,7 @@
           <p:cNvPr id="8" name="">
             <a:extLst xmlns:a="http://schemas.openxmlformats.org/drawingml/2006/main">
               <a:ext uri="{FF2B5EF4-FFF2-40B4-BE49-F238E27FC236}">
-                <a16:creationId xmlns:a16="http://schemas.microsoft.com/office/drawing/2014/main" id="{ACA6F3EA-CE7D-4D0E-B2FE-9420E6A4EF53}"/>
+                <a16:creationId xmlns:a16="http://schemas.microsoft.com/office/drawing/2014/main" id="{E8CE5C48-8058-417A-B530-B63638C56E1B}"/>
               </a:ext>
             </a:extLst>
           </p:cNvPr>
@@ -4444,7 +4444,7 @@
           <p:cNvPr id="9" name="">
             <a:extLst xmlns:a="http://schemas.openxmlformats.org/drawingml/2006/main">
               <a:ext uri="{FF2B5EF4-FFF2-40B4-BE49-F238E27FC236}">
-                <a16:creationId xmlns:a16="http://schemas.microsoft.com/office/drawing/2014/main" id="{DC7CE212-284E-41AC-AB15-9FE2AE22461D}"/>
+                <a16:creationId xmlns:a16="http://schemas.microsoft.com/office/drawing/2014/main" id="{6EFF2F8A-5063-4ECE-8A24-3FCA198CB640}"/>
               </a:ext>
             </a:extLst>
           </p:cNvPr>
@@ -4494,7 +4494,7 @@
           <p:cNvPr id="10" name="">
             <a:extLst xmlns:a="http://schemas.openxmlformats.org/drawingml/2006/main">
               <a:ext uri="{FF2B5EF4-FFF2-40B4-BE49-F238E27FC236}">
-                <a16:creationId xmlns:a16="http://schemas.microsoft.com/office/drawing/2014/main" id="{21FDF136-0384-463F-969A-F1F19C13D5B3}"/>
+                <a16:creationId xmlns:a16="http://schemas.microsoft.com/office/drawing/2014/main" id="{08A1C6D8-8FE8-4219-B723-37DB21B6A68E}"/>
               </a:ext>
             </a:extLst>
           </p:cNvPr>
@@ -4548,7 +4548,7 @@
           <p:cNvPr id="11" name="">
             <a:extLst xmlns:a="http://schemas.openxmlformats.org/drawingml/2006/main">
               <a:ext uri="{FF2B5EF4-FFF2-40B4-BE49-F238E27FC236}">
-                <a16:creationId xmlns:a16="http://schemas.microsoft.com/office/drawing/2014/main" id="{32C0E8FE-2FD4-4D20-A6E8-2F4797BD1BF9}"/>
+                <a16:creationId xmlns:a16="http://schemas.microsoft.com/office/drawing/2014/main" id="{7E98942E-DF41-4ED5-BD14-3929014E2E11}"/>
               </a:ext>
             </a:extLst>
           </p:cNvPr>
@@ -4598,7 +4598,7 @@
           <p:cNvPr id="12" name="">
             <a:extLst xmlns:a="http://schemas.openxmlformats.org/drawingml/2006/main">
               <a:ext uri="{FF2B5EF4-FFF2-40B4-BE49-F238E27FC236}">
-                <a16:creationId xmlns:a16="http://schemas.microsoft.com/office/drawing/2014/main" id="{F72FA87B-799F-47B5-A53C-835AC8C5AD40}"/>
+                <a16:creationId xmlns:a16="http://schemas.microsoft.com/office/drawing/2014/main" id="{733D863C-9E03-4FA0-ADC6-20987F3052FD}"/>
               </a:ext>
             </a:extLst>
           </p:cNvPr>
@@ -4652,7 +4652,7 @@
           <p:cNvPr id="13" name="">
             <a:extLst xmlns:a="http://schemas.openxmlformats.org/drawingml/2006/main">
               <a:ext uri="{FF2B5EF4-FFF2-40B4-BE49-F238E27FC236}">
-                <a16:creationId xmlns:a16="http://schemas.microsoft.com/office/drawing/2014/main" id="{22B3036B-A88A-4BA9-8A1E-54A22A2AB19A}"/>
+                <a16:creationId xmlns:a16="http://schemas.microsoft.com/office/drawing/2014/main" id="{C3E035D7-1B56-4704-9B6C-55C13F8C21B7}"/>
               </a:ext>
             </a:extLst>
           </p:cNvPr>
@@ -4702,7 +4702,7 @@
           <p:cNvPr id="14" name="">
             <a:extLst xmlns:a="http://schemas.openxmlformats.org/drawingml/2006/main">
               <a:ext uri="{FF2B5EF4-FFF2-40B4-BE49-F238E27FC236}">
-                <a16:creationId xmlns:a16="http://schemas.microsoft.com/office/drawing/2014/main" id="{50601092-7AE1-49A2-AD40-54B41B22D60C}"/>
+                <a16:creationId xmlns:a16="http://schemas.microsoft.com/office/drawing/2014/main" id="{CF1CF588-33CA-4070-8BBD-674E1EB5B963}"/>
               </a:ext>
             </a:extLst>
           </p:cNvPr>
@@ -4756,7 +4756,7 @@
           <p:cNvPr id="15" name="">
             <a:extLst xmlns:a="http://schemas.openxmlformats.org/drawingml/2006/main">
               <a:ext uri="{FF2B5EF4-FFF2-40B4-BE49-F238E27FC236}">
-                <a16:creationId xmlns:a16="http://schemas.microsoft.com/office/drawing/2014/main" id="{E32BEB6F-7A86-47A2-B7E7-8A86B28C2AC6}"/>
+                <a16:creationId xmlns:a16="http://schemas.microsoft.com/office/drawing/2014/main" id="{2F4ECB12-CF1C-4301-BC8F-928B6A43877A}"/>
               </a:ext>
             </a:extLst>
           </p:cNvPr>
@@ -4806,7 +4806,7 @@
           <p:cNvPr id="16" name="">
             <a:extLst xmlns:a="http://schemas.openxmlformats.org/drawingml/2006/main">
               <a:ext uri="{FF2B5EF4-FFF2-40B4-BE49-F238E27FC236}">
-                <a16:creationId xmlns:a16="http://schemas.microsoft.com/office/drawing/2014/main" id="{0AE3D597-CDC3-4BF0-B829-F4724178BA15}"/>
+                <a16:creationId xmlns:a16="http://schemas.microsoft.com/office/drawing/2014/main" id="{46EA01F2-620B-4EDB-A5F9-B3426360535C}"/>
               </a:ext>
             </a:extLst>
           </p:cNvPr>
@@ -4841,7 +4841,7 @@
           <p:cNvPr id="17" name="">
             <a:extLst xmlns:a="http://schemas.openxmlformats.org/drawingml/2006/main">
               <a:ext uri="{FF2B5EF4-FFF2-40B4-BE49-F238E27FC236}">
-                <a16:creationId xmlns:a16="http://schemas.microsoft.com/office/drawing/2014/main" id="{95DB9850-8A7C-4539-BA10-9AE43C76C64D}"/>
+                <a16:creationId xmlns:a16="http://schemas.microsoft.com/office/drawing/2014/main" id="{B59344C9-B9CF-4F18-B3E4-DF5971A38816}"/>
               </a:ext>
             </a:extLst>
           </p:cNvPr>
@@ -4891,7 +4891,7 @@
           <p:cNvPr id="18" name="">
             <a:extLst xmlns:a="http://schemas.openxmlformats.org/drawingml/2006/main">
               <a:ext uri="{FF2B5EF4-FFF2-40B4-BE49-F238E27FC236}">
-                <a16:creationId xmlns:a16="http://schemas.microsoft.com/office/drawing/2014/main" id="{7B11F788-29D3-4F31-A150-FC328F11EFF2}"/>
+                <a16:creationId xmlns:a16="http://schemas.microsoft.com/office/drawing/2014/main" id="{BDC3A993-700C-434E-BCB4-6B791D39B2A6}"/>
               </a:ext>
             </a:extLst>
           </p:cNvPr>
@@ -5007,7 +5007,7 @@
     </p:spTree>
     <p:extLst>
       <p:ext uri="{BB962C8B-B14F-4D97-AF65-F5344CB8AC3E}">
-        <p14:creationId xmlns:p14="http://schemas.microsoft.com/office/powerpoint/2010/main" val="2046498720"/>
+        <p14:creationId xmlns:p14="http://schemas.microsoft.com/office/powerpoint/2010/main" val="797967680"/>
       </p:ext>
     </p:extLst>
   </p:cSld>
@@ -5038,7 +5038,7 @@
           <p:cNvPr id="22" name="">
             <a:extLst xmlns:a="http://schemas.openxmlformats.org/drawingml/2006/main">
               <a:ext uri="{FF2B5EF4-FFF2-40B4-BE49-F238E27FC236}">
-                <a16:creationId xmlns:a16="http://schemas.microsoft.com/office/drawing/2014/main" id="{8DC71BA3-BABE-49FD-8267-3586A7D48CDE}"/>
+                <a16:creationId xmlns:a16="http://schemas.microsoft.com/office/drawing/2014/main" id="{CF63C342-BDDA-45A7-A108-7B3888560032}"/>
               </a:ext>
             </a:extLst>
           </p:cNvPr>
@@ -5088,7 +5088,7 @@
           <p:cNvPr id="2" name="">
             <a:extLst xmlns:a="http://schemas.openxmlformats.org/drawingml/2006/main">
               <a:ext uri="{FF2B5EF4-FFF2-40B4-BE49-F238E27FC236}">
-                <a16:creationId xmlns:a16="http://schemas.microsoft.com/office/drawing/2014/main" id="{AFDEFAB3-85BB-4B49-AFEB-05CB1717BD0A}"/>
+                <a16:creationId xmlns:a16="http://schemas.microsoft.com/office/drawing/2014/main" id="{87C8B49C-FA1B-4AAD-BC74-EDB5DF875FF3}"/>
               </a:ext>
             </a:extLst>
           </p:cNvPr>
@@ -5138,7 +5138,7 @@
           <p:cNvPr id="3" name="">
             <a:extLst xmlns:a="http://schemas.openxmlformats.org/drawingml/2006/main">
               <a:ext uri="{FF2B5EF4-FFF2-40B4-BE49-F238E27FC236}">
-                <a16:creationId xmlns:a16="http://schemas.microsoft.com/office/drawing/2014/main" id="{A59D10B1-F17A-4966-BBBC-9DB08F18F493}"/>
+                <a16:creationId xmlns:a16="http://schemas.microsoft.com/office/drawing/2014/main" id="{F5DA55EF-C9BE-49EE-8FA9-1E55CE6E13EF}"/>
               </a:ext>
             </a:extLst>
           </p:cNvPr>
@@ -5169,7 +5169,7 @@
           <p:cNvPr id="4" name="">
             <a:extLst xmlns:a="http://schemas.openxmlformats.org/drawingml/2006/main">
               <a:ext uri="{FF2B5EF4-FFF2-40B4-BE49-F238E27FC236}">
-                <a16:creationId xmlns:a16="http://schemas.microsoft.com/office/drawing/2014/main" id="{4AA253FC-AB70-43B1-9A8F-00C521C7BB56}"/>
+                <a16:creationId xmlns:a16="http://schemas.microsoft.com/office/drawing/2014/main" id="{0621D5C6-8131-439C-8460-48894A674D89}"/>
               </a:ext>
             </a:extLst>
           </p:cNvPr>
@@ -5219,7 +5219,7 @@
           <p:cNvPr id="5" name="">
             <a:extLst xmlns:a="http://schemas.openxmlformats.org/drawingml/2006/main">
               <a:ext uri="{FF2B5EF4-FFF2-40B4-BE49-F238E27FC236}">
-                <a16:creationId xmlns:a16="http://schemas.microsoft.com/office/drawing/2014/main" id="{F51371B3-DDE1-418C-89B6-1DAC835E1A10}"/>
+                <a16:creationId xmlns:a16="http://schemas.microsoft.com/office/drawing/2014/main" id="{1D38DA9C-1368-4CC0-815A-266B9AD9E26F}"/>
               </a:ext>
             </a:extLst>
           </p:cNvPr>
@@ -5269,7 +5269,7 @@
           <p:cNvPr id="6" name="">
             <a:extLst xmlns:a="http://schemas.openxmlformats.org/drawingml/2006/main">
               <a:ext uri="{FF2B5EF4-FFF2-40B4-BE49-F238E27FC236}">
-                <a16:creationId xmlns:a16="http://schemas.microsoft.com/office/drawing/2014/main" id="{63B3B433-F8C3-4A7E-B763-81A615DEC690}"/>
+                <a16:creationId xmlns:a16="http://schemas.microsoft.com/office/drawing/2014/main" id="{0C0BBACB-B918-45C2-B795-1917D355A236}"/>
               </a:ext>
             </a:extLst>
           </p:cNvPr>
@@ -5319,7 +5319,7 @@
           <p:cNvPr id="7" name="">
             <a:extLst xmlns:a="http://schemas.openxmlformats.org/drawingml/2006/main">
               <a:ext uri="{FF2B5EF4-FFF2-40B4-BE49-F238E27FC236}">
-                <a16:creationId xmlns:a16="http://schemas.microsoft.com/office/drawing/2014/main" id="{0D9FC47C-1B2F-44D7-A3A8-B1C8BEE5788A}"/>
+                <a16:creationId xmlns:a16="http://schemas.microsoft.com/office/drawing/2014/main" id="{AE411E25-EDD5-41F9-8A74-35DFB6E83644}"/>
               </a:ext>
             </a:extLst>
           </p:cNvPr>
@@ -5350,7 +5350,7 @@
           <p:cNvPr id="8" name="">
             <a:extLst xmlns:a="http://schemas.openxmlformats.org/drawingml/2006/main">
               <a:ext uri="{FF2B5EF4-FFF2-40B4-BE49-F238E27FC236}">
-                <a16:creationId xmlns:a16="http://schemas.microsoft.com/office/drawing/2014/main" id="{6DA37944-8264-47F3-89F2-37CC00D04112}"/>
+                <a16:creationId xmlns:a16="http://schemas.microsoft.com/office/drawing/2014/main" id="{0D05A2AD-5026-4074-8E8B-700FC76A24BC}"/>
               </a:ext>
             </a:extLst>
           </p:cNvPr>
@@ -5400,7 +5400,7 @@
           <p:cNvPr id="9" name="">
             <a:extLst xmlns:a="http://schemas.openxmlformats.org/drawingml/2006/main">
               <a:ext uri="{FF2B5EF4-FFF2-40B4-BE49-F238E27FC236}">
-                <a16:creationId xmlns:a16="http://schemas.microsoft.com/office/drawing/2014/main" id="{F31556B4-4F51-44F9-94CE-68C9150EF132}"/>
+                <a16:creationId xmlns:a16="http://schemas.microsoft.com/office/drawing/2014/main" id="{FE9673E5-DB08-4022-8066-7D186A601BA1}"/>
               </a:ext>
             </a:extLst>
           </p:cNvPr>
@@ -5431,7 +5431,7 @@
           <p:cNvPr id="10" name="">
             <a:extLst xmlns:a="http://schemas.openxmlformats.org/drawingml/2006/main">
               <a:ext uri="{FF2B5EF4-FFF2-40B4-BE49-F238E27FC236}">
-                <a16:creationId xmlns:a16="http://schemas.microsoft.com/office/drawing/2014/main" id="{3EB4883A-A880-49B5-81E5-57223035D220}"/>
+                <a16:creationId xmlns:a16="http://schemas.microsoft.com/office/drawing/2014/main" id="{3BBDE9AD-114E-4B0F-892A-8A396C57E181}"/>
               </a:ext>
             </a:extLst>
           </p:cNvPr>
@@ -5481,7 +5481,7 @@
           <p:cNvPr id="11" name="">
             <a:extLst xmlns:a="http://schemas.openxmlformats.org/drawingml/2006/main">
               <a:ext uri="{FF2B5EF4-FFF2-40B4-BE49-F238E27FC236}">
-                <a16:creationId xmlns:a16="http://schemas.microsoft.com/office/drawing/2014/main" id="{26B9982E-104C-41CD-A5DF-A9106FA05761}"/>
+                <a16:creationId xmlns:a16="http://schemas.microsoft.com/office/drawing/2014/main" id="{E49D84AA-A4E1-4CAC-A1EF-5551DA99430E}"/>
               </a:ext>
             </a:extLst>
           </p:cNvPr>
@@ -5512,7 +5512,7 @@
           <p:cNvPr id="12" name="">
             <a:extLst xmlns:a="http://schemas.openxmlformats.org/drawingml/2006/main">
               <a:ext uri="{FF2B5EF4-FFF2-40B4-BE49-F238E27FC236}">
-                <a16:creationId xmlns:a16="http://schemas.microsoft.com/office/drawing/2014/main" id="{5525A7C9-E9AF-467E-A64F-C3638E99215F}"/>
+                <a16:creationId xmlns:a16="http://schemas.microsoft.com/office/drawing/2014/main" id="{DE9A2AE9-26BB-4462-8853-0CE744D392F5}"/>
               </a:ext>
             </a:extLst>
           </p:cNvPr>
@@ -5562,7 +5562,7 @@
           <p:cNvPr id="13" name="">
             <a:extLst xmlns:a="http://schemas.openxmlformats.org/drawingml/2006/main">
               <a:ext uri="{FF2B5EF4-FFF2-40B4-BE49-F238E27FC236}">
-                <a16:creationId xmlns:a16="http://schemas.microsoft.com/office/drawing/2014/main" id="{DBCF6853-1BB9-4009-BBB1-97A8404CA5FC}"/>
+                <a16:creationId xmlns:a16="http://schemas.microsoft.com/office/drawing/2014/main" id="{53BB4321-956B-4D21-B25C-C0E54A95B1CF}"/>
               </a:ext>
             </a:extLst>
           </p:cNvPr>
@@ -5612,7 +5612,7 @@
           <p:cNvPr id="14" name="">
             <a:extLst xmlns:a="http://schemas.openxmlformats.org/drawingml/2006/main">
               <a:ext uri="{FF2B5EF4-FFF2-40B4-BE49-F238E27FC236}">
-                <a16:creationId xmlns:a16="http://schemas.microsoft.com/office/drawing/2014/main" id="{6D1675B1-8E68-4C42-81DF-36A6F1FC7E7A}"/>
+                <a16:creationId xmlns:a16="http://schemas.microsoft.com/office/drawing/2014/main" id="{8B1884E1-B998-49BB-B16B-AB9828F112B9}"/>
               </a:ext>
             </a:extLst>
           </p:cNvPr>
@@ -5643,7 +5643,7 @@
           <p:cNvPr id="15" name="">
             <a:extLst xmlns:a="http://schemas.openxmlformats.org/drawingml/2006/main">
               <a:ext uri="{FF2B5EF4-FFF2-40B4-BE49-F238E27FC236}">
-                <a16:creationId xmlns:a16="http://schemas.microsoft.com/office/drawing/2014/main" id="{759D7EBC-5C26-4AC8-9D75-14AF2F9905D2}"/>
+                <a16:creationId xmlns:a16="http://schemas.microsoft.com/office/drawing/2014/main" id="{DDEDC019-DC50-42AE-9E3A-E10B25F4F185}"/>
               </a:ext>
             </a:extLst>
           </p:cNvPr>
@@ -5693,7 +5693,7 @@
           <p:cNvPr id="16" name="">
             <a:extLst xmlns:a="http://schemas.openxmlformats.org/drawingml/2006/main">
               <a:ext uri="{FF2B5EF4-FFF2-40B4-BE49-F238E27FC236}">
-                <a16:creationId xmlns:a16="http://schemas.microsoft.com/office/drawing/2014/main" id="{0E13E1AC-AA88-449B-B52C-C45A1F631EBE}"/>
+                <a16:creationId xmlns:a16="http://schemas.microsoft.com/office/drawing/2014/main" id="{74DDE839-12BF-46C1-AFDC-F850A37CD663}"/>
               </a:ext>
             </a:extLst>
           </p:cNvPr>
@@ -5724,7 +5724,7 @@
           <p:cNvPr id="17" name="">
             <a:extLst xmlns:a="http://schemas.openxmlformats.org/drawingml/2006/main">
               <a:ext uri="{FF2B5EF4-FFF2-40B4-BE49-F238E27FC236}">
-                <a16:creationId xmlns:a16="http://schemas.microsoft.com/office/drawing/2014/main" id="{D7402148-7512-4CAC-85D4-1C7DB5B11965}"/>
+                <a16:creationId xmlns:a16="http://schemas.microsoft.com/office/drawing/2014/main" id="{06995157-CA16-43DE-8B20-3DE14075F9D9}"/>
               </a:ext>
             </a:extLst>
           </p:cNvPr>
@@ -5774,7 +5774,7 @@
           <p:cNvPr id="18" name="">
             <a:extLst xmlns:a="http://schemas.openxmlformats.org/drawingml/2006/main">
               <a:ext uri="{FF2B5EF4-FFF2-40B4-BE49-F238E27FC236}">
-                <a16:creationId xmlns:a16="http://schemas.microsoft.com/office/drawing/2014/main" id="{8704FA87-0899-4B20-A305-9D82EB5DDE63}"/>
+                <a16:creationId xmlns:a16="http://schemas.microsoft.com/office/drawing/2014/main" id="{623843CA-5783-41D8-BEE4-09D053A5B995}"/>
               </a:ext>
             </a:extLst>
           </p:cNvPr>
@@ -5805,7 +5805,7 @@
           <p:cNvPr id="19" name="">
             <a:extLst xmlns:a="http://schemas.openxmlformats.org/drawingml/2006/main">
               <a:ext uri="{FF2B5EF4-FFF2-40B4-BE49-F238E27FC236}">
-                <a16:creationId xmlns:a16="http://schemas.microsoft.com/office/drawing/2014/main" id="{7530A3EC-2F0C-47AA-871E-257245EA7432}"/>
+                <a16:creationId xmlns:a16="http://schemas.microsoft.com/office/drawing/2014/main" id="{5A353829-DFD8-4210-8542-AE75B9DA41BD}"/>
               </a:ext>
             </a:extLst>
           </p:cNvPr>
@@ -5855,7 +5855,7 @@
           <p:cNvPr id="20" name="">
             <a:extLst xmlns:a="http://schemas.openxmlformats.org/drawingml/2006/main">
               <a:ext uri="{FF2B5EF4-FFF2-40B4-BE49-F238E27FC236}">
-                <a16:creationId xmlns:a16="http://schemas.microsoft.com/office/drawing/2014/main" id="{10A0BA28-5CD4-42EE-9C56-BFFF877BD192}"/>
+                <a16:creationId xmlns:a16="http://schemas.microsoft.com/office/drawing/2014/main" id="{3796C23B-05C7-4304-A5B8-DB2E512BA1CB}"/>
               </a:ext>
             </a:extLst>
           </p:cNvPr>
@@ -5890,7 +5890,7 @@
           <p:cNvPr id="21" name="">
             <a:extLst xmlns:a="http://schemas.openxmlformats.org/drawingml/2006/main">
               <a:ext uri="{FF2B5EF4-FFF2-40B4-BE49-F238E27FC236}">
-                <a16:creationId xmlns:a16="http://schemas.microsoft.com/office/drawing/2014/main" id="{D03CA90D-5D74-47FA-8664-F1AD4413CDE1}"/>
+                <a16:creationId xmlns:a16="http://schemas.microsoft.com/office/drawing/2014/main" id="{D15A739A-AAA6-4F98-812E-42F45DDE168E}"/>
               </a:ext>
             </a:extLst>
           </p:cNvPr>
@@ -5938,7 +5938,7 @@
     </p:spTree>
     <p:extLst>
       <p:ext uri="{BB962C8B-B14F-4D97-AF65-F5344CB8AC3E}">
-        <p14:creationId xmlns:p14="http://schemas.microsoft.com/office/powerpoint/2010/main" val="1753689858"/>
+        <p14:creationId xmlns:p14="http://schemas.microsoft.com/office/powerpoint/2010/main" val="359652323"/>
       </p:ext>
     </p:extLst>
   </p:cSld>
@@ -5969,7 +5969,7 @@
           <p:cNvPr id="24" name="">
             <a:extLst xmlns:a="http://schemas.openxmlformats.org/drawingml/2006/main">
               <a:ext uri="{FF2B5EF4-FFF2-40B4-BE49-F238E27FC236}">
-                <a16:creationId xmlns:a16="http://schemas.microsoft.com/office/drawing/2014/main" id="{B9745CFB-499E-4FF2-B34D-8C7039C91FA4}"/>
+                <a16:creationId xmlns:a16="http://schemas.microsoft.com/office/drawing/2014/main" id="{966AB431-10F3-41DA-8CD7-72C15929D492}"/>
               </a:ext>
             </a:extLst>
           </p:cNvPr>
@@ -6019,7 +6019,7 @@
           <p:cNvPr id="2" name="">
             <a:extLst xmlns:a="http://schemas.openxmlformats.org/drawingml/2006/main">
               <a:ext uri="{FF2B5EF4-FFF2-40B4-BE49-F238E27FC236}">
-                <a16:creationId xmlns:a16="http://schemas.microsoft.com/office/drawing/2014/main" id="{2123A18D-AD25-441B-B1A3-168A7E048C38}"/>
+                <a16:creationId xmlns:a16="http://schemas.microsoft.com/office/drawing/2014/main" id="{4E51EF9C-F25B-46ED-A142-E56750DA28C4}"/>
               </a:ext>
             </a:extLst>
           </p:cNvPr>
@@ -6069,7 +6069,7 @@
           <p:cNvPr id="3" name="">
             <a:extLst xmlns:a="http://schemas.openxmlformats.org/drawingml/2006/main">
               <a:ext uri="{FF2B5EF4-FFF2-40B4-BE49-F238E27FC236}">
-                <a16:creationId xmlns:a16="http://schemas.microsoft.com/office/drawing/2014/main" id="{04BC8943-9D01-46B1-8B3A-2E1EB7402641}"/>
+                <a16:creationId xmlns:a16="http://schemas.microsoft.com/office/drawing/2014/main" id="{4E0D02FE-4BC0-48B5-AD0A-2F19CC6BA554}"/>
               </a:ext>
             </a:extLst>
           </p:cNvPr>
@@ -6100,7 +6100,7 @@
           <p:cNvPr id="4" name="">
             <a:extLst xmlns:a="http://schemas.openxmlformats.org/drawingml/2006/main">
               <a:ext uri="{FF2B5EF4-FFF2-40B4-BE49-F238E27FC236}">
-                <a16:creationId xmlns:a16="http://schemas.microsoft.com/office/drawing/2014/main" id="{7198E421-8415-49E2-A89F-52E062DC5802}"/>
+                <a16:creationId xmlns:a16="http://schemas.microsoft.com/office/drawing/2014/main" id="{C7E253DC-6697-44B2-B0BE-85361DC4D89D}"/>
               </a:ext>
             </a:extLst>
           </p:cNvPr>
@@ -6150,7 +6150,7 @@
           <p:cNvPr id="5" name="">
             <a:extLst xmlns:a="http://schemas.openxmlformats.org/drawingml/2006/main">
               <a:ext uri="{FF2B5EF4-FFF2-40B4-BE49-F238E27FC236}">
-                <a16:creationId xmlns:a16="http://schemas.microsoft.com/office/drawing/2014/main" id="{4898B702-6F13-4D9F-950F-A86347962E82}"/>
+                <a16:creationId xmlns:a16="http://schemas.microsoft.com/office/drawing/2014/main" id="{2F999CD4-236F-4E28-978F-8839816C99B4}"/>
               </a:ext>
             </a:extLst>
           </p:cNvPr>
@@ -6200,7 +6200,7 @@
           <p:cNvPr id="6" name="">
             <a:extLst xmlns:a="http://schemas.openxmlformats.org/drawingml/2006/main">
               <a:ext uri="{FF2B5EF4-FFF2-40B4-BE49-F238E27FC236}">
-                <a16:creationId xmlns:a16="http://schemas.microsoft.com/office/drawing/2014/main" id="{B6E840E6-AB3C-46E0-BD36-2FE8D58DE886}"/>
+                <a16:creationId xmlns:a16="http://schemas.microsoft.com/office/drawing/2014/main" id="{C2443F80-4B74-4910-A928-B1B8D57FEB8E}"/>
               </a:ext>
             </a:extLst>
           </p:cNvPr>
@@ -6250,7 +6250,7 @@
           <p:cNvPr id="7" name="">
             <a:extLst xmlns:a="http://schemas.openxmlformats.org/drawingml/2006/main">
               <a:ext uri="{FF2B5EF4-FFF2-40B4-BE49-F238E27FC236}">
-                <a16:creationId xmlns:a16="http://schemas.microsoft.com/office/drawing/2014/main" id="{2A2FB707-FE39-422F-8FB7-4330F06E6D44}"/>
+                <a16:creationId xmlns:a16="http://schemas.microsoft.com/office/drawing/2014/main" id="{4A41718D-0B79-48E3-809B-087329D1B121}"/>
               </a:ext>
             </a:extLst>
           </p:cNvPr>
@@ -6281,7 +6281,7 @@
           <p:cNvPr id="8" name="">
             <a:extLst xmlns:a="http://schemas.openxmlformats.org/drawingml/2006/main">
               <a:ext uri="{FF2B5EF4-FFF2-40B4-BE49-F238E27FC236}">
-                <a16:creationId xmlns:a16="http://schemas.microsoft.com/office/drawing/2014/main" id="{42246D3F-6F82-4194-B808-C972F78A1F73}"/>
+                <a16:creationId xmlns:a16="http://schemas.microsoft.com/office/drawing/2014/main" id="{D5EEC9DF-3E87-48CD-A822-5363AA0BCCA1}"/>
               </a:ext>
             </a:extLst>
           </p:cNvPr>
@@ -6331,7 +6331,7 @@
           <p:cNvPr id="9" name="">
             <a:extLst xmlns:a="http://schemas.openxmlformats.org/drawingml/2006/main">
               <a:ext uri="{FF2B5EF4-FFF2-40B4-BE49-F238E27FC236}">
-                <a16:creationId xmlns:a16="http://schemas.microsoft.com/office/drawing/2014/main" id="{8772739E-E5B7-45BA-A47A-8ADD6BDD8EE5}"/>
+                <a16:creationId xmlns:a16="http://schemas.microsoft.com/office/drawing/2014/main" id="{E96A55B2-C67F-489A-B3F2-89313F495BDC}"/>
               </a:ext>
             </a:extLst>
           </p:cNvPr>
@@ -6362,7 +6362,7 @@
           <p:cNvPr id="10" name="">
             <a:extLst xmlns:a="http://schemas.openxmlformats.org/drawingml/2006/main">
               <a:ext uri="{FF2B5EF4-FFF2-40B4-BE49-F238E27FC236}">
-                <a16:creationId xmlns:a16="http://schemas.microsoft.com/office/drawing/2014/main" id="{E376BB26-F84A-45B6-8352-E30557D90B5E}"/>
+                <a16:creationId xmlns:a16="http://schemas.microsoft.com/office/drawing/2014/main" id="{6D474B52-83CF-4D1B-B2D1-7577A9E65D31}"/>
               </a:ext>
             </a:extLst>
           </p:cNvPr>
@@ -6412,7 +6412,7 @@
           <p:cNvPr id="11" name="">
             <a:extLst xmlns:a="http://schemas.openxmlformats.org/drawingml/2006/main">
               <a:ext uri="{FF2B5EF4-FFF2-40B4-BE49-F238E27FC236}">
-                <a16:creationId xmlns:a16="http://schemas.microsoft.com/office/drawing/2014/main" id="{8485790C-D3D5-4B27-98C8-FE86606C032C}"/>
+                <a16:creationId xmlns:a16="http://schemas.microsoft.com/office/drawing/2014/main" id="{7FB54C0A-8759-4EAC-BDAF-73A72AB87610}"/>
               </a:ext>
             </a:extLst>
           </p:cNvPr>
@@ -6443,7 +6443,7 @@
           <p:cNvPr id="12" name="">
             <a:extLst xmlns:a="http://schemas.openxmlformats.org/drawingml/2006/main">
               <a:ext uri="{FF2B5EF4-FFF2-40B4-BE49-F238E27FC236}">
-                <a16:creationId xmlns:a16="http://schemas.microsoft.com/office/drawing/2014/main" id="{8FCE8963-FDCE-4DED-AEAE-3AFBEFBC6AD6}"/>
+                <a16:creationId xmlns:a16="http://schemas.microsoft.com/office/drawing/2014/main" id="{2C6DC7FF-4ECB-4858-BDB1-F33897939524}"/>
               </a:ext>
             </a:extLst>
           </p:cNvPr>
@@ -6493,7 +6493,7 @@
           <p:cNvPr id="13" name="">
             <a:extLst xmlns:a="http://schemas.openxmlformats.org/drawingml/2006/main">
               <a:ext uri="{FF2B5EF4-FFF2-40B4-BE49-F238E27FC236}">
-                <a16:creationId xmlns:a16="http://schemas.microsoft.com/office/drawing/2014/main" id="{B1854766-FFAD-40B4-B5E0-95118E83D1FE}"/>
+                <a16:creationId xmlns:a16="http://schemas.microsoft.com/office/drawing/2014/main" id="{FF09279C-7BFB-4893-BB0E-935700396E06}"/>
               </a:ext>
             </a:extLst>
           </p:cNvPr>
@@ -6524,7 +6524,7 @@
           <p:cNvPr id="14" name="">
             <a:extLst xmlns:a="http://schemas.openxmlformats.org/drawingml/2006/main">
               <a:ext uri="{FF2B5EF4-FFF2-40B4-BE49-F238E27FC236}">
-                <a16:creationId xmlns:a16="http://schemas.microsoft.com/office/drawing/2014/main" id="{8523232C-E234-4753-BB09-2D5239BBD69E}"/>
+                <a16:creationId xmlns:a16="http://schemas.microsoft.com/office/drawing/2014/main" id="{A492D58D-251C-487F-9B9F-B4D710ED0EA8}"/>
               </a:ext>
             </a:extLst>
           </p:cNvPr>
@@ -6574,7 +6574,7 @@
           <p:cNvPr id="15" name="">
             <a:extLst xmlns:a="http://schemas.openxmlformats.org/drawingml/2006/main">
               <a:ext uri="{FF2B5EF4-FFF2-40B4-BE49-F238E27FC236}">
-                <a16:creationId xmlns:a16="http://schemas.microsoft.com/office/drawing/2014/main" id="{CFAE7343-95C4-46A6-B7CA-48B819E92D94}"/>
+                <a16:creationId xmlns:a16="http://schemas.microsoft.com/office/drawing/2014/main" id="{6A97F8F9-003C-4648-92FD-C24815464FCF}"/>
               </a:ext>
             </a:extLst>
           </p:cNvPr>
@@ -6624,7 +6624,7 @@
           <p:cNvPr id="16" name="">
             <a:extLst xmlns:a="http://schemas.openxmlformats.org/drawingml/2006/main">
               <a:ext uri="{FF2B5EF4-FFF2-40B4-BE49-F238E27FC236}">
-                <a16:creationId xmlns:a16="http://schemas.microsoft.com/office/drawing/2014/main" id="{61529C79-9173-444A-9465-C735FA59A84A}"/>
+                <a16:creationId xmlns:a16="http://schemas.microsoft.com/office/drawing/2014/main" id="{79F2B33E-55A9-4C60-B145-8F92D4295EBF}"/>
               </a:ext>
             </a:extLst>
           </p:cNvPr>
@@ -6655,7 +6655,7 @@
           <p:cNvPr id="17" name="">
             <a:extLst xmlns:a="http://schemas.openxmlformats.org/drawingml/2006/main">
               <a:ext uri="{FF2B5EF4-FFF2-40B4-BE49-F238E27FC236}">
-                <a16:creationId xmlns:a16="http://schemas.microsoft.com/office/drawing/2014/main" id="{19553A68-021F-448D-80CF-5EB43A65BD15}"/>
+                <a16:creationId xmlns:a16="http://schemas.microsoft.com/office/drawing/2014/main" id="{0EE5789A-E375-48E1-B82E-647404833293}"/>
               </a:ext>
             </a:extLst>
           </p:cNvPr>
@@ -6705,7 +6705,7 @@
           <p:cNvPr id="18" name="">
             <a:extLst xmlns:a="http://schemas.openxmlformats.org/drawingml/2006/main">
               <a:ext uri="{FF2B5EF4-FFF2-40B4-BE49-F238E27FC236}">
-                <a16:creationId xmlns:a16="http://schemas.microsoft.com/office/drawing/2014/main" id="{ABA05AFB-D5D7-4AFB-BC5E-EE0D015F8A73}"/>
+                <a16:creationId xmlns:a16="http://schemas.microsoft.com/office/drawing/2014/main" id="{E2312C2D-BCB5-4063-9064-EDE4A7902863}"/>
               </a:ext>
             </a:extLst>
           </p:cNvPr>
@@ -6736,7 +6736,7 @@
           <p:cNvPr id="19" name="">
             <a:extLst xmlns:a="http://schemas.openxmlformats.org/drawingml/2006/main">
               <a:ext uri="{FF2B5EF4-FFF2-40B4-BE49-F238E27FC236}">
-                <a16:creationId xmlns:a16="http://schemas.microsoft.com/office/drawing/2014/main" id="{750A13E4-06DB-46BA-8534-FF1A0A91D3C5}"/>
+                <a16:creationId xmlns:a16="http://schemas.microsoft.com/office/drawing/2014/main" id="{C34035D1-7B79-4A78-86C6-763357D257BA}"/>
               </a:ext>
             </a:extLst>
           </p:cNvPr>
@@ -6786,7 +6786,7 @@
           <p:cNvPr id="20" name="">
             <a:extLst xmlns:a="http://schemas.openxmlformats.org/drawingml/2006/main">
               <a:ext uri="{FF2B5EF4-FFF2-40B4-BE49-F238E27FC236}">
-                <a16:creationId xmlns:a16="http://schemas.microsoft.com/office/drawing/2014/main" id="{217C4AB9-06C7-4433-A53D-C8756EBE6290}"/>
+                <a16:creationId xmlns:a16="http://schemas.microsoft.com/office/drawing/2014/main" id="{5558B40C-A631-4605-A466-15A3B0B9DE68}"/>
               </a:ext>
             </a:extLst>
           </p:cNvPr>
@@ -6817,7 +6817,7 @@
           <p:cNvPr id="21" name="">
             <a:extLst xmlns:a="http://schemas.openxmlformats.org/drawingml/2006/main">
               <a:ext uri="{FF2B5EF4-FFF2-40B4-BE49-F238E27FC236}">
-                <a16:creationId xmlns:a16="http://schemas.microsoft.com/office/drawing/2014/main" id="{EDC411F5-D1FD-45DA-BD12-C10B5C922AC5}"/>
+                <a16:creationId xmlns:a16="http://schemas.microsoft.com/office/drawing/2014/main" id="{25A43CC6-2CF3-4A1C-BC7F-A6D6C3D40F79}"/>
               </a:ext>
             </a:extLst>
           </p:cNvPr>
@@ -6867,7 +6867,7 @@
           <p:cNvPr id="22" name="">
             <a:extLst xmlns:a="http://schemas.openxmlformats.org/drawingml/2006/main">
               <a:ext uri="{FF2B5EF4-FFF2-40B4-BE49-F238E27FC236}">
-                <a16:creationId xmlns:a16="http://schemas.microsoft.com/office/drawing/2014/main" id="{3F649D4A-EF69-49EA-A4E9-F78FE134BC43}"/>
+                <a16:creationId xmlns:a16="http://schemas.microsoft.com/office/drawing/2014/main" id="{EAC8EE79-ADF4-410F-A3D6-908AE0E810D9}"/>
               </a:ext>
             </a:extLst>
           </p:cNvPr>
@@ -6898,7 +6898,7 @@
           <p:cNvPr id="23" name="">
             <a:extLst xmlns:a="http://schemas.openxmlformats.org/drawingml/2006/main">
               <a:ext uri="{FF2B5EF4-FFF2-40B4-BE49-F238E27FC236}">
-                <a16:creationId xmlns:a16="http://schemas.microsoft.com/office/drawing/2014/main" id="{30206F1A-5695-4267-8475-C2571DA9E24E}"/>
+                <a16:creationId xmlns:a16="http://schemas.microsoft.com/office/drawing/2014/main" id="{F6207350-42D5-47B9-9EEB-41062BCD6FB6}"/>
               </a:ext>
             </a:extLst>
           </p:cNvPr>
@@ -6946,7 +6946,7 @@
     </p:spTree>
     <p:extLst>
       <p:ext uri="{BB962C8B-B14F-4D97-AF65-F5344CB8AC3E}">
-        <p14:creationId xmlns:p14="http://schemas.microsoft.com/office/powerpoint/2010/main" val="1370534528"/>
+        <p14:creationId xmlns:p14="http://schemas.microsoft.com/office/powerpoint/2010/main" val="1204216313"/>
       </p:ext>
     </p:extLst>
   </p:cSld>
@@ -6977,7 +6977,7 @@
           <p:cNvPr id="24" name="">
             <a:extLst xmlns:a="http://schemas.openxmlformats.org/drawingml/2006/main">
               <a:ext uri="{FF2B5EF4-FFF2-40B4-BE49-F238E27FC236}">
-                <a16:creationId xmlns:a16="http://schemas.microsoft.com/office/drawing/2014/main" id="{0C1EAE1B-3E60-4CF4-B983-E255C001016E}"/>
+                <a16:creationId xmlns:a16="http://schemas.microsoft.com/office/drawing/2014/main" id="{826D833F-98CE-4002-867F-B3FC37EA215C}"/>
               </a:ext>
             </a:extLst>
           </p:cNvPr>
@@ -7027,7 +7027,7 @@
           <p:cNvPr id="2" name="">
             <a:extLst xmlns:a="http://schemas.openxmlformats.org/drawingml/2006/main">
               <a:ext uri="{FF2B5EF4-FFF2-40B4-BE49-F238E27FC236}">
-                <a16:creationId xmlns:a16="http://schemas.microsoft.com/office/drawing/2014/main" id="{CBD952C5-17E4-42E8-A164-7DBA865810D9}"/>
+                <a16:creationId xmlns:a16="http://schemas.microsoft.com/office/drawing/2014/main" id="{01A63265-E791-4C14-8967-7B63F146CDDE}"/>
               </a:ext>
             </a:extLst>
           </p:cNvPr>
@@ -7077,7 +7077,7 @@
           <p:cNvPr id="3" name="">
             <a:extLst xmlns:a="http://schemas.openxmlformats.org/drawingml/2006/main">
               <a:ext uri="{FF2B5EF4-FFF2-40B4-BE49-F238E27FC236}">
-                <a16:creationId xmlns:a16="http://schemas.microsoft.com/office/drawing/2014/main" id="{14C35E77-2884-4B15-84F8-9BAE2E3F6B28}"/>
+                <a16:creationId xmlns:a16="http://schemas.microsoft.com/office/drawing/2014/main" id="{4EAA57E9-4CD1-412D-99AD-DDC4295BFFA7}"/>
               </a:ext>
             </a:extLst>
           </p:cNvPr>
@@ -7108,7 +7108,7 @@
           <p:cNvPr id="4" name="">
             <a:extLst xmlns:a="http://schemas.openxmlformats.org/drawingml/2006/main">
               <a:ext uri="{FF2B5EF4-FFF2-40B4-BE49-F238E27FC236}">
-                <a16:creationId xmlns:a16="http://schemas.microsoft.com/office/drawing/2014/main" id="{DB857B75-8FEE-451D-B9E6-2118E1D834AC}"/>
+                <a16:creationId xmlns:a16="http://schemas.microsoft.com/office/drawing/2014/main" id="{1990F114-C200-427F-88E1-6691D6E5DDFE}"/>
               </a:ext>
             </a:extLst>
           </p:cNvPr>
@@ -7158,7 +7158,7 @@
           <p:cNvPr id="5" name="">
             <a:extLst xmlns:a="http://schemas.openxmlformats.org/drawingml/2006/main">
               <a:ext uri="{FF2B5EF4-FFF2-40B4-BE49-F238E27FC236}">
-                <a16:creationId xmlns:a16="http://schemas.microsoft.com/office/drawing/2014/main" id="{2330B428-85DE-43BC-9C03-93196ECFEFB1}"/>
+                <a16:creationId xmlns:a16="http://schemas.microsoft.com/office/drawing/2014/main" id="{E2C55418-D608-474D-858E-5EFD86373009}"/>
               </a:ext>
             </a:extLst>
           </p:cNvPr>
@@ -7208,7 +7208,7 @@
           <p:cNvPr id="6" name="">
             <a:extLst xmlns:a="http://schemas.openxmlformats.org/drawingml/2006/main">
               <a:ext uri="{FF2B5EF4-FFF2-40B4-BE49-F238E27FC236}">
-                <a16:creationId xmlns:a16="http://schemas.microsoft.com/office/drawing/2014/main" id="{2131EC86-3A3A-43E8-886D-C2CD57E25F03}"/>
+                <a16:creationId xmlns:a16="http://schemas.microsoft.com/office/drawing/2014/main" id="{AC0F58CD-7577-4696-BA49-DB7271DC281B}"/>
               </a:ext>
             </a:extLst>
           </p:cNvPr>
@@ -7258,7 +7258,7 @@
           <p:cNvPr id="7" name="">
             <a:extLst xmlns:a="http://schemas.openxmlformats.org/drawingml/2006/main">
               <a:ext uri="{FF2B5EF4-FFF2-40B4-BE49-F238E27FC236}">
-                <a16:creationId xmlns:a16="http://schemas.microsoft.com/office/drawing/2014/main" id="{D202F92D-8AE8-4690-8C00-A159BD602C9D}"/>
+                <a16:creationId xmlns:a16="http://schemas.microsoft.com/office/drawing/2014/main" id="{531FB41C-E020-41F0-925B-53FEF492981C}"/>
               </a:ext>
             </a:extLst>
           </p:cNvPr>
@@ -7289,7 +7289,7 @@
           <p:cNvPr id="8" name="">
             <a:extLst xmlns:a="http://schemas.openxmlformats.org/drawingml/2006/main">
               <a:ext uri="{FF2B5EF4-FFF2-40B4-BE49-F238E27FC236}">
-                <a16:creationId xmlns:a16="http://schemas.microsoft.com/office/drawing/2014/main" id="{4ABA7E49-A900-4DEA-B797-A2EF0DC064F7}"/>
+                <a16:creationId xmlns:a16="http://schemas.microsoft.com/office/drawing/2014/main" id="{3A572722-2873-4D6D-834C-5995493D18A0}"/>
               </a:ext>
             </a:extLst>
           </p:cNvPr>
@@ -7339,7 +7339,7 @@
           <p:cNvPr id="9" name="">
             <a:extLst xmlns:a="http://schemas.openxmlformats.org/drawingml/2006/main">
               <a:ext uri="{FF2B5EF4-FFF2-40B4-BE49-F238E27FC236}">
-                <a16:creationId xmlns:a16="http://schemas.microsoft.com/office/drawing/2014/main" id="{B0261559-7CF2-4624-B07F-DEA7D014F5C7}"/>
+                <a16:creationId xmlns:a16="http://schemas.microsoft.com/office/drawing/2014/main" id="{7C80D6FC-05FF-470C-B67C-9CAA42CAE9B2}"/>
               </a:ext>
             </a:extLst>
           </p:cNvPr>
@@ -7370,7 +7370,7 @@
           <p:cNvPr id="10" name="">
             <a:extLst xmlns:a="http://schemas.openxmlformats.org/drawingml/2006/main">
               <a:ext uri="{FF2B5EF4-FFF2-40B4-BE49-F238E27FC236}">
-                <a16:creationId xmlns:a16="http://schemas.microsoft.com/office/drawing/2014/main" id="{CC37975B-70DE-4562-A8A7-43C04AEF5588}"/>
+                <a16:creationId xmlns:a16="http://schemas.microsoft.com/office/drawing/2014/main" id="{1F9F8498-A222-48E5-8CB8-8400519DEC2D}"/>
               </a:ext>
             </a:extLst>
           </p:cNvPr>
@@ -7420,7 +7420,7 @@
           <p:cNvPr id="11" name="">
             <a:extLst xmlns:a="http://schemas.openxmlformats.org/drawingml/2006/main">
               <a:ext uri="{FF2B5EF4-FFF2-40B4-BE49-F238E27FC236}">
-                <a16:creationId xmlns:a16="http://schemas.microsoft.com/office/drawing/2014/main" id="{2C39B6CE-63A0-489A-BBE4-D3CD9C81D3C7}"/>
+                <a16:creationId xmlns:a16="http://schemas.microsoft.com/office/drawing/2014/main" id="{70AD1477-F456-46A2-996C-98A0CDEB5302}"/>
               </a:ext>
             </a:extLst>
           </p:cNvPr>
@@ -7451,7 +7451,7 @@
           <p:cNvPr id="12" name="">
             <a:extLst xmlns:a="http://schemas.openxmlformats.org/drawingml/2006/main">
               <a:ext uri="{FF2B5EF4-FFF2-40B4-BE49-F238E27FC236}">
-                <a16:creationId xmlns:a16="http://schemas.microsoft.com/office/drawing/2014/main" id="{7A3662C9-CD84-4408-8212-BD2A50746D5C}"/>
+                <a16:creationId xmlns:a16="http://schemas.microsoft.com/office/drawing/2014/main" id="{97FD80F1-42F6-4100-8320-D6A05772C62F}"/>
               </a:ext>
             </a:extLst>
           </p:cNvPr>
@@ -7501,7 +7501,7 @@
           <p:cNvPr id="13" name="">
             <a:extLst xmlns:a="http://schemas.openxmlformats.org/drawingml/2006/main">
               <a:ext uri="{FF2B5EF4-FFF2-40B4-BE49-F238E27FC236}">
-                <a16:creationId xmlns:a16="http://schemas.microsoft.com/office/drawing/2014/main" id="{224029BC-86DC-49C5-B0A6-2683027E7491}"/>
+                <a16:creationId xmlns:a16="http://schemas.microsoft.com/office/drawing/2014/main" id="{43478A4A-E106-4420-B0F5-A2D6D9706B7B}"/>
               </a:ext>
             </a:extLst>
           </p:cNvPr>
@@ -7532,7 +7532,7 @@
           <p:cNvPr id="14" name="">
             <a:extLst xmlns:a="http://schemas.openxmlformats.org/drawingml/2006/main">
               <a:ext uri="{FF2B5EF4-FFF2-40B4-BE49-F238E27FC236}">
-                <a16:creationId xmlns:a16="http://schemas.microsoft.com/office/drawing/2014/main" id="{764FB0EB-DA56-4B4C-9BB2-E4BE313D14ED}"/>
+                <a16:creationId xmlns:a16="http://schemas.microsoft.com/office/drawing/2014/main" id="{E097EF49-469F-4F90-A378-32097D489067}"/>
               </a:ext>
             </a:extLst>
           </p:cNvPr>
@@ -7582,7 +7582,7 @@
           <p:cNvPr id="15" name="">
             <a:extLst xmlns:a="http://schemas.openxmlformats.org/drawingml/2006/main">
               <a:ext uri="{FF2B5EF4-FFF2-40B4-BE49-F238E27FC236}">
-                <a16:creationId xmlns:a16="http://schemas.microsoft.com/office/drawing/2014/main" id="{0A1AFBF4-F5EF-4527-AC73-82B3CE6B7EFE}"/>
+                <a16:creationId xmlns:a16="http://schemas.microsoft.com/office/drawing/2014/main" id="{7C9CEC26-24D9-4B3A-8643-27DC7642B64A}"/>
               </a:ext>
             </a:extLst>
           </p:cNvPr>
@@ -7632,7 +7632,7 @@
           <p:cNvPr id="16" name="">
             <a:extLst xmlns:a="http://schemas.openxmlformats.org/drawingml/2006/main">
               <a:ext uri="{FF2B5EF4-FFF2-40B4-BE49-F238E27FC236}">
-                <a16:creationId xmlns:a16="http://schemas.microsoft.com/office/drawing/2014/main" id="{04548AE7-F280-45B0-AEAF-02B2CDD4009B}"/>
+                <a16:creationId xmlns:a16="http://schemas.microsoft.com/office/drawing/2014/main" id="{6366DD05-4322-482A-9B98-264BAE1A4B13}"/>
               </a:ext>
             </a:extLst>
           </p:cNvPr>
@@ -7663,7 +7663,7 @@
           <p:cNvPr id="17" name="">
             <a:extLst xmlns:a="http://schemas.openxmlformats.org/drawingml/2006/main">
               <a:ext uri="{FF2B5EF4-FFF2-40B4-BE49-F238E27FC236}">
-                <a16:creationId xmlns:a16="http://schemas.microsoft.com/office/drawing/2014/main" id="{73251A63-5037-42B8-B942-209B3D694AB5}"/>
+                <a16:creationId xmlns:a16="http://schemas.microsoft.com/office/drawing/2014/main" id="{0F49102D-E7C9-4337-B9CB-720CDAC70614}"/>
               </a:ext>
             </a:extLst>
           </p:cNvPr>
@@ -7713,7 +7713,7 @@
           <p:cNvPr id="18" name="">
             <a:extLst xmlns:a="http://schemas.openxmlformats.org/drawingml/2006/main">
               <a:ext uri="{FF2B5EF4-FFF2-40B4-BE49-F238E27FC236}">
-                <a16:creationId xmlns:a16="http://schemas.microsoft.com/office/drawing/2014/main" id="{B884B3DA-0AF3-4DF0-8D37-A580DF6013EC}"/>
+                <a16:creationId xmlns:a16="http://schemas.microsoft.com/office/drawing/2014/main" id="{476E36EC-FFD0-4243-A358-471F3F2D7D41}"/>
               </a:ext>
             </a:extLst>
           </p:cNvPr>
@@ -7744,7 +7744,7 @@
           <p:cNvPr id="19" name="">
             <a:extLst xmlns:a="http://schemas.openxmlformats.org/drawingml/2006/main">
               <a:ext uri="{FF2B5EF4-FFF2-40B4-BE49-F238E27FC236}">
-                <a16:creationId xmlns:a16="http://schemas.microsoft.com/office/drawing/2014/main" id="{5C48A51C-3423-44D6-8376-5F54CDB7B16A}"/>
+                <a16:creationId xmlns:a16="http://schemas.microsoft.com/office/drawing/2014/main" id="{84030BC7-4D12-42E5-B60C-48045FEEB876}"/>
               </a:ext>
             </a:extLst>
           </p:cNvPr>
@@ -7794,7 +7794,7 @@
           <p:cNvPr id="20" name="">
             <a:extLst xmlns:a="http://schemas.openxmlformats.org/drawingml/2006/main">
               <a:ext uri="{FF2B5EF4-FFF2-40B4-BE49-F238E27FC236}">
-                <a16:creationId xmlns:a16="http://schemas.microsoft.com/office/drawing/2014/main" id="{E70FCC04-3280-4706-95B8-5279DA7FA25C}"/>
+                <a16:creationId xmlns:a16="http://schemas.microsoft.com/office/drawing/2014/main" id="{DD5ED9DC-0A9F-445E-B11C-9696AEA2F510}"/>
               </a:ext>
             </a:extLst>
           </p:cNvPr>
@@ -7825,7 +7825,7 @@
           <p:cNvPr id="21" name="">
             <a:extLst xmlns:a="http://schemas.openxmlformats.org/drawingml/2006/main">
               <a:ext uri="{FF2B5EF4-FFF2-40B4-BE49-F238E27FC236}">
-                <a16:creationId xmlns:a16="http://schemas.microsoft.com/office/drawing/2014/main" id="{66E2AA9C-FE77-4F93-8000-0A21E30611FB}"/>
+                <a16:creationId xmlns:a16="http://schemas.microsoft.com/office/drawing/2014/main" id="{5D08B62B-8D9B-4712-828B-46E5A35B152D}"/>
               </a:ext>
             </a:extLst>
           </p:cNvPr>
@@ -7875,7 +7875,7 @@
           <p:cNvPr id="22" name="">
             <a:extLst xmlns:a="http://schemas.openxmlformats.org/drawingml/2006/main">
               <a:ext uri="{FF2B5EF4-FFF2-40B4-BE49-F238E27FC236}">
-                <a16:creationId xmlns:a16="http://schemas.microsoft.com/office/drawing/2014/main" id="{A399829D-C853-4AE1-BFB4-B02227E55A5C}"/>
+                <a16:creationId xmlns:a16="http://schemas.microsoft.com/office/drawing/2014/main" id="{930C3239-DA41-4ADC-A4CF-268BFEEF9A2E}"/>
               </a:ext>
             </a:extLst>
           </p:cNvPr>
@@ -7906,7 +7906,7 @@
           <p:cNvPr id="23" name="">
             <a:extLst xmlns:a="http://schemas.openxmlformats.org/drawingml/2006/main">
               <a:ext uri="{FF2B5EF4-FFF2-40B4-BE49-F238E27FC236}">
-                <a16:creationId xmlns:a16="http://schemas.microsoft.com/office/drawing/2014/main" id="{CD5EFDBA-B272-4F09-A19F-8B99277C2039}"/>
+                <a16:creationId xmlns:a16="http://schemas.microsoft.com/office/drawing/2014/main" id="{BC30DF5D-28B7-4A8F-AEB2-14CE3ACFDC90}"/>
               </a:ext>
             </a:extLst>
           </p:cNvPr>
@@ -7954,7 +7954,7 @@
     </p:spTree>
     <p:extLst>
       <p:ext uri="{BB962C8B-B14F-4D97-AF65-F5344CB8AC3E}">
-        <p14:creationId xmlns:p14="http://schemas.microsoft.com/office/powerpoint/2010/main" val="711652390"/>
+        <p14:creationId xmlns:p14="http://schemas.microsoft.com/office/powerpoint/2010/main" val="369303177"/>
       </p:ext>
     </p:extLst>
   </p:cSld>
@@ -7982,10 +7982,10 @@
       </p:grpSpPr>
       <p:sp>
         <p:nvSpPr>
-          <p:cNvPr id="21" name="">
-            <a:extLst xmlns:a="http://schemas.openxmlformats.org/drawingml/2006/main">
-              <a:ext uri="{FF2B5EF4-FFF2-40B4-BE49-F238E27FC236}">
-                <a16:creationId xmlns:a16="http://schemas.microsoft.com/office/drawing/2014/main" id="{9371343E-AA66-4221-B3B8-1CE3750616F1}"/>
+          <p:cNvPr id="24" name="">
+            <a:extLst xmlns:a="http://schemas.openxmlformats.org/drawingml/2006/main">
+              <a:ext uri="{FF2B5EF4-FFF2-40B4-BE49-F238E27FC236}">
+                <a16:creationId xmlns:a16="http://schemas.microsoft.com/office/drawing/2014/main" id="{F279A5BD-BA52-41A1-9000-6CE0F07D650F}"/>
               </a:ext>
             </a:extLst>
           </p:cNvPr>
@@ -8035,7 +8035,7 @@
           <p:cNvPr id="2" name="">
             <a:extLst xmlns:a="http://schemas.openxmlformats.org/drawingml/2006/main">
               <a:ext uri="{FF2B5EF4-FFF2-40B4-BE49-F238E27FC236}">
-                <a16:creationId xmlns:a16="http://schemas.microsoft.com/office/drawing/2014/main" id="{236C92F1-081A-4BA7-BC62-D360FB5B866F}"/>
+                <a16:creationId xmlns:a16="http://schemas.microsoft.com/office/drawing/2014/main" id="{A5B677B0-932A-406E-B155-4AD8A7E2B6CF}"/>
               </a:ext>
             </a:extLst>
           </p:cNvPr>
@@ -8085,7 +8085,7 @@
           <p:cNvPr id="3" name="">
             <a:extLst xmlns:a="http://schemas.openxmlformats.org/drawingml/2006/main">
               <a:ext uri="{FF2B5EF4-FFF2-40B4-BE49-F238E27FC236}">
-                <a16:creationId xmlns:a16="http://schemas.microsoft.com/office/drawing/2014/main" id="{BB3F1875-64A9-4700-8E3A-57278238E933}"/>
+                <a16:creationId xmlns:a16="http://schemas.microsoft.com/office/drawing/2014/main" id="{7AA20A63-47C3-4ED5-B0E7-C267941B8F17}"/>
               </a:ext>
             </a:extLst>
           </p:cNvPr>
@@ -8116,7 +8116,7 @@
           <p:cNvPr id="4" name="">
             <a:extLst xmlns:a="http://schemas.openxmlformats.org/drawingml/2006/main">
               <a:ext uri="{FF2B5EF4-FFF2-40B4-BE49-F238E27FC236}">
-                <a16:creationId xmlns:a16="http://schemas.microsoft.com/office/drawing/2014/main" id="{17CB3E11-F123-4592-B475-CDCA17A69D50}"/>
+                <a16:creationId xmlns:a16="http://schemas.microsoft.com/office/drawing/2014/main" id="{5ADCA52C-770C-437F-9170-FD2E738266FC}"/>
               </a:ext>
             </a:extLst>
           </p:cNvPr>
@@ -8166,7 +8166,7 @@
           <p:cNvPr id="5" name="">
             <a:extLst xmlns:a="http://schemas.openxmlformats.org/drawingml/2006/main">
               <a:ext uri="{FF2B5EF4-FFF2-40B4-BE49-F238E27FC236}">
-                <a16:creationId xmlns:a16="http://schemas.microsoft.com/office/drawing/2014/main" id="{93255DE4-0D00-455D-B597-5426FC8191AB}"/>
+                <a16:creationId xmlns:a16="http://schemas.microsoft.com/office/drawing/2014/main" id="{6F50E19C-D394-4F0E-82F1-4CFB8CAF3AE8}"/>
               </a:ext>
             </a:extLst>
           </p:cNvPr>
@@ -8216,23 +8216,23 @@
           <p:cNvPr id="6" name="">
             <a:extLst xmlns:a="http://schemas.openxmlformats.org/drawingml/2006/main">
               <a:ext uri="{FF2B5EF4-FFF2-40B4-BE49-F238E27FC236}">
-                <a16:creationId xmlns:a16="http://schemas.microsoft.com/office/drawing/2014/main" id="{5F798788-2A68-4465-B0BA-FA5DCAB05733}"/>
-              </a:ext>
-            </a:extLst>
-          </p:cNvPr>
-          <p:cNvSpPr>
-            <a:spLocks xmlns:a="http://schemas.openxmlformats.org/drawingml/2006/main" noGrp="1"/>
-          </p:cNvSpPr>
-          <p:nvPr/>
-        </p:nvSpPr>
-        <p:spPr>
-          <a:xfrm xmlns:a="http://schemas.openxmlformats.org/drawingml/2006/main">
-            <a:off x="1162050" y="1847850"/>
-            <a:ext cx="457200" cy="457200"/>
+                <a16:creationId xmlns:a16="http://schemas.microsoft.com/office/drawing/2014/main" id="{C21C03D2-B95C-4F17-BA73-0F8DCFF2A195}"/>
+              </a:ext>
+            </a:extLst>
+          </p:cNvPr>
+          <p:cNvSpPr>
+            <a:spLocks xmlns:a="http://schemas.openxmlformats.org/drawingml/2006/main" noGrp="1"/>
+          </p:cNvSpPr>
+          <p:nvPr/>
+        </p:nvSpPr>
+        <p:spPr>
+          <a:xfrm xmlns:a="http://schemas.openxmlformats.org/drawingml/2006/main">
+            <a:off x="1162050" y="1752600"/>
+            <a:ext cx="438150" cy="438150"/>
           </a:xfrm>
           <a:prstGeom xmlns:a="http://schemas.openxmlformats.org/drawingml/2006/main" prst="roundRect">
             <a:avLst>
-              <a:gd name="adj" fmla="val 16667"/>
+              <a:gd name="adj" fmla="val 17391"/>
             </a:avLst>
           </a:prstGeom>
           <a:solidFill xmlns:a="http://schemas.openxmlformats.org/drawingml/2006/main">
@@ -8270,18 +8270,18 @@
           <p:cNvPr id="7" name="">
             <a:extLst xmlns:a="http://schemas.openxmlformats.org/drawingml/2006/main">
               <a:ext uri="{FF2B5EF4-FFF2-40B4-BE49-F238E27FC236}">
-                <a16:creationId xmlns:a16="http://schemas.microsoft.com/office/drawing/2014/main" id="{A455ECF7-E90C-4B26-8AF0-676322D0160B}"/>
-              </a:ext>
-            </a:extLst>
-          </p:cNvPr>
-          <p:cNvSpPr>
-            <a:spLocks xmlns:a="http://schemas.openxmlformats.org/drawingml/2006/main" noGrp="1"/>
-          </p:cNvSpPr>
-          <p:nvPr/>
-        </p:nvSpPr>
-        <p:spPr>
-          <a:xfrm xmlns:a="http://schemas.openxmlformats.org/drawingml/2006/main">
-            <a:off x="2019300" y="1866900"/>
+                <a16:creationId xmlns:a16="http://schemas.microsoft.com/office/drawing/2014/main" id="{2B7DDA25-C522-4DE5-909A-7A3A1917820D}"/>
+              </a:ext>
+            </a:extLst>
+          </p:cNvPr>
+          <p:cNvSpPr>
+            <a:spLocks xmlns:a="http://schemas.openxmlformats.org/drawingml/2006/main" noGrp="1"/>
+          </p:cNvSpPr>
+          <p:nvPr/>
+        </p:nvSpPr>
+        <p:spPr>
+          <a:xfrm xmlns:a="http://schemas.openxmlformats.org/drawingml/2006/main">
+            <a:off x="2019300" y="1771650"/>
             <a:ext cx="3143250" cy="266700"/>
           </a:xfrm>
           <a:prstGeom xmlns:a="http://schemas.openxmlformats.org/drawingml/2006/main" prst="rect">
@@ -8320,18 +8320,18 @@
           <p:cNvPr id="8" name="">
             <a:extLst xmlns:a="http://schemas.openxmlformats.org/drawingml/2006/main">
               <a:ext uri="{FF2B5EF4-FFF2-40B4-BE49-F238E27FC236}">
-                <a16:creationId xmlns:a16="http://schemas.microsoft.com/office/drawing/2014/main" id="{13011794-1A74-42DC-B132-339AAF9AB788}"/>
-              </a:ext>
-            </a:extLst>
-          </p:cNvPr>
-          <p:cNvSpPr>
-            <a:spLocks xmlns:a="http://schemas.openxmlformats.org/drawingml/2006/main" noGrp="1"/>
-          </p:cNvSpPr>
-          <p:nvPr/>
-        </p:nvSpPr>
-        <p:spPr>
-          <a:xfrm xmlns:a="http://schemas.openxmlformats.org/drawingml/2006/main">
-            <a:off x="5429250" y="1905000"/>
+                <a16:creationId xmlns:a16="http://schemas.microsoft.com/office/drawing/2014/main" id="{B2100202-F6EB-4872-84A8-15A3DDDDEB56}"/>
+              </a:ext>
+            </a:extLst>
+          </p:cNvPr>
+          <p:cNvSpPr>
+            <a:spLocks xmlns:a="http://schemas.openxmlformats.org/drawingml/2006/main" noGrp="1"/>
+          </p:cNvSpPr>
+          <p:nvPr/>
+        </p:nvSpPr>
+        <p:spPr>
+          <a:xfrm xmlns:a="http://schemas.openxmlformats.org/drawingml/2006/main">
+            <a:off x="5429250" y="1809750"/>
             <a:ext cx="4953000" cy="266700"/>
           </a:xfrm>
           <a:prstGeom xmlns:a="http://schemas.openxmlformats.org/drawingml/2006/main" prst="rect">
@@ -8370,23 +8370,23 @@
           <p:cNvPr id="9" name="">
             <a:extLst xmlns:a="http://schemas.openxmlformats.org/drawingml/2006/main">
               <a:ext uri="{FF2B5EF4-FFF2-40B4-BE49-F238E27FC236}">
-                <a16:creationId xmlns:a16="http://schemas.microsoft.com/office/drawing/2014/main" id="{9E9363C3-B926-4A35-8314-0885C9AF2B26}"/>
-              </a:ext>
-            </a:extLst>
-          </p:cNvPr>
-          <p:cNvSpPr>
-            <a:spLocks xmlns:a="http://schemas.openxmlformats.org/drawingml/2006/main" noGrp="1"/>
-          </p:cNvSpPr>
-          <p:nvPr/>
-        </p:nvSpPr>
-        <p:spPr>
-          <a:xfrm xmlns:a="http://schemas.openxmlformats.org/drawingml/2006/main">
-            <a:off x="1162050" y="2590800"/>
-            <a:ext cx="457200" cy="457200"/>
+                <a16:creationId xmlns:a16="http://schemas.microsoft.com/office/drawing/2014/main" id="{F91ED8C4-3A04-4EC2-AC12-B266D906DA9A}"/>
+              </a:ext>
+            </a:extLst>
+          </p:cNvPr>
+          <p:cNvSpPr>
+            <a:spLocks xmlns:a="http://schemas.openxmlformats.org/drawingml/2006/main" noGrp="1"/>
+          </p:cNvSpPr>
+          <p:nvPr/>
+        </p:nvSpPr>
+        <p:spPr>
+          <a:xfrm xmlns:a="http://schemas.openxmlformats.org/drawingml/2006/main">
+            <a:off x="1162050" y="2362200"/>
+            <a:ext cx="438150" cy="438150"/>
           </a:xfrm>
           <a:prstGeom xmlns:a="http://schemas.openxmlformats.org/drawingml/2006/main" prst="roundRect">
             <a:avLst>
-              <a:gd name="adj" fmla="val 16667"/>
+              <a:gd name="adj" fmla="val 17391"/>
             </a:avLst>
           </a:prstGeom>
           <a:solidFill xmlns:a="http://schemas.openxmlformats.org/drawingml/2006/main">
@@ -8424,18 +8424,18 @@
           <p:cNvPr id="10" name="">
             <a:extLst xmlns:a="http://schemas.openxmlformats.org/drawingml/2006/main">
               <a:ext uri="{FF2B5EF4-FFF2-40B4-BE49-F238E27FC236}">
-                <a16:creationId xmlns:a16="http://schemas.microsoft.com/office/drawing/2014/main" id="{F0568359-0505-4B97-8FCB-10624085BB45}"/>
-              </a:ext>
-            </a:extLst>
-          </p:cNvPr>
-          <p:cNvSpPr>
-            <a:spLocks xmlns:a="http://schemas.openxmlformats.org/drawingml/2006/main" noGrp="1"/>
-          </p:cNvSpPr>
-          <p:nvPr/>
-        </p:nvSpPr>
-        <p:spPr>
-          <a:xfrm xmlns:a="http://schemas.openxmlformats.org/drawingml/2006/main">
-            <a:off x="2019300" y="2609850"/>
+                <a16:creationId xmlns:a16="http://schemas.microsoft.com/office/drawing/2014/main" id="{3B1672A4-315E-4095-873B-0E2496107112}"/>
+              </a:ext>
+            </a:extLst>
+          </p:cNvPr>
+          <p:cNvSpPr>
+            <a:spLocks xmlns:a="http://schemas.openxmlformats.org/drawingml/2006/main" noGrp="1"/>
+          </p:cNvSpPr>
+          <p:nvPr/>
+        </p:nvSpPr>
+        <p:spPr>
+          <a:xfrm xmlns:a="http://schemas.openxmlformats.org/drawingml/2006/main">
+            <a:off x="2019300" y="2381250"/>
             <a:ext cx="3143250" cy="266700"/>
           </a:xfrm>
           <a:prstGeom xmlns:a="http://schemas.openxmlformats.org/drawingml/2006/main" prst="rect">
@@ -8464,7 +8464,7 @@
                   <a:srgbClr val="102A43"/>
                 </a:solidFill>
               </a:rPr>
-              <a:t>Start search-node services</a:t>
+              <a:t>Share generated artifacts</a:t>
             </a:r>
           </a:p>
         </p:txBody>
@@ -8474,18 +8474,18 @@
           <p:cNvPr id="11" name="">
             <a:extLst xmlns:a="http://schemas.openxmlformats.org/drawingml/2006/main">
               <a:ext uri="{FF2B5EF4-FFF2-40B4-BE49-F238E27FC236}">
-                <a16:creationId xmlns:a16="http://schemas.microsoft.com/office/drawing/2014/main" id="{5AA18CB5-111C-4B89-84A5-5867D36D46E9}"/>
-              </a:ext>
-            </a:extLst>
-          </p:cNvPr>
-          <p:cNvSpPr>
-            <a:spLocks xmlns:a="http://schemas.openxmlformats.org/drawingml/2006/main" noGrp="1"/>
-          </p:cNvSpPr>
-          <p:nvPr/>
-        </p:nvSpPr>
-        <p:spPr>
-          <a:xfrm xmlns:a="http://schemas.openxmlformats.org/drawingml/2006/main">
-            <a:off x="5429250" y="2647950"/>
+                <a16:creationId xmlns:a16="http://schemas.microsoft.com/office/drawing/2014/main" id="{ADE4CD87-C9FE-4E31-9464-6CC6CB7AE9EC}"/>
+              </a:ext>
+            </a:extLst>
+          </p:cNvPr>
+          <p:cNvSpPr>
+            <a:spLocks xmlns:a="http://schemas.openxmlformats.org/drawingml/2006/main" noGrp="1"/>
+          </p:cNvSpPr>
+          <p:nvPr/>
+        </p:nvSpPr>
+        <p:spPr>
+          <a:xfrm xmlns:a="http://schemas.openxmlformats.org/drawingml/2006/main">
+            <a:off x="5429250" y="2419350"/>
             <a:ext cx="4953000" cy="266700"/>
           </a:xfrm>
           <a:prstGeom xmlns:a="http://schemas.openxmlformats.org/drawingml/2006/main" prst="rect">
@@ -8514,7 +8514,7 @@
                   <a:srgbClr val="5D6B78"/>
                 </a:solidFill>
               </a:rPr>
-              <a:t>each node loads one shard and index</a:t>
+              <a:t>use data/shards and indexes from the offline repo</a:t>
             </a:r>
           </a:p>
         </p:txBody>
@@ -8524,23 +8524,23 @@
           <p:cNvPr id="12" name="">
             <a:extLst xmlns:a="http://schemas.openxmlformats.org/drawingml/2006/main">
               <a:ext uri="{FF2B5EF4-FFF2-40B4-BE49-F238E27FC236}">
-                <a16:creationId xmlns:a16="http://schemas.microsoft.com/office/drawing/2014/main" id="{4AD405F2-2214-42ED-80F7-32DD8EB62606}"/>
-              </a:ext>
-            </a:extLst>
-          </p:cNvPr>
-          <p:cNvSpPr>
-            <a:spLocks xmlns:a="http://schemas.openxmlformats.org/drawingml/2006/main" noGrp="1"/>
-          </p:cNvSpPr>
-          <p:nvPr/>
-        </p:nvSpPr>
-        <p:spPr>
-          <a:xfrm xmlns:a="http://schemas.openxmlformats.org/drawingml/2006/main">
-            <a:off x="1162050" y="3333750"/>
-            <a:ext cx="457200" cy="457200"/>
+                <a16:creationId xmlns:a16="http://schemas.microsoft.com/office/drawing/2014/main" id="{D6DAA589-9DEB-444D-A6DE-AF9E63EBB9D3}"/>
+              </a:ext>
+            </a:extLst>
+          </p:cNvPr>
+          <p:cNvSpPr>
+            <a:spLocks xmlns:a="http://schemas.openxmlformats.org/drawingml/2006/main" noGrp="1"/>
+          </p:cNvSpPr>
+          <p:nvPr/>
+        </p:nvSpPr>
+        <p:spPr>
+          <a:xfrm xmlns:a="http://schemas.openxmlformats.org/drawingml/2006/main">
+            <a:off x="1162050" y="2971800"/>
+            <a:ext cx="438150" cy="438150"/>
           </a:xfrm>
           <a:prstGeom xmlns:a="http://schemas.openxmlformats.org/drawingml/2006/main" prst="roundRect">
             <a:avLst>
-              <a:gd name="adj" fmla="val 16667"/>
+              <a:gd name="adj" fmla="val 17391"/>
             </a:avLst>
           </a:prstGeom>
           <a:solidFill xmlns:a="http://schemas.openxmlformats.org/drawingml/2006/main">
@@ -8578,18 +8578,18 @@
           <p:cNvPr id="13" name="">
             <a:extLst xmlns:a="http://schemas.openxmlformats.org/drawingml/2006/main">
               <a:ext uri="{FF2B5EF4-FFF2-40B4-BE49-F238E27FC236}">
-                <a16:creationId xmlns:a16="http://schemas.microsoft.com/office/drawing/2014/main" id="{1F3924F8-56F0-4D91-8846-9D0D52223360}"/>
-              </a:ext>
-            </a:extLst>
-          </p:cNvPr>
-          <p:cNvSpPr>
-            <a:spLocks xmlns:a="http://schemas.openxmlformats.org/drawingml/2006/main" noGrp="1"/>
-          </p:cNvSpPr>
-          <p:nvPr/>
-        </p:nvSpPr>
-        <p:spPr>
-          <a:xfrm xmlns:a="http://schemas.openxmlformats.org/drawingml/2006/main">
-            <a:off x="2019300" y="3352800"/>
+                <a16:creationId xmlns:a16="http://schemas.microsoft.com/office/drawing/2014/main" id="{92645837-2C94-43D9-A62C-5227BAAACD73}"/>
+              </a:ext>
+            </a:extLst>
+          </p:cNvPr>
+          <p:cNvSpPr>
+            <a:spLocks xmlns:a="http://schemas.openxmlformats.org/drawingml/2006/main" noGrp="1"/>
+          </p:cNvSpPr>
+          <p:nvPr/>
+        </p:nvSpPr>
+        <p:spPr>
+          <a:xfrm xmlns:a="http://schemas.openxmlformats.org/drawingml/2006/main">
+            <a:off x="2019300" y="2990850"/>
             <a:ext cx="3143250" cy="266700"/>
           </a:xfrm>
           <a:prstGeom xmlns:a="http://schemas.openxmlformats.org/drawingml/2006/main" prst="rect">
@@ -8618,7 +8618,7 @@
                   <a:srgbClr val="102A43"/>
                 </a:solidFill>
               </a:rPr>
-              <a:t>Start coordinator</a:t>
+              <a:t>Start search-node services</a:t>
             </a:r>
           </a:p>
         </p:txBody>
@@ -8628,18 +8628,18 @@
           <p:cNvPr id="14" name="">
             <a:extLst xmlns:a="http://schemas.openxmlformats.org/drawingml/2006/main">
               <a:ext uri="{FF2B5EF4-FFF2-40B4-BE49-F238E27FC236}">
-                <a16:creationId xmlns:a16="http://schemas.microsoft.com/office/drawing/2014/main" id="{B0367BAE-36ED-434E-B903-B70152E6AA19}"/>
-              </a:ext>
-            </a:extLst>
-          </p:cNvPr>
-          <p:cNvSpPr>
-            <a:spLocks xmlns:a="http://schemas.openxmlformats.org/drawingml/2006/main" noGrp="1"/>
-          </p:cNvSpPr>
-          <p:nvPr/>
-        </p:nvSpPr>
-        <p:spPr>
-          <a:xfrm xmlns:a="http://schemas.openxmlformats.org/drawingml/2006/main">
-            <a:off x="5429250" y="3390900"/>
+                <a16:creationId xmlns:a16="http://schemas.microsoft.com/office/drawing/2014/main" id="{D7CAA340-7F66-40BD-B515-2CD86A686DB4}"/>
+              </a:ext>
+            </a:extLst>
+          </p:cNvPr>
+          <p:cNvSpPr>
+            <a:spLocks xmlns:a="http://schemas.openxmlformats.org/drawingml/2006/main" noGrp="1"/>
+          </p:cNvSpPr>
+          <p:nvPr/>
+        </p:nvSpPr>
+        <p:spPr>
+          <a:xfrm xmlns:a="http://schemas.openxmlformats.org/drawingml/2006/main">
+            <a:off x="5429250" y="3028950"/>
             <a:ext cx="4953000" cy="266700"/>
           </a:xfrm>
           <a:prstGeom xmlns:a="http://schemas.openxmlformats.org/drawingml/2006/main" prst="rect">
@@ -8668,7 +8668,7 @@
                   <a:srgbClr val="5D6B78"/>
                 </a:solidFill>
               </a:rPr>
-              <a:t>register node addresses and send fan-out query</a:t>
+              <a:t>each node loads one shard and index</a:t>
             </a:r>
           </a:p>
         </p:txBody>
@@ -8678,23 +8678,23 @@
           <p:cNvPr id="15" name="">
             <a:extLst xmlns:a="http://schemas.openxmlformats.org/drawingml/2006/main">
               <a:ext uri="{FF2B5EF4-FFF2-40B4-BE49-F238E27FC236}">
-                <a16:creationId xmlns:a16="http://schemas.microsoft.com/office/drawing/2014/main" id="{05A3B9F4-B2A6-40CA-A946-30BED127878C}"/>
-              </a:ext>
-            </a:extLst>
-          </p:cNvPr>
-          <p:cNvSpPr>
-            <a:spLocks xmlns:a="http://schemas.openxmlformats.org/drawingml/2006/main" noGrp="1"/>
-          </p:cNvSpPr>
-          <p:nvPr/>
-        </p:nvSpPr>
-        <p:spPr>
-          <a:xfrm xmlns:a="http://schemas.openxmlformats.org/drawingml/2006/main">
-            <a:off x="1162050" y="4076700"/>
-            <a:ext cx="457200" cy="457200"/>
+                <a16:creationId xmlns:a16="http://schemas.microsoft.com/office/drawing/2014/main" id="{06EE6EFA-336F-43C6-9C57-78D6D8B33833}"/>
+              </a:ext>
+            </a:extLst>
+          </p:cNvPr>
+          <p:cNvSpPr>
+            <a:spLocks xmlns:a="http://schemas.openxmlformats.org/drawingml/2006/main" noGrp="1"/>
+          </p:cNvSpPr>
+          <p:nvPr/>
+        </p:nvSpPr>
+        <p:spPr>
+          <a:xfrm xmlns:a="http://schemas.openxmlformats.org/drawingml/2006/main">
+            <a:off x="1162050" y="3581400"/>
+            <a:ext cx="438150" cy="438150"/>
           </a:xfrm>
           <a:prstGeom xmlns:a="http://schemas.openxmlformats.org/drawingml/2006/main" prst="roundRect">
             <a:avLst>
-              <a:gd name="adj" fmla="val 16667"/>
+              <a:gd name="adj" fmla="val 17391"/>
             </a:avLst>
           </a:prstGeom>
           <a:solidFill xmlns:a="http://schemas.openxmlformats.org/drawingml/2006/main">
@@ -8732,18 +8732,18 @@
           <p:cNvPr id="16" name="">
             <a:extLst xmlns:a="http://schemas.openxmlformats.org/drawingml/2006/main">
               <a:ext uri="{FF2B5EF4-FFF2-40B4-BE49-F238E27FC236}">
-                <a16:creationId xmlns:a16="http://schemas.microsoft.com/office/drawing/2014/main" id="{0A306119-52C1-4CF5-A303-6BDD368A3D35}"/>
-              </a:ext>
-            </a:extLst>
-          </p:cNvPr>
-          <p:cNvSpPr>
-            <a:spLocks xmlns:a="http://schemas.openxmlformats.org/drawingml/2006/main" noGrp="1"/>
-          </p:cNvSpPr>
-          <p:nvPr/>
-        </p:nvSpPr>
-        <p:spPr>
-          <a:xfrm xmlns:a="http://schemas.openxmlformats.org/drawingml/2006/main">
-            <a:off x="2019300" y="4095750"/>
+                <a16:creationId xmlns:a16="http://schemas.microsoft.com/office/drawing/2014/main" id="{395FA955-7442-4E4E-BA84-8E8B48EC0626}"/>
+              </a:ext>
+            </a:extLst>
+          </p:cNvPr>
+          <p:cNvSpPr>
+            <a:spLocks xmlns:a="http://schemas.openxmlformats.org/drawingml/2006/main" noGrp="1"/>
+          </p:cNvSpPr>
+          <p:nvPr/>
+        </p:nvSpPr>
+        <p:spPr>
+          <a:xfrm xmlns:a="http://schemas.openxmlformats.org/drawingml/2006/main">
+            <a:off x="2019300" y="3600450"/>
             <a:ext cx="3143250" cy="266700"/>
           </a:xfrm>
           <a:prstGeom xmlns:a="http://schemas.openxmlformats.org/drawingml/2006/main" prst="rect">
@@ -8772,7 +8772,7 @@
                   <a:srgbClr val="102A43"/>
                 </a:solidFill>
               </a:rPr>
-              <a:t>Search from UI/API</a:t>
+              <a:t>Start coordinator</a:t>
             </a:r>
           </a:p>
         </p:txBody>
@@ -8782,18 +8782,18 @@
           <p:cNvPr id="17" name="">
             <a:extLst xmlns:a="http://schemas.openxmlformats.org/drawingml/2006/main">
               <a:ext uri="{FF2B5EF4-FFF2-40B4-BE49-F238E27FC236}">
-                <a16:creationId xmlns:a16="http://schemas.microsoft.com/office/drawing/2014/main" id="{26769871-CB5C-4EE0-A7AD-7B05D8C93A07}"/>
-              </a:ext>
-            </a:extLst>
-          </p:cNvPr>
-          <p:cNvSpPr>
-            <a:spLocks xmlns:a="http://schemas.openxmlformats.org/drawingml/2006/main" noGrp="1"/>
-          </p:cNvSpPr>
-          <p:nvPr/>
-        </p:nvSpPr>
-        <p:spPr>
-          <a:xfrm xmlns:a="http://schemas.openxmlformats.org/drawingml/2006/main">
-            <a:off x="5429250" y="4133850"/>
+                <a16:creationId xmlns:a16="http://schemas.microsoft.com/office/drawing/2014/main" id="{9D3B50D1-7295-41FD-9035-E8A7B80D43A9}"/>
+              </a:ext>
+            </a:extLst>
+          </p:cNvPr>
+          <p:cNvSpPr>
+            <a:spLocks xmlns:a="http://schemas.openxmlformats.org/drawingml/2006/main" noGrp="1"/>
+          </p:cNvSpPr>
+          <p:nvPr/>
+        </p:nvSpPr>
+        <p:spPr>
+          <a:xfrm xmlns:a="http://schemas.openxmlformats.org/drawingml/2006/main">
+            <a:off x="5429250" y="3638550"/>
             <a:ext cx="4953000" cy="266700"/>
           </a:xfrm>
           <a:prstGeom xmlns:a="http://schemas.openxmlformats.org/drawingml/2006/main" prst="rect">
@@ -8822,7 +8822,7 @@
                   <a:srgbClr val="5D6B78"/>
                 </a:solidFill>
               </a:rPr>
-              <a:t>display merged ranked results</a:t>
+              <a:t>register node addresses and send fan-out query</a:t>
             </a:r>
           </a:p>
         </p:txBody>
@@ -8832,23 +8832,177 @@
           <p:cNvPr id="18" name="">
             <a:extLst xmlns:a="http://schemas.openxmlformats.org/drawingml/2006/main">
               <a:ext uri="{FF2B5EF4-FFF2-40B4-BE49-F238E27FC236}">
-                <a16:creationId xmlns:a16="http://schemas.microsoft.com/office/drawing/2014/main" id="{48054B2D-15AF-4E8F-8CB3-88D8ED4C3DA4}"/>
-              </a:ext>
-            </a:extLst>
-          </p:cNvPr>
-          <p:cNvSpPr>
-            <a:spLocks xmlns:a="http://schemas.openxmlformats.org/drawingml/2006/main" noGrp="1"/>
-          </p:cNvSpPr>
-          <p:nvPr/>
-        </p:nvSpPr>
-        <p:spPr>
-          <a:xfrm xmlns:a="http://schemas.openxmlformats.org/drawingml/2006/main">
-            <a:off x="1162050" y="4819650"/>
-            <a:ext cx="457200" cy="457200"/>
+                <a16:creationId xmlns:a16="http://schemas.microsoft.com/office/drawing/2014/main" id="{0C40C0EC-8C8A-4970-969E-463A7ACC5256}"/>
+              </a:ext>
+            </a:extLst>
+          </p:cNvPr>
+          <p:cNvSpPr>
+            <a:spLocks xmlns:a="http://schemas.openxmlformats.org/drawingml/2006/main" noGrp="1"/>
+          </p:cNvSpPr>
+          <p:nvPr/>
+        </p:nvSpPr>
+        <p:spPr>
+          <a:xfrm xmlns:a="http://schemas.openxmlformats.org/drawingml/2006/main">
+            <a:off x="1162050" y="4191000"/>
+            <a:ext cx="438150" cy="438150"/>
           </a:xfrm>
           <a:prstGeom xmlns:a="http://schemas.openxmlformats.org/drawingml/2006/main" prst="roundRect">
             <a:avLst>
-              <a:gd name="adj" fmla="val 16667"/>
+              <a:gd name="adj" fmla="val 17391"/>
+            </a:avLst>
+          </a:prstGeom>
+          <a:solidFill xmlns:a="http://schemas.openxmlformats.org/drawingml/2006/main">
+            <a:srgbClr val="0E7C7B"/>
+          </a:solidFill>
+          <a:ln xmlns:a="http://schemas.openxmlformats.org/drawingml/2006/main" w="0">
+            <a:noFill/>
+            <a:prstDash val="solid"/>
+          </a:ln>
+        </p:spPr>
+        <p:txBody>
+          <a:bodyPr xmlns:a="http://schemas.openxmlformats.org/drawingml/2006/main"/>
+          <a:lstStyle xmlns:a="http://schemas.openxmlformats.org/drawingml/2006/main"/>
+          <a:p xmlns:a="http://schemas.openxmlformats.org/drawingml/2006/main">
+            <a:pPr algn="ctr">
+              <a:defRPr sz="1350" b="1">
+                <a:solidFill>
+                  <a:srgbClr val="FFFFFF"/>
+                </a:solidFill>
+              </a:defRPr>
+            </a:pPr>
+            <a:r>
+              <a:rPr sz="1350" b="1">
+                <a:solidFill>
+                  <a:srgbClr val="FFFFFF"/>
+                </a:solidFill>
+              </a:rPr>
+              <a:t>5</a:t>
+            </a:r>
+          </a:p>
+        </p:txBody>
+      </p:sp>
+      <p:sp>
+        <p:nvSpPr>
+          <p:cNvPr id="19" name="">
+            <a:extLst xmlns:a="http://schemas.openxmlformats.org/drawingml/2006/main">
+              <a:ext uri="{FF2B5EF4-FFF2-40B4-BE49-F238E27FC236}">
+                <a16:creationId xmlns:a16="http://schemas.microsoft.com/office/drawing/2014/main" id="{C3E8DB97-D182-4A43-8651-DCD1E4942501}"/>
+              </a:ext>
+            </a:extLst>
+          </p:cNvPr>
+          <p:cNvSpPr>
+            <a:spLocks xmlns:a="http://schemas.openxmlformats.org/drawingml/2006/main" noGrp="1"/>
+          </p:cNvSpPr>
+          <p:nvPr/>
+        </p:nvSpPr>
+        <p:spPr>
+          <a:xfrm xmlns:a="http://schemas.openxmlformats.org/drawingml/2006/main">
+            <a:off x="2019300" y="4210050"/>
+            <a:ext cx="3143250" cy="266700"/>
+          </a:xfrm>
+          <a:prstGeom xmlns:a="http://schemas.openxmlformats.org/drawingml/2006/main" prst="rect">
+            <a:avLst/>
+          </a:prstGeom>
+          <a:noFill xmlns:a="http://schemas.openxmlformats.org/drawingml/2006/main"/>
+          <a:ln xmlns:a="http://schemas.openxmlformats.org/drawingml/2006/main" w="0">
+            <a:noFill/>
+            <a:prstDash val="solid"/>
+          </a:ln>
+        </p:spPr>
+        <p:txBody>
+          <a:bodyPr xmlns:a="http://schemas.openxmlformats.org/drawingml/2006/main"/>
+          <a:lstStyle xmlns:a="http://schemas.openxmlformats.org/drawingml/2006/main"/>
+          <a:p xmlns:a="http://schemas.openxmlformats.org/drawingml/2006/main">
+            <a:pPr algn="l">
+              <a:defRPr sz="1650" b="1">
+                <a:solidFill>
+                  <a:srgbClr val="102A43"/>
+                </a:solidFill>
+              </a:defRPr>
+            </a:pPr>
+            <a:r>
+              <a:rPr sz="1650" b="1">
+                <a:solidFill>
+                  <a:srgbClr val="102A43"/>
+                </a:solidFill>
+              </a:rPr>
+              <a:t>Search from UI/API</a:t>
+            </a:r>
+          </a:p>
+        </p:txBody>
+      </p:sp>
+      <p:sp>
+        <p:nvSpPr>
+          <p:cNvPr id="20" name="">
+            <a:extLst xmlns:a="http://schemas.openxmlformats.org/drawingml/2006/main">
+              <a:ext uri="{FF2B5EF4-FFF2-40B4-BE49-F238E27FC236}">
+                <a16:creationId xmlns:a16="http://schemas.microsoft.com/office/drawing/2014/main" id="{27B8BFE3-BF93-421D-9B95-1D6972A21985}"/>
+              </a:ext>
+            </a:extLst>
+          </p:cNvPr>
+          <p:cNvSpPr>
+            <a:spLocks xmlns:a="http://schemas.openxmlformats.org/drawingml/2006/main" noGrp="1"/>
+          </p:cNvSpPr>
+          <p:nvPr/>
+        </p:nvSpPr>
+        <p:spPr>
+          <a:xfrm xmlns:a="http://schemas.openxmlformats.org/drawingml/2006/main">
+            <a:off x="5429250" y="4248150"/>
+            <a:ext cx="4953000" cy="266700"/>
+          </a:xfrm>
+          <a:prstGeom xmlns:a="http://schemas.openxmlformats.org/drawingml/2006/main" prst="rect">
+            <a:avLst/>
+          </a:prstGeom>
+          <a:noFill xmlns:a="http://schemas.openxmlformats.org/drawingml/2006/main"/>
+          <a:ln xmlns:a="http://schemas.openxmlformats.org/drawingml/2006/main" w="0">
+            <a:noFill/>
+            <a:prstDash val="solid"/>
+          </a:ln>
+        </p:spPr>
+        <p:txBody>
+          <a:bodyPr xmlns:a="http://schemas.openxmlformats.org/drawingml/2006/main"/>
+          <a:lstStyle xmlns:a="http://schemas.openxmlformats.org/drawingml/2006/main"/>
+          <a:p xmlns:a="http://schemas.openxmlformats.org/drawingml/2006/main">
+            <a:pPr algn="l">
+              <a:defRPr sz="1425" b="0">
+                <a:solidFill>
+                  <a:srgbClr val="5D6B78"/>
+                </a:solidFill>
+              </a:defRPr>
+            </a:pPr>
+            <a:r>
+              <a:rPr sz="1425" b="0">
+                <a:solidFill>
+                  <a:srgbClr val="5D6B78"/>
+                </a:solidFill>
+              </a:rPr>
+              <a:t>display merged ranked results</a:t>
+            </a:r>
+          </a:p>
+        </p:txBody>
+      </p:sp>
+      <p:sp>
+        <p:nvSpPr>
+          <p:cNvPr id="21" name="">
+            <a:extLst xmlns:a="http://schemas.openxmlformats.org/drawingml/2006/main">
+              <a:ext uri="{FF2B5EF4-FFF2-40B4-BE49-F238E27FC236}">
+                <a16:creationId xmlns:a16="http://schemas.microsoft.com/office/drawing/2014/main" id="{96CC20AB-F633-4D69-9CE0-264D6C5F00B4}"/>
+              </a:ext>
+            </a:extLst>
+          </p:cNvPr>
+          <p:cNvSpPr>
+            <a:spLocks xmlns:a="http://schemas.openxmlformats.org/drawingml/2006/main" noGrp="1"/>
+          </p:cNvSpPr>
+          <p:nvPr/>
+        </p:nvSpPr>
+        <p:spPr>
+          <a:xfrm xmlns:a="http://schemas.openxmlformats.org/drawingml/2006/main">
+            <a:off x="1162050" y="4800600"/>
+            <a:ext cx="438150" cy="438150"/>
+          </a:xfrm>
+          <a:prstGeom xmlns:a="http://schemas.openxmlformats.org/drawingml/2006/main" prst="roundRect">
+            <a:avLst>
+              <a:gd name="adj" fmla="val 17391"/>
             </a:avLst>
           </a:prstGeom>
           <a:solidFill xmlns:a="http://schemas.openxmlformats.org/drawingml/2006/main">
@@ -8876,28 +9030,28 @@
                   <a:srgbClr val="FFFFFF"/>
                 </a:solidFill>
               </a:rPr>
-              <a:t>5</a:t>
-            </a:r>
-          </a:p>
-        </p:txBody>
-      </p:sp>
-      <p:sp>
-        <p:nvSpPr>
-          <p:cNvPr id="19" name="">
-            <a:extLst xmlns:a="http://schemas.openxmlformats.org/drawingml/2006/main">
-              <a:ext uri="{FF2B5EF4-FFF2-40B4-BE49-F238E27FC236}">
-                <a16:creationId xmlns:a16="http://schemas.microsoft.com/office/drawing/2014/main" id="{9289E95F-EE35-4D07-B01F-DB0E3151D1B3}"/>
-              </a:ext>
-            </a:extLst>
-          </p:cNvPr>
-          <p:cNvSpPr>
-            <a:spLocks xmlns:a="http://schemas.openxmlformats.org/drawingml/2006/main" noGrp="1"/>
-          </p:cNvSpPr>
-          <p:nvPr/>
-        </p:nvSpPr>
-        <p:spPr>
-          <a:xfrm xmlns:a="http://schemas.openxmlformats.org/drawingml/2006/main">
-            <a:off x="2019300" y="4838700"/>
+              <a:t>6</a:t>
+            </a:r>
+          </a:p>
+        </p:txBody>
+      </p:sp>
+      <p:sp>
+        <p:nvSpPr>
+          <p:cNvPr id="22" name="">
+            <a:extLst xmlns:a="http://schemas.openxmlformats.org/drawingml/2006/main">
+              <a:ext uri="{FF2B5EF4-FFF2-40B4-BE49-F238E27FC236}">
+                <a16:creationId xmlns:a16="http://schemas.microsoft.com/office/drawing/2014/main" id="{3172C0DF-246F-4ABD-8E8D-85B127EDC2D0}"/>
+              </a:ext>
+            </a:extLst>
+          </p:cNvPr>
+          <p:cNvSpPr>
+            <a:spLocks xmlns:a="http://schemas.openxmlformats.org/drawingml/2006/main" noGrp="1"/>
+          </p:cNvSpPr>
+          <p:nvPr/>
+        </p:nvSpPr>
+        <p:spPr>
+          <a:xfrm xmlns:a="http://schemas.openxmlformats.org/drawingml/2006/main">
+            <a:off x="2019300" y="4819650"/>
             <a:ext cx="3143250" cy="266700"/>
           </a:xfrm>
           <a:prstGeom xmlns:a="http://schemas.openxmlformats.org/drawingml/2006/main" prst="rect">
@@ -8933,21 +9087,21 @@
       </p:sp>
       <p:sp>
         <p:nvSpPr>
-          <p:cNvPr id="20" name="">
-            <a:extLst xmlns:a="http://schemas.openxmlformats.org/drawingml/2006/main">
-              <a:ext uri="{FF2B5EF4-FFF2-40B4-BE49-F238E27FC236}">
-                <a16:creationId xmlns:a16="http://schemas.microsoft.com/office/drawing/2014/main" id="{9D9E194A-869A-4EBC-B27B-B83DC30027C1}"/>
-              </a:ext>
-            </a:extLst>
-          </p:cNvPr>
-          <p:cNvSpPr>
-            <a:spLocks xmlns:a="http://schemas.openxmlformats.org/drawingml/2006/main" noGrp="1"/>
-          </p:cNvSpPr>
-          <p:nvPr/>
-        </p:nvSpPr>
-        <p:spPr>
-          <a:xfrm xmlns:a="http://schemas.openxmlformats.org/drawingml/2006/main">
-            <a:off x="5429250" y="4876800"/>
+          <p:cNvPr id="23" name="">
+            <a:extLst xmlns:a="http://schemas.openxmlformats.org/drawingml/2006/main">
+              <a:ext uri="{FF2B5EF4-FFF2-40B4-BE49-F238E27FC236}">
+                <a16:creationId xmlns:a16="http://schemas.microsoft.com/office/drawing/2014/main" id="{86599A1B-7BEB-4A4E-8C83-D72818E1CAEB}"/>
+              </a:ext>
+            </a:extLst>
+          </p:cNvPr>
+          <p:cNvSpPr>
+            <a:spLocks xmlns:a="http://schemas.openxmlformats.org/drawingml/2006/main" noGrp="1"/>
+          </p:cNvSpPr>
+          <p:nvPr/>
+        </p:nvSpPr>
+        <p:spPr>
+          <a:xfrm xmlns:a="http://schemas.openxmlformats.org/drawingml/2006/main">
+            <a:off x="5429250" y="4857750"/>
             <a:ext cx="4953000" cy="266700"/>
           </a:xfrm>
           <a:prstGeom xmlns:a="http://schemas.openxmlformats.org/drawingml/2006/main" prst="rect">
@@ -8984,7 +9138,7 @@
     </p:spTree>
     <p:extLst>
       <p:ext uri="{BB962C8B-B14F-4D97-AF65-F5344CB8AC3E}">
-        <p14:creationId xmlns:p14="http://schemas.microsoft.com/office/powerpoint/2010/main" val="1595253320"/>
+        <p14:creationId xmlns:p14="http://schemas.microsoft.com/office/powerpoint/2010/main" val="28090016"/>
       </p:ext>
     </p:extLst>
   </p:cSld>
@@ -9015,7 +9169,7 @@
           <p:cNvPr id="21" name="">
             <a:extLst xmlns:a="http://schemas.openxmlformats.org/drawingml/2006/main">
               <a:ext uri="{FF2B5EF4-FFF2-40B4-BE49-F238E27FC236}">
-                <a16:creationId xmlns:a16="http://schemas.microsoft.com/office/drawing/2014/main" id="{78AD0888-79BF-4733-B783-B603DA703C20}"/>
+                <a16:creationId xmlns:a16="http://schemas.microsoft.com/office/drawing/2014/main" id="{742FD129-59DA-4E05-998C-CDDB36D54974}"/>
               </a:ext>
             </a:extLst>
           </p:cNvPr>
@@ -9065,7 +9219,7 @@
           <p:cNvPr id="2" name="">
             <a:extLst xmlns:a="http://schemas.openxmlformats.org/drawingml/2006/main">
               <a:ext uri="{FF2B5EF4-FFF2-40B4-BE49-F238E27FC236}">
-                <a16:creationId xmlns:a16="http://schemas.microsoft.com/office/drawing/2014/main" id="{F60D6D7E-B999-43BF-B52E-75C125D47924}"/>
+                <a16:creationId xmlns:a16="http://schemas.microsoft.com/office/drawing/2014/main" id="{86E1D618-AA0C-4903-858F-A7DBD998CB3E}"/>
               </a:ext>
             </a:extLst>
           </p:cNvPr>
@@ -9115,7 +9269,7 @@
           <p:cNvPr id="3" name="">
             <a:extLst xmlns:a="http://schemas.openxmlformats.org/drawingml/2006/main">
               <a:ext uri="{FF2B5EF4-FFF2-40B4-BE49-F238E27FC236}">
-                <a16:creationId xmlns:a16="http://schemas.microsoft.com/office/drawing/2014/main" id="{B790DCBC-0F09-4451-BC8D-4BDD8E00D40B}"/>
+                <a16:creationId xmlns:a16="http://schemas.microsoft.com/office/drawing/2014/main" id="{904E1687-7C6D-4C84-9FF5-E005783C47A8}"/>
               </a:ext>
             </a:extLst>
           </p:cNvPr>
@@ -9146,7 +9300,7 @@
           <p:cNvPr id="4" name="">
             <a:extLst xmlns:a="http://schemas.openxmlformats.org/drawingml/2006/main">
               <a:ext uri="{FF2B5EF4-FFF2-40B4-BE49-F238E27FC236}">
-                <a16:creationId xmlns:a16="http://schemas.microsoft.com/office/drawing/2014/main" id="{A09B0C2E-157E-4457-A78E-A58DB5B0A127}"/>
+                <a16:creationId xmlns:a16="http://schemas.microsoft.com/office/drawing/2014/main" id="{198FCA1B-D145-42BA-AF9D-AC2F0BE8BD79}"/>
               </a:ext>
             </a:extLst>
           </p:cNvPr>
@@ -9196,7 +9350,7 @@
           <p:cNvPr id="5" name="">
             <a:extLst xmlns:a="http://schemas.openxmlformats.org/drawingml/2006/main">
               <a:ext uri="{FF2B5EF4-FFF2-40B4-BE49-F238E27FC236}">
-                <a16:creationId xmlns:a16="http://schemas.microsoft.com/office/drawing/2014/main" id="{7D70778C-6696-4D88-A805-E141AD994DBE}"/>
+                <a16:creationId xmlns:a16="http://schemas.microsoft.com/office/drawing/2014/main" id="{E92F1033-CA86-4DDC-81E0-747855C8EAD7}"/>
               </a:ext>
             </a:extLst>
           </p:cNvPr>
@@ -9246,7 +9400,7 @@
           <p:cNvPr id="6" name="">
             <a:extLst xmlns:a="http://schemas.openxmlformats.org/drawingml/2006/main">
               <a:ext uri="{FF2B5EF4-FFF2-40B4-BE49-F238E27FC236}">
-                <a16:creationId xmlns:a16="http://schemas.microsoft.com/office/drawing/2014/main" id="{C0EC8F47-F2ED-4294-AAC0-ACC10B0AA5DF}"/>
+                <a16:creationId xmlns:a16="http://schemas.microsoft.com/office/drawing/2014/main" id="{732344E4-5F3B-4AF4-B9A4-016AFAFCA31D}"/>
               </a:ext>
             </a:extLst>
           </p:cNvPr>
@@ -9296,7 +9450,7 @@
           <p:cNvPr id="7" name="">
             <a:extLst xmlns:a="http://schemas.openxmlformats.org/drawingml/2006/main">
               <a:ext uri="{FF2B5EF4-FFF2-40B4-BE49-F238E27FC236}">
-                <a16:creationId xmlns:a16="http://schemas.microsoft.com/office/drawing/2014/main" id="{737FB207-30B6-4851-A877-151D3DE890E8}"/>
+                <a16:creationId xmlns:a16="http://schemas.microsoft.com/office/drawing/2014/main" id="{8C6E2464-A289-49E2-8CCF-C12424807755}"/>
               </a:ext>
             </a:extLst>
           </p:cNvPr>
@@ -9350,7 +9504,7 @@
           <p:cNvPr id="8" name="">
             <a:extLst xmlns:a="http://schemas.openxmlformats.org/drawingml/2006/main">
               <a:ext uri="{FF2B5EF4-FFF2-40B4-BE49-F238E27FC236}">
-                <a16:creationId xmlns:a16="http://schemas.microsoft.com/office/drawing/2014/main" id="{5C74C108-CF59-465F-9118-F84C271B29B4}"/>
+                <a16:creationId xmlns:a16="http://schemas.microsoft.com/office/drawing/2014/main" id="{2F9A936D-89C3-4984-93D6-4DF5949E90E9}"/>
               </a:ext>
             </a:extLst>
           </p:cNvPr>
@@ -9381,7 +9535,7 @@
           <p:cNvPr id="9" name="">
             <a:extLst xmlns:a="http://schemas.openxmlformats.org/drawingml/2006/main">
               <a:ext uri="{FF2B5EF4-FFF2-40B4-BE49-F238E27FC236}">
-                <a16:creationId xmlns:a16="http://schemas.microsoft.com/office/drawing/2014/main" id="{E124E673-5FC2-492B-B790-7EDF500788D1}"/>
+                <a16:creationId xmlns:a16="http://schemas.microsoft.com/office/drawing/2014/main" id="{7CE5BD88-F998-44A2-BF57-CFBB578B9C4F}"/>
               </a:ext>
             </a:extLst>
           </p:cNvPr>
@@ -9452,7 +9606,7 @@
           <p:cNvPr id="10" name="">
             <a:extLst xmlns:a="http://schemas.openxmlformats.org/drawingml/2006/main">
               <a:ext uri="{FF2B5EF4-FFF2-40B4-BE49-F238E27FC236}">
-                <a16:creationId xmlns:a16="http://schemas.microsoft.com/office/drawing/2014/main" id="{A7A1AC0B-2348-45E5-964F-985CEF1977D1}"/>
+                <a16:creationId xmlns:a16="http://schemas.microsoft.com/office/drawing/2014/main" id="{A0761226-B34D-4DD4-9C29-D7386A5469D7}"/>
               </a:ext>
             </a:extLst>
           </p:cNvPr>
@@ -9506,7 +9660,7 @@
           <p:cNvPr id="11" name="">
             <a:extLst xmlns:a="http://schemas.openxmlformats.org/drawingml/2006/main">
               <a:ext uri="{FF2B5EF4-FFF2-40B4-BE49-F238E27FC236}">
-                <a16:creationId xmlns:a16="http://schemas.microsoft.com/office/drawing/2014/main" id="{1D48DB77-6F27-434E-8D3D-FCE52EC5EEE9}"/>
+                <a16:creationId xmlns:a16="http://schemas.microsoft.com/office/drawing/2014/main" id="{A559A36B-2984-44CE-91A5-8E45FD8A6F9C}"/>
               </a:ext>
             </a:extLst>
           </p:cNvPr>
@@ -9556,7 +9710,7 @@
           <p:cNvPr id="12" name="">
             <a:extLst xmlns:a="http://schemas.openxmlformats.org/drawingml/2006/main">
               <a:ext uri="{FF2B5EF4-FFF2-40B4-BE49-F238E27FC236}">
-                <a16:creationId xmlns:a16="http://schemas.microsoft.com/office/drawing/2014/main" id="{011FFFFD-3699-4C2D-A56D-770F2FE8EA71}"/>
+                <a16:creationId xmlns:a16="http://schemas.microsoft.com/office/drawing/2014/main" id="{341ADF33-DAC1-4696-9754-849A7FC2DABE}"/>
               </a:ext>
             </a:extLst>
           </p:cNvPr>
@@ -9606,7 +9760,7 @@
           <p:cNvPr id="13" name="">
             <a:extLst xmlns:a="http://schemas.openxmlformats.org/drawingml/2006/main">
               <a:ext uri="{FF2B5EF4-FFF2-40B4-BE49-F238E27FC236}">
-                <a16:creationId xmlns:a16="http://schemas.microsoft.com/office/drawing/2014/main" id="{3AA13146-1335-45F0-82D3-6F8615A66FAE}"/>
+                <a16:creationId xmlns:a16="http://schemas.microsoft.com/office/drawing/2014/main" id="{6393D0F6-9769-4C39-BD1B-48744AD0D968}"/>
               </a:ext>
             </a:extLst>
           </p:cNvPr>
@@ -9660,7 +9814,7 @@
           <p:cNvPr id="14" name="">
             <a:extLst xmlns:a="http://schemas.openxmlformats.org/drawingml/2006/main">
               <a:ext uri="{FF2B5EF4-FFF2-40B4-BE49-F238E27FC236}">
-                <a16:creationId xmlns:a16="http://schemas.microsoft.com/office/drawing/2014/main" id="{ABA22349-832D-49C8-ADB2-FAFB01E794E1}"/>
+                <a16:creationId xmlns:a16="http://schemas.microsoft.com/office/drawing/2014/main" id="{C4FC779E-5F8F-41EC-A585-9BDED28D6821}"/>
               </a:ext>
             </a:extLst>
           </p:cNvPr>
@@ -9710,7 +9864,7 @@
           <p:cNvPr id="15" name="">
             <a:extLst xmlns:a="http://schemas.openxmlformats.org/drawingml/2006/main">
               <a:ext uri="{FF2B5EF4-FFF2-40B4-BE49-F238E27FC236}">
-                <a16:creationId xmlns:a16="http://schemas.microsoft.com/office/drawing/2014/main" id="{8D706D56-5D74-461C-A871-779DC3348444}"/>
+                <a16:creationId xmlns:a16="http://schemas.microsoft.com/office/drawing/2014/main" id="{1A54EDC9-73DE-46E7-B825-0BBC46299AAA}"/>
               </a:ext>
             </a:extLst>
           </p:cNvPr>
@@ -9741,7 +9895,7 @@
           <p:cNvPr id="16" name="">
             <a:extLst xmlns:a="http://schemas.openxmlformats.org/drawingml/2006/main">
               <a:ext uri="{FF2B5EF4-FFF2-40B4-BE49-F238E27FC236}">
-                <a16:creationId xmlns:a16="http://schemas.microsoft.com/office/drawing/2014/main" id="{E1D586AA-1704-4EE2-B390-134BE62887A1}"/>
+                <a16:creationId xmlns:a16="http://schemas.microsoft.com/office/drawing/2014/main" id="{50B9EC78-27C8-4F89-9FAD-214C5385E0A6}"/>
               </a:ext>
             </a:extLst>
           </p:cNvPr>
@@ -9795,7 +9949,7 @@
           <p:cNvPr id="17" name="">
             <a:extLst xmlns:a="http://schemas.openxmlformats.org/drawingml/2006/main">
               <a:ext uri="{FF2B5EF4-FFF2-40B4-BE49-F238E27FC236}">
-                <a16:creationId xmlns:a16="http://schemas.microsoft.com/office/drawing/2014/main" id="{0CA9E2A8-4729-4CD1-96F3-B6C6908127A9}"/>
+                <a16:creationId xmlns:a16="http://schemas.microsoft.com/office/drawing/2014/main" id="{9F80F368-9C9B-4E3A-9261-F54C16BA9866}"/>
               </a:ext>
             </a:extLst>
           </p:cNvPr>
@@ -9849,7 +10003,7 @@
           <p:cNvPr id="18" name="">
             <a:extLst xmlns:a="http://schemas.openxmlformats.org/drawingml/2006/main">
               <a:ext uri="{FF2B5EF4-FFF2-40B4-BE49-F238E27FC236}">
-                <a16:creationId xmlns:a16="http://schemas.microsoft.com/office/drawing/2014/main" id="{B4139F25-2C7B-466E-9AB0-CAC5530EAE09}"/>
+                <a16:creationId xmlns:a16="http://schemas.microsoft.com/office/drawing/2014/main" id="{A3A1E44E-45F8-4764-9310-34C82718E36A}"/>
               </a:ext>
             </a:extLst>
           </p:cNvPr>
@@ -9903,7 +10057,7 @@
           <p:cNvPr id="19" name="">
             <a:extLst xmlns:a="http://schemas.openxmlformats.org/drawingml/2006/main">
               <a:ext uri="{FF2B5EF4-FFF2-40B4-BE49-F238E27FC236}">
-                <a16:creationId xmlns:a16="http://schemas.microsoft.com/office/drawing/2014/main" id="{45ACA8E6-04A9-4C36-9704-188D1F27ECFA}"/>
+                <a16:creationId xmlns:a16="http://schemas.microsoft.com/office/drawing/2014/main" id="{9C8AF025-9E8D-4140-AFCF-208AC277A716}"/>
               </a:ext>
             </a:extLst>
           </p:cNvPr>
@@ -9953,7 +10107,7 @@
           <p:cNvPr id="20" name="">
             <a:extLst xmlns:a="http://schemas.openxmlformats.org/drawingml/2006/main">
               <a:ext uri="{FF2B5EF4-FFF2-40B4-BE49-F238E27FC236}">
-                <a16:creationId xmlns:a16="http://schemas.microsoft.com/office/drawing/2014/main" id="{A9380311-7CFC-4021-A0F6-60171CBDA1C0}"/>
+                <a16:creationId xmlns:a16="http://schemas.microsoft.com/office/drawing/2014/main" id="{2FD85064-AC20-4FB8-958C-E609813B69CA}"/>
               </a:ext>
             </a:extLst>
           </p:cNvPr>
@@ -10001,7 +10155,7 @@
     </p:spTree>
     <p:extLst>
       <p:ext uri="{BB962C8B-B14F-4D97-AF65-F5344CB8AC3E}">
-        <p14:creationId xmlns:p14="http://schemas.microsoft.com/office/powerpoint/2010/main" val="63869787"/>
+        <p14:creationId xmlns:p14="http://schemas.microsoft.com/office/powerpoint/2010/main" val="1780336857"/>
       </p:ext>
     </p:extLst>
   </p:cSld>
@@ -10032,7 +10186,7 @@
           <p:cNvPr id="25" name="">
             <a:extLst xmlns:a="http://schemas.openxmlformats.org/drawingml/2006/main">
               <a:ext uri="{FF2B5EF4-FFF2-40B4-BE49-F238E27FC236}">
-                <a16:creationId xmlns:a16="http://schemas.microsoft.com/office/drawing/2014/main" id="{48C8363E-8CF7-4A60-A1EE-DE3B13995C87}"/>
+                <a16:creationId xmlns:a16="http://schemas.microsoft.com/office/drawing/2014/main" id="{2913A86C-BAB3-41B6-B8F2-39B990951D3F}"/>
               </a:ext>
             </a:extLst>
           </p:cNvPr>
@@ -10082,7 +10236,7 @@
           <p:cNvPr id="2" name="">
             <a:extLst xmlns:a="http://schemas.openxmlformats.org/drawingml/2006/main">
               <a:ext uri="{FF2B5EF4-FFF2-40B4-BE49-F238E27FC236}">
-                <a16:creationId xmlns:a16="http://schemas.microsoft.com/office/drawing/2014/main" id="{C4336F4A-50BD-44CB-A914-4AC2E644672F}"/>
+                <a16:creationId xmlns:a16="http://schemas.microsoft.com/office/drawing/2014/main" id="{BF8A8FE6-B677-4DAE-A10C-B243C309FA37}"/>
               </a:ext>
             </a:extLst>
           </p:cNvPr>
@@ -10132,7 +10286,7 @@
           <p:cNvPr id="3" name="">
             <a:extLst xmlns:a="http://schemas.openxmlformats.org/drawingml/2006/main">
               <a:ext uri="{FF2B5EF4-FFF2-40B4-BE49-F238E27FC236}">
-                <a16:creationId xmlns:a16="http://schemas.microsoft.com/office/drawing/2014/main" id="{B5C69484-F877-4751-8E5D-F4B37AFB92FA}"/>
+                <a16:creationId xmlns:a16="http://schemas.microsoft.com/office/drawing/2014/main" id="{53FEFAE4-228B-41E5-91E1-E51EED71A365}"/>
               </a:ext>
             </a:extLst>
           </p:cNvPr>
@@ -10163,7 +10317,7 @@
           <p:cNvPr id="4" name="">
             <a:extLst xmlns:a="http://schemas.openxmlformats.org/drawingml/2006/main">
               <a:ext uri="{FF2B5EF4-FFF2-40B4-BE49-F238E27FC236}">
-                <a16:creationId xmlns:a16="http://schemas.microsoft.com/office/drawing/2014/main" id="{96E9F69B-5376-4333-8415-C064510D8B1C}"/>
+                <a16:creationId xmlns:a16="http://schemas.microsoft.com/office/drawing/2014/main" id="{D7A57E63-28AD-48FC-8444-AC9E8F8E5385}"/>
               </a:ext>
             </a:extLst>
           </p:cNvPr>
@@ -10213,7 +10367,7 @@
           <p:cNvPr id="5" name="">
             <a:extLst xmlns:a="http://schemas.openxmlformats.org/drawingml/2006/main">
               <a:ext uri="{FF2B5EF4-FFF2-40B4-BE49-F238E27FC236}">
-                <a16:creationId xmlns:a16="http://schemas.microsoft.com/office/drawing/2014/main" id="{2283CEB9-7D38-43D7-84FB-BA4BB2BAC246}"/>
+                <a16:creationId xmlns:a16="http://schemas.microsoft.com/office/drawing/2014/main" id="{B706FC7A-C323-459F-A7B5-3D7063A6DEB4}"/>
               </a:ext>
             </a:extLst>
           </p:cNvPr>
@@ -10263,7 +10417,7 @@
           <p:cNvPr id="6" name="">
             <a:extLst xmlns:a="http://schemas.openxmlformats.org/drawingml/2006/main">
               <a:ext uri="{FF2B5EF4-FFF2-40B4-BE49-F238E27FC236}">
-                <a16:creationId xmlns:a16="http://schemas.microsoft.com/office/drawing/2014/main" id="{70215DE0-D9C3-4687-A652-136020698BC4}"/>
+                <a16:creationId xmlns:a16="http://schemas.microsoft.com/office/drawing/2014/main" id="{1F2BF44C-7B5E-4D37-A4F0-9FE7273183C8}"/>
               </a:ext>
             </a:extLst>
           </p:cNvPr>
@@ -10317,7 +10471,7 @@
           <p:cNvPr id="7" name="">
             <a:extLst xmlns:a="http://schemas.openxmlformats.org/drawingml/2006/main">
               <a:ext uri="{FF2B5EF4-FFF2-40B4-BE49-F238E27FC236}">
-                <a16:creationId xmlns:a16="http://schemas.microsoft.com/office/drawing/2014/main" id="{33884CC2-95AA-4812-85E6-CEB5F9137C21}"/>
+                <a16:creationId xmlns:a16="http://schemas.microsoft.com/office/drawing/2014/main" id="{D0D0A7B4-5DEF-4118-8286-F5A800D31C92}"/>
               </a:ext>
             </a:extLst>
           </p:cNvPr>
@@ -10348,7 +10502,7 @@
           <p:cNvPr id="8" name="">
             <a:extLst xmlns:a="http://schemas.openxmlformats.org/drawingml/2006/main">
               <a:ext uri="{FF2B5EF4-FFF2-40B4-BE49-F238E27FC236}">
-                <a16:creationId xmlns:a16="http://schemas.microsoft.com/office/drawing/2014/main" id="{8470A9E7-4D62-4957-AA97-1CE9B3E23605}"/>
+                <a16:creationId xmlns:a16="http://schemas.microsoft.com/office/drawing/2014/main" id="{CE37C036-DE00-4BC1-A862-05263E58C73B}"/>
               </a:ext>
             </a:extLst>
           </p:cNvPr>
@@ -10402,7 +10556,7 @@
           <p:cNvPr id="9" name="">
             <a:extLst xmlns:a="http://schemas.openxmlformats.org/drawingml/2006/main">
               <a:ext uri="{FF2B5EF4-FFF2-40B4-BE49-F238E27FC236}">
-                <a16:creationId xmlns:a16="http://schemas.microsoft.com/office/drawing/2014/main" id="{8E7E2B39-9A3A-4EF0-8390-91CAFB8B0142}"/>
+                <a16:creationId xmlns:a16="http://schemas.microsoft.com/office/drawing/2014/main" id="{C1C9EE22-3EE6-4103-AF88-2F397E905F0F}"/>
               </a:ext>
             </a:extLst>
           </p:cNvPr>
@@ -10433,7 +10587,7 @@
           <p:cNvPr id="10" name="">
             <a:extLst xmlns:a="http://schemas.openxmlformats.org/drawingml/2006/main">
               <a:ext uri="{FF2B5EF4-FFF2-40B4-BE49-F238E27FC236}">
-                <a16:creationId xmlns:a16="http://schemas.microsoft.com/office/drawing/2014/main" id="{A7EE8CD0-3677-40BC-BA3F-E7734D27130B}"/>
+                <a16:creationId xmlns:a16="http://schemas.microsoft.com/office/drawing/2014/main" id="{452461A9-087F-4B68-A4D1-D0FF91D14FBD}"/>
               </a:ext>
             </a:extLst>
           </p:cNvPr>
@@ -10487,7 +10641,7 @@
           <p:cNvPr id="11" name="">
             <a:extLst xmlns:a="http://schemas.openxmlformats.org/drawingml/2006/main">
               <a:ext uri="{FF2B5EF4-FFF2-40B4-BE49-F238E27FC236}">
-                <a16:creationId xmlns:a16="http://schemas.microsoft.com/office/drawing/2014/main" id="{98906C16-6933-43E2-AAE9-9D7BC757A169}"/>
+                <a16:creationId xmlns:a16="http://schemas.microsoft.com/office/drawing/2014/main" id="{958AA567-E46C-43F3-9CD7-18F17CD473E7}"/>
               </a:ext>
             </a:extLst>
           </p:cNvPr>
@@ -10518,7 +10672,7 @@
           <p:cNvPr id="12" name="">
             <a:extLst xmlns:a="http://schemas.openxmlformats.org/drawingml/2006/main">
               <a:ext uri="{FF2B5EF4-FFF2-40B4-BE49-F238E27FC236}">
-                <a16:creationId xmlns:a16="http://schemas.microsoft.com/office/drawing/2014/main" id="{6625B56D-C37F-4A0B-A82F-7059DAFFC3A7}"/>
+                <a16:creationId xmlns:a16="http://schemas.microsoft.com/office/drawing/2014/main" id="{20C1E2B8-3504-4E68-B355-AD5873DD4A9E}"/>
               </a:ext>
             </a:extLst>
           </p:cNvPr>
@@ -10572,7 +10726,7 @@
           <p:cNvPr id="13" name="">
             <a:extLst xmlns:a="http://schemas.openxmlformats.org/drawingml/2006/main">
               <a:ext uri="{FF2B5EF4-FFF2-40B4-BE49-F238E27FC236}">
-                <a16:creationId xmlns:a16="http://schemas.microsoft.com/office/drawing/2014/main" id="{437221FB-917D-44E2-B6FE-619455217B67}"/>
+                <a16:creationId xmlns:a16="http://schemas.microsoft.com/office/drawing/2014/main" id="{F30EBFF7-BE06-4540-88B7-8AC442A0FF18}"/>
               </a:ext>
             </a:extLst>
           </p:cNvPr>
@@ -10603,7 +10757,7 @@
           <p:cNvPr id="14" name="">
             <a:extLst xmlns:a="http://schemas.openxmlformats.org/drawingml/2006/main">
               <a:ext uri="{FF2B5EF4-FFF2-40B4-BE49-F238E27FC236}">
-                <a16:creationId xmlns:a16="http://schemas.microsoft.com/office/drawing/2014/main" id="{643BE777-6C89-4057-A86D-E6D23D424752}"/>
+                <a16:creationId xmlns:a16="http://schemas.microsoft.com/office/drawing/2014/main" id="{445E0674-9711-4049-A3E8-72643C03DD60}"/>
               </a:ext>
             </a:extLst>
           </p:cNvPr>
@@ -10657,7 +10811,7 @@
           <p:cNvPr id="15" name="">
             <a:extLst xmlns:a="http://schemas.openxmlformats.org/drawingml/2006/main">
               <a:ext uri="{FF2B5EF4-FFF2-40B4-BE49-F238E27FC236}">
-                <a16:creationId xmlns:a16="http://schemas.microsoft.com/office/drawing/2014/main" id="{1C7EF1B2-A63A-4D8C-B5AE-52A5C08EFD9F}"/>
+                <a16:creationId xmlns:a16="http://schemas.microsoft.com/office/drawing/2014/main" id="{F0C391DA-8364-41CE-B932-CC6BD9371EF2}"/>
               </a:ext>
             </a:extLst>
           </p:cNvPr>
@@ -10688,7 +10842,7 @@
           <p:cNvPr id="16" name="">
             <a:extLst xmlns:a="http://schemas.openxmlformats.org/drawingml/2006/main">
               <a:ext uri="{FF2B5EF4-FFF2-40B4-BE49-F238E27FC236}">
-                <a16:creationId xmlns:a16="http://schemas.microsoft.com/office/drawing/2014/main" id="{41203313-ECF2-40B4-96B8-B910BD9A5F91}"/>
+                <a16:creationId xmlns:a16="http://schemas.microsoft.com/office/drawing/2014/main" id="{A6B083D3-E06B-4EE7-AA59-E086BDE5041D}"/>
               </a:ext>
             </a:extLst>
           </p:cNvPr>
@@ -10742,7 +10896,7 @@
           <p:cNvPr id="17" name="">
             <a:extLst xmlns:a="http://schemas.openxmlformats.org/drawingml/2006/main">
               <a:ext uri="{FF2B5EF4-FFF2-40B4-BE49-F238E27FC236}">
-                <a16:creationId xmlns:a16="http://schemas.microsoft.com/office/drawing/2014/main" id="{8105887F-4444-4C40-BEB5-CF352B4CCA67}"/>
+                <a16:creationId xmlns:a16="http://schemas.microsoft.com/office/drawing/2014/main" id="{01E7D386-111E-4C10-8384-7B68629668B1}"/>
               </a:ext>
             </a:extLst>
           </p:cNvPr>
@@ -10773,7 +10927,7 @@
           <p:cNvPr id="18" name="">
             <a:extLst xmlns:a="http://schemas.openxmlformats.org/drawingml/2006/main">
               <a:ext uri="{FF2B5EF4-FFF2-40B4-BE49-F238E27FC236}">
-                <a16:creationId xmlns:a16="http://schemas.microsoft.com/office/drawing/2014/main" id="{BD631DFC-F31C-440F-A0DE-64967E54F838}"/>
+                <a16:creationId xmlns:a16="http://schemas.microsoft.com/office/drawing/2014/main" id="{1A605F53-41E0-4FF9-B8B0-1C79447EEA07}"/>
               </a:ext>
             </a:extLst>
           </p:cNvPr>
@@ -10827,7 +10981,7 @@
           <p:cNvPr id="19" name="">
             <a:extLst xmlns:a="http://schemas.openxmlformats.org/drawingml/2006/main">
               <a:ext uri="{FF2B5EF4-FFF2-40B4-BE49-F238E27FC236}">
-                <a16:creationId xmlns:a16="http://schemas.microsoft.com/office/drawing/2014/main" id="{B33407CB-DFAB-43E0-A91E-32EDE4C9ABB1}"/>
+                <a16:creationId xmlns:a16="http://schemas.microsoft.com/office/drawing/2014/main" id="{2BB8C6E6-66AC-47C2-90CD-3DF58AB04554}"/>
               </a:ext>
             </a:extLst>
           </p:cNvPr>
@@ -10877,7 +11031,7 @@
           <p:cNvPr id="20" name="">
             <a:extLst xmlns:a="http://schemas.openxmlformats.org/drawingml/2006/main">
               <a:ext uri="{FF2B5EF4-FFF2-40B4-BE49-F238E27FC236}">
-                <a16:creationId xmlns:a16="http://schemas.microsoft.com/office/drawing/2014/main" id="{0B6807B8-AAD2-4381-8E1F-A064DCC6B50A}"/>
+                <a16:creationId xmlns:a16="http://schemas.microsoft.com/office/drawing/2014/main" id="{49F57DCE-BA29-4902-A325-1A12A22879F6}"/>
               </a:ext>
             </a:extLst>
           </p:cNvPr>
@@ -10927,7 +11081,7 @@
           <p:cNvPr id="21" name="">
             <a:extLst xmlns:a="http://schemas.openxmlformats.org/drawingml/2006/main">
               <a:ext uri="{FF2B5EF4-FFF2-40B4-BE49-F238E27FC236}">
-                <a16:creationId xmlns:a16="http://schemas.microsoft.com/office/drawing/2014/main" id="{BA1D6FC7-2693-4603-94A3-673B4DFE4E76}"/>
+                <a16:creationId xmlns:a16="http://schemas.microsoft.com/office/drawing/2014/main" id="{EC30E6E0-83F3-47E7-A5EA-19DDAFE3DF47}"/>
               </a:ext>
             </a:extLst>
           </p:cNvPr>
@@ -10962,7 +11116,7 @@
           <p:cNvPr id="22" name="">
             <a:extLst xmlns:a="http://schemas.openxmlformats.org/drawingml/2006/main">
               <a:ext uri="{FF2B5EF4-FFF2-40B4-BE49-F238E27FC236}">
-                <a16:creationId xmlns:a16="http://schemas.microsoft.com/office/drawing/2014/main" id="{B8CD45B8-4382-49B0-B8ED-2A91DDD4CC26}"/>
+                <a16:creationId xmlns:a16="http://schemas.microsoft.com/office/drawing/2014/main" id="{A8354A55-6C85-4998-861E-1151BAA850F6}"/>
               </a:ext>
             </a:extLst>
           </p:cNvPr>
@@ -11012,7 +11166,7 @@
           <p:cNvPr id="23" name="">
             <a:extLst xmlns:a="http://schemas.openxmlformats.org/drawingml/2006/main">
               <a:ext uri="{FF2B5EF4-FFF2-40B4-BE49-F238E27FC236}">
-                <a16:creationId xmlns:a16="http://schemas.microsoft.com/office/drawing/2014/main" id="{0B75A471-4F4E-4E51-A013-A986612C52C3}"/>
+                <a16:creationId xmlns:a16="http://schemas.microsoft.com/office/drawing/2014/main" id="{29E94648-A811-4168-8203-3BB21209BF65}"/>
               </a:ext>
             </a:extLst>
           </p:cNvPr>
@@ -11047,7 +11201,7 @@
           <p:cNvPr id="24" name="">
             <a:extLst xmlns:a="http://schemas.openxmlformats.org/drawingml/2006/main">
               <a:ext uri="{FF2B5EF4-FFF2-40B4-BE49-F238E27FC236}">
-                <a16:creationId xmlns:a16="http://schemas.microsoft.com/office/drawing/2014/main" id="{8DCF058D-6C23-4BC8-A8D8-A8A7F964BA78}"/>
+                <a16:creationId xmlns:a16="http://schemas.microsoft.com/office/drawing/2014/main" id="{329C137B-90F2-4C50-84E9-F1C480918A20}"/>
               </a:ext>
             </a:extLst>
           </p:cNvPr>
@@ -11095,7 +11249,7 @@
     </p:spTree>
     <p:extLst>
       <p:ext uri="{BB962C8B-B14F-4D97-AF65-F5344CB8AC3E}">
-        <p14:creationId xmlns:p14="http://schemas.microsoft.com/office/powerpoint/2010/main" val="526636182"/>
+        <p14:creationId xmlns:p14="http://schemas.microsoft.com/office/powerpoint/2010/main" val="702197805"/>
       </p:ext>
     </p:extLst>
   </p:cSld>
@@ -11126,7 +11280,7 @@
           <p:cNvPr id="26" name="">
             <a:extLst xmlns:a="http://schemas.openxmlformats.org/drawingml/2006/main">
               <a:ext uri="{FF2B5EF4-FFF2-40B4-BE49-F238E27FC236}">
-                <a16:creationId xmlns:a16="http://schemas.microsoft.com/office/drawing/2014/main" id="{419199C4-7FFE-4641-8198-9B19287391BD}"/>
+                <a16:creationId xmlns:a16="http://schemas.microsoft.com/office/drawing/2014/main" id="{BEB5A46B-7501-4197-9850-A9737EFFBBDE}"/>
               </a:ext>
             </a:extLst>
           </p:cNvPr>
@@ -11166,7 +11320,7 @@
                   <a:srgbClr val="102A43"/>
                 </a:solidFill>
               </a:rPr>
-              <a:t>Implementation is divided into two connected layers</a:t>
+              <a:t>Implementation is split across two connected repositories</a:t>
             </a:r>
           </a:p>
         </p:txBody>
@@ -11176,7 +11330,7 @@
           <p:cNvPr id="2" name="">
             <a:extLst xmlns:a="http://schemas.openxmlformats.org/drawingml/2006/main">
               <a:ext uri="{FF2B5EF4-FFF2-40B4-BE49-F238E27FC236}">
-                <a16:creationId xmlns:a16="http://schemas.microsoft.com/office/drawing/2014/main" id="{F75A2BFD-D3F6-4065-A6D4-430C171E96FA}"/>
+                <a16:creationId xmlns:a16="http://schemas.microsoft.com/office/drawing/2014/main" id="{16079B3B-0C48-485C-A727-3683BE067202}"/>
               </a:ext>
             </a:extLst>
           </p:cNvPr>
@@ -11216,7 +11370,7 @@
                   <a:srgbClr val="5D6B78"/>
                 </a:solidFill>
               </a:rPr>
-              <a:t>The final system combines offline indexing with online distributed query processing.</a:t>
+              <a:t>The offline repository prepares data artifacts; the runtime repository consumes them through a fixed contract.</a:t>
             </a:r>
           </a:p>
         </p:txBody>
@@ -11226,7 +11380,7 @@
           <p:cNvPr id="3" name="">
             <a:extLst xmlns:a="http://schemas.openxmlformats.org/drawingml/2006/main">
               <a:ext uri="{FF2B5EF4-FFF2-40B4-BE49-F238E27FC236}">
-                <a16:creationId xmlns:a16="http://schemas.microsoft.com/office/drawing/2014/main" id="{DCAF9F1F-0025-4264-961F-45DA1588E271}"/>
+                <a16:creationId xmlns:a16="http://schemas.microsoft.com/office/drawing/2014/main" id="{54E54130-700F-40C1-8A82-F56A3CC8278B}"/>
               </a:ext>
             </a:extLst>
           </p:cNvPr>
@@ -11257,7 +11411,7 @@
           <p:cNvPr id="4" name="">
             <a:extLst xmlns:a="http://schemas.openxmlformats.org/drawingml/2006/main">
               <a:ext uri="{FF2B5EF4-FFF2-40B4-BE49-F238E27FC236}">
-                <a16:creationId xmlns:a16="http://schemas.microsoft.com/office/drawing/2014/main" id="{F51EE3BD-EE3D-4AC5-B26F-21D4049AB685}"/>
+                <a16:creationId xmlns:a16="http://schemas.microsoft.com/office/drawing/2014/main" id="{6841CDEB-F608-455D-8A8B-C3FE4B5BD41E}"/>
               </a:ext>
             </a:extLst>
           </p:cNvPr>
@@ -11307,7 +11461,7 @@
           <p:cNvPr id="5" name="">
             <a:extLst xmlns:a="http://schemas.openxmlformats.org/drawingml/2006/main">
               <a:ext uri="{FF2B5EF4-FFF2-40B4-BE49-F238E27FC236}">
-                <a16:creationId xmlns:a16="http://schemas.microsoft.com/office/drawing/2014/main" id="{BEAAF4C7-7D30-4997-8E77-026561288779}"/>
+                <a16:creationId xmlns:a16="http://schemas.microsoft.com/office/drawing/2014/main" id="{4C0ED877-422C-4246-BE0F-0052FE644173}"/>
               </a:ext>
             </a:extLst>
           </p:cNvPr>
@@ -11357,7 +11511,7 @@
           <p:cNvPr id="6" name="">
             <a:extLst xmlns:a="http://schemas.openxmlformats.org/drawingml/2006/main">
               <a:ext uri="{FF2B5EF4-FFF2-40B4-BE49-F238E27FC236}">
-                <a16:creationId xmlns:a16="http://schemas.microsoft.com/office/drawing/2014/main" id="{77F1DB85-013B-4756-91A1-6AD02FC266BD}"/>
+                <a16:creationId xmlns:a16="http://schemas.microsoft.com/office/drawing/2014/main" id="{9C7E56D5-185F-4CA0-B9BD-0747B662D214}"/>
               </a:ext>
             </a:extLst>
           </p:cNvPr>
@@ -11397,7 +11551,7 @@
                   <a:srgbClr val="0E7C7B"/>
                 </a:solidFill>
               </a:rPr>
-              <a:t>Offline data/indexing layer</a:t>
+              <a:t>Offline repository</a:t>
             </a:r>
           </a:p>
         </p:txBody>
@@ -11407,7 +11561,7 @@
           <p:cNvPr id="7" name="">
             <a:extLst xmlns:a="http://schemas.openxmlformats.org/drawingml/2006/main">
               <a:ext uri="{FF2B5EF4-FFF2-40B4-BE49-F238E27FC236}">
-                <a16:creationId xmlns:a16="http://schemas.microsoft.com/office/drawing/2014/main" id="{3730BEFD-148E-44AF-97DC-1DBF6BF1BE56}"/>
+                <a16:creationId xmlns:a16="http://schemas.microsoft.com/office/drawing/2014/main" id="{64FFBBB2-6FBE-443D-9BD1-C77D51AC486C}"/>
               </a:ext>
             </a:extLst>
           </p:cNvPr>
@@ -11438,7 +11592,7 @@
           <p:cNvPr id="8" name="">
             <a:extLst xmlns:a="http://schemas.openxmlformats.org/drawingml/2006/main">
               <a:ext uri="{FF2B5EF4-FFF2-40B4-BE49-F238E27FC236}">
-                <a16:creationId xmlns:a16="http://schemas.microsoft.com/office/drawing/2014/main" id="{7DD141AE-2B6E-4DA2-815D-5E4A4DC961A9}"/>
+                <a16:creationId xmlns:a16="http://schemas.microsoft.com/office/drawing/2014/main" id="{68277E8E-9570-4BDE-8B74-5BD6D20F6D40}"/>
               </a:ext>
             </a:extLst>
           </p:cNvPr>
@@ -11488,7 +11642,7 @@
           <p:cNvPr id="9" name="">
             <a:extLst xmlns:a="http://schemas.openxmlformats.org/drawingml/2006/main">
               <a:ext uri="{FF2B5EF4-FFF2-40B4-BE49-F238E27FC236}">
-                <a16:creationId xmlns:a16="http://schemas.microsoft.com/office/drawing/2014/main" id="{128C47A7-303E-4E99-AB40-27C76FC04878}"/>
+                <a16:creationId xmlns:a16="http://schemas.microsoft.com/office/drawing/2014/main" id="{66F6D724-5103-4C59-A456-1EBF831BB033}"/>
               </a:ext>
             </a:extLst>
           </p:cNvPr>
@@ -11519,7 +11673,7 @@
           <p:cNvPr id="10" name="">
             <a:extLst xmlns:a="http://schemas.openxmlformats.org/drawingml/2006/main">
               <a:ext uri="{FF2B5EF4-FFF2-40B4-BE49-F238E27FC236}">
-                <a16:creationId xmlns:a16="http://schemas.microsoft.com/office/drawing/2014/main" id="{0D33DDDA-0709-4C92-9776-453FBA92D3B8}"/>
+                <a16:creationId xmlns:a16="http://schemas.microsoft.com/office/drawing/2014/main" id="{E81E7DDC-CC53-4750-9C4F-FFC6072751A1}"/>
               </a:ext>
             </a:extLst>
           </p:cNvPr>
@@ -11559,7 +11713,7 @@
                   <a:srgbClr val="17212B"/>
                 </a:solidFill>
               </a:rPr>
-              <a:t>HTML parsing into document records</a:t>
+              <a:t>HTML parsing into documents.jsonl</a:t>
             </a:r>
           </a:p>
         </p:txBody>
@@ -11569,7 +11723,7 @@
           <p:cNvPr id="11" name="">
             <a:extLst xmlns:a="http://schemas.openxmlformats.org/drawingml/2006/main">
               <a:ext uri="{FF2B5EF4-FFF2-40B4-BE49-F238E27FC236}">
-                <a16:creationId xmlns:a16="http://schemas.microsoft.com/office/drawing/2014/main" id="{359BE8A5-6547-4FE4-BE5D-155FC5EA2AB4}"/>
+                <a16:creationId xmlns:a16="http://schemas.microsoft.com/office/drawing/2014/main" id="{F27EF02F-8CDE-49E6-8C08-E20D52B48E43}"/>
               </a:ext>
             </a:extLst>
           </p:cNvPr>
@@ -11600,7 +11754,7 @@
           <p:cNvPr id="12" name="">
             <a:extLst xmlns:a="http://schemas.openxmlformats.org/drawingml/2006/main">
               <a:ext uri="{FF2B5EF4-FFF2-40B4-BE49-F238E27FC236}">
-                <a16:creationId xmlns:a16="http://schemas.microsoft.com/office/drawing/2014/main" id="{AA5BBD69-543E-4363-960D-597E2E7EF457}"/>
+                <a16:creationId xmlns:a16="http://schemas.microsoft.com/office/drawing/2014/main" id="{A59EBDAD-235E-4C1F-88BC-4417F2E7078A}"/>
               </a:ext>
             </a:extLst>
           </p:cNvPr>
@@ -11640,7 +11794,7 @@
                   <a:srgbClr val="17212B"/>
                 </a:solidFill>
               </a:rPr>
-              <a:t>document partitioning into shards</a:t>
+              <a:t>partitioned shard files for nodes</a:t>
             </a:r>
           </a:p>
         </p:txBody>
@@ -11650,7 +11804,7 @@
           <p:cNvPr id="13" name="">
             <a:extLst xmlns:a="http://schemas.openxmlformats.org/drawingml/2006/main">
               <a:ext uri="{FF2B5EF4-FFF2-40B4-BE49-F238E27FC236}">
-                <a16:creationId xmlns:a16="http://schemas.microsoft.com/office/drawing/2014/main" id="{2BFEDDD8-8441-473D-B826-E43A7AEC8B45}"/>
+                <a16:creationId xmlns:a16="http://schemas.microsoft.com/office/drawing/2014/main" id="{FB288FC1-6334-467F-8097-2DAD990C25D4}"/>
               </a:ext>
             </a:extLst>
           </p:cNvPr>
@@ -11681,7 +11835,7 @@
           <p:cNvPr id="14" name="">
             <a:extLst xmlns:a="http://schemas.openxmlformats.org/drawingml/2006/main">
               <a:ext uri="{FF2B5EF4-FFF2-40B4-BE49-F238E27FC236}">
-                <a16:creationId xmlns:a16="http://schemas.microsoft.com/office/drawing/2014/main" id="{F2B25C54-8E50-41B4-ACE0-5CA0D18FC050}"/>
+                <a16:creationId xmlns:a16="http://schemas.microsoft.com/office/drawing/2014/main" id="{321468F7-D355-4DEE-9F26-5DE7DC0C4306}"/>
               </a:ext>
             </a:extLst>
           </p:cNvPr>
@@ -11721,7 +11875,7 @@
                   <a:srgbClr val="17212B"/>
                 </a:solidFill>
               </a:rPr>
-              <a:t>local inverted indexes with global stats</a:t>
+              <a:t>node index folders plus global_stats.json</a:t>
             </a:r>
           </a:p>
         </p:txBody>
@@ -11731,7 +11885,7 @@
           <p:cNvPr id="15" name="">
             <a:extLst xmlns:a="http://schemas.openxmlformats.org/drawingml/2006/main">
               <a:ext uri="{FF2B5EF4-FFF2-40B4-BE49-F238E27FC236}">
-                <a16:creationId xmlns:a16="http://schemas.microsoft.com/office/drawing/2014/main" id="{E873D5FB-8F4F-43AF-8F71-5CE8F0490CCA}"/>
+                <a16:creationId xmlns:a16="http://schemas.microsoft.com/office/drawing/2014/main" id="{06BAD2FC-0D78-47E5-AD6B-C4119937D81E}"/>
               </a:ext>
             </a:extLst>
           </p:cNvPr>
@@ -11771,7 +11925,7 @@
                   <a:srgbClr val="3267B1"/>
                 </a:solidFill>
               </a:rPr>
-              <a:t>Online query/runtime layer</a:t>
+              <a:t>Runtime repository</a:t>
             </a:r>
           </a:p>
         </p:txBody>
@@ -11781,7 +11935,7 @@
           <p:cNvPr id="16" name="">
             <a:extLst xmlns:a="http://schemas.openxmlformats.org/drawingml/2006/main">
               <a:ext uri="{FF2B5EF4-FFF2-40B4-BE49-F238E27FC236}">
-                <a16:creationId xmlns:a16="http://schemas.microsoft.com/office/drawing/2014/main" id="{349792D5-86EF-4D24-9BF8-FB3E9077A4B2}"/>
+                <a16:creationId xmlns:a16="http://schemas.microsoft.com/office/drawing/2014/main" id="{C1322557-4A88-4D1C-80B2-9671BC1E4568}"/>
               </a:ext>
             </a:extLst>
           </p:cNvPr>
@@ -11812,7 +11966,7 @@
           <p:cNvPr id="17" name="">
             <a:extLst xmlns:a="http://schemas.openxmlformats.org/drawingml/2006/main">
               <a:ext uri="{FF2B5EF4-FFF2-40B4-BE49-F238E27FC236}">
-                <a16:creationId xmlns:a16="http://schemas.microsoft.com/office/drawing/2014/main" id="{7718E2AC-4422-4176-B9F8-FF4A57B8D50C}"/>
+                <a16:creationId xmlns:a16="http://schemas.microsoft.com/office/drawing/2014/main" id="{E31CC52A-EAAF-4A26-A61B-BC78E587BF94}"/>
               </a:ext>
             </a:extLst>
           </p:cNvPr>
@@ -11862,7 +12016,7 @@
           <p:cNvPr id="18" name="">
             <a:extLst xmlns:a="http://schemas.openxmlformats.org/drawingml/2006/main">
               <a:ext uri="{FF2B5EF4-FFF2-40B4-BE49-F238E27FC236}">
-                <a16:creationId xmlns:a16="http://schemas.microsoft.com/office/drawing/2014/main" id="{78265526-EA35-4DD1-AF61-472DEB5BD9B1}"/>
+                <a16:creationId xmlns:a16="http://schemas.microsoft.com/office/drawing/2014/main" id="{BC14C35B-791A-48C9-8C8F-BA60CD518E41}"/>
               </a:ext>
             </a:extLst>
           </p:cNvPr>
@@ -11893,7 +12047,7 @@
           <p:cNvPr id="19" name="">
             <a:extLst xmlns:a="http://schemas.openxmlformats.org/drawingml/2006/main">
               <a:ext uri="{FF2B5EF4-FFF2-40B4-BE49-F238E27FC236}">
-                <a16:creationId xmlns:a16="http://schemas.microsoft.com/office/drawing/2014/main" id="{E7AC612B-D477-4B1F-9698-32E0BC2EFFC6}"/>
+                <a16:creationId xmlns:a16="http://schemas.microsoft.com/office/drawing/2014/main" id="{D112A882-9D98-49A1-B6EB-95DB200896F6}"/>
               </a:ext>
             </a:extLst>
           </p:cNvPr>
@@ -11943,7 +12097,7 @@
           <p:cNvPr id="20" name="">
             <a:extLst xmlns:a="http://schemas.openxmlformats.org/drawingml/2006/main">
               <a:ext uri="{FF2B5EF4-FFF2-40B4-BE49-F238E27FC236}">
-                <a16:creationId xmlns:a16="http://schemas.microsoft.com/office/drawing/2014/main" id="{4E46CFF3-E927-41D5-B9A2-03BF9F9EBC9F}"/>
+                <a16:creationId xmlns:a16="http://schemas.microsoft.com/office/drawing/2014/main" id="{F2453FD1-894D-4FCD-892B-B7368B939234}"/>
               </a:ext>
             </a:extLst>
           </p:cNvPr>
@@ -11974,7 +12128,7 @@
           <p:cNvPr id="21" name="">
             <a:extLst xmlns:a="http://schemas.openxmlformats.org/drawingml/2006/main">
               <a:ext uri="{FF2B5EF4-FFF2-40B4-BE49-F238E27FC236}">
-                <a16:creationId xmlns:a16="http://schemas.microsoft.com/office/drawing/2014/main" id="{632B98D7-AB01-440C-B5C2-09B161F0FE29}"/>
+                <a16:creationId xmlns:a16="http://schemas.microsoft.com/office/drawing/2014/main" id="{979065CD-02F0-458F-BB15-A75AC165620D}"/>
               </a:ext>
             </a:extLst>
           </p:cNvPr>
@@ -12024,7 +12178,7 @@
           <p:cNvPr id="22" name="">
             <a:extLst xmlns:a="http://schemas.openxmlformats.org/drawingml/2006/main">
               <a:ext uri="{FF2B5EF4-FFF2-40B4-BE49-F238E27FC236}">
-                <a16:creationId xmlns:a16="http://schemas.microsoft.com/office/drawing/2014/main" id="{A496EC80-0277-4F90-82C3-03CA8BF4CCE9}"/>
+                <a16:creationId xmlns:a16="http://schemas.microsoft.com/office/drawing/2014/main" id="{5C22EEC1-B2D0-4F3F-A414-B090489A0815}"/>
               </a:ext>
             </a:extLst>
           </p:cNvPr>
@@ -12055,7 +12209,7 @@
           <p:cNvPr id="23" name="">
             <a:extLst xmlns:a="http://schemas.openxmlformats.org/drawingml/2006/main">
               <a:ext uri="{FF2B5EF4-FFF2-40B4-BE49-F238E27FC236}">
-                <a16:creationId xmlns:a16="http://schemas.microsoft.com/office/drawing/2014/main" id="{3839CFFD-0062-4E5A-ACC1-0B34D5FFA062}"/>
+                <a16:creationId xmlns:a16="http://schemas.microsoft.com/office/drawing/2014/main" id="{7869B474-4C4B-4D08-9E54-FA32A82417AD}"/>
               </a:ext>
             </a:extLst>
           </p:cNvPr>
@@ -12105,7 +12259,7 @@
           <p:cNvPr id="24" name="">
             <a:extLst xmlns:a="http://schemas.openxmlformats.org/drawingml/2006/main">
               <a:ext uri="{FF2B5EF4-FFF2-40B4-BE49-F238E27FC236}">
-                <a16:creationId xmlns:a16="http://schemas.microsoft.com/office/drawing/2014/main" id="{B8C0EBCD-E060-42AE-A684-D89E7070973A}"/>
+                <a16:creationId xmlns:a16="http://schemas.microsoft.com/office/drawing/2014/main" id="{40D4CDCF-7BD4-4452-BA84-291ABD4A6C50}"/>
               </a:ext>
             </a:extLst>
           </p:cNvPr>
@@ -12140,7 +12294,7 @@
           <p:cNvPr id="25" name="">
             <a:extLst xmlns:a="http://schemas.openxmlformats.org/drawingml/2006/main">
               <a:ext uri="{FF2B5EF4-FFF2-40B4-BE49-F238E27FC236}">
-                <a16:creationId xmlns:a16="http://schemas.microsoft.com/office/drawing/2014/main" id="{9312DF48-F744-4B9A-BC81-13F5B3F63C67}"/>
+                <a16:creationId xmlns:a16="http://schemas.microsoft.com/office/drawing/2014/main" id="{0C851429-D937-43BC-AD86-7B727AC2F6CC}"/>
               </a:ext>
             </a:extLst>
           </p:cNvPr>
@@ -12168,19 +12322,19 @@
           <a:lstStyle xmlns:a="http://schemas.openxmlformats.org/drawingml/2006/main"/>
           <a:p xmlns:a="http://schemas.openxmlformats.org/drawingml/2006/main">
             <a:pPr algn="ctr">
-              <a:defRPr sz="1425" b="1">
-                <a:solidFill>
-                  <a:srgbClr val="17212B"/>
-                </a:solidFill>
-              </a:defRPr>
-            </a:pPr>
-            <a:r>
-              <a:rPr sz="1425" b="1">
-                <a:solidFill>
-                  <a:srgbClr val="17212B"/>
-                </a:solidFill>
-              </a:rPr>
-              <a:t>Common contract: node_id, shard path, index path, QueryRequest, SearchResult</a:t>
+              <a:defRPr sz="1350" b="1">
+                <a:solidFill>
+                  <a:srgbClr val="17212B"/>
+                </a:solidFill>
+              </a:defRPr>
+            </a:pPr>
+            <a:r>
+              <a:rPr sz="1350" b="1">
+                <a:solidFill>
+                  <a:srgbClr val="17212B"/>
+                </a:solidFill>
+              </a:rPr>
+              <a:t>Shared contract: shard files, node indexes, global stats, QueryRequest, SearchResult</a:t>
             </a:r>
           </a:p>
         </p:txBody>
@@ -12188,7 +12342,7 @@
     </p:spTree>
     <p:extLst>
       <p:ext uri="{BB962C8B-B14F-4D97-AF65-F5344CB8AC3E}">
-        <p14:creationId xmlns:p14="http://schemas.microsoft.com/office/powerpoint/2010/main" val="1148806321"/>
+        <p14:creationId xmlns:p14="http://schemas.microsoft.com/office/powerpoint/2010/main" val="1577960250"/>
       </p:ext>
     </p:extLst>
   </p:cSld>
@@ -12219,7 +12373,7 @@
           <p:cNvPr id="18" name="">
             <a:extLst xmlns:a="http://schemas.openxmlformats.org/drawingml/2006/main">
               <a:ext uri="{FF2B5EF4-FFF2-40B4-BE49-F238E27FC236}">
-                <a16:creationId xmlns:a16="http://schemas.microsoft.com/office/drawing/2014/main" id="{C3B9C0B5-713F-4FBF-A946-1580C7DC5742}"/>
+                <a16:creationId xmlns:a16="http://schemas.microsoft.com/office/drawing/2014/main" id="{A7411AE1-A4F1-4641-9D09-9D3585FC769F}"/>
               </a:ext>
             </a:extLst>
           </p:cNvPr>
@@ -12269,7 +12423,7 @@
           <p:cNvPr id="2" name="">
             <a:extLst xmlns:a="http://schemas.openxmlformats.org/drawingml/2006/main">
               <a:ext uri="{FF2B5EF4-FFF2-40B4-BE49-F238E27FC236}">
-                <a16:creationId xmlns:a16="http://schemas.microsoft.com/office/drawing/2014/main" id="{3A49300F-7A0C-4C87-ABD0-9D9BFDE9D3C5}"/>
+                <a16:creationId xmlns:a16="http://schemas.microsoft.com/office/drawing/2014/main" id="{D37BBA03-11EC-4302-B93D-D6BCAFEAB664}"/>
               </a:ext>
             </a:extLst>
           </p:cNvPr>
@@ -12319,7 +12473,7 @@
           <p:cNvPr id="3" name="">
             <a:extLst xmlns:a="http://schemas.openxmlformats.org/drawingml/2006/main">
               <a:ext uri="{FF2B5EF4-FFF2-40B4-BE49-F238E27FC236}">
-                <a16:creationId xmlns:a16="http://schemas.microsoft.com/office/drawing/2014/main" id="{01B17906-786A-432D-A227-5DB7F7D6FDC5}"/>
+                <a16:creationId xmlns:a16="http://schemas.microsoft.com/office/drawing/2014/main" id="{A18AD5D6-C5E5-4C59-A472-2A98BFBA0F08}"/>
               </a:ext>
             </a:extLst>
           </p:cNvPr>
@@ -12350,7 +12504,7 @@
           <p:cNvPr id="4" name="">
             <a:extLst xmlns:a="http://schemas.openxmlformats.org/drawingml/2006/main">
               <a:ext uri="{FF2B5EF4-FFF2-40B4-BE49-F238E27FC236}">
-                <a16:creationId xmlns:a16="http://schemas.microsoft.com/office/drawing/2014/main" id="{2BD2B426-7EB2-47AF-8B3C-54D12F997B08}"/>
+                <a16:creationId xmlns:a16="http://schemas.microsoft.com/office/drawing/2014/main" id="{409A87C1-E867-4538-8AE9-36515ED1C4A7}"/>
               </a:ext>
             </a:extLst>
           </p:cNvPr>
@@ -12400,7 +12554,7 @@
           <p:cNvPr id="5" name="">
             <a:extLst xmlns:a="http://schemas.openxmlformats.org/drawingml/2006/main">
               <a:ext uri="{FF2B5EF4-FFF2-40B4-BE49-F238E27FC236}">
-                <a16:creationId xmlns:a16="http://schemas.microsoft.com/office/drawing/2014/main" id="{EBAD7733-1A9B-47F3-8A8A-63DCF33D4368}"/>
+                <a16:creationId xmlns:a16="http://schemas.microsoft.com/office/drawing/2014/main" id="{26315679-BC8D-4F4C-ABEB-2F6A5B8AB69F}"/>
               </a:ext>
             </a:extLst>
           </p:cNvPr>
@@ -12450,7 +12604,7 @@
           <p:cNvPr id="6" name="">
             <a:extLst xmlns:a="http://schemas.openxmlformats.org/drawingml/2006/main">
               <a:ext uri="{FF2B5EF4-FFF2-40B4-BE49-F238E27FC236}">
-                <a16:creationId xmlns:a16="http://schemas.microsoft.com/office/drawing/2014/main" id="{6E90121A-C27D-4A8D-AE1F-31CDB268D983}"/>
+                <a16:creationId xmlns:a16="http://schemas.microsoft.com/office/drawing/2014/main" id="{E88BEF5B-3B81-4C63-B7C6-929C69EE9DD0}"/>
               </a:ext>
             </a:extLst>
           </p:cNvPr>
@@ -12500,7 +12654,7 @@
           <p:cNvPr id="7" name="">
             <a:extLst xmlns:a="http://schemas.openxmlformats.org/drawingml/2006/main">
               <a:ext uri="{FF2B5EF4-FFF2-40B4-BE49-F238E27FC236}">
-                <a16:creationId xmlns:a16="http://schemas.microsoft.com/office/drawing/2014/main" id="{B1D8515E-2E38-4BEF-901E-2DBC9E1E9DEA}"/>
+                <a16:creationId xmlns:a16="http://schemas.microsoft.com/office/drawing/2014/main" id="{CAC319B4-AC6A-4DEA-B627-F9F3688A7951}"/>
               </a:ext>
             </a:extLst>
           </p:cNvPr>
@@ -12550,7 +12704,7 @@
           <p:cNvPr id="8" name="">
             <a:extLst xmlns:a="http://schemas.openxmlformats.org/drawingml/2006/main">
               <a:ext uri="{FF2B5EF4-FFF2-40B4-BE49-F238E27FC236}">
-                <a16:creationId xmlns:a16="http://schemas.microsoft.com/office/drawing/2014/main" id="{424B6891-B3C3-49B0-A211-770B17770391}"/>
+                <a16:creationId xmlns:a16="http://schemas.microsoft.com/office/drawing/2014/main" id="{7400E408-B29A-4023-A34F-7A3B03D0B78D}"/>
               </a:ext>
             </a:extLst>
           </p:cNvPr>
@@ -12581,7 +12735,7 @@
           <p:cNvPr id="9" name="">
             <a:extLst xmlns:a="http://schemas.openxmlformats.org/drawingml/2006/main">
               <a:ext uri="{FF2B5EF4-FFF2-40B4-BE49-F238E27FC236}">
-                <a16:creationId xmlns:a16="http://schemas.microsoft.com/office/drawing/2014/main" id="{34F3E75D-31E3-45F9-811C-449A0C2A65D9}"/>
+                <a16:creationId xmlns:a16="http://schemas.microsoft.com/office/drawing/2014/main" id="{628362C0-F989-45A3-AC3A-3A4ADB478210}"/>
               </a:ext>
             </a:extLst>
           </p:cNvPr>
@@ -12631,7 +12785,7 @@
           <p:cNvPr id="10" name="">
             <a:extLst xmlns:a="http://schemas.openxmlformats.org/drawingml/2006/main">
               <a:ext uri="{FF2B5EF4-FFF2-40B4-BE49-F238E27FC236}">
-                <a16:creationId xmlns:a16="http://schemas.microsoft.com/office/drawing/2014/main" id="{DD01963D-73ED-43EF-89F9-0740ED3963C4}"/>
+                <a16:creationId xmlns:a16="http://schemas.microsoft.com/office/drawing/2014/main" id="{49523408-7A53-4A61-A73A-92A07CDFB4FF}"/>
               </a:ext>
             </a:extLst>
           </p:cNvPr>
@@ -12681,7 +12835,7 @@
           <p:cNvPr id="11" name="">
             <a:extLst xmlns:a="http://schemas.openxmlformats.org/drawingml/2006/main">
               <a:ext uri="{FF2B5EF4-FFF2-40B4-BE49-F238E27FC236}">
-                <a16:creationId xmlns:a16="http://schemas.microsoft.com/office/drawing/2014/main" id="{23BAE2B5-1AEF-480F-B13A-C63B1657CDE6}"/>
+                <a16:creationId xmlns:a16="http://schemas.microsoft.com/office/drawing/2014/main" id="{AB8E389A-E67B-42C3-AAB2-B8A6B8055E86}"/>
               </a:ext>
             </a:extLst>
           </p:cNvPr>
@@ -12712,7 +12866,7 @@
           <p:cNvPr id="12" name="">
             <a:extLst xmlns:a="http://schemas.openxmlformats.org/drawingml/2006/main">
               <a:ext uri="{FF2B5EF4-FFF2-40B4-BE49-F238E27FC236}">
-                <a16:creationId xmlns:a16="http://schemas.microsoft.com/office/drawing/2014/main" id="{6DB49798-8C06-4D3D-960E-C38AD02186B8}"/>
+                <a16:creationId xmlns:a16="http://schemas.microsoft.com/office/drawing/2014/main" id="{977477E5-E7B2-43C7-ACA9-B6422EB8D0FF}"/>
               </a:ext>
             </a:extLst>
           </p:cNvPr>
@@ -12762,7 +12916,7 @@
           <p:cNvPr id="13" name="">
             <a:extLst xmlns:a="http://schemas.openxmlformats.org/drawingml/2006/main">
               <a:ext uri="{FF2B5EF4-FFF2-40B4-BE49-F238E27FC236}">
-                <a16:creationId xmlns:a16="http://schemas.microsoft.com/office/drawing/2014/main" id="{A053A99C-88F7-49A3-A86B-65DECDE6338E}"/>
+                <a16:creationId xmlns:a16="http://schemas.microsoft.com/office/drawing/2014/main" id="{7704D348-8ADD-45B0-B466-B8DEA292F189}"/>
               </a:ext>
             </a:extLst>
           </p:cNvPr>
@@ -12812,7 +12966,7 @@
           <p:cNvPr id="14" name="">
             <a:extLst xmlns:a="http://schemas.openxmlformats.org/drawingml/2006/main">
               <a:ext uri="{FF2B5EF4-FFF2-40B4-BE49-F238E27FC236}">
-                <a16:creationId xmlns:a16="http://schemas.microsoft.com/office/drawing/2014/main" id="{79FB7CB5-90B9-4F38-8E4A-C6E7C3ACD238}"/>
+                <a16:creationId xmlns:a16="http://schemas.microsoft.com/office/drawing/2014/main" id="{3D32FEA1-8F72-474C-B048-34ADE9C5C4C4}"/>
               </a:ext>
             </a:extLst>
           </p:cNvPr>
@@ -12843,7 +12997,7 @@
           <p:cNvPr id="15" name="">
             <a:extLst xmlns:a="http://schemas.openxmlformats.org/drawingml/2006/main">
               <a:ext uri="{FF2B5EF4-FFF2-40B4-BE49-F238E27FC236}">
-                <a16:creationId xmlns:a16="http://schemas.microsoft.com/office/drawing/2014/main" id="{1A8A2D35-604F-42D7-B0C6-85BC31F842EC}"/>
+                <a16:creationId xmlns:a16="http://schemas.microsoft.com/office/drawing/2014/main" id="{57D06FCC-6DA0-4B41-AE77-D82F606DD27E}"/>
               </a:ext>
             </a:extLst>
           </p:cNvPr>
@@ -12893,7 +13047,7 @@
           <p:cNvPr id="16" name="">
             <a:extLst xmlns:a="http://schemas.openxmlformats.org/drawingml/2006/main">
               <a:ext uri="{FF2B5EF4-FFF2-40B4-BE49-F238E27FC236}">
-                <a16:creationId xmlns:a16="http://schemas.microsoft.com/office/drawing/2014/main" id="{BB82BB1E-23A8-4956-8B84-090EBF43F378}"/>
+                <a16:creationId xmlns:a16="http://schemas.microsoft.com/office/drawing/2014/main" id="{94F17100-62D8-40CF-8D07-342D179D8588}"/>
               </a:ext>
             </a:extLst>
           </p:cNvPr>
@@ -12943,7 +13097,7 @@
           <p:cNvPr id="17" name="">
             <a:extLst xmlns:a="http://schemas.openxmlformats.org/drawingml/2006/main">
               <a:ext uri="{FF2B5EF4-FFF2-40B4-BE49-F238E27FC236}">
-                <a16:creationId xmlns:a16="http://schemas.microsoft.com/office/drawing/2014/main" id="{E65CD9B0-3284-414F-AF35-122A45B7BDA2}"/>
+                <a16:creationId xmlns:a16="http://schemas.microsoft.com/office/drawing/2014/main" id="{324E82F3-67C8-4A95-8C55-B225D7C31C3F}"/>
               </a:ext>
             </a:extLst>
           </p:cNvPr>
@@ -12972,7 +13126,7 @@
     </p:spTree>
     <p:extLst>
       <p:ext uri="{BB962C8B-B14F-4D97-AF65-F5344CB8AC3E}">
-        <p14:creationId xmlns:p14="http://schemas.microsoft.com/office/powerpoint/2010/main" val="858152912"/>
+        <p14:creationId xmlns:p14="http://schemas.microsoft.com/office/powerpoint/2010/main" val="1222785405"/>
       </p:ext>
     </p:extLst>
   </p:cSld>
@@ -13003,7 +13157,7 @@
           <p:cNvPr id="15" name="">
             <a:extLst xmlns:a="http://schemas.openxmlformats.org/drawingml/2006/main">
               <a:ext uri="{FF2B5EF4-FFF2-40B4-BE49-F238E27FC236}">
-                <a16:creationId xmlns:a16="http://schemas.microsoft.com/office/drawing/2014/main" id="{23F595BB-A53B-46F3-8F72-089B73B7E725}"/>
+                <a16:creationId xmlns:a16="http://schemas.microsoft.com/office/drawing/2014/main" id="{EF5BD4DD-1E3D-4169-8C25-2C56FCFF01B5}"/>
               </a:ext>
             </a:extLst>
           </p:cNvPr>
@@ -13053,7 +13207,7 @@
           <p:cNvPr id="2" name="">
             <a:extLst xmlns:a="http://schemas.openxmlformats.org/drawingml/2006/main">
               <a:ext uri="{FF2B5EF4-FFF2-40B4-BE49-F238E27FC236}">
-                <a16:creationId xmlns:a16="http://schemas.microsoft.com/office/drawing/2014/main" id="{C2B60E09-DBE5-40C7-9FC9-20DC7B76961D}"/>
+                <a16:creationId xmlns:a16="http://schemas.microsoft.com/office/drawing/2014/main" id="{775797EE-8279-457E-BDE4-A30E073A84D3}"/>
               </a:ext>
             </a:extLst>
           </p:cNvPr>
@@ -13103,7 +13257,7 @@
           <p:cNvPr id="3" name="">
             <a:extLst xmlns:a="http://schemas.openxmlformats.org/drawingml/2006/main">
               <a:ext uri="{FF2B5EF4-FFF2-40B4-BE49-F238E27FC236}">
-                <a16:creationId xmlns:a16="http://schemas.microsoft.com/office/drawing/2014/main" id="{D1E35042-2083-4618-AD73-C16871D524D9}"/>
+                <a16:creationId xmlns:a16="http://schemas.microsoft.com/office/drawing/2014/main" id="{A5F23820-C8F3-4FA6-A6AB-1CAC98510529}"/>
               </a:ext>
             </a:extLst>
           </p:cNvPr>
@@ -13134,7 +13288,7 @@
           <p:cNvPr id="4" name="">
             <a:extLst xmlns:a="http://schemas.openxmlformats.org/drawingml/2006/main">
               <a:ext uri="{FF2B5EF4-FFF2-40B4-BE49-F238E27FC236}">
-                <a16:creationId xmlns:a16="http://schemas.microsoft.com/office/drawing/2014/main" id="{9F201EFC-203C-44A5-96B5-863A9BC737FC}"/>
+                <a16:creationId xmlns:a16="http://schemas.microsoft.com/office/drawing/2014/main" id="{023402F3-A8A8-4FD3-B1B4-7EE534555DFF}"/>
               </a:ext>
             </a:extLst>
           </p:cNvPr>
@@ -13184,7 +13338,7 @@
           <p:cNvPr id="5" name="">
             <a:extLst xmlns:a="http://schemas.openxmlformats.org/drawingml/2006/main">
               <a:ext uri="{FF2B5EF4-FFF2-40B4-BE49-F238E27FC236}">
-                <a16:creationId xmlns:a16="http://schemas.microsoft.com/office/drawing/2014/main" id="{08410B61-8E77-4AD3-ABAE-B11D96790514}"/>
+                <a16:creationId xmlns:a16="http://schemas.microsoft.com/office/drawing/2014/main" id="{AF0CB2C1-57F2-45C7-9D77-69CEF6AC55E8}"/>
               </a:ext>
             </a:extLst>
           </p:cNvPr>
@@ -13234,7 +13388,7 @@
           <p:cNvPr id="6" name="">
             <a:extLst xmlns:a="http://schemas.openxmlformats.org/drawingml/2006/main">
               <a:ext uri="{FF2B5EF4-FFF2-40B4-BE49-F238E27FC236}">
-                <a16:creationId xmlns:a16="http://schemas.microsoft.com/office/drawing/2014/main" id="{53EAD7AC-F8BE-4094-B8C3-98249385DAF3}"/>
+                <a16:creationId xmlns:a16="http://schemas.microsoft.com/office/drawing/2014/main" id="{3DDECF0E-DFA9-41AB-9A1B-7BA91FD9647C}"/>
               </a:ext>
             </a:extLst>
           </p:cNvPr>
@@ -13288,7 +13442,7 @@
           <p:cNvPr id="7" name="">
             <a:extLst xmlns:a="http://schemas.openxmlformats.org/drawingml/2006/main">
               <a:ext uri="{FF2B5EF4-FFF2-40B4-BE49-F238E27FC236}">
-                <a16:creationId xmlns:a16="http://schemas.microsoft.com/office/drawing/2014/main" id="{2AB287B2-2DED-4C43-86DC-8AB5834250A4}"/>
+                <a16:creationId xmlns:a16="http://schemas.microsoft.com/office/drawing/2014/main" id="{9734C16D-D7EB-42AE-8C6F-538795BCA930}"/>
               </a:ext>
             </a:extLst>
           </p:cNvPr>
@@ -13319,7 +13473,7 @@
           <p:cNvPr id="8" name="">
             <a:extLst xmlns:a="http://schemas.openxmlformats.org/drawingml/2006/main">
               <a:ext uri="{FF2B5EF4-FFF2-40B4-BE49-F238E27FC236}">
-                <a16:creationId xmlns:a16="http://schemas.microsoft.com/office/drawing/2014/main" id="{4C796B3C-DDD6-4F53-96C2-56D4613E1D6B}"/>
+                <a16:creationId xmlns:a16="http://schemas.microsoft.com/office/drawing/2014/main" id="{94002394-F933-4C6D-8EE8-E7A03CDC3CEE}"/>
               </a:ext>
             </a:extLst>
           </p:cNvPr>
@@ -13373,7 +13527,7 @@
           <p:cNvPr id="9" name="">
             <a:extLst xmlns:a="http://schemas.openxmlformats.org/drawingml/2006/main">
               <a:ext uri="{FF2B5EF4-FFF2-40B4-BE49-F238E27FC236}">
-                <a16:creationId xmlns:a16="http://schemas.microsoft.com/office/drawing/2014/main" id="{62DB0356-FD73-4BBD-9ED5-BB91EBB63B8E}"/>
+                <a16:creationId xmlns:a16="http://schemas.microsoft.com/office/drawing/2014/main" id="{3DF0ACA7-F4D1-46F7-A9B4-F27D671C256A}"/>
               </a:ext>
             </a:extLst>
           </p:cNvPr>
@@ -13427,7 +13581,7 @@
           <p:cNvPr id="10" name="">
             <a:extLst xmlns:a="http://schemas.openxmlformats.org/drawingml/2006/main">
               <a:ext uri="{FF2B5EF4-FFF2-40B4-BE49-F238E27FC236}">
-                <a16:creationId xmlns:a16="http://schemas.microsoft.com/office/drawing/2014/main" id="{5870D470-6A04-4774-86A2-A23449618EA5}"/>
+                <a16:creationId xmlns:a16="http://schemas.microsoft.com/office/drawing/2014/main" id="{CFD4A9DF-EFB2-40CE-BA2B-544B940737ED}"/>
               </a:ext>
             </a:extLst>
           </p:cNvPr>
@@ -13481,7 +13635,7 @@
           <p:cNvPr id="11" name="">
             <a:extLst xmlns:a="http://schemas.openxmlformats.org/drawingml/2006/main">
               <a:ext uri="{FF2B5EF4-FFF2-40B4-BE49-F238E27FC236}">
-                <a16:creationId xmlns:a16="http://schemas.microsoft.com/office/drawing/2014/main" id="{210FE21D-FE3C-439A-966F-CC30526212E9}"/>
+                <a16:creationId xmlns:a16="http://schemas.microsoft.com/office/drawing/2014/main" id="{2E47A1C9-C031-4CD2-A114-AD28108323C1}"/>
               </a:ext>
             </a:extLst>
           </p:cNvPr>
@@ -13531,7 +13685,7 @@
           <p:cNvPr id="12" name="">
             <a:extLst xmlns:a="http://schemas.openxmlformats.org/drawingml/2006/main">
               <a:ext uri="{FF2B5EF4-FFF2-40B4-BE49-F238E27FC236}">
-                <a16:creationId xmlns:a16="http://schemas.microsoft.com/office/drawing/2014/main" id="{3B23E334-D0F3-4B72-B6E9-DBF82B4B7DB1}"/>
+                <a16:creationId xmlns:a16="http://schemas.microsoft.com/office/drawing/2014/main" id="{26F19B05-4C05-4626-B9F9-E9B73AAE1CAD}"/>
               </a:ext>
             </a:extLst>
           </p:cNvPr>
@@ -13566,7 +13720,7 @@
           <p:cNvPr id="13" name="">
             <a:extLst xmlns:a="http://schemas.openxmlformats.org/drawingml/2006/main">
               <a:ext uri="{FF2B5EF4-FFF2-40B4-BE49-F238E27FC236}">
-                <a16:creationId xmlns:a16="http://schemas.microsoft.com/office/drawing/2014/main" id="{36FB7415-A66E-472F-AAB2-5420B9364C31}"/>
+                <a16:creationId xmlns:a16="http://schemas.microsoft.com/office/drawing/2014/main" id="{E476FCB7-9A5E-49E5-887E-49511A4B0A4B}"/>
               </a:ext>
             </a:extLst>
           </p:cNvPr>
@@ -13616,7 +13770,7 @@
           <p:cNvPr id="14" name="">
             <a:extLst xmlns:a="http://schemas.openxmlformats.org/drawingml/2006/main">
               <a:ext uri="{FF2B5EF4-FFF2-40B4-BE49-F238E27FC236}">
-                <a16:creationId xmlns:a16="http://schemas.microsoft.com/office/drawing/2014/main" id="{2D69BC38-CA78-4CC5-9CAA-CA41E14DCB55}"/>
+                <a16:creationId xmlns:a16="http://schemas.microsoft.com/office/drawing/2014/main" id="{64A7B3AA-8D68-42DF-BB23-1C2EA8AE9997}"/>
               </a:ext>
             </a:extLst>
           </p:cNvPr>
@@ -13708,7 +13862,7 @@
     </p:spTree>
     <p:extLst>
       <p:ext uri="{BB962C8B-B14F-4D97-AF65-F5344CB8AC3E}">
-        <p14:creationId xmlns:p14="http://schemas.microsoft.com/office/powerpoint/2010/main" val="453276888"/>
+        <p14:creationId xmlns:p14="http://schemas.microsoft.com/office/powerpoint/2010/main" val="1310553521"/>
       </p:ext>
     </p:extLst>
   </p:cSld>
@@ -13739,7 +13893,7 @@
           <p:cNvPr id="15" name="">
             <a:extLst xmlns:a="http://schemas.openxmlformats.org/drawingml/2006/main">
               <a:ext uri="{FF2B5EF4-FFF2-40B4-BE49-F238E27FC236}">
-                <a16:creationId xmlns:a16="http://schemas.microsoft.com/office/drawing/2014/main" id="{87AE4038-A33E-4076-B9F4-5A21FC1F37BE}"/>
+                <a16:creationId xmlns:a16="http://schemas.microsoft.com/office/drawing/2014/main" id="{EE62EFA5-A8F2-4434-9D2C-038FD014D12F}"/>
               </a:ext>
             </a:extLst>
           </p:cNvPr>
@@ -13789,7 +13943,7 @@
           <p:cNvPr id="2" name="">
             <a:extLst xmlns:a="http://schemas.openxmlformats.org/drawingml/2006/main">
               <a:ext uri="{FF2B5EF4-FFF2-40B4-BE49-F238E27FC236}">
-                <a16:creationId xmlns:a16="http://schemas.microsoft.com/office/drawing/2014/main" id="{CBE9F4B2-8622-4501-A520-7948E909C08A}"/>
+                <a16:creationId xmlns:a16="http://schemas.microsoft.com/office/drawing/2014/main" id="{B54A6872-82D1-4B49-BDB7-29D46A579541}"/>
               </a:ext>
             </a:extLst>
           </p:cNvPr>
@@ -13839,7 +13993,7 @@
           <p:cNvPr id="3" name="">
             <a:extLst xmlns:a="http://schemas.openxmlformats.org/drawingml/2006/main">
               <a:ext uri="{FF2B5EF4-FFF2-40B4-BE49-F238E27FC236}">
-                <a16:creationId xmlns:a16="http://schemas.microsoft.com/office/drawing/2014/main" id="{57DBA9D2-D5C5-4A4D-8ECD-45230F3372C9}"/>
+                <a16:creationId xmlns:a16="http://schemas.microsoft.com/office/drawing/2014/main" id="{EC987A52-C957-4D37-9B52-E42DA087E3BD}"/>
               </a:ext>
             </a:extLst>
           </p:cNvPr>
@@ -13870,7 +14024,7 @@
           <p:cNvPr id="4" name="">
             <a:extLst xmlns:a="http://schemas.openxmlformats.org/drawingml/2006/main">
               <a:ext uri="{FF2B5EF4-FFF2-40B4-BE49-F238E27FC236}">
-                <a16:creationId xmlns:a16="http://schemas.microsoft.com/office/drawing/2014/main" id="{78631725-CD8C-49A7-8A46-99BC8E98E703}"/>
+                <a16:creationId xmlns:a16="http://schemas.microsoft.com/office/drawing/2014/main" id="{B37E6F12-5982-4D0A-A762-CAB690450A6D}"/>
               </a:ext>
             </a:extLst>
           </p:cNvPr>
@@ -13920,7 +14074,7 @@
           <p:cNvPr id="5" name="">
             <a:extLst xmlns:a="http://schemas.openxmlformats.org/drawingml/2006/main">
               <a:ext uri="{FF2B5EF4-FFF2-40B4-BE49-F238E27FC236}">
-                <a16:creationId xmlns:a16="http://schemas.microsoft.com/office/drawing/2014/main" id="{766735E4-B755-4CE9-AF6E-432CE042EBCE}"/>
+                <a16:creationId xmlns:a16="http://schemas.microsoft.com/office/drawing/2014/main" id="{11F176B6-320B-41CD-B6BD-D0EEB5A8EE7A}"/>
               </a:ext>
             </a:extLst>
           </p:cNvPr>
@@ -13970,7 +14124,7 @@
           <p:cNvPr id="6" name="">
             <a:extLst xmlns:a="http://schemas.openxmlformats.org/drawingml/2006/main">
               <a:ext uri="{FF2B5EF4-FFF2-40B4-BE49-F238E27FC236}">
-                <a16:creationId xmlns:a16="http://schemas.microsoft.com/office/drawing/2014/main" id="{C3DC0C40-A5F4-4607-8154-9E6E5E5270DE}"/>
+                <a16:creationId xmlns:a16="http://schemas.microsoft.com/office/drawing/2014/main" id="{DB8C8C97-7C1F-4523-9FAB-28F6170131F4}"/>
               </a:ext>
             </a:extLst>
           </p:cNvPr>
@@ -14005,7 +14159,7 @@
           <p:cNvPr id="7" name="">
             <a:extLst xmlns:a="http://schemas.openxmlformats.org/drawingml/2006/main">
               <a:ext uri="{FF2B5EF4-FFF2-40B4-BE49-F238E27FC236}">
-                <a16:creationId xmlns:a16="http://schemas.microsoft.com/office/drawing/2014/main" id="{DFF5DB53-B582-41ED-B05F-C933C08507D2}"/>
+                <a16:creationId xmlns:a16="http://schemas.microsoft.com/office/drawing/2014/main" id="{582E768C-1604-47E7-95EA-22F131D81228}"/>
               </a:ext>
             </a:extLst>
           </p:cNvPr>
@@ -14055,7 +14209,7 @@
           <p:cNvPr id="8" name="">
             <a:extLst xmlns:a="http://schemas.openxmlformats.org/drawingml/2006/main">
               <a:ext uri="{FF2B5EF4-FFF2-40B4-BE49-F238E27FC236}">
-                <a16:creationId xmlns:a16="http://schemas.microsoft.com/office/drawing/2014/main" id="{867DD451-E4C4-40BE-933D-4734C2E0E78C}"/>
+                <a16:creationId xmlns:a16="http://schemas.microsoft.com/office/drawing/2014/main" id="{4181BC70-BF1C-446B-8467-49EDCEDF8C20}"/>
               </a:ext>
             </a:extLst>
           </p:cNvPr>
@@ -14173,7 +14327,7 @@
           <p:cNvPr id="9" name="">
             <a:extLst xmlns:a="http://schemas.openxmlformats.org/drawingml/2006/main">
               <a:ext uri="{FF2B5EF4-FFF2-40B4-BE49-F238E27FC236}">
-                <a16:creationId xmlns:a16="http://schemas.microsoft.com/office/drawing/2014/main" id="{8779E068-D984-4DE4-A2E4-A680206D6505}"/>
+                <a16:creationId xmlns:a16="http://schemas.microsoft.com/office/drawing/2014/main" id="{13A5BBDB-8558-4C4F-BA13-73E9E77DBEEE}"/>
               </a:ext>
             </a:extLst>
           </p:cNvPr>
@@ -14223,7 +14377,7 @@
           <p:cNvPr id="10" name="">
             <a:extLst xmlns:a="http://schemas.openxmlformats.org/drawingml/2006/main">
               <a:ext uri="{FF2B5EF4-FFF2-40B4-BE49-F238E27FC236}">
-                <a16:creationId xmlns:a16="http://schemas.microsoft.com/office/drawing/2014/main" id="{64609797-23D2-43F8-9324-D95695453E60}"/>
+                <a16:creationId xmlns:a16="http://schemas.microsoft.com/office/drawing/2014/main" id="{8E8F9140-AB02-45B8-BD69-62467554B4D6}"/>
               </a:ext>
             </a:extLst>
           </p:cNvPr>
@@ -14273,7 +14427,7 @@
           <p:cNvPr id="11" name="">
             <a:extLst xmlns:a="http://schemas.openxmlformats.org/drawingml/2006/main">
               <a:ext uri="{FF2B5EF4-FFF2-40B4-BE49-F238E27FC236}">
-                <a16:creationId xmlns:a16="http://schemas.microsoft.com/office/drawing/2014/main" id="{ABB2F454-5BE7-45FD-8AB0-E8FEA9F6A556}"/>
+                <a16:creationId xmlns:a16="http://schemas.microsoft.com/office/drawing/2014/main" id="{97DCC08D-F7D6-41DB-BE9E-9B4788B68963}"/>
               </a:ext>
             </a:extLst>
           </p:cNvPr>
@@ -14308,7 +14462,7 @@
           <p:cNvPr id="12" name="">
             <a:extLst xmlns:a="http://schemas.openxmlformats.org/drawingml/2006/main">
               <a:ext uri="{FF2B5EF4-FFF2-40B4-BE49-F238E27FC236}">
-                <a16:creationId xmlns:a16="http://schemas.microsoft.com/office/drawing/2014/main" id="{FBA2C02D-3119-40B4-A15E-CB625A0AF34A}"/>
+                <a16:creationId xmlns:a16="http://schemas.microsoft.com/office/drawing/2014/main" id="{24AB667D-D414-443E-B473-633D918D1CE6}"/>
               </a:ext>
             </a:extLst>
           </p:cNvPr>
@@ -14358,7 +14512,7 @@
           <p:cNvPr id="13" name="">
             <a:extLst xmlns:a="http://schemas.openxmlformats.org/drawingml/2006/main">
               <a:ext uri="{FF2B5EF4-FFF2-40B4-BE49-F238E27FC236}">
-                <a16:creationId xmlns:a16="http://schemas.microsoft.com/office/drawing/2014/main" id="{0F852CCB-D8F3-4CDA-85A0-9685F557A92D}"/>
+                <a16:creationId xmlns:a16="http://schemas.microsoft.com/office/drawing/2014/main" id="{23F2FD71-ACBD-460A-8AC0-1DB331ABAFA7}"/>
               </a:ext>
             </a:extLst>
           </p:cNvPr>
@@ -14544,7 +14698,7 @@
           <p:cNvPr id="14" name="">
             <a:extLst xmlns:a="http://schemas.openxmlformats.org/drawingml/2006/main">
               <a:ext uri="{FF2B5EF4-FFF2-40B4-BE49-F238E27FC236}">
-                <a16:creationId xmlns:a16="http://schemas.microsoft.com/office/drawing/2014/main" id="{131A92D9-2769-4A7A-B74C-72BFF86C8F37}"/>
+                <a16:creationId xmlns:a16="http://schemas.microsoft.com/office/drawing/2014/main" id="{220A5E78-30B3-4AA2-8BF0-0ABCCA3C6659}"/>
               </a:ext>
             </a:extLst>
           </p:cNvPr>
@@ -14592,7 +14746,7 @@
     </p:spTree>
     <p:extLst>
       <p:ext uri="{BB962C8B-B14F-4D97-AF65-F5344CB8AC3E}">
-        <p14:creationId xmlns:p14="http://schemas.microsoft.com/office/powerpoint/2010/main" val="816521264"/>
+        <p14:creationId xmlns:p14="http://schemas.microsoft.com/office/powerpoint/2010/main" val="2065415418"/>
       </p:ext>
     </p:extLst>
   </p:cSld>
@@ -14623,7 +14777,7 @@
           <p:cNvPr id="13" name="">
             <a:extLst xmlns:a="http://schemas.openxmlformats.org/drawingml/2006/main">
               <a:ext uri="{FF2B5EF4-FFF2-40B4-BE49-F238E27FC236}">
-                <a16:creationId xmlns:a16="http://schemas.microsoft.com/office/drawing/2014/main" id="{22DF3215-05DF-403F-ABFF-2A26D26081A8}"/>
+                <a16:creationId xmlns:a16="http://schemas.microsoft.com/office/drawing/2014/main" id="{9FD0D935-9E6B-4003-A089-A3CC494CFEB6}"/>
               </a:ext>
             </a:extLst>
           </p:cNvPr>
@@ -14673,7 +14827,7 @@
           <p:cNvPr id="2" name="">
             <a:extLst xmlns:a="http://schemas.openxmlformats.org/drawingml/2006/main">
               <a:ext uri="{FF2B5EF4-FFF2-40B4-BE49-F238E27FC236}">
-                <a16:creationId xmlns:a16="http://schemas.microsoft.com/office/drawing/2014/main" id="{C109D836-A6D9-46B2-BAA5-E366A0A818B1}"/>
+                <a16:creationId xmlns:a16="http://schemas.microsoft.com/office/drawing/2014/main" id="{4FC4495D-C6B9-4607-9E08-DFBABFB8281B}"/>
               </a:ext>
             </a:extLst>
           </p:cNvPr>
@@ -14723,7 +14877,7 @@
           <p:cNvPr id="3" name="">
             <a:extLst xmlns:a="http://schemas.openxmlformats.org/drawingml/2006/main">
               <a:ext uri="{FF2B5EF4-FFF2-40B4-BE49-F238E27FC236}">
-                <a16:creationId xmlns:a16="http://schemas.microsoft.com/office/drawing/2014/main" id="{9A522A39-52EC-487A-B44A-A6C6B6C48DF5}"/>
+                <a16:creationId xmlns:a16="http://schemas.microsoft.com/office/drawing/2014/main" id="{F5418B78-F897-4DC6-8DA5-DE638203AC3D}"/>
               </a:ext>
             </a:extLst>
           </p:cNvPr>
@@ -14754,7 +14908,7 @@
           <p:cNvPr id="4" name="">
             <a:extLst xmlns:a="http://schemas.openxmlformats.org/drawingml/2006/main">
               <a:ext uri="{FF2B5EF4-FFF2-40B4-BE49-F238E27FC236}">
-                <a16:creationId xmlns:a16="http://schemas.microsoft.com/office/drawing/2014/main" id="{C821B674-2A41-43D1-B202-1048ACF2DC7B}"/>
+                <a16:creationId xmlns:a16="http://schemas.microsoft.com/office/drawing/2014/main" id="{5FD4C568-A08C-4FC8-AF10-6EC9E7D6017A}"/>
               </a:ext>
             </a:extLst>
           </p:cNvPr>
@@ -14804,7 +14958,7 @@
           <p:cNvPr id="5" name="">
             <a:extLst xmlns:a="http://schemas.openxmlformats.org/drawingml/2006/main">
               <a:ext uri="{FF2B5EF4-FFF2-40B4-BE49-F238E27FC236}">
-                <a16:creationId xmlns:a16="http://schemas.microsoft.com/office/drawing/2014/main" id="{08FCEBA2-9B12-437B-B6E4-36F2F2F10250}"/>
+                <a16:creationId xmlns:a16="http://schemas.microsoft.com/office/drawing/2014/main" id="{3C4E3D85-5A81-42F1-9E61-588A98642241}"/>
               </a:ext>
             </a:extLst>
           </p:cNvPr>
@@ -14854,7 +15008,7 @@
           <p:cNvPr id="6" name="">
             <a:extLst xmlns:a="http://schemas.openxmlformats.org/drawingml/2006/main">
               <a:ext uri="{FF2B5EF4-FFF2-40B4-BE49-F238E27FC236}">
-                <a16:creationId xmlns:a16="http://schemas.microsoft.com/office/drawing/2014/main" id="{874CEE97-7E01-4573-A066-5D33ABC1DAA3}"/>
+                <a16:creationId xmlns:a16="http://schemas.microsoft.com/office/drawing/2014/main" id="{0E288EBB-7F8C-4E5B-925B-53EB15A5075D}"/>
               </a:ext>
             </a:extLst>
           </p:cNvPr>
@@ -14889,7 +15043,7 @@
           <p:cNvPr id="7" name="">
             <a:extLst xmlns:a="http://schemas.openxmlformats.org/drawingml/2006/main">
               <a:ext uri="{FF2B5EF4-FFF2-40B4-BE49-F238E27FC236}">
-                <a16:creationId xmlns:a16="http://schemas.microsoft.com/office/drawing/2014/main" id="{A11DF0F8-0789-4D78-9E4D-24084F8C1BFA}"/>
+                <a16:creationId xmlns:a16="http://schemas.microsoft.com/office/drawing/2014/main" id="{C68B51C3-AF9A-4247-9388-D21BC2B42D2F}"/>
               </a:ext>
             </a:extLst>
           </p:cNvPr>
@@ -14939,7 +15093,7 @@
           <p:cNvPr id="8" name="">
             <a:extLst xmlns:a="http://schemas.openxmlformats.org/drawingml/2006/main">
               <a:ext uri="{FF2B5EF4-FFF2-40B4-BE49-F238E27FC236}">
-                <a16:creationId xmlns:a16="http://schemas.microsoft.com/office/drawing/2014/main" id="{104A31BA-5D55-4628-A391-EB548B39FC7F}"/>
+                <a16:creationId xmlns:a16="http://schemas.microsoft.com/office/drawing/2014/main" id="{49721059-2C28-4D35-9082-2F74DDE698D1}"/>
               </a:ext>
             </a:extLst>
           </p:cNvPr>
@@ -15091,7 +15245,7 @@
           <p:cNvPr id="9" name="">
             <a:extLst xmlns:a="http://schemas.openxmlformats.org/drawingml/2006/main">
               <a:ext uri="{FF2B5EF4-FFF2-40B4-BE49-F238E27FC236}">
-                <a16:creationId xmlns:a16="http://schemas.microsoft.com/office/drawing/2014/main" id="{98FFED1A-6AEA-43FF-B696-FD29953FA21E}"/>
+                <a16:creationId xmlns:a16="http://schemas.microsoft.com/office/drawing/2014/main" id="{236A8CDB-58D9-412D-808A-B756D071CD90}"/>
               </a:ext>
             </a:extLst>
           </p:cNvPr>
@@ -15126,7 +15280,7 @@
           <p:cNvPr id="10" name="">
             <a:extLst xmlns:a="http://schemas.openxmlformats.org/drawingml/2006/main">
               <a:ext uri="{FF2B5EF4-FFF2-40B4-BE49-F238E27FC236}">
-                <a16:creationId xmlns:a16="http://schemas.microsoft.com/office/drawing/2014/main" id="{C20EFA78-0573-45E0-91F5-A67A8AAC95DD}"/>
+                <a16:creationId xmlns:a16="http://schemas.microsoft.com/office/drawing/2014/main" id="{B95D084C-104A-4735-A68D-702702A415BF}"/>
               </a:ext>
             </a:extLst>
           </p:cNvPr>
@@ -15176,7 +15330,7 @@
           <p:cNvPr id="11" name="">
             <a:extLst xmlns:a="http://schemas.openxmlformats.org/drawingml/2006/main">
               <a:ext uri="{FF2B5EF4-FFF2-40B4-BE49-F238E27FC236}">
-                <a16:creationId xmlns:a16="http://schemas.microsoft.com/office/drawing/2014/main" id="{C1F8FFD6-4C94-4E0D-9319-2A15AD9B8120}"/>
+                <a16:creationId xmlns:a16="http://schemas.microsoft.com/office/drawing/2014/main" id="{38213982-5AFB-4595-93E5-89D48B533FE9}"/>
               </a:ext>
             </a:extLst>
           </p:cNvPr>
@@ -15321,7 +15475,7 @@
           <p:cNvPr id="12" name="">
             <a:extLst xmlns:a="http://schemas.openxmlformats.org/drawingml/2006/main">
               <a:ext uri="{FF2B5EF4-FFF2-40B4-BE49-F238E27FC236}">
-                <a16:creationId xmlns:a16="http://schemas.microsoft.com/office/drawing/2014/main" id="{6B0D9CA0-445D-4AFB-AB09-17C0C81FC22E}"/>
+                <a16:creationId xmlns:a16="http://schemas.microsoft.com/office/drawing/2014/main" id="{5D47F0D0-39FB-4EBB-81FB-8D0E8048C106}"/>
               </a:ext>
             </a:extLst>
           </p:cNvPr>
@@ -15369,7 +15523,7 @@
     </p:spTree>
     <p:extLst>
       <p:ext uri="{BB962C8B-B14F-4D97-AF65-F5344CB8AC3E}">
-        <p14:creationId xmlns:p14="http://schemas.microsoft.com/office/powerpoint/2010/main" val="1852785290"/>
+        <p14:creationId xmlns:p14="http://schemas.microsoft.com/office/powerpoint/2010/main" val="98100833"/>
       </p:ext>
     </p:extLst>
   </p:cSld>
@@ -15400,7 +15554,7 @@
           <p:cNvPr id="18" name="">
             <a:extLst xmlns:a="http://schemas.openxmlformats.org/drawingml/2006/main">
               <a:ext uri="{FF2B5EF4-FFF2-40B4-BE49-F238E27FC236}">
-                <a16:creationId xmlns:a16="http://schemas.microsoft.com/office/drawing/2014/main" id="{E1DB65D3-6BE7-4AF5-BDCD-A85DBA4C2779}"/>
+                <a16:creationId xmlns:a16="http://schemas.microsoft.com/office/drawing/2014/main" id="{095C4E9F-ACBE-4375-8BD9-62A68D56E102}"/>
               </a:ext>
             </a:extLst>
           </p:cNvPr>
@@ -15450,7 +15604,7 @@
           <p:cNvPr id="2" name="">
             <a:extLst xmlns:a="http://schemas.openxmlformats.org/drawingml/2006/main">
               <a:ext uri="{FF2B5EF4-FFF2-40B4-BE49-F238E27FC236}">
-                <a16:creationId xmlns:a16="http://schemas.microsoft.com/office/drawing/2014/main" id="{A0C01F30-9F0D-4922-BE4E-CC5C1A6E87AB}"/>
+                <a16:creationId xmlns:a16="http://schemas.microsoft.com/office/drawing/2014/main" id="{2D366130-CBBD-44D0-A4F8-22707317C57E}"/>
               </a:ext>
             </a:extLst>
           </p:cNvPr>
@@ -15500,7 +15654,7 @@
           <p:cNvPr id="3" name="">
             <a:extLst xmlns:a="http://schemas.openxmlformats.org/drawingml/2006/main">
               <a:ext uri="{FF2B5EF4-FFF2-40B4-BE49-F238E27FC236}">
-                <a16:creationId xmlns:a16="http://schemas.microsoft.com/office/drawing/2014/main" id="{7A74605B-B262-4C7C-8557-E1FDE024244A}"/>
+                <a16:creationId xmlns:a16="http://schemas.microsoft.com/office/drawing/2014/main" id="{5AF1B499-3677-4D81-8AB7-7FE425865802}"/>
               </a:ext>
             </a:extLst>
           </p:cNvPr>
@@ -15531,7 +15685,7 @@
           <p:cNvPr id="4" name="">
             <a:extLst xmlns:a="http://schemas.openxmlformats.org/drawingml/2006/main">
               <a:ext uri="{FF2B5EF4-FFF2-40B4-BE49-F238E27FC236}">
-                <a16:creationId xmlns:a16="http://schemas.microsoft.com/office/drawing/2014/main" id="{5B683007-2ADF-4DBE-B030-AB3D968CE68A}"/>
+                <a16:creationId xmlns:a16="http://schemas.microsoft.com/office/drawing/2014/main" id="{575FFE23-9477-4559-8D81-6B376DE712E1}"/>
               </a:ext>
             </a:extLst>
           </p:cNvPr>
@@ -15581,7 +15735,7 @@
           <p:cNvPr id="5" name="">
             <a:extLst xmlns:a="http://schemas.openxmlformats.org/drawingml/2006/main">
               <a:ext uri="{FF2B5EF4-FFF2-40B4-BE49-F238E27FC236}">
-                <a16:creationId xmlns:a16="http://schemas.microsoft.com/office/drawing/2014/main" id="{47B17408-6E2D-4B4E-8514-35190C31804B}"/>
+                <a16:creationId xmlns:a16="http://schemas.microsoft.com/office/drawing/2014/main" id="{24690FEF-C706-40F0-BEF2-08FC1880A8C3}"/>
               </a:ext>
             </a:extLst>
           </p:cNvPr>
@@ -15631,7 +15785,7 @@
           <p:cNvPr id="6" name="">
             <a:extLst xmlns:a="http://schemas.openxmlformats.org/drawingml/2006/main">
               <a:ext uri="{FF2B5EF4-FFF2-40B4-BE49-F238E27FC236}">
-                <a16:creationId xmlns:a16="http://schemas.microsoft.com/office/drawing/2014/main" id="{B2AA53BC-450F-494C-AFFE-EA440F1177C5}"/>
+                <a16:creationId xmlns:a16="http://schemas.microsoft.com/office/drawing/2014/main" id="{A7A04B3F-BECC-42E3-AB07-1A29F18B7B59}"/>
               </a:ext>
             </a:extLst>
           </p:cNvPr>
@@ -15666,7 +15820,7 @@
           <p:cNvPr id="7" name="">
             <a:extLst xmlns:a="http://schemas.openxmlformats.org/drawingml/2006/main">
               <a:ext uri="{FF2B5EF4-FFF2-40B4-BE49-F238E27FC236}">
-                <a16:creationId xmlns:a16="http://schemas.microsoft.com/office/drawing/2014/main" id="{AF76F643-3DA1-4B42-AD4A-218027AA1B48}"/>
+                <a16:creationId xmlns:a16="http://schemas.microsoft.com/office/drawing/2014/main" id="{218900F5-A1B9-4F62-9D1C-957D43968C85}"/>
               </a:ext>
             </a:extLst>
           </p:cNvPr>
@@ -15716,7 +15870,7 @@
           <p:cNvPr id="8" name="">
             <a:extLst xmlns:a="http://schemas.openxmlformats.org/drawingml/2006/main">
               <a:ext uri="{FF2B5EF4-FFF2-40B4-BE49-F238E27FC236}">
-                <a16:creationId xmlns:a16="http://schemas.microsoft.com/office/drawing/2014/main" id="{39F3CEC0-D988-40C0-AA4B-A7BEAEC239C1}"/>
+                <a16:creationId xmlns:a16="http://schemas.microsoft.com/office/drawing/2014/main" id="{AEB01907-5E09-46D6-B948-3317F9C4A850}"/>
               </a:ext>
             </a:extLst>
           </p:cNvPr>
@@ -15766,7 +15920,7 @@
           <p:cNvPr id="9" name="">
             <a:extLst xmlns:a="http://schemas.openxmlformats.org/drawingml/2006/main">
               <a:ext uri="{FF2B5EF4-FFF2-40B4-BE49-F238E27FC236}">
-                <a16:creationId xmlns:a16="http://schemas.microsoft.com/office/drawing/2014/main" id="{1DB7F1E0-727A-4CD3-AE63-21FA2FFB8408}"/>
+                <a16:creationId xmlns:a16="http://schemas.microsoft.com/office/drawing/2014/main" id="{89A960DF-303D-47B1-889F-09FA3514C269}"/>
               </a:ext>
             </a:extLst>
           </p:cNvPr>
@@ -15801,7 +15955,7 @@
           <p:cNvPr id="10" name="">
             <a:extLst xmlns:a="http://schemas.openxmlformats.org/drawingml/2006/main">
               <a:ext uri="{FF2B5EF4-FFF2-40B4-BE49-F238E27FC236}">
-                <a16:creationId xmlns:a16="http://schemas.microsoft.com/office/drawing/2014/main" id="{88320B9A-96EA-4F77-9A5B-594F7B639962}"/>
+                <a16:creationId xmlns:a16="http://schemas.microsoft.com/office/drawing/2014/main" id="{98A7F775-DE01-4555-A81E-01CECCAC615F}"/>
               </a:ext>
             </a:extLst>
           </p:cNvPr>
@@ -15851,7 +16005,7 @@
           <p:cNvPr id="11" name="">
             <a:extLst xmlns:a="http://schemas.openxmlformats.org/drawingml/2006/main">
               <a:ext uri="{FF2B5EF4-FFF2-40B4-BE49-F238E27FC236}">
-                <a16:creationId xmlns:a16="http://schemas.microsoft.com/office/drawing/2014/main" id="{32C74E3F-0F74-453A-AF97-64335F319E27}"/>
+                <a16:creationId xmlns:a16="http://schemas.microsoft.com/office/drawing/2014/main" id="{9686BB2D-9144-43DA-93A9-61906E1340DE}"/>
               </a:ext>
             </a:extLst>
           </p:cNvPr>
@@ -15901,7 +16055,7 @@
           <p:cNvPr id="12" name="">
             <a:extLst xmlns:a="http://schemas.openxmlformats.org/drawingml/2006/main">
               <a:ext uri="{FF2B5EF4-FFF2-40B4-BE49-F238E27FC236}">
-                <a16:creationId xmlns:a16="http://schemas.microsoft.com/office/drawing/2014/main" id="{D20940C0-E141-49C6-B111-7B0EEECEC1EA}"/>
+                <a16:creationId xmlns:a16="http://schemas.microsoft.com/office/drawing/2014/main" id="{B2F89CDB-77FC-4A47-A30E-308AFF095E57}"/>
               </a:ext>
             </a:extLst>
           </p:cNvPr>
@@ -15936,7 +16090,7 @@
           <p:cNvPr id="13" name="">
             <a:extLst xmlns:a="http://schemas.openxmlformats.org/drawingml/2006/main">
               <a:ext uri="{FF2B5EF4-FFF2-40B4-BE49-F238E27FC236}">
-                <a16:creationId xmlns:a16="http://schemas.microsoft.com/office/drawing/2014/main" id="{74E2ABE4-6286-4537-B5B4-A84BE28FD68B}"/>
+                <a16:creationId xmlns:a16="http://schemas.microsoft.com/office/drawing/2014/main" id="{2FB32EAD-60AD-4BEF-85B8-297FDA6401C5}"/>
               </a:ext>
             </a:extLst>
           </p:cNvPr>
@@ -15986,7 +16140,7 @@
           <p:cNvPr id="14" name="">
             <a:extLst xmlns:a="http://schemas.openxmlformats.org/drawingml/2006/main">
               <a:ext uri="{FF2B5EF4-FFF2-40B4-BE49-F238E27FC236}">
-                <a16:creationId xmlns:a16="http://schemas.microsoft.com/office/drawing/2014/main" id="{2885447F-8DC5-4B14-B1C6-46DB7C2E4F0B}"/>
+                <a16:creationId xmlns:a16="http://schemas.microsoft.com/office/drawing/2014/main" id="{AE9F072E-D304-462F-983A-A80C10E4FFAF}"/>
               </a:ext>
             </a:extLst>
           </p:cNvPr>
@@ -16036,7 +16190,7 @@
           <p:cNvPr id="15" name="">
             <a:extLst xmlns:a="http://schemas.openxmlformats.org/drawingml/2006/main">
               <a:ext uri="{FF2B5EF4-FFF2-40B4-BE49-F238E27FC236}">
-                <a16:creationId xmlns:a16="http://schemas.microsoft.com/office/drawing/2014/main" id="{9AF2E414-15F3-4F23-88E7-860544AD6D3A}"/>
+                <a16:creationId xmlns:a16="http://schemas.microsoft.com/office/drawing/2014/main" id="{7C45682C-425C-4B3B-86B8-1FC82D76BB01}"/>
               </a:ext>
             </a:extLst>
           </p:cNvPr>
@@ -16071,7 +16225,7 @@
           <p:cNvPr id="16" name="">
             <a:extLst xmlns:a="http://schemas.openxmlformats.org/drawingml/2006/main">
               <a:ext uri="{FF2B5EF4-FFF2-40B4-BE49-F238E27FC236}">
-                <a16:creationId xmlns:a16="http://schemas.microsoft.com/office/drawing/2014/main" id="{F808A3BD-976D-49D0-A928-3E1F3E3280AF}"/>
+                <a16:creationId xmlns:a16="http://schemas.microsoft.com/office/drawing/2014/main" id="{7CC51171-C5D8-4E19-BB24-8CD1A4BDBA07}"/>
               </a:ext>
             </a:extLst>
           </p:cNvPr>
@@ -16121,7 +16275,7 @@
           <p:cNvPr id="17" name="">
             <a:extLst xmlns:a="http://schemas.openxmlformats.org/drawingml/2006/main">
               <a:ext uri="{FF2B5EF4-FFF2-40B4-BE49-F238E27FC236}">
-                <a16:creationId xmlns:a16="http://schemas.microsoft.com/office/drawing/2014/main" id="{2AAD1BF2-E82B-49FE-97A0-CF85662FEFFF}"/>
+                <a16:creationId xmlns:a16="http://schemas.microsoft.com/office/drawing/2014/main" id="{8F7C3DF3-9C36-420A-8AB6-7D81CB91634C}"/>
               </a:ext>
             </a:extLst>
           </p:cNvPr>
@@ -16169,7 +16323,7 @@
     </p:spTree>
     <p:extLst>
       <p:ext uri="{BB962C8B-B14F-4D97-AF65-F5344CB8AC3E}">
-        <p14:creationId xmlns:p14="http://schemas.microsoft.com/office/powerpoint/2010/main" val="970746317"/>
+        <p14:creationId xmlns:p14="http://schemas.microsoft.com/office/powerpoint/2010/main" val="1149608308"/>
       </p:ext>
     </p:extLst>
   </p:cSld>

</xml_diff>

<commit_message>
Update title slide team details
</commit_message>
<xml_diff>
--- a/Distributed_Search_Engine_FA1_Technical_Presentation.pptx
+++ b/Distributed_Search_Engine_FA1_Technical_Presentation.pptx
@@ -2,27 +2,27 @@
 <file path=ppt/presentation.xml><?xml version="1.0" encoding="utf-8"?>
 <p:presentation xmlns:p="http://schemas.openxmlformats.org/presentationml/2006/main">
   <p:sldMasterIdLst>
-    <p:sldMasterId xmlns:r="http://schemas.openxmlformats.org/officeDocument/2006/relationships" id="2147483648" r:id="Rc0807b14650d469d"/>
+    <p:sldMasterId xmlns:r="http://schemas.openxmlformats.org/officeDocument/2006/relationships" id="2147483648" r:id="R5a44dfc979ae41fd"/>
   </p:sldMasterIdLst>
   <p:notesMasterIdLst>
-    <p:notesMasterId xmlns:r="http://schemas.openxmlformats.org/officeDocument/2006/relationships" r:id="R6ad1c22f67c945c2"/>
+    <p:notesMasterId xmlns:r="http://schemas.openxmlformats.org/officeDocument/2006/relationships" r:id="R16ace1bccf9641c4"/>
   </p:notesMasterIdLst>
   <p:sldIdLst>
-    <p:sldId xmlns:r="http://schemas.openxmlformats.org/officeDocument/2006/relationships" id="256" r:id="R1964ffa22ab44d88"/>
-    <p:sldId xmlns:r="http://schemas.openxmlformats.org/officeDocument/2006/relationships" id="257" r:id="Rcbd0dfd172174a64"/>
-    <p:sldId xmlns:r="http://schemas.openxmlformats.org/officeDocument/2006/relationships" id="258" r:id="R2dc401371a2d49f5"/>
-    <p:sldId xmlns:r="http://schemas.openxmlformats.org/officeDocument/2006/relationships" id="259" r:id="Rd0e388f9d4714175"/>
-    <p:sldId xmlns:r="http://schemas.openxmlformats.org/officeDocument/2006/relationships" id="260" r:id="Rd9e1d00370d443e1"/>
-    <p:sldId xmlns:r="http://schemas.openxmlformats.org/officeDocument/2006/relationships" id="261" r:id="R4a0f30c9e5fa4995"/>
-    <p:sldId xmlns:r="http://schemas.openxmlformats.org/officeDocument/2006/relationships" id="262" r:id="Re1181825c27b4df1"/>
-    <p:sldId xmlns:r="http://schemas.openxmlformats.org/officeDocument/2006/relationships" id="263" r:id="R6f92070000d54b7f"/>
-    <p:sldId xmlns:r="http://schemas.openxmlformats.org/officeDocument/2006/relationships" id="264" r:id="R76261e63c52746b0"/>
-    <p:sldId xmlns:r="http://schemas.openxmlformats.org/officeDocument/2006/relationships" id="265" r:id="R76d74e422a554a83"/>
-    <p:sldId xmlns:r="http://schemas.openxmlformats.org/officeDocument/2006/relationships" id="266" r:id="R20627bdb17c1429a"/>
-    <p:sldId xmlns:r="http://schemas.openxmlformats.org/officeDocument/2006/relationships" id="267" r:id="Rac492dea374a4988"/>
-    <p:sldId xmlns:r="http://schemas.openxmlformats.org/officeDocument/2006/relationships" id="268" r:id="R811c9e38ae8c4f08"/>
-    <p:sldId xmlns:r="http://schemas.openxmlformats.org/officeDocument/2006/relationships" id="269" r:id="R3b64f24acd5f42a0"/>
-    <p:sldId xmlns:r="http://schemas.openxmlformats.org/officeDocument/2006/relationships" id="270" r:id="R3a199f9526c94267"/>
+    <p:sldId xmlns:r="http://schemas.openxmlformats.org/officeDocument/2006/relationships" id="256" r:id="R22f74b0ab1524ea1"/>
+    <p:sldId xmlns:r="http://schemas.openxmlformats.org/officeDocument/2006/relationships" id="257" r:id="Rfc4a9536a42947ce"/>
+    <p:sldId xmlns:r="http://schemas.openxmlformats.org/officeDocument/2006/relationships" id="258" r:id="R3a9a30c3ac6f4c23"/>
+    <p:sldId xmlns:r="http://schemas.openxmlformats.org/officeDocument/2006/relationships" id="259" r:id="Re1fd5a8fe5684beb"/>
+    <p:sldId xmlns:r="http://schemas.openxmlformats.org/officeDocument/2006/relationships" id="260" r:id="Rfed89f7648354f63"/>
+    <p:sldId xmlns:r="http://schemas.openxmlformats.org/officeDocument/2006/relationships" id="261" r:id="R93d5bee73323472e"/>
+    <p:sldId xmlns:r="http://schemas.openxmlformats.org/officeDocument/2006/relationships" id="262" r:id="R72f7083e7ce5425b"/>
+    <p:sldId xmlns:r="http://schemas.openxmlformats.org/officeDocument/2006/relationships" id="263" r:id="R2bfb171a81ac458b"/>
+    <p:sldId xmlns:r="http://schemas.openxmlformats.org/officeDocument/2006/relationships" id="264" r:id="R5793f3dc381e4342"/>
+    <p:sldId xmlns:r="http://schemas.openxmlformats.org/officeDocument/2006/relationships" id="265" r:id="R5df32d202345477c"/>
+    <p:sldId xmlns:r="http://schemas.openxmlformats.org/officeDocument/2006/relationships" id="266" r:id="R3b0af33477744b72"/>
+    <p:sldId xmlns:r="http://schemas.openxmlformats.org/officeDocument/2006/relationships" id="267" r:id="Rc50551c92dee4507"/>
+    <p:sldId xmlns:r="http://schemas.openxmlformats.org/officeDocument/2006/relationships" id="268" r:id="R5bdd4358c17d40b1"/>
+    <p:sldId xmlns:r="http://schemas.openxmlformats.org/officeDocument/2006/relationships" id="269" r:id="R32a4d255ebd648fb"/>
+    <p:sldId xmlns:r="http://schemas.openxmlformats.org/officeDocument/2006/relationships" id="270" r:id="Rf161e512dd614e25"/>
   </p:sldIdLst>
   <p:sldSz cx="12192000" cy="6858000"/>
   <p:notesSz cx="6858000" cy="9144000"/>
@@ -2254,7 +2254,7 @@
   </p:cSld>
   <p:clrMap bg1="lt1" tx1="dk1" bg2="lt2" tx2="dk2" accent1="accent1" accent2="accent2" accent3="accent3" accent4="accent4" accent5="accent5" accent6="accent6" hlink="hlink" folHlink="folHlink"/>
   <p:sldLayoutIdLst>
-    <p:sldLayoutId xmlns:r="http://schemas.openxmlformats.org/officeDocument/2006/relationships" id="2147483649" r:id="R5dbad5382e754a14"/>
+    <p:sldLayoutId xmlns:r="http://schemas.openxmlformats.org/officeDocument/2006/relationships" id="2147483649" r:id="R2af3d444e98e4b2d"/>
   </p:sldLayoutIdLst>
   <p:txStyles>
     <p:titleStyle>
@@ -2802,10 +2802,10 @@
       </p:grpSpPr>
       <p:sp>
         <p:nvSpPr>
-          <p:cNvPr id="13" name="">
-            <a:extLst xmlns:a="http://schemas.openxmlformats.org/drawingml/2006/main">
-              <a:ext uri="{FF2B5EF4-FFF2-40B4-BE49-F238E27FC236}">
-                <a16:creationId xmlns:a16="http://schemas.microsoft.com/office/drawing/2014/main" id="{9656D427-0D54-456E-A557-B017D8B6DCC1}"/>
+          <p:cNvPr id="9" name="">
+            <a:extLst xmlns:a="http://schemas.openxmlformats.org/drawingml/2006/main">
+              <a:ext uri="{FF2B5EF4-FFF2-40B4-BE49-F238E27FC236}">
+                <a16:creationId xmlns:a16="http://schemas.microsoft.com/office/drawing/2014/main" id="{E3624857-5880-4E30-B787-E28EDD6E11B6}"/>
               </a:ext>
             </a:extLst>
           </p:cNvPr>
@@ -2836,7 +2836,7 @@
           <p:cNvPr id="2" name="">
             <a:extLst xmlns:a="http://schemas.openxmlformats.org/drawingml/2006/main">
               <a:ext uri="{FF2B5EF4-FFF2-40B4-BE49-F238E27FC236}">
-                <a16:creationId xmlns:a16="http://schemas.microsoft.com/office/drawing/2014/main" id="{44484C8C-60C4-4829-A65F-AAB975C6A2A9}"/>
+                <a16:creationId xmlns:a16="http://schemas.microsoft.com/office/drawing/2014/main" id="{4EEF512B-9518-4383-A3EE-7E53228F1951}"/>
               </a:ext>
             </a:extLst>
           </p:cNvPr>
@@ -2886,7 +2886,7 @@
           <p:cNvPr id="3" name="">
             <a:extLst xmlns:a="http://schemas.openxmlformats.org/drawingml/2006/main">
               <a:ext uri="{FF2B5EF4-FFF2-40B4-BE49-F238E27FC236}">
-                <a16:creationId xmlns:a16="http://schemas.microsoft.com/office/drawing/2014/main" id="{5ACB46F8-63A4-4461-8B97-39924D67D4BC}"/>
+                <a16:creationId xmlns:a16="http://schemas.microsoft.com/office/drawing/2014/main" id="{075D29E1-79FA-4B80-88D0-299DEA671A9F}"/>
               </a:ext>
             </a:extLst>
           </p:cNvPr>
@@ -2936,7 +2936,7 @@
           <p:cNvPr id="4" name="">
             <a:extLst xmlns:a="http://schemas.openxmlformats.org/drawingml/2006/main">
               <a:ext uri="{FF2B5EF4-FFF2-40B4-BE49-F238E27FC236}">
-                <a16:creationId xmlns:a16="http://schemas.microsoft.com/office/drawing/2014/main" id="{9F3C411B-9F20-477A-9132-1032A736FBB3}"/>
+                <a16:creationId xmlns:a16="http://schemas.microsoft.com/office/drawing/2014/main" id="{E2F3281F-F21F-41C2-BAA9-94FCD70C401A}"/>
               </a:ext>
             </a:extLst>
           </p:cNvPr>
@@ -2986,54 +2986,69 @@
           <p:cNvPr id="5" name="">
             <a:extLst xmlns:a="http://schemas.openxmlformats.org/drawingml/2006/main">
               <a:ext uri="{FF2B5EF4-FFF2-40B4-BE49-F238E27FC236}">
-                <a16:creationId xmlns:a16="http://schemas.microsoft.com/office/drawing/2014/main" id="{7CF3F1C0-623D-4876-9642-702671ABBF7C}"/>
-              </a:ext>
-            </a:extLst>
-          </p:cNvPr>
-          <p:cNvSpPr>
-            <a:spLocks xmlns:a="http://schemas.openxmlformats.org/drawingml/2006/main" noGrp="1"/>
-          </p:cNvSpPr>
-          <p:nvPr/>
-        </p:nvSpPr>
-        <p:spPr>
-          <a:xfrm xmlns:a="http://schemas.openxmlformats.org/drawingml/2006/main">
-            <a:off x="8096250" y="1771650"/>
-            <a:ext cx="2724150" cy="2000250"/>
-          </a:xfrm>
-          <a:prstGeom xmlns:a="http://schemas.openxmlformats.org/drawingml/2006/main" prst="roundRect">
-            <a:avLst>
-              <a:gd name="adj" fmla="val 3810"/>
-            </a:avLst>
-          </a:prstGeom>
-          <a:solidFill xmlns:a="http://schemas.openxmlformats.org/drawingml/2006/main">
-            <a:srgbClr val="FFFFFF"/>
-          </a:solidFill>
-          <a:ln xmlns:a="http://schemas.openxmlformats.org/drawingml/2006/main" w="9525">
-            <a:solidFill>
-              <a:srgbClr val="D8E0E8"/>
-            </a:solidFill>
-            <a:prstDash val="solid"/>
-          </a:ln>
-        </p:spPr>
+                <a16:creationId xmlns:a16="http://schemas.microsoft.com/office/drawing/2014/main" id="{9B5BD6FF-C419-4CC4-9BDB-3340CFD24E68}"/>
+              </a:ext>
+            </a:extLst>
+          </p:cNvPr>
+          <p:cNvSpPr>
+            <a:spLocks xmlns:a="http://schemas.openxmlformats.org/drawingml/2006/main" noGrp="1"/>
+          </p:cNvSpPr>
+          <p:nvPr/>
+        </p:nvSpPr>
+        <p:spPr>
+          <a:xfrm xmlns:a="http://schemas.openxmlformats.org/drawingml/2006/main">
+            <a:off x="8420100" y="2152650"/>
+            <a:ext cx="2286000" cy="285750"/>
+          </a:xfrm>
+          <a:prstGeom xmlns:a="http://schemas.openxmlformats.org/drawingml/2006/main" prst="rect">
+            <a:avLst/>
+          </a:prstGeom>
+          <a:noFill xmlns:a="http://schemas.openxmlformats.org/drawingml/2006/main"/>
+          <a:ln xmlns:a="http://schemas.openxmlformats.org/drawingml/2006/main" w="0">
+            <a:noFill/>
+            <a:prstDash val="solid"/>
+          </a:ln>
+        </p:spPr>
+        <p:txBody>
+          <a:bodyPr xmlns:a="http://schemas.openxmlformats.org/drawingml/2006/main"/>
+          <a:lstStyle xmlns:a="http://schemas.openxmlformats.org/drawingml/2006/main"/>
+          <a:p xmlns:a="http://schemas.openxmlformats.org/drawingml/2006/main">
+            <a:pPr algn="ctr">
+              <a:defRPr sz="1650" b="1">
+                <a:solidFill>
+                  <a:srgbClr val="102A43"/>
+                </a:solidFill>
+              </a:defRPr>
+            </a:pPr>
+            <a:r>
+              <a:rPr sz="1650" b="1">
+                <a:solidFill>
+                  <a:srgbClr val="102A43"/>
+                </a:solidFill>
+              </a:rPr>
+              <a:t>Presented by</a:t>
+            </a:r>
+          </a:p>
+        </p:txBody>
       </p:sp>
       <p:sp>
         <p:nvSpPr>
           <p:cNvPr id="6" name="">
             <a:extLst xmlns:a="http://schemas.openxmlformats.org/drawingml/2006/main">
               <a:ext uri="{FF2B5EF4-FFF2-40B4-BE49-F238E27FC236}">
-                <a16:creationId xmlns:a16="http://schemas.microsoft.com/office/drawing/2014/main" id="{AF9D872B-729A-47D7-AF45-A85E8F69F57A}"/>
-              </a:ext>
-            </a:extLst>
-          </p:cNvPr>
-          <p:cNvSpPr>
-            <a:spLocks xmlns:a="http://schemas.openxmlformats.org/drawingml/2006/main" noGrp="1"/>
-          </p:cNvSpPr>
-          <p:nvPr/>
-        </p:nvSpPr>
-        <p:spPr>
-          <a:xfrm xmlns:a="http://schemas.openxmlformats.org/drawingml/2006/main">
-            <a:off x="8515350" y="2133600"/>
-            <a:ext cx="1905000" cy="285750"/>
+                <a16:creationId xmlns:a16="http://schemas.microsoft.com/office/drawing/2014/main" id="{41018A63-CEDD-4000-9CE5-5337D8E95832}"/>
+              </a:ext>
+            </a:extLst>
+          </p:cNvPr>
+          <p:cNvSpPr>
+            <a:spLocks xmlns:a="http://schemas.openxmlformats.org/drawingml/2006/main" noGrp="1"/>
+          </p:cNvSpPr>
+          <p:nvPr/>
+        </p:nvSpPr>
+        <p:spPr>
+          <a:xfrm xmlns:a="http://schemas.openxmlformats.org/drawingml/2006/main">
+            <a:off x="7734300" y="2667000"/>
+            <a:ext cx="3676650" cy="781050"/>
           </a:xfrm>
           <a:prstGeom xmlns:a="http://schemas.openxmlformats.org/drawingml/2006/main" prst="rect">
             <a:avLst/>
@@ -3049,19 +3064,36 @@
           <a:lstStyle xmlns:a="http://schemas.openxmlformats.org/drawingml/2006/main"/>
           <a:p xmlns:a="http://schemas.openxmlformats.org/drawingml/2006/main">
             <a:pPr algn="ctr">
-              <a:defRPr sz="1875" b="1">
-                <a:solidFill>
-                  <a:srgbClr val="102A43"/>
-                </a:solidFill>
-              </a:defRPr>
-            </a:pPr>
-            <a:r>
-              <a:rPr sz="1875" b="1">
-                <a:solidFill>
-                  <a:srgbClr val="102A43"/>
-                </a:solidFill>
-              </a:rPr>
-              <a:t>Scope</a:t>
+              <a:defRPr sz="1500" b="0">
+                <a:solidFill>
+                  <a:srgbClr val="17212B"/>
+                </a:solidFill>
+              </a:defRPr>
+            </a:pPr>
+            <a:r>
+              <a:rPr sz="1500" b="0">
+                <a:solidFill>
+                  <a:srgbClr val="17212B"/>
+                </a:solidFill>
+              </a:rPr>
+              <a:t>123B1B024  Atharv Rao</a:t>
+            </a:r>
+          </a:p>
+          <a:p xmlns:a="http://schemas.openxmlformats.org/drawingml/2006/main">
+            <a:pPr algn="ctr">
+              <a:defRPr sz="1500" b="0">
+                <a:solidFill>
+                  <a:srgbClr val="17212B"/>
+                </a:solidFill>
+              </a:defRPr>
+            </a:pPr>
+            <a:r>
+              <a:rPr sz="1500" b="0">
+                <a:solidFill>
+                  <a:srgbClr val="17212B"/>
+                </a:solidFill>
+              </a:rPr>
+              <a:t>123B1B040  Parth Darandale</a:t>
             </a:r>
           </a:p>
         </p:txBody>
@@ -3071,169 +3103,7 @@
           <p:cNvPr id="7" name="">
             <a:extLst xmlns:a="http://schemas.openxmlformats.org/drawingml/2006/main">
               <a:ext uri="{FF2B5EF4-FFF2-40B4-BE49-F238E27FC236}">
-                <a16:creationId xmlns:a16="http://schemas.microsoft.com/office/drawing/2014/main" id="{73D59542-FDBE-46C8-A55D-EF55D067F018}"/>
-              </a:ext>
-            </a:extLst>
-          </p:cNvPr>
-          <p:cNvSpPr>
-            <a:spLocks xmlns:a="http://schemas.openxmlformats.org/drawingml/2006/main" noGrp="1"/>
-          </p:cNvSpPr>
-          <p:nvPr/>
-        </p:nvSpPr>
-        <p:spPr>
-          <a:xfrm xmlns:a="http://schemas.openxmlformats.org/drawingml/2006/main">
-            <a:off x="8572500" y="2800350"/>
-            <a:ext cx="76200" cy="76200"/>
-          </a:xfrm>
-          <a:prstGeom xmlns:a="http://schemas.openxmlformats.org/drawingml/2006/main" prst="ellipse">
-            <a:avLst/>
-          </a:prstGeom>
-          <a:solidFill xmlns:a="http://schemas.openxmlformats.org/drawingml/2006/main">
-            <a:srgbClr val="0E7C7B"/>
-          </a:solidFill>
-          <a:ln xmlns:a="http://schemas.openxmlformats.org/drawingml/2006/main" w="0">
-            <a:noFill/>
-            <a:prstDash val="solid"/>
-          </a:ln>
-        </p:spPr>
-      </p:sp>
-      <p:sp>
-        <p:nvSpPr>
-          <p:cNvPr id="8" name="">
-            <a:extLst xmlns:a="http://schemas.openxmlformats.org/drawingml/2006/main">
-              <a:ext uri="{FF2B5EF4-FFF2-40B4-BE49-F238E27FC236}">
-                <a16:creationId xmlns:a16="http://schemas.microsoft.com/office/drawing/2014/main" id="{A1527F6B-A1E1-459E-868B-A1D3080B0B5A}"/>
-              </a:ext>
-            </a:extLst>
-          </p:cNvPr>
-          <p:cNvSpPr>
-            <a:spLocks xmlns:a="http://schemas.openxmlformats.org/drawingml/2006/main" noGrp="1"/>
-          </p:cNvSpPr>
-          <p:nvPr/>
-        </p:nvSpPr>
-        <p:spPr>
-          <a:xfrm xmlns:a="http://schemas.openxmlformats.org/drawingml/2006/main">
-            <a:off x="8782050" y="2724150"/>
-            <a:ext cx="2000250" cy="323850"/>
-          </a:xfrm>
-          <a:prstGeom xmlns:a="http://schemas.openxmlformats.org/drawingml/2006/main" prst="rect">
-            <a:avLst/>
-          </a:prstGeom>
-          <a:noFill xmlns:a="http://schemas.openxmlformats.org/drawingml/2006/main"/>
-          <a:ln xmlns:a="http://schemas.openxmlformats.org/drawingml/2006/main" w="0">
-            <a:noFill/>
-            <a:prstDash val="solid"/>
-          </a:ln>
-        </p:spPr>
-        <p:txBody>
-          <a:bodyPr xmlns:a="http://schemas.openxmlformats.org/drawingml/2006/main"/>
-          <a:lstStyle xmlns:a="http://schemas.openxmlformats.org/drawingml/2006/main"/>
-          <a:p xmlns:a="http://schemas.openxmlformats.org/drawingml/2006/main">
-            <a:pPr algn="l">
-              <a:defRPr sz="1350" b="0">
-                <a:solidFill>
-                  <a:srgbClr val="17212B"/>
-                </a:solidFill>
-              </a:defRPr>
-            </a:pPr>
-            <a:r>
-              <a:rPr sz="1350" b="0">
-                <a:solidFill>
-                  <a:srgbClr val="17212B"/>
-                </a:solidFill>
-              </a:rPr>
-              <a:t>offline indexing layer</a:t>
-            </a:r>
-          </a:p>
-        </p:txBody>
-      </p:sp>
-      <p:sp>
-        <p:nvSpPr>
-          <p:cNvPr id="9" name="">
-            <a:extLst xmlns:a="http://schemas.openxmlformats.org/drawingml/2006/main">
-              <a:ext uri="{FF2B5EF4-FFF2-40B4-BE49-F238E27FC236}">
-                <a16:creationId xmlns:a16="http://schemas.microsoft.com/office/drawing/2014/main" id="{FB6D81F3-FAC3-4602-8D8F-D79F31818279}"/>
-              </a:ext>
-            </a:extLst>
-          </p:cNvPr>
-          <p:cNvSpPr>
-            <a:spLocks xmlns:a="http://schemas.openxmlformats.org/drawingml/2006/main" noGrp="1"/>
-          </p:cNvSpPr>
-          <p:nvPr/>
-        </p:nvSpPr>
-        <p:spPr>
-          <a:xfrm xmlns:a="http://schemas.openxmlformats.org/drawingml/2006/main">
-            <a:off x="8572500" y="3295650"/>
-            <a:ext cx="76200" cy="76200"/>
-          </a:xfrm>
-          <a:prstGeom xmlns:a="http://schemas.openxmlformats.org/drawingml/2006/main" prst="ellipse">
-            <a:avLst/>
-          </a:prstGeom>
-          <a:solidFill xmlns:a="http://schemas.openxmlformats.org/drawingml/2006/main">
-            <a:srgbClr val="3267B1"/>
-          </a:solidFill>
-          <a:ln xmlns:a="http://schemas.openxmlformats.org/drawingml/2006/main" w="0">
-            <a:noFill/>
-            <a:prstDash val="solid"/>
-          </a:ln>
-        </p:spPr>
-      </p:sp>
-      <p:sp>
-        <p:nvSpPr>
-          <p:cNvPr id="10" name="">
-            <a:extLst xmlns:a="http://schemas.openxmlformats.org/drawingml/2006/main">
-              <a:ext uri="{FF2B5EF4-FFF2-40B4-BE49-F238E27FC236}">
-                <a16:creationId xmlns:a16="http://schemas.microsoft.com/office/drawing/2014/main" id="{3DEA9E8F-7769-45C2-849E-960D23B65DE9}"/>
-              </a:ext>
-            </a:extLst>
-          </p:cNvPr>
-          <p:cNvSpPr>
-            <a:spLocks xmlns:a="http://schemas.openxmlformats.org/drawingml/2006/main" noGrp="1"/>
-          </p:cNvSpPr>
-          <p:nvPr/>
-        </p:nvSpPr>
-        <p:spPr>
-          <a:xfrm xmlns:a="http://schemas.openxmlformats.org/drawingml/2006/main">
-            <a:off x="8782050" y="3219450"/>
-            <a:ext cx="2000250" cy="323850"/>
-          </a:xfrm>
-          <a:prstGeom xmlns:a="http://schemas.openxmlformats.org/drawingml/2006/main" prst="rect">
-            <a:avLst/>
-          </a:prstGeom>
-          <a:noFill xmlns:a="http://schemas.openxmlformats.org/drawingml/2006/main"/>
-          <a:ln xmlns:a="http://schemas.openxmlformats.org/drawingml/2006/main" w="0">
-            <a:noFill/>
-            <a:prstDash val="solid"/>
-          </a:ln>
-        </p:spPr>
-        <p:txBody>
-          <a:bodyPr xmlns:a="http://schemas.openxmlformats.org/drawingml/2006/main"/>
-          <a:lstStyle xmlns:a="http://schemas.openxmlformats.org/drawingml/2006/main"/>
-          <a:p xmlns:a="http://schemas.openxmlformats.org/drawingml/2006/main">
-            <a:pPr algn="l">
-              <a:defRPr sz="1350" b="0">
-                <a:solidFill>
-                  <a:srgbClr val="17212B"/>
-                </a:solidFill>
-              </a:defRPr>
-            </a:pPr>
-            <a:r>
-              <a:rPr sz="1350" b="0">
-                <a:solidFill>
-                  <a:srgbClr val="17212B"/>
-                </a:solidFill>
-              </a:rPr>
-              <a:t>online query layer</a:t>
-            </a:r>
-          </a:p>
-        </p:txBody>
-      </p:sp>
-      <p:sp>
-        <p:nvSpPr>
-          <p:cNvPr id="11" name="">
-            <a:extLst xmlns:a="http://schemas.openxmlformats.org/drawingml/2006/main">
-              <a:ext uri="{FF2B5EF4-FFF2-40B4-BE49-F238E27FC236}">
-                <a16:creationId xmlns:a16="http://schemas.microsoft.com/office/drawing/2014/main" id="{AAF61B99-7F7B-4C23-B5BD-9074EEAB2177}"/>
+                <a16:creationId xmlns:a16="http://schemas.microsoft.com/office/drawing/2014/main" id="{645C46E8-B30A-4905-86FA-AAFDC1858F7D}"/>
               </a:ext>
             </a:extLst>
           </p:cNvPr>
@@ -3280,10 +3150,10 @@
       </p:sp>
       <p:sp>
         <p:nvSpPr>
-          <p:cNvPr id="12" name="">
-            <a:extLst xmlns:a="http://schemas.openxmlformats.org/drawingml/2006/main">
-              <a:ext uri="{FF2B5EF4-FFF2-40B4-BE49-F238E27FC236}">
-                <a16:creationId xmlns:a16="http://schemas.microsoft.com/office/drawing/2014/main" id="{C081EA4B-ABDB-4B6D-9198-5F4D8D33B90A}"/>
+          <p:cNvPr id="8" name="">
+            <a:extLst xmlns:a="http://schemas.openxmlformats.org/drawingml/2006/main">
+              <a:ext uri="{FF2B5EF4-FFF2-40B4-BE49-F238E27FC236}">
+                <a16:creationId xmlns:a16="http://schemas.microsoft.com/office/drawing/2014/main" id="{48861BDC-AC5D-4B66-9718-C469470CCDF2}"/>
               </a:ext>
             </a:extLst>
           </p:cNvPr>
@@ -3331,7 +3201,7 @@
     </p:spTree>
     <p:extLst>
       <p:ext uri="{BB962C8B-B14F-4D97-AF65-F5344CB8AC3E}">
-        <p14:creationId xmlns:p14="http://schemas.microsoft.com/office/powerpoint/2010/main" val="1426566713"/>
+        <p14:creationId xmlns:p14="http://schemas.microsoft.com/office/powerpoint/2010/main" val="2047299586"/>
       </p:ext>
     </p:extLst>
   </p:cSld>
@@ -3362,7 +3232,7 @@
           <p:cNvPr id="13" name="">
             <a:extLst xmlns:a="http://schemas.openxmlformats.org/drawingml/2006/main">
               <a:ext uri="{FF2B5EF4-FFF2-40B4-BE49-F238E27FC236}">
-                <a16:creationId xmlns:a16="http://schemas.microsoft.com/office/drawing/2014/main" id="{05D537F6-1D2E-4FD2-9C0C-2B335C790771}"/>
+                <a16:creationId xmlns:a16="http://schemas.microsoft.com/office/drawing/2014/main" id="{87407404-98C7-4A0C-B7F3-C2DBFB8C5534}"/>
               </a:ext>
             </a:extLst>
           </p:cNvPr>
@@ -3412,7 +3282,7 @@
           <p:cNvPr id="2" name="">
             <a:extLst xmlns:a="http://schemas.openxmlformats.org/drawingml/2006/main">
               <a:ext uri="{FF2B5EF4-FFF2-40B4-BE49-F238E27FC236}">
-                <a16:creationId xmlns:a16="http://schemas.microsoft.com/office/drawing/2014/main" id="{2B938599-4EAB-43EA-8ECA-9B17D234C222}"/>
+                <a16:creationId xmlns:a16="http://schemas.microsoft.com/office/drawing/2014/main" id="{57FF7C1A-BBF1-495B-9A30-E665AF31A536}"/>
               </a:ext>
             </a:extLst>
           </p:cNvPr>
@@ -3462,7 +3332,7 @@
           <p:cNvPr id="3" name="">
             <a:extLst xmlns:a="http://schemas.openxmlformats.org/drawingml/2006/main">
               <a:ext uri="{FF2B5EF4-FFF2-40B4-BE49-F238E27FC236}">
-                <a16:creationId xmlns:a16="http://schemas.microsoft.com/office/drawing/2014/main" id="{2731255A-70CA-4CA9-BDE4-798FE938413F}"/>
+                <a16:creationId xmlns:a16="http://schemas.microsoft.com/office/drawing/2014/main" id="{156CCA2B-AD81-4944-9435-DFC0CF8E7CBA}"/>
               </a:ext>
             </a:extLst>
           </p:cNvPr>
@@ -3493,7 +3363,7 @@
           <p:cNvPr id="4" name="">
             <a:extLst xmlns:a="http://schemas.openxmlformats.org/drawingml/2006/main">
               <a:ext uri="{FF2B5EF4-FFF2-40B4-BE49-F238E27FC236}">
-                <a16:creationId xmlns:a16="http://schemas.microsoft.com/office/drawing/2014/main" id="{05E0C84E-7AB9-49B0-897F-F430B513430D}"/>
+                <a16:creationId xmlns:a16="http://schemas.microsoft.com/office/drawing/2014/main" id="{18361E1F-50CF-47FA-9B90-DD65DBC07F11}"/>
               </a:ext>
             </a:extLst>
           </p:cNvPr>
@@ -3543,7 +3413,7 @@
           <p:cNvPr id="5" name="">
             <a:extLst xmlns:a="http://schemas.openxmlformats.org/drawingml/2006/main">
               <a:ext uri="{FF2B5EF4-FFF2-40B4-BE49-F238E27FC236}">
-                <a16:creationId xmlns:a16="http://schemas.microsoft.com/office/drawing/2014/main" id="{D5964A19-5979-4125-9CE2-38C7C52139E4}"/>
+                <a16:creationId xmlns:a16="http://schemas.microsoft.com/office/drawing/2014/main" id="{5756C6C1-B012-4729-AA3D-8C76B1182188}"/>
               </a:ext>
             </a:extLst>
           </p:cNvPr>
@@ -3593,7 +3463,7 @@
           <p:cNvPr id="6" name="">
             <a:extLst xmlns:a="http://schemas.openxmlformats.org/drawingml/2006/main">
               <a:ext uri="{FF2B5EF4-FFF2-40B4-BE49-F238E27FC236}">
-                <a16:creationId xmlns:a16="http://schemas.microsoft.com/office/drawing/2014/main" id="{84AE8DBB-E164-41A3-A0AD-BA1843C4AD1A}"/>
+                <a16:creationId xmlns:a16="http://schemas.microsoft.com/office/drawing/2014/main" id="{7DC169DC-2AEF-4844-80A4-7EBFEB6EA167}"/>
               </a:ext>
             </a:extLst>
           </p:cNvPr>
@@ -3628,7 +3498,7 @@
           <p:cNvPr id="7" name="">
             <a:extLst xmlns:a="http://schemas.openxmlformats.org/drawingml/2006/main">
               <a:ext uri="{FF2B5EF4-FFF2-40B4-BE49-F238E27FC236}">
-                <a16:creationId xmlns:a16="http://schemas.microsoft.com/office/drawing/2014/main" id="{EF0A4F43-3734-4700-BA9B-3082DB86A093}"/>
+                <a16:creationId xmlns:a16="http://schemas.microsoft.com/office/drawing/2014/main" id="{E3AFFFB3-973D-43B8-9E51-8A320149490C}"/>
               </a:ext>
             </a:extLst>
           </p:cNvPr>
@@ -3678,7 +3548,7 @@
           <p:cNvPr id="8" name="">
             <a:extLst xmlns:a="http://schemas.openxmlformats.org/drawingml/2006/main">
               <a:ext uri="{FF2B5EF4-FFF2-40B4-BE49-F238E27FC236}">
-                <a16:creationId xmlns:a16="http://schemas.microsoft.com/office/drawing/2014/main" id="{7E302E63-AF08-49D1-974E-247D6040670A}"/>
+                <a16:creationId xmlns:a16="http://schemas.microsoft.com/office/drawing/2014/main" id="{3706007F-3BD6-4502-AF52-826A85A8A32B}"/>
               </a:ext>
             </a:extLst>
           </p:cNvPr>
@@ -3794,7 +3664,7 @@
           <p:cNvPr id="9" name="">
             <a:extLst xmlns:a="http://schemas.openxmlformats.org/drawingml/2006/main">
               <a:ext uri="{FF2B5EF4-FFF2-40B4-BE49-F238E27FC236}">
-                <a16:creationId xmlns:a16="http://schemas.microsoft.com/office/drawing/2014/main" id="{00533E13-BFDA-44D1-B0CC-FC2021793B20}"/>
+                <a16:creationId xmlns:a16="http://schemas.microsoft.com/office/drawing/2014/main" id="{80114F70-B40C-46B3-A76D-F9A04234E67D}"/>
               </a:ext>
             </a:extLst>
           </p:cNvPr>
@@ -3829,7 +3699,7 @@
           <p:cNvPr id="10" name="">
             <a:extLst xmlns:a="http://schemas.openxmlformats.org/drawingml/2006/main">
               <a:ext uri="{FF2B5EF4-FFF2-40B4-BE49-F238E27FC236}">
-                <a16:creationId xmlns:a16="http://schemas.microsoft.com/office/drawing/2014/main" id="{35FB6070-EC02-491C-8806-DF0CEBF85FE4}"/>
+                <a16:creationId xmlns:a16="http://schemas.microsoft.com/office/drawing/2014/main" id="{A374F63C-2F66-48C5-BBF2-5CD7DDAD4C0C}"/>
               </a:ext>
             </a:extLst>
           </p:cNvPr>
@@ -3879,7 +3749,7 @@
           <p:cNvPr id="11" name="">
             <a:extLst xmlns:a="http://schemas.openxmlformats.org/drawingml/2006/main">
               <a:ext uri="{FF2B5EF4-FFF2-40B4-BE49-F238E27FC236}">
-                <a16:creationId xmlns:a16="http://schemas.microsoft.com/office/drawing/2014/main" id="{7251D682-34D0-4614-959E-69B0513104E0}"/>
+                <a16:creationId xmlns:a16="http://schemas.microsoft.com/office/drawing/2014/main" id="{143CEE36-E9A4-44D3-BA86-35ECEE77C596}"/>
               </a:ext>
             </a:extLst>
           </p:cNvPr>
@@ -3995,7 +3865,7 @@
           <p:cNvPr id="12" name="">
             <a:extLst xmlns:a="http://schemas.openxmlformats.org/drawingml/2006/main">
               <a:ext uri="{FF2B5EF4-FFF2-40B4-BE49-F238E27FC236}">
-                <a16:creationId xmlns:a16="http://schemas.microsoft.com/office/drawing/2014/main" id="{17AA35D1-E68A-40BC-B52B-3A943C034AA7}"/>
+                <a16:creationId xmlns:a16="http://schemas.microsoft.com/office/drawing/2014/main" id="{39078822-AA3E-456A-BD14-3CE261ADB02D}"/>
               </a:ext>
             </a:extLst>
           </p:cNvPr>
@@ -4024,7 +3894,7 @@
     </p:spTree>
     <p:extLst>
       <p:ext uri="{BB962C8B-B14F-4D97-AF65-F5344CB8AC3E}">
-        <p14:creationId xmlns:p14="http://schemas.microsoft.com/office/powerpoint/2010/main" val="1261324308"/>
+        <p14:creationId xmlns:p14="http://schemas.microsoft.com/office/powerpoint/2010/main" val="2026708359"/>
       </p:ext>
     </p:extLst>
   </p:cSld>
@@ -4055,7 +3925,7 @@
           <p:cNvPr id="19" name="">
             <a:extLst xmlns:a="http://schemas.openxmlformats.org/drawingml/2006/main">
               <a:ext uri="{FF2B5EF4-FFF2-40B4-BE49-F238E27FC236}">
-                <a16:creationId xmlns:a16="http://schemas.microsoft.com/office/drawing/2014/main" id="{F773E2E6-5029-4161-AFA7-830FAE0D4C13}"/>
+                <a16:creationId xmlns:a16="http://schemas.microsoft.com/office/drawing/2014/main" id="{6D144189-FA7A-49C3-8B5A-4A76D6214213}"/>
               </a:ext>
             </a:extLst>
           </p:cNvPr>
@@ -4105,7 +3975,7 @@
           <p:cNvPr id="2" name="">
             <a:extLst xmlns:a="http://schemas.openxmlformats.org/drawingml/2006/main">
               <a:ext uri="{FF2B5EF4-FFF2-40B4-BE49-F238E27FC236}">
-                <a16:creationId xmlns:a16="http://schemas.microsoft.com/office/drawing/2014/main" id="{9894DF38-4449-41EF-AB08-5163B4161098}"/>
+                <a16:creationId xmlns:a16="http://schemas.microsoft.com/office/drawing/2014/main" id="{0B714CCE-6A15-4EBF-81A9-0202E13BE68C}"/>
               </a:ext>
             </a:extLst>
           </p:cNvPr>
@@ -4155,7 +4025,7 @@
           <p:cNvPr id="3" name="">
             <a:extLst xmlns:a="http://schemas.openxmlformats.org/drawingml/2006/main">
               <a:ext uri="{FF2B5EF4-FFF2-40B4-BE49-F238E27FC236}">
-                <a16:creationId xmlns:a16="http://schemas.microsoft.com/office/drawing/2014/main" id="{669E9E2C-FC3B-4E91-A40B-4CD289A73B48}"/>
+                <a16:creationId xmlns:a16="http://schemas.microsoft.com/office/drawing/2014/main" id="{224EC2E8-517B-48A2-997F-56B15AF70068}"/>
               </a:ext>
             </a:extLst>
           </p:cNvPr>
@@ -4186,7 +4056,7 @@
           <p:cNvPr id="4" name="">
             <a:extLst xmlns:a="http://schemas.openxmlformats.org/drawingml/2006/main">
               <a:ext uri="{FF2B5EF4-FFF2-40B4-BE49-F238E27FC236}">
-                <a16:creationId xmlns:a16="http://schemas.microsoft.com/office/drawing/2014/main" id="{B5C655FE-671C-4681-A7B8-C2AC02E6AE58}"/>
+                <a16:creationId xmlns:a16="http://schemas.microsoft.com/office/drawing/2014/main" id="{E0032CAF-CE47-400F-B037-E1EA027209B6}"/>
               </a:ext>
             </a:extLst>
           </p:cNvPr>
@@ -4236,7 +4106,7 @@
           <p:cNvPr id="5" name="">
             <a:extLst xmlns:a="http://schemas.openxmlformats.org/drawingml/2006/main">
               <a:ext uri="{FF2B5EF4-FFF2-40B4-BE49-F238E27FC236}">
-                <a16:creationId xmlns:a16="http://schemas.microsoft.com/office/drawing/2014/main" id="{F30D8CE3-26A2-46EE-AB40-D9BDA3059582}"/>
+                <a16:creationId xmlns:a16="http://schemas.microsoft.com/office/drawing/2014/main" id="{86DD6CAD-2B5E-4DA5-BA62-2B9F4FD67382}"/>
               </a:ext>
             </a:extLst>
           </p:cNvPr>
@@ -4286,7 +4156,7 @@
           <p:cNvPr id="6" name="">
             <a:extLst xmlns:a="http://schemas.openxmlformats.org/drawingml/2006/main">
               <a:ext uri="{FF2B5EF4-FFF2-40B4-BE49-F238E27FC236}">
-                <a16:creationId xmlns:a16="http://schemas.microsoft.com/office/drawing/2014/main" id="{B509FB15-CCAA-4799-905A-207128E55C24}"/>
+                <a16:creationId xmlns:a16="http://schemas.microsoft.com/office/drawing/2014/main" id="{D6071F5C-0CF4-4FDD-B375-11B31FED265D}"/>
               </a:ext>
             </a:extLst>
           </p:cNvPr>
@@ -4340,7 +4210,7 @@
           <p:cNvPr id="7" name="">
             <a:extLst xmlns:a="http://schemas.openxmlformats.org/drawingml/2006/main">
               <a:ext uri="{FF2B5EF4-FFF2-40B4-BE49-F238E27FC236}">
-                <a16:creationId xmlns:a16="http://schemas.microsoft.com/office/drawing/2014/main" id="{C7FECFFD-27A5-4FED-A1B0-01D97D8D1240}"/>
+                <a16:creationId xmlns:a16="http://schemas.microsoft.com/office/drawing/2014/main" id="{E10E1B9E-8FEE-440D-9292-EF3666DD99AA}"/>
               </a:ext>
             </a:extLst>
           </p:cNvPr>
@@ -4390,7 +4260,7 @@
           <p:cNvPr id="8" name="">
             <a:extLst xmlns:a="http://schemas.openxmlformats.org/drawingml/2006/main">
               <a:ext uri="{FF2B5EF4-FFF2-40B4-BE49-F238E27FC236}">
-                <a16:creationId xmlns:a16="http://schemas.microsoft.com/office/drawing/2014/main" id="{E8CE5C48-8058-417A-B530-B63638C56E1B}"/>
+                <a16:creationId xmlns:a16="http://schemas.microsoft.com/office/drawing/2014/main" id="{02726DA5-67D5-48E6-B931-6523EA732822}"/>
               </a:ext>
             </a:extLst>
           </p:cNvPr>
@@ -4444,7 +4314,7 @@
           <p:cNvPr id="9" name="">
             <a:extLst xmlns:a="http://schemas.openxmlformats.org/drawingml/2006/main">
               <a:ext uri="{FF2B5EF4-FFF2-40B4-BE49-F238E27FC236}">
-                <a16:creationId xmlns:a16="http://schemas.microsoft.com/office/drawing/2014/main" id="{6EFF2F8A-5063-4ECE-8A24-3FCA198CB640}"/>
+                <a16:creationId xmlns:a16="http://schemas.microsoft.com/office/drawing/2014/main" id="{F1996893-16F2-4905-B990-8804551367FE}"/>
               </a:ext>
             </a:extLst>
           </p:cNvPr>
@@ -4494,7 +4364,7 @@
           <p:cNvPr id="10" name="">
             <a:extLst xmlns:a="http://schemas.openxmlformats.org/drawingml/2006/main">
               <a:ext uri="{FF2B5EF4-FFF2-40B4-BE49-F238E27FC236}">
-                <a16:creationId xmlns:a16="http://schemas.microsoft.com/office/drawing/2014/main" id="{08A1C6D8-8FE8-4219-B723-37DB21B6A68E}"/>
+                <a16:creationId xmlns:a16="http://schemas.microsoft.com/office/drawing/2014/main" id="{3BAAF69C-612C-4D64-BCC3-D0FDB4DC1990}"/>
               </a:ext>
             </a:extLst>
           </p:cNvPr>
@@ -4548,7 +4418,7 @@
           <p:cNvPr id="11" name="">
             <a:extLst xmlns:a="http://schemas.openxmlformats.org/drawingml/2006/main">
               <a:ext uri="{FF2B5EF4-FFF2-40B4-BE49-F238E27FC236}">
-                <a16:creationId xmlns:a16="http://schemas.microsoft.com/office/drawing/2014/main" id="{7E98942E-DF41-4ED5-BD14-3929014E2E11}"/>
+                <a16:creationId xmlns:a16="http://schemas.microsoft.com/office/drawing/2014/main" id="{32675EF9-D9A7-48D4-8D65-D30DE1A253F8}"/>
               </a:ext>
             </a:extLst>
           </p:cNvPr>
@@ -4598,7 +4468,7 @@
           <p:cNvPr id="12" name="">
             <a:extLst xmlns:a="http://schemas.openxmlformats.org/drawingml/2006/main">
               <a:ext uri="{FF2B5EF4-FFF2-40B4-BE49-F238E27FC236}">
-                <a16:creationId xmlns:a16="http://schemas.microsoft.com/office/drawing/2014/main" id="{733D863C-9E03-4FA0-ADC6-20987F3052FD}"/>
+                <a16:creationId xmlns:a16="http://schemas.microsoft.com/office/drawing/2014/main" id="{120F6038-541F-4C91-8484-17135A50F1D7}"/>
               </a:ext>
             </a:extLst>
           </p:cNvPr>
@@ -4652,7 +4522,7 @@
           <p:cNvPr id="13" name="">
             <a:extLst xmlns:a="http://schemas.openxmlformats.org/drawingml/2006/main">
               <a:ext uri="{FF2B5EF4-FFF2-40B4-BE49-F238E27FC236}">
-                <a16:creationId xmlns:a16="http://schemas.microsoft.com/office/drawing/2014/main" id="{C3E035D7-1B56-4704-9B6C-55C13F8C21B7}"/>
+                <a16:creationId xmlns:a16="http://schemas.microsoft.com/office/drawing/2014/main" id="{0C0384DE-C42F-449D-B228-4BD77B479F3F}"/>
               </a:ext>
             </a:extLst>
           </p:cNvPr>
@@ -4702,7 +4572,7 @@
           <p:cNvPr id="14" name="">
             <a:extLst xmlns:a="http://schemas.openxmlformats.org/drawingml/2006/main">
               <a:ext uri="{FF2B5EF4-FFF2-40B4-BE49-F238E27FC236}">
-                <a16:creationId xmlns:a16="http://schemas.microsoft.com/office/drawing/2014/main" id="{CF1CF588-33CA-4070-8BBD-674E1EB5B963}"/>
+                <a16:creationId xmlns:a16="http://schemas.microsoft.com/office/drawing/2014/main" id="{24918CCC-8A0D-4FB1-990C-23A65140E916}"/>
               </a:ext>
             </a:extLst>
           </p:cNvPr>
@@ -4756,7 +4626,7 @@
           <p:cNvPr id="15" name="">
             <a:extLst xmlns:a="http://schemas.openxmlformats.org/drawingml/2006/main">
               <a:ext uri="{FF2B5EF4-FFF2-40B4-BE49-F238E27FC236}">
-                <a16:creationId xmlns:a16="http://schemas.microsoft.com/office/drawing/2014/main" id="{2F4ECB12-CF1C-4301-BC8F-928B6A43877A}"/>
+                <a16:creationId xmlns:a16="http://schemas.microsoft.com/office/drawing/2014/main" id="{1BC66634-9779-45C4-9726-3295D32CC20E}"/>
               </a:ext>
             </a:extLst>
           </p:cNvPr>
@@ -4806,7 +4676,7 @@
           <p:cNvPr id="16" name="">
             <a:extLst xmlns:a="http://schemas.openxmlformats.org/drawingml/2006/main">
               <a:ext uri="{FF2B5EF4-FFF2-40B4-BE49-F238E27FC236}">
-                <a16:creationId xmlns:a16="http://schemas.microsoft.com/office/drawing/2014/main" id="{46EA01F2-620B-4EDB-A5F9-B3426360535C}"/>
+                <a16:creationId xmlns:a16="http://schemas.microsoft.com/office/drawing/2014/main" id="{6BAFA5DF-3642-4ECC-AD69-6FA6AEFC6BFB}"/>
               </a:ext>
             </a:extLst>
           </p:cNvPr>
@@ -4841,7 +4711,7 @@
           <p:cNvPr id="17" name="">
             <a:extLst xmlns:a="http://schemas.openxmlformats.org/drawingml/2006/main">
               <a:ext uri="{FF2B5EF4-FFF2-40B4-BE49-F238E27FC236}">
-                <a16:creationId xmlns:a16="http://schemas.microsoft.com/office/drawing/2014/main" id="{B59344C9-B9CF-4F18-B3E4-DF5971A38816}"/>
+                <a16:creationId xmlns:a16="http://schemas.microsoft.com/office/drawing/2014/main" id="{54EDFD92-2241-4694-84BC-ACA99E32668F}"/>
               </a:ext>
             </a:extLst>
           </p:cNvPr>
@@ -4891,7 +4761,7 @@
           <p:cNvPr id="18" name="">
             <a:extLst xmlns:a="http://schemas.openxmlformats.org/drawingml/2006/main">
               <a:ext uri="{FF2B5EF4-FFF2-40B4-BE49-F238E27FC236}">
-                <a16:creationId xmlns:a16="http://schemas.microsoft.com/office/drawing/2014/main" id="{BDC3A993-700C-434E-BCB4-6B791D39B2A6}"/>
+                <a16:creationId xmlns:a16="http://schemas.microsoft.com/office/drawing/2014/main" id="{70EB65F2-1062-4D9A-9B93-85222AB185BE}"/>
               </a:ext>
             </a:extLst>
           </p:cNvPr>
@@ -5007,7 +4877,7 @@
     </p:spTree>
     <p:extLst>
       <p:ext uri="{BB962C8B-B14F-4D97-AF65-F5344CB8AC3E}">
-        <p14:creationId xmlns:p14="http://schemas.microsoft.com/office/powerpoint/2010/main" val="797967680"/>
+        <p14:creationId xmlns:p14="http://schemas.microsoft.com/office/powerpoint/2010/main" val="210406703"/>
       </p:ext>
     </p:extLst>
   </p:cSld>
@@ -5038,7 +4908,7 @@
           <p:cNvPr id="22" name="">
             <a:extLst xmlns:a="http://schemas.openxmlformats.org/drawingml/2006/main">
               <a:ext uri="{FF2B5EF4-FFF2-40B4-BE49-F238E27FC236}">
-                <a16:creationId xmlns:a16="http://schemas.microsoft.com/office/drawing/2014/main" id="{CF63C342-BDDA-45A7-A108-7B3888560032}"/>
+                <a16:creationId xmlns:a16="http://schemas.microsoft.com/office/drawing/2014/main" id="{0FCFD63A-7CD0-44E3-9543-E74298B32E20}"/>
               </a:ext>
             </a:extLst>
           </p:cNvPr>
@@ -5088,7 +4958,7 @@
           <p:cNvPr id="2" name="">
             <a:extLst xmlns:a="http://schemas.openxmlformats.org/drawingml/2006/main">
               <a:ext uri="{FF2B5EF4-FFF2-40B4-BE49-F238E27FC236}">
-                <a16:creationId xmlns:a16="http://schemas.microsoft.com/office/drawing/2014/main" id="{87C8B49C-FA1B-4AAD-BC74-EDB5DF875FF3}"/>
+                <a16:creationId xmlns:a16="http://schemas.microsoft.com/office/drawing/2014/main" id="{488D4417-945A-4303-B23F-30E4DF5F4ABC}"/>
               </a:ext>
             </a:extLst>
           </p:cNvPr>
@@ -5138,7 +5008,7 @@
           <p:cNvPr id="3" name="">
             <a:extLst xmlns:a="http://schemas.openxmlformats.org/drawingml/2006/main">
               <a:ext uri="{FF2B5EF4-FFF2-40B4-BE49-F238E27FC236}">
-                <a16:creationId xmlns:a16="http://schemas.microsoft.com/office/drawing/2014/main" id="{F5DA55EF-C9BE-49EE-8FA9-1E55CE6E13EF}"/>
+                <a16:creationId xmlns:a16="http://schemas.microsoft.com/office/drawing/2014/main" id="{1B9BB66C-42FE-41DC-89FC-8CEE6E9C841C}"/>
               </a:ext>
             </a:extLst>
           </p:cNvPr>
@@ -5169,7 +5039,7 @@
           <p:cNvPr id="4" name="">
             <a:extLst xmlns:a="http://schemas.openxmlformats.org/drawingml/2006/main">
               <a:ext uri="{FF2B5EF4-FFF2-40B4-BE49-F238E27FC236}">
-                <a16:creationId xmlns:a16="http://schemas.microsoft.com/office/drawing/2014/main" id="{0621D5C6-8131-439C-8460-48894A674D89}"/>
+                <a16:creationId xmlns:a16="http://schemas.microsoft.com/office/drawing/2014/main" id="{9387E662-45D6-41DA-B49A-9A8DD3754AC7}"/>
               </a:ext>
             </a:extLst>
           </p:cNvPr>
@@ -5219,7 +5089,7 @@
           <p:cNvPr id="5" name="">
             <a:extLst xmlns:a="http://schemas.openxmlformats.org/drawingml/2006/main">
               <a:ext uri="{FF2B5EF4-FFF2-40B4-BE49-F238E27FC236}">
-                <a16:creationId xmlns:a16="http://schemas.microsoft.com/office/drawing/2014/main" id="{1D38DA9C-1368-4CC0-815A-266B9AD9E26F}"/>
+                <a16:creationId xmlns:a16="http://schemas.microsoft.com/office/drawing/2014/main" id="{1D24DE1B-D322-4602-8D36-76F35AAFFF49}"/>
               </a:ext>
             </a:extLst>
           </p:cNvPr>
@@ -5269,7 +5139,7 @@
           <p:cNvPr id="6" name="">
             <a:extLst xmlns:a="http://schemas.openxmlformats.org/drawingml/2006/main">
               <a:ext uri="{FF2B5EF4-FFF2-40B4-BE49-F238E27FC236}">
-                <a16:creationId xmlns:a16="http://schemas.microsoft.com/office/drawing/2014/main" id="{0C0BBACB-B918-45C2-B795-1917D355A236}"/>
+                <a16:creationId xmlns:a16="http://schemas.microsoft.com/office/drawing/2014/main" id="{FD7F8712-43F4-4394-8871-D3928BE5B868}"/>
               </a:ext>
             </a:extLst>
           </p:cNvPr>
@@ -5319,7 +5189,7 @@
           <p:cNvPr id="7" name="">
             <a:extLst xmlns:a="http://schemas.openxmlformats.org/drawingml/2006/main">
               <a:ext uri="{FF2B5EF4-FFF2-40B4-BE49-F238E27FC236}">
-                <a16:creationId xmlns:a16="http://schemas.microsoft.com/office/drawing/2014/main" id="{AE411E25-EDD5-41F9-8A74-35DFB6E83644}"/>
+                <a16:creationId xmlns:a16="http://schemas.microsoft.com/office/drawing/2014/main" id="{06EA9DDD-64BB-4A19-B27A-4507FC287349}"/>
               </a:ext>
             </a:extLst>
           </p:cNvPr>
@@ -5350,7 +5220,7 @@
           <p:cNvPr id="8" name="">
             <a:extLst xmlns:a="http://schemas.openxmlformats.org/drawingml/2006/main">
               <a:ext uri="{FF2B5EF4-FFF2-40B4-BE49-F238E27FC236}">
-                <a16:creationId xmlns:a16="http://schemas.microsoft.com/office/drawing/2014/main" id="{0D05A2AD-5026-4074-8E8B-700FC76A24BC}"/>
+                <a16:creationId xmlns:a16="http://schemas.microsoft.com/office/drawing/2014/main" id="{16551FAA-2F6F-448F-B548-723F266AC717}"/>
               </a:ext>
             </a:extLst>
           </p:cNvPr>
@@ -5400,7 +5270,7 @@
           <p:cNvPr id="9" name="">
             <a:extLst xmlns:a="http://schemas.openxmlformats.org/drawingml/2006/main">
               <a:ext uri="{FF2B5EF4-FFF2-40B4-BE49-F238E27FC236}">
-                <a16:creationId xmlns:a16="http://schemas.microsoft.com/office/drawing/2014/main" id="{FE9673E5-DB08-4022-8066-7D186A601BA1}"/>
+                <a16:creationId xmlns:a16="http://schemas.microsoft.com/office/drawing/2014/main" id="{EDD73427-DDA2-4C75-ABFE-93B748C8E906}"/>
               </a:ext>
             </a:extLst>
           </p:cNvPr>
@@ -5431,7 +5301,7 @@
           <p:cNvPr id="10" name="">
             <a:extLst xmlns:a="http://schemas.openxmlformats.org/drawingml/2006/main">
               <a:ext uri="{FF2B5EF4-FFF2-40B4-BE49-F238E27FC236}">
-                <a16:creationId xmlns:a16="http://schemas.microsoft.com/office/drawing/2014/main" id="{3BBDE9AD-114E-4B0F-892A-8A396C57E181}"/>
+                <a16:creationId xmlns:a16="http://schemas.microsoft.com/office/drawing/2014/main" id="{98198B56-E3B7-4409-985C-420FFD7A63A7}"/>
               </a:ext>
             </a:extLst>
           </p:cNvPr>
@@ -5481,7 +5351,7 @@
           <p:cNvPr id="11" name="">
             <a:extLst xmlns:a="http://schemas.openxmlformats.org/drawingml/2006/main">
               <a:ext uri="{FF2B5EF4-FFF2-40B4-BE49-F238E27FC236}">
-                <a16:creationId xmlns:a16="http://schemas.microsoft.com/office/drawing/2014/main" id="{E49D84AA-A4E1-4CAC-A1EF-5551DA99430E}"/>
+                <a16:creationId xmlns:a16="http://schemas.microsoft.com/office/drawing/2014/main" id="{543E67A1-423C-493D-BD7C-A6BB3699C609}"/>
               </a:ext>
             </a:extLst>
           </p:cNvPr>
@@ -5512,7 +5382,7 @@
           <p:cNvPr id="12" name="">
             <a:extLst xmlns:a="http://schemas.openxmlformats.org/drawingml/2006/main">
               <a:ext uri="{FF2B5EF4-FFF2-40B4-BE49-F238E27FC236}">
-                <a16:creationId xmlns:a16="http://schemas.microsoft.com/office/drawing/2014/main" id="{DE9A2AE9-26BB-4462-8853-0CE744D392F5}"/>
+                <a16:creationId xmlns:a16="http://schemas.microsoft.com/office/drawing/2014/main" id="{1C61E832-423F-4E82-9677-57A10C398AC3}"/>
               </a:ext>
             </a:extLst>
           </p:cNvPr>
@@ -5562,7 +5432,7 @@
           <p:cNvPr id="13" name="">
             <a:extLst xmlns:a="http://schemas.openxmlformats.org/drawingml/2006/main">
               <a:ext uri="{FF2B5EF4-FFF2-40B4-BE49-F238E27FC236}">
-                <a16:creationId xmlns:a16="http://schemas.microsoft.com/office/drawing/2014/main" id="{53BB4321-956B-4D21-B25C-C0E54A95B1CF}"/>
+                <a16:creationId xmlns:a16="http://schemas.microsoft.com/office/drawing/2014/main" id="{D1F6C3AA-D0DA-4C65-B841-068565250607}"/>
               </a:ext>
             </a:extLst>
           </p:cNvPr>
@@ -5612,7 +5482,7 @@
           <p:cNvPr id="14" name="">
             <a:extLst xmlns:a="http://schemas.openxmlformats.org/drawingml/2006/main">
               <a:ext uri="{FF2B5EF4-FFF2-40B4-BE49-F238E27FC236}">
-                <a16:creationId xmlns:a16="http://schemas.microsoft.com/office/drawing/2014/main" id="{8B1884E1-B998-49BB-B16B-AB9828F112B9}"/>
+                <a16:creationId xmlns:a16="http://schemas.microsoft.com/office/drawing/2014/main" id="{927B398D-A392-42C8-B3E3-C49618F47192}"/>
               </a:ext>
             </a:extLst>
           </p:cNvPr>
@@ -5643,7 +5513,7 @@
           <p:cNvPr id="15" name="">
             <a:extLst xmlns:a="http://schemas.openxmlformats.org/drawingml/2006/main">
               <a:ext uri="{FF2B5EF4-FFF2-40B4-BE49-F238E27FC236}">
-                <a16:creationId xmlns:a16="http://schemas.microsoft.com/office/drawing/2014/main" id="{DDEDC019-DC50-42AE-9E3A-E10B25F4F185}"/>
+                <a16:creationId xmlns:a16="http://schemas.microsoft.com/office/drawing/2014/main" id="{8C9D18AB-5FD9-456E-8557-F318B67F0BA4}"/>
               </a:ext>
             </a:extLst>
           </p:cNvPr>
@@ -5693,7 +5563,7 @@
           <p:cNvPr id="16" name="">
             <a:extLst xmlns:a="http://schemas.openxmlformats.org/drawingml/2006/main">
               <a:ext uri="{FF2B5EF4-FFF2-40B4-BE49-F238E27FC236}">
-                <a16:creationId xmlns:a16="http://schemas.microsoft.com/office/drawing/2014/main" id="{74DDE839-12BF-46C1-AFDC-F850A37CD663}"/>
+                <a16:creationId xmlns:a16="http://schemas.microsoft.com/office/drawing/2014/main" id="{91C69988-3288-4223-820C-E1771E3A744A}"/>
               </a:ext>
             </a:extLst>
           </p:cNvPr>
@@ -5724,7 +5594,7 @@
           <p:cNvPr id="17" name="">
             <a:extLst xmlns:a="http://schemas.openxmlformats.org/drawingml/2006/main">
               <a:ext uri="{FF2B5EF4-FFF2-40B4-BE49-F238E27FC236}">
-                <a16:creationId xmlns:a16="http://schemas.microsoft.com/office/drawing/2014/main" id="{06995157-CA16-43DE-8B20-3DE14075F9D9}"/>
+                <a16:creationId xmlns:a16="http://schemas.microsoft.com/office/drawing/2014/main" id="{D8F71DB9-4684-4F26-B8D5-EA6F4BB2C2A2}"/>
               </a:ext>
             </a:extLst>
           </p:cNvPr>
@@ -5774,7 +5644,7 @@
           <p:cNvPr id="18" name="">
             <a:extLst xmlns:a="http://schemas.openxmlformats.org/drawingml/2006/main">
               <a:ext uri="{FF2B5EF4-FFF2-40B4-BE49-F238E27FC236}">
-                <a16:creationId xmlns:a16="http://schemas.microsoft.com/office/drawing/2014/main" id="{623843CA-5783-41D8-BEE4-09D053A5B995}"/>
+                <a16:creationId xmlns:a16="http://schemas.microsoft.com/office/drawing/2014/main" id="{D94673BD-9407-425F-8C72-23EF1A06D163}"/>
               </a:ext>
             </a:extLst>
           </p:cNvPr>
@@ -5805,7 +5675,7 @@
           <p:cNvPr id="19" name="">
             <a:extLst xmlns:a="http://schemas.openxmlformats.org/drawingml/2006/main">
               <a:ext uri="{FF2B5EF4-FFF2-40B4-BE49-F238E27FC236}">
-                <a16:creationId xmlns:a16="http://schemas.microsoft.com/office/drawing/2014/main" id="{5A353829-DFD8-4210-8542-AE75B9DA41BD}"/>
+                <a16:creationId xmlns:a16="http://schemas.microsoft.com/office/drawing/2014/main" id="{D344BC4F-4FE5-447D-8736-C366B687EA71}"/>
               </a:ext>
             </a:extLst>
           </p:cNvPr>
@@ -5855,7 +5725,7 @@
           <p:cNvPr id="20" name="">
             <a:extLst xmlns:a="http://schemas.openxmlformats.org/drawingml/2006/main">
               <a:ext uri="{FF2B5EF4-FFF2-40B4-BE49-F238E27FC236}">
-                <a16:creationId xmlns:a16="http://schemas.microsoft.com/office/drawing/2014/main" id="{3796C23B-05C7-4304-A5B8-DB2E512BA1CB}"/>
+                <a16:creationId xmlns:a16="http://schemas.microsoft.com/office/drawing/2014/main" id="{C68E5358-7075-4EA1-8B6F-C628D850F5FE}"/>
               </a:ext>
             </a:extLst>
           </p:cNvPr>
@@ -5890,7 +5760,7 @@
           <p:cNvPr id="21" name="">
             <a:extLst xmlns:a="http://schemas.openxmlformats.org/drawingml/2006/main">
               <a:ext uri="{FF2B5EF4-FFF2-40B4-BE49-F238E27FC236}">
-                <a16:creationId xmlns:a16="http://schemas.microsoft.com/office/drawing/2014/main" id="{D15A739A-AAA6-4F98-812E-42F45DDE168E}"/>
+                <a16:creationId xmlns:a16="http://schemas.microsoft.com/office/drawing/2014/main" id="{0C34D13A-8C7B-4978-82FE-8C60D8895384}"/>
               </a:ext>
             </a:extLst>
           </p:cNvPr>
@@ -5938,7 +5808,7 @@
     </p:spTree>
     <p:extLst>
       <p:ext uri="{BB962C8B-B14F-4D97-AF65-F5344CB8AC3E}">
-        <p14:creationId xmlns:p14="http://schemas.microsoft.com/office/powerpoint/2010/main" val="359652323"/>
+        <p14:creationId xmlns:p14="http://schemas.microsoft.com/office/powerpoint/2010/main" val="599062959"/>
       </p:ext>
     </p:extLst>
   </p:cSld>
@@ -5969,7 +5839,7 @@
           <p:cNvPr id="24" name="">
             <a:extLst xmlns:a="http://schemas.openxmlformats.org/drawingml/2006/main">
               <a:ext uri="{FF2B5EF4-FFF2-40B4-BE49-F238E27FC236}">
-                <a16:creationId xmlns:a16="http://schemas.microsoft.com/office/drawing/2014/main" id="{966AB431-10F3-41DA-8CD7-72C15929D492}"/>
+                <a16:creationId xmlns:a16="http://schemas.microsoft.com/office/drawing/2014/main" id="{CE8261D4-C6BE-4761-ACF6-D95042567D89}"/>
               </a:ext>
             </a:extLst>
           </p:cNvPr>
@@ -6019,7 +5889,7 @@
           <p:cNvPr id="2" name="">
             <a:extLst xmlns:a="http://schemas.openxmlformats.org/drawingml/2006/main">
               <a:ext uri="{FF2B5EF4-FFF2-40B4-BE49-F238E27FC236}">
-                <a16:creationId xmlns:a16="http://schemas.microsoft.com/office/drawing/2014/main" id="{4E51EF9C-F25B-46ED-A142-E56750DA28C4}"/>
+                <a16:creationId xmlns:a16="http://schemas.microsoft.com/office/drawing/2014/main" id="{BE202628-403B-450F-B7A1-2A2D32BA954B}"/>
               </a:ext>
             </a:extLst>
           </p:cNvPr>
@@ -6069,7 +5939,7 @@
           <p:cNvPr id="3" name="">
             <a:extLst xmlns:a="http://schemas.openxmlformats.org/drawingml/2006/main">
               <a:ext uri="{FF2B5EF4-FFF2-40B4-BE49-F238E27FC236}">
-                <a16:creationId xmlns:a16="http://schemas.microsoft.com/office/drawing/2014/main" id="{4E0D02FE-4BC0-48B5-AD0A-2F19CC6BA554}"/>
+                <a16:creationId xmlns:a16="http://schemas.microsoft.com/office/drawing/2014/main" id="{01ACC8D3-049B-493B-803A-C348B813A49C}"/>
               </a:ext>
             </a:extLst>
           </p:cNvPr>
@@ -6100,7 +5970,7 @@
           <p:cNvPr id="4" name="">
             <a:extLst xmlns:a="http://schemas.openxmlformats.org/drawingml/2006/main">
               <a:ext uri="{FF2B5EF4-FFF2-40B4-BE49-F238E27FC236}">
-                <a16:creationId xmlns:a16="http://schemas.microsoft.com/office/drawing/2014/main" id="{C7E253DC-6697-44B2-B0BE-85361DC4D89D}"/>
+                <a16:creationId xmlns:a16="http://schemas.microsoft.com/office/drawing/2014/main" id="{939F309C-EB72-4C56-ACE2-000B90918EC7}"/>
               </a:ext>
             </a:extLst>
           </p:cNvPr>
@@ -6150,7 +6020,7 @@
           <p:cNvPr id="5" name="">
             <a:extLst xmlns:a="http://schemas.openxmlformats.org/drawingml/2006/main">
               <a:ext uri="{FF2B5EF4-FFF2-40B4-BE49-F238E27FC236}">
-                <a16:creationId xmlns:a16="http://schemas.microsoft.com/office/drawing/2014/main" id="{2F999CD4-236F-4E28-978F-8839816C99B4}"/>
+                <a16:creationId xmlns:a16="http://schemas.microsoft.com/office/drawing/2014/main" id="{90F9503B-ABDF-43A8-B97D-B6223448F1B1}"/>
               </a:ext>
             </a:extLst>
           </p:cNvPr>
@@ -6200,7 +6070,7 @@
           <p:cNvPr id="6" name="">
             <a:extLst xmlns:a="http://schemas.openxmlformats.org/drawingml/2006/main">
               <a:ext uri="{FF2B5EF4-FFF2-40B4-BE49-F238E27FC236}">
-                <a16:creationId xmlns:a16="http://schemas.microsoft.com/office/drawing/2014/main" id="{C2443F80-4B74-4910-A928-B1B8D57FEB8E}"/>
+                <a16:creationId xmlns:a16="http://schemas.microsoft.com/office/drawing/2014/main" id="{57D4FBF5-F449-4446-840B-B0218F86BF0D}"/>
               </a:ext>
             </a:extLst>
           </p:cNvPr>
@@ -6250,7 +6120,7 @@
           <p:cNvPr id="7" name="">
             <a:extLst xmlns:a="http://schemas.openxmlformats.org/drawingml/2006/main">
               <a:ext uri="{FF2B5EF4-FFF2-40B4-BE49-F238E27FC236}">
-                <a16:creationId xmlns:a16="http://schemas.microsoft.com/office/drawing/2014/main" id="{4A41718D-0B79-48E3-809B-087329D1B121}"/>
+                <a16:creationId xmlns:a16="http://schemas.microsoft.com/office/drawing/2014/main" id="{669E5676-E862-4F77-AB0E-0CFB8C570B03}"/>
               </a:ext>
             </a:extLst>
           </p:cNvPr>
@@ -6281,7 +6151,7 @@
           <p:cNvPr id="8" name="">
             <a:extLst xmlns:a="http://schemas.openxmlformats.org/drawingml/2006/main">
               <a:ext uri="{FF2B5EF4-FFF2-40B4-BE49-F238E27FC236}">
-                <a16:creationId xmlns:a16="http://schemas.microsoft.com/office/drawing/2014/main" id="{D5EEC9DF-3E87-48CD-A822-5363AA0BCCA1}"/>
+                <a16:creationId xmlns:a16="http://schemas.microsoft.com/office/drawing/2014/main" id="{805F09BE-02B9-4413-A88E-31148970279B}"/>
               </a:ext>
             </a:extLst>
           </p:cNvPr>
@@ -6331,7 +6201,7 @@
           <p:cNvPr id="9" name="">
             <a:extLst xmlns:a="http://schemas.openxmlformats.org/drawingml/2006/main">
               <a:ext uri="{FF2B5EF4-FFF2-40B4-BE49-F238E27FC236}">
-                <a16:creationId xmlns:a16="http://schemas.microsoft.com/office/drawing/2014/main" id="{E96A55B2-C67F-489A-B3F2-89313F495BDC}"/>
+                <a16:creationId xmlns:a16="http://schemas.microsoft.com/office/drawing/2014/main" id="{1A3B63F9-729B-452B-93F8-86C04D5006A4}"/>
               </a:ext>
             </a:extLst>
           </p:cNvPr>
@@ -6362,7 +6232,7 @@
           <p:cNvPr id="10" name="">
             <a:extLst xmlns:a="http://schemas.openxmlformats.org/drawingml/2006/main">
               <a:ext uri="{FF2B5EF4-FFF2-40B4-BE49-F238E27FC236}">
-                <a16:creationId xmlns:a16="http://schemas.microsoft.com/office/drawing/2014/main" id="{6D474B52-83CF-4D1B-B2D1-7577A9E65D31}"/>
+                <a16:creationId xmlns:a16="http://schemas.microsoft.com/office/drawing/2014/main" id="{C1B7FCF2-E24B-4392-AE8D-4A25E890F88C}"/>
               </a:ext>
             </a:extLst>
           </p:cNvPr>
@@ -6412,7 +6282,7 @@
           <p:cNvPr id="11" name="">
             <a:extLst xmlns:a="http://schemas.openxmlformats.org/drawingml/2006/main">
               <a:ext uri="{FF2B5EF4-FFF2-40B4-BE49-F238E27FC236}">
-                <a16:creationId xmlns:a16="http://schemas.microsoft.com/office/drawing/2014/main" id="{7FB54C0A-8759-4EAC-BDAF-73A72AB87610}"/>
+                <a16:creationId xmlns:a16="http://schemas.microsoft.com/office/drawing/2014/main" id="{D216622F-DF64-47AC-9AF1-D46F7BFDAF1C}"/>
               </a:ext>
             </a:extLst>
           </p:cNvPr>
@@ -6443,7 +6313,7 @@
           <p:cNvPr id="12" name="">
             <a:extLst xmlns:a="http://schemas.openxmlformats.org/drawingml/2006/main">
               <a:ext uri="{FF2B5EF4-FFF2-40B4-BE49-F238E27FC236}">
-                <a16:creationId xmlns:a16="http://schemas.microsoft.com/office/drawing/2014/main" id="{2C6DC7FF-4ECB-4858-BDB1-F33897939524}"/>
+                <a16:creationId xmlns:a16="http://schemas.microsoft.com/office/drawing/2014/main" id="{BED1E5B6-E139-4E13-B208-87FDBD2FC242}"/>
               </a:ext>
             </a:extLst>
           </p:cNvPr>
@@ -6493,7 +6363,7 @@
           <p:cNvPr id="13" name="">
             <a:extLst xmlns:a="http://schemas.openxmlformats.org/drawingml/2006/main">
               <a:ext uri="{FF2B5EF4-FFF2-40B4-BE49-F238E27FC236}">
-                <a16:creationId xmlns:a16="http://schemas.microsoft.com/office/drawing/2014/main" id="{FF09279C-7BFB-4893-BB0E-935700396E06}"/>
+                <a16:creationId xmlns:a16="http://schemas.microsoft.com/office/drawing/2014/main" id="{8AB15CB5-6BB8-41AE-9CF8-CEFF2DBBFAD4}"/>
               </a:ext>
             </a:extLst>
           </p:cNvPr>
@@ -6524,7 +6394,7 @@
           <p:cNvPr id="14" name="">
             <a:extLst xmlns:a="http://schemas.openxmlformats.org/drawingml/2006/main">
               <a:ext uri="{FF2B5EF4-FFF2-40B4-BE49-F238E27FC236}">
-                <a16:creationId xmlns:a16="http://schemas.microsoft.com/office/drawing/2014/main" id="{A492D58D-251C-487F-9B9F-B4D710ED0EA8}"/>
+                <a16:creationId xmlns:a16="http://schemas.microsoft.com/office/drawing/2014/main" id="{F4204FAE-8625-4737-A75F-020131CC76C4}"/>
               </a:ext>
             </a:extLst>
           </p:cNvPr>
@@ -6574,7 +6444,7 @@
           <p:cNvPr id="15" name="">
             <a:extLst xmlns:a="http://schemas.openxmlformats.org/drawingml/2006/main">
               <a:ext uri="{FF2B5EF4-FFF2-40B4-BE49-F238E27FC236}">
-                <a16:creationId xmlns:a16="http://schemas.microsoft.com/office/drawing/2014/main" id="{6A97F8F9-003C-4648-92FD-C24815464FCF}"/>
+                <a16:creationId xmlns:a16="http://schemas.microsoft.com/office/drawing/2014/main" id="{63BF154A-18A1-464D-9C70-F898156187CC}"/>
               </a:ext>
             </a:extLst>
           </p:cNvPr>
@@ -6624,7 +6494,7 @@
           <p:cNvPr id="16" name="">
             <a:extLst xmlns:a="http://schemas.openxmlformats.org/drawingml/2006/main">
               <a:ext uri="{FF2B5EF4-FFF2-40B4-BE49-F238E27FC236}">
-                <a16:creationId xmlns:a16="http://schemas.microsoft.com/office/drawing/2014/main" id="{79F2B33E-55A9-4C60-B145-8F92D4295EBF}"/>
+                <a16:creationId xmlns:a16="http://schemas.microsoft.com/office/drawing/2014/main" id="{9F2ACA01-1E88-4558-9A79-4ED2EFAABE38}"/>
               </a:ext>
             </a:extLst>
           </p:cNvPr>
@@ -6655,7 +6525,7 @@
           <p:cNvPr id="17" name="">
             <a:extLst xmlns:a="http://schemas.openxmlformats.org/drawingml/2006/main">
               <a:ext uri="{FF2B5EF4-FFF2-40B4-BE49-F238E27FC236}">
-                <a16:creationId xmlns:a16="http://schemas.microsoft.com/office/drawing/2014/main" id="{0EE5789A-E375-48E1-B82E-647404833293}"/>
+                <a16:creationId xmlns:a16="http://schemas.microsoft.com/office/drawing/2014/main" id="{F5728583-C88F-4A5C-8295-1E47F25D36F8}"/>
               </a:ext>
             </a:extLst>
           </p:cNvPr>
@@ -6705,7 +6575,7 @@
           <p:cNvPr id="18" name="">
             <a:extLst xmlns:a="http://schemas.openxmlformats.org/drawingml/2006/main">
               <a:ext uri="{FF2B5EF4-FFF2-40B4-BE49-F238E27FC236}">
-                <a16:creationId xmlns:a16="http://schemas.microsoft.com/office/drawing/2014/main" id="{E2312C2D-BCB5-4063-9064-EDE4A7902863}"/>
+                <a16:creationId xmlns:a16="http://schemas.microsoft.com/office/drawing/2014/main" id="{1ED82C10-B73D-42E3-9C8B-F338B350A173}"/>
               </a:ext>
             </a:extLst>
           </p:cNvPr>
@@ -6736,7 +6606,7 @@
           <p:cNvPr id="19" name="">
             <a:extLst xmlns:a="http://schemas.openxmlformats.org/drawingml/2006/main">
               <a:ext uri="{FF2B5EF4-FFF2-40B4-BE49-F238E27FC236}">
-                <a16:creationId xmlns:a16="http://schemas.microsoft.com/office/drawing/2014/main" id="{C34035D1-7B79-4A78-86C6-763357D257BA}"/>
+                <a16:creationId xmlns:a16="http://schemas.microsoft.com/office/drawing/2014/main" id="{58F5D2AC-8B4C-4793-9237-774840315E22}"/>
               </a:ext>
             </a:extLst>
           </p:cNvPr>
@@ -6786,7 +6656,7 @@
           <p:cNvPr id="20" name="">
             <a:extLst xmlns:a="http://schemas.openxmlformats.org/drawingml/2006/main">
               <a:ext uri="{FF2B5EF4-FFF2-40B4-BE49-F238E27FC236}">
-                <a16:creationId xmlns:a16="http://schemas.microsoft.com/office/drawing/2014/main" id="{5558B40C-A631-4605-A466-15A3B0B9DE68}"/>
+                <a16:creationId xmlns:a16="http://schemas.microsoft.com/office/drawing/2014/main" id="{7BA47A70-ADA6-41B1-84F5-20BB2569CD56}"/>
               </a:ext>
             </a:extLst>
           </p:cNvPr>
@@ -6817,7 +6687,7 @@
           <p:cNvPr id="21" name="">
             <a:extLst xmlns:a="http://schemas.openxmlformats.org/drawingml/2006/main">
               <a:ext uri="{FF2B5EF4-FFF2-40B4-BE49-F238E27FC236}">
-                <a16:creationId xmlns:a16="http://schemas.microsoft.com/office/drawing/2014/main" id="{25A43CC6-2CF3-4A1C-BC7F-A6D6C3D40F79}"/>
+                <a16:creationId xmlns:a16="http://schemas.microsoft.com/office/drawing/2014/main" id="{66DC512F-9CEB-4806-9DCF-E2A0DD77D4F3}"/>
               </a:ext>
             </a:extLst>
           </p:cNvPr>
@@ -6867,7 +6737,7 @@
           <p:cNvPr id="22" name="">
             <a:extLst xmlns:a="http://schemas.openxmlformats.org/drawingml/2006/main">
               <a:ext uri="{FF2B5EF4-FFF2-40B4-BE49-F238E27FC236}">
-                <a16:creationId xmlns:a16="http://schemas.microsoft.com/office/drawing/2014/main" id="{EAC8EE79-ADF4-410F-A3D6-908AE0E810D9}"/>
+                <a16:creationId xmlns:a16="http://schemas.microsoft.com/office/drawing/2014/main" id="{9DE0AC4E-1875-432A-9B0B-5E3FFBABC6EC}"/>
               </a:ext>
             </a:extLst>
           </p:cNvPr>
@@ -6898,7 +6768,7 @@
           <p:cNvPr id="23" name="">
             <a:extLst xmlns:a="http://schemas.openxmlformats.org/drawingml/2006/main">
               <a:ext uri="{FF2B5EF4-FFF2-40B4-BE49-F238E27FC236}">
-                <a16:creationId xmlns:a16="http://schemas.microsoft.com/office/drawing/2014/main" id="{F6207350-42D5-47B9-9EEB-41062BCD6FB6}"/>
+                <a16:creationId xmlns:a16="http://schemas.microsoft.com/office/drawing/2014/main" id="{EB2006C0-F35E-477B-9507-6B1BAB98F38D}"/>
               </a:ext>
             </a:extLst>
           </p:cNvPr>
@@ -6946,7 +6816,7 @@
     </p:spTree>
     <p:extLst>
       <p:ext uri="{BB962C8B-B14F-4D97-AF65-F5344CB8AC3E}">
-        <p14:creationId xmlns:p14="http://schemas.microsoft.com/office/powerpoint/2010/main" val="1204216313"/>
+        <p14:creationId xmlns:p14="http://schemas.microsoft.com/office/powerpoint/2010/main" val="1342476029"/>
       </p:ext>
     </p:extLst>
   </p:cSld>
@@ -6977,7 +6847,7 @@
           <p:cNvPr id="24" name="">
             <a:extLst xmlns:a="http://schemas.openxmlformats.org/drawingml/2006/main">
               <a:ext uri="{FF2B5EF4-FFF2-40B4-BE49-F238E27FC236}">
-                <a16:creationId xmlns:a16="http://schemas.microsoft.com/office/drawing/2014/main" id="{826D833F-98CE-4002-867F-B3FC37EA215C}"/>
+                <a16:creationId xmlns:a16="http://schemas.microsoft.com/office/drawing/2014/main" id="{431C9A3F-18A3-4CB9-A63A-C77280C73CB0}"/>
               </a:ext>
             </a:extLst>
           </p:cNvPr>
@@ -7027,7 +6897,7 @@
           <p:cNvPr id="2" name="">
             <a:extLst xmlns:a="http://schemas.openxmlformats.org/drawingml/2006/main">
               <a:ext uri="{FF2B5EF4-FFF2-40B4-BE49-F238E27FC236}">
-                <a16:creationId xmlns:a16="http://schemas.microsoft.com/office/drawing/2014/main" id="{01A63265-E791-4C14-8967-7B63F146CDDE}"/>
+                <a16:creationId xmlns:a16="http://schemas.microsoft.com/office/drawing/2014/main" id="{E4A0A787-A7D5-4230-90C1-2DC5E02AAB13}"/>
               </a:ext>
             </a:extLst>
           </p:cNvPr>
@@ -7077,7 +6947,7 @@
           <p:cNvPr id="3" name="">
             <a:extLst xmlns:a="http://schemas.openxmlformats.org/drawingml/2006/main">
               <a:ext uri="{FF2B5EF4-FFF2-40B4-BE49-F238E27FC236}">
-                <a16:creationId xmlns:a16="http://schemas.microsoft.com/office/drawing/2014/main" id="{4EAA57E9-4CD1-412D-99AD-DDC4295BFFA7}"/>
+                <a16:creationId xmlns:a16="http://schemas.microsoft.com/office/drawing/2014/main" id="{A9B011F3-8147-47ED-961D-87DA7F0BCC14}"/>
               </a:ext>
             </a:extLst>
           </p:cNvPr>
@@ -7108,7 +6978,7 @@
           <p:cNvPr id="4" name="">
             <a:extLst xmlns:a="http://schemas.openxmlformats.org/drawingml/2006/main">
               <a:ext uri="{FF2B5EF4-FFF2-40B4-BE49-F238E27FC236}">
-                <a16:creationId xmlns:a16="http://schemas.microsoft.com/office/drawing/2014/main" id="{1990F114-C200-427F-88E1-6691D6E5DDFE}"/>
+                <a16:creationId xmlns:a16="http://schemas.microsoft.com/office/drawing/2014/main" id="{2A29D524-FADA-422D-9880-91095E7F0A2F}"/>
               </a:ext>
             </a:extLst>
           </p:cNvPr>
@@ -7158,7 +7028,7 @@
           <p:cNvPr id="5" name="">
             <a:extLst xmlns:a="http://schemas.openxmlformats.org/drawingml/2006/main">
               <a:ext uri="{FF2B5EF4-FFF2-40B4-BE49-F238E27FC236}">
-                <a16:creationId xmlns:a16="http://schemas.microsoft.com/office/drawing/2014/main" id="{E2C55418-D608-474D-858E-5EFD86373009}"/>
+                <a16:creationId xmlns:a16="http://schemas.microsoft.com/office/drawing/2014/main" id="{93D7A4F2-DABD-4D08-B6B8-91D02454874B}"/>
               </a:ext>
             </a:extLst>
           </p:cNvPr>
@@ -7208,7 +7078,7 @@
           <p:cNvPr id="6" name="">
             <a:extLst xmlns:a="http://schemas.openxmlformats.org/drawingml/2006/main">
               <a:ext uri="{FF2B5EF4-FFF2-40B4-BE49-F238E27FC236}">
-                <a16:creationId xmlns:a16="http://schemas.microsoft.com/office/drawing/2014/main" id="{AC0F58CD-7577-4696-BA49-DB7271DC281B}"/>
+                <a16:creationId xmlns:a16="http://schemas.microsoft.com/office/drawing/2014/main" id="{F26BE6A1-6A24-4B65-81BE-DEA24FF79CFB}"/>
               </a:ext>
             </a:extLst>
           </p:cNvPr>
@@ -7258,7 +7128,7 @@
           <p:cNvPr id="7" name="">
             <a:extLst xmlns:a="http://schemas.openxmlformats.org/drawingml/2006/main">
               <a:ext uri="{FF2B5EF4-FFF2-40B4-BE49-F238E27FC236}">
-                <a16:creationId xmlns:a16="http://schemas.microsoft.com/office/drawing/2014/main" id="{531FB41C-E020-41F0-925B-53FEF492981C}"/>
+                <a16:creationId xmlns:a16="http://schemas.microsoft.com/office/drawing/2014/main" id="{819BF5C4-B0FB-4016-B3CF-177B0E49E1E8}"/>
               </a:ext>
             </a:extLst>
           </p:cNvPr>
@@ -7289,7 +7159,7 @@
           <p:cNvPr id="8" name="">
             <a:extLst xmlns:a="http://schemas.openxmlformats.org/drawingml/2006/main">
               <a:ext uri="{FF2B5EF4-FFF2-40B4-BE49-F238E27FC236}">
-                <a16:creationId xmlns:a16="http://schemas.microsoft.com/office/drawing/2014/main" id="{3A572722-2873-4D6D-834C-5995493D18A0}"/>
+                <a16:creationId xmlns:a16="http://schemas.microsoft.com/office/drawing/2014/main" id="{2B408AB8-93C7-471A-8C5D-45443BF37311}"/>
               </a:ext>
             </a:extLst>
           </p:cNvPr>
@@ -7339,7 +7209,7 @@
           <p:cNvPr id="9" name="">
             <a:extLst xmlns:a="http://schemas.openxmlformats.org/drawingml/2006/main">
               <a:ext uri="{FF2B5EF4-FFF2-40B4-BE49-F238E27FC236}">
-                <a16:creationId xmlns:a16="http://schemas.microsoft.com/office/drawing/2014/main" id="{7C80D6FC-05FF-470C-B67C-9CAA42CAE9B2}"/>
+                <a16:creationId xmlns:a16="http://schemas.microsoft.com/office/drawing/2014/main" id="{E8E7779E-D152-444A-8506-C4C7DD7D9FBB}"/>
               </a:ext>
             </a:extLst>
           </p:cNvPr>
@@ -7370,7 +7240,7 @@
           <p:cNvPr id="10" name="">
             <a:extLst xmlns:a="http://schemas.openxmlformats.org/drawingml/2006/main">
               <a:ext uri="{FF2B5EF4-FFF2-40B4-BE49-F238E27FC236}">
-                <a16:creationId xmlns:a16="http://schemas.microsoft.com/office/drawing/2014/main" id="{1F9F8498-A222-48E5-8CB8-8400519DEC2D}"/>
+                <a16:creationId xmlns:a16="http://schemas.microsoft.com/office/drawing/2014/main" id="{A5772B48-68CF-4442-A2E2-74C17FD4C188}"/>
               </a:ext>
             </a:extLst>
           </p:cNvPr>
@@ -7420,7 +7290,7 @@
           <p:cNvPr id="11" name="">
             <a:extLst xmlns:a="http://schemas.openxmlformats.org/drawingml/2006/main">
               <a:ext uri="{FF2B5EF4-FFF2-40B4-BE49-F238E27FC236}">
-                <a16:creationId xmlns:a16="http://schemas.microsoft.com/office/drawing/2014/main" id="{70AD1477-F456-46A2-996C-98A0CDEB5302}"/>
+                <a16:creationId xmlns:a16="http://schemas.microsoft.com/office/drawing/2014/main" id="{976FC72B-0613-4ECA-8B59-5AE2C74852E5}"/>
               </a:ext>
             </a:extLst>
           </p:cNvPr>
@@ -7451,7 +7321,7 @@
           <p:cNvPr id="12" name="">
             <a:extLst xmlns:a="http://schemas.openxmlformats.org/drawingml/2006/main">
               <a:ext uri="{FF2B5EF4-FFF2-40B4-BE49-F238E27FC236}">
-                <a16:creationId xmlns:a16="http://schemas.microsoft.com/office/drawing/2014/main" id="{97FD80F1-42F6-4100-8320-D6A05772C62F}"/>
+                <a16:creationId xmlns:a16="http://schemas.microsoft.com/office/drawing/2014/main" id="{07E684E2-B53A-4B9E-8BF2-4D17CFDA8DC7}"/>
               </a:ext>
             </a:extLst>
           </p:cNvPr>
@@ -7501,7 +7371,7 @@
           <p:cNvPr id="13" name="">
             <a:extLst xmlns:a="http://schemas.openxmlformats.org/drawingml/2006/main">
               <a:ext uri="{FF2B5EF4-FFF2-40B4-BE49-F238E27FC236}">
-                <a16:creationId xmlns:a16="http://schemas.microsoft.com/office/drawing/2014/main" id="{43478A4A-E106-4420-B0F5-A2D6D9706B7B}"/>
+                <a16:creationId xmlns:a16="http://schemas.microsoft.com/office/drawing/2014/main" id="{B0DB8E7A-2CC5-45C4-9876-DF7AD5F401B8}"/>
               </a:ext>
             </a:extLst>
           </p:cNvPr>
@@ -7532,7 +7402,7 @@
           <p:cNvPr id="14" name="">
             <a:extLst xmlns:a="http://schemas.openxmlformats.org/drawingml/2006/main">
               <a:ext uri="{FF2B5EF4-FFF2-40B4-BE49-F238E27FC236}">
-                <a16:creationId xmlns:a16="http://schemas.microsoft.com/office/drawing/2014/main" id="{E097EF49-469F-4F90-A378-32097D489067}"/>
+                <a16:creationId xmlns:a16="http://schemas.microsoft.com/office/drawing/2014/main" id="{1B0897EF-4063-4CE7-B4D0-C0E86631E391}"/>
               </a:ext>
             </a:extLst>
           </p:cNvPr>
@@ -7582,7 +7452,7 @@
           <p:cNvPr id="15" name="">
             <a:extLst xmlns:a="http://schemas.openxmlformats.org/drawingml/2006/main">
               <a:ext uri="{FF2B5EF4-FFF2-40B4-BE49-F238E27FC236}">
-                <a16:creationId xmlns:a16="http://schemas.microsoft.com/office/drawing/2014/main" id="{7C9CEC26-24D9-4B3A-8643-27DC7642B64A}"/>
+                <a16:creationId xmlns:a16="http://schemas.microsoft.com/office/drawing/2014/main" id="{D3C910C7-1381-4E4E-95A9-3A168708B757}"/>
               </a:ext>
             </a:extLst>
           </p:cNvPr>
@@ -7632,7 +7502,7 @@
           <p:cNvPr id="16" name="">
             <a:extLst xmlns:a="http://schemas.openxmlformats.org/drawingml/2006/main">
               <a:ext uri="{FF2B5EF4-FFF2-40B4-BE49-F238E27FC236}">
-                <a16:creationId xmlns:a16="http://schemas.microsoft.com/office/drawing/2014/main" id="{6366DD05-4322-482A-9B98-264BAE1A4B13}"/>
+                <a16:creationId xmlns:a16="http://schemas.microsoft.com/office/drawing/2014/main" id="{B4487650-9B6B-4AD5-8B31-E0EBF7814374}"/>
               </a:ext>
             </a:extLst>
           </p:cNvPr>
@@ -7663,7 +7533,7 @@
           <p:cNvPr id="17" name="">
             <a:extLst xmlns:a="http://schemas.openxmlformats.org/drawingml/2006/main">
               <a:ext uri="{FF2B5EF4-FFF2-40B4-BE49-F238E27FC236}">
-                <a16:creationId xmlns:a16="http://schemas.microsoft.com/office/drawing/2014/main" id="{0F49102D-E7C9-4337-B9CB-720CDAC70614}"/>
+                <a16:creationId xmlns:a16="http://schemas.microsoft.com/office/drawing/2014/main" id="{68A55EA5-6373-4A94-8D98-2ACF1943B7D6}"/>
               </a:ext>
             </a:extLst>
           </p:cNvPr>
@@ -7713,7 +7583,7 @@
           <p:cNvPr id="18" name="">
             <a:extLst xmlns:a="http://schemas.openxmlformats.org/drawingml/2006/main">
               <a:ext uri="{FF2B5EF4-FFF2-40B4-BE49-F238E27FC236}">
-                <a16:creationId xmlns:a16="http://schemas.microsoft.com/office/drawing/2014/main" id="{476E36EC-FFD0-4243-A358-471F3F2D7D41}"/>
+                <a16:creationId xmlns:a16="http://schemas.microsoft.com/office/drawing/2014/main" id="{67EAC199-DD18-4A0D-BAB7-F940CE304E92}"/>
               </a:ext>
             </a:extLst>
           </p:cNvPr>
@@ -7744,7 +7614,7 @@
           <p:cNvPr id="19" name="">
             <a:extLst xmlns:a="http://schemas.openxmlformats.org/drawingml/2006/main">
               <a:ext uri="{FF2B5EF4-FFF2-40B4-BE49-F238E27FC236}">
-                <a16:creationId xmlns:a16="http://schemas.microsoft.com/office/drawing/2014/main" id="{84030BC7-4D12-42E5-B60C-48045FEEB876}"/>
+                <a16:creationId xmlns:a16="http://schemas.microsoft.com/office/drawing/2014/main" id="{C9FBCEE8-1DD8-48A0-8523-82E36AD81E80}"/>
               </a:ext>
             </a:extLst>
           </p:cNvPr>
@@ -7794,7 +7664,7 @@
           <p:cNvPr id="20" name="">
             <a:extLst xmlns:a="http://schemas.openxmlformats.org/drawingml/2006/main">
               <a:ext uri="{FF2B5EF4-FFF2-40B4-BE49-F238E27FC236}">
-                <a16:creationId xmlns:a16="http://schemas.microsoft.com/office/drawing/2014/main" id="{DD5ED9DC-0A9F-445E-B11C-9696AEA2F510}"/>
+                <a16:creationId xmlns:a16="http://schemas.microsoft.com/office/drawing/2014/main" id="{26948D20-7B6C-4C58-89A7-0030071C72F2}"/>
               </a:ext>
             </a:extLst>
           </p:cNvPr>
@@ -7825,7 +7695,7 @@
           <p:cNvPr id="21" name="">
             <a:extLst xmlns:a="http://schemas.openxmlformats.org/drawingml/2006/main">
               <a:ext uri="{FF2B5EF4-FFF2-40B4-BE49-F238E27FC236}">
-                <a16:creationId xmlns:a16="http://schemas.microsoft.com/office/drawing/2014/main" id="{5D08B62B-8D9B-4712-828B-46E5A35B152D}"/>
+                <a16:creationId xmlns:a16="http://schemas.microsoft.com/office/drawing/2014/main" id="{2E87FB2B-82BE-46F7-A5B6-A24FEED87710}"/>
               </a:ext>
             </a:extLst>
           </p:cNvPr>
@@ -7875,7 +7745,7 @@
           <p:cNvPr id="22" name="">
             <a:extLst xmlns:a="http://schemas.openxmlformats.org/drawingml/2006/main">
               <a:ext uri="{FF2B5EF4-FFF2-40B4-BE49-F238E27FC236}">
-                <a16:creationId xmlns:a16="http://schemas.microsoft.com/office/drawing/2014/main" id="{930C3239-DA41-4ADC-A4CF-268BFEEF9A2E}"/>
+                <a16:creationId xmlns:a16="http://schemas.microsoft.com/office/drawing/2014/main" id="{8639E509-333F-4B30-9A5D-5F2FAD183C9D}"/>
               </a:ext>
             </a:extLst>
           </p:cNvPr>
@@ -7906,7 +7776,7 @@
           <p:cNvPr id="23" name="">
             <a:extLst xmlns:a="http://schemas.openxmlformats.org/drawingml/2006/main">
               <a:ext uri="{FF2B5EF4-FFF2-40B4-BE49-F238E27FC236}">
-                <a16:creationId xmlns:a16="http://schemas.microsoft.com/office/drawing/2014/main" id="{BC30DF5D-28B7-4A8F-AEB2-14CE3ACFDC90}"/>
+                <a16:creationId xmlns:a16="http://schemas.microsoft.com/office/drawing/2014/main" id="{A96B471A-8C55-473A-8D31-470433AD556A}"/>
               </a:ext>
             </a:extLst>
           </p:cNvPr>
@@ -7954,7 +7824,7 @@
     </p:spTree>
     <p:extLst>
       <p:ext uri="{BB962C8B-B14F-4D97-AF65-F5344CB8AC3E}">
-        <p14:creationId xmlns:p14="http://schemas.microsoft.com/office/powerpoint/2010/main" val="369303177"/>
+        <p14:creationId xmlns:p14="http://schemas.microsoft.com/office/powerpoint/2010/main" val="80758510"/>
       </p:ext>
     </p:extLst>
   </p:cSld>
@@ -7985,7 +7855,7 @@
           <p:cNvPr id="24" name="">
             <a:extLst xmlns:a="http://schemas.openxmlformats.org/drawingml/2006/main">
               <a:ext uri="{FF2B5EF4-FFF2-40B4-BE49-F238E27FC236}">
-                <a16:creationId xmlns:a16="http://schemas.microsoft.com/office/drawing/2014/main" id="{F279A5BD-BA52-41A1-9000-6CE0F07D650F}"/>
+                <a16:creationId xmlns:a16="http://schemas.microsoft.com/office/drawing/2014/main" id="{37C88C0C-97A4-422F-8CEB-FD0C49A09C33}"/>
               </a:ext>
             </a:extLst>
           </p:cNvPr>
@@ -8035,7 +7905,7 @@
           <p:cNvPr id="2" name="">
             <a:extLst xmlns:a="http://schemas.openxmlformats.org/drawingml/2006/main">
               <a:ext uri="{FF2B5EF4-FFF2-40B4-BE49-F238E27FC236}">
-                <a16:creationId xmlns:a16="http://schemas.microsoft.com/office/drawing/2014/main" id="{A5B677B0-932A-406E-B155-4AD8A7E2B6CF}"/>
+                <a16:creationId xmlns:a16="http://schemas.microsoft.com/office/drawing/2014/main" id="{7771BA91-385D-47BA-9ECD-089C9C60ACA9}"/>
               </a:ext>
             </a:extLst>
           </p:cNvPr>
@@ -8085,7 +7955,7 @@
           <p:cNvPr id="3" name="">
             <a:extLst xmlns:a="http://schemas.openxmlformats.org/drawingml/2006/main">
               <a:ext uri="{FF2B5EF4-FFF2-40B4-BE49-F238E27FC236}">
-                <a16:creationId xmlns:a16="http://schemas.microsoft.com/office/drawing/2014/main" id="{7AA20A63-47C3-4ED5-B0E7-C267941B8F17}"/>
+                <a16:creationId xmlns:a16="http://schemas.microsoft.com/office/drawing/2014/main" id="{FB5F2DFC-A972-4F1A-A100-4FBEA61917BB}"/>
               </a:ext>
             </a:extLst>
           </p:cNvPr>
@@ -8116,7 +7986,7 @@
           <p:cNvPr id="4" name="">
             <a:extLst xmlns:a="http://schemas.openxmlformats.org/drawingml/2006/main">
               <a:ext uri="{FF2B5EF4-FFF2-40B4-BE49-F238E27FC236}">
-                <a16:creationId xmlns:a16="http://schemas.microsoft.com/office/drawing/2014/main" id="{5ADCA52C-770C-437F-9170-FD2E738266FC}"/>
+                <a16:creationId xmlns:a16="http://schemas.microsoft.com/office/drawing/2014/main" id="{828D8AD4-6923-4CB6-BA9E-92849990EA76}"/>
               </a:ext>
             </a:extLst>
           </p:cNvPr>
@@ -8166,7 +8036,7 @@
           <p:cNvPr id="5" name="">
             <a:extLst xmlns:a="http://schemas.openxmlformats.org/drawingml/2006/main">
               <a:ext uri="{FF2B5EF4-FFF2-40B4-BE49-F238E27FC236}">
-                <a16:creationId xmlns:a16="http://schemas.microsoft.com/office/drawing/2014/main" id="{6F50E19C-D394-4F0E-82F1-4CFB8CAF3AE8}"/>
+                <a16:creationId xmlns:a16="http://schemas.microsoft.com/office/drawing/2014/main" id="{E4D9D102-3663-4B00-8A72-2FFE2ED34FBA}"/>
               </a:ext>
             </a:extLst>
           </p:cNvPr>
@@ -8216,7 +8086,7 @@
           <p:cNvPr id="6" name="">
             <a:extLst xmlns:a="http://schemas.openxmlformats.org/drawingml/2006/main">
               <a:ext uri="{FF2B5EF4-FFF2-40B4-BE49-F238E27FC236}">
-                <a16:creationId xmlns:a16="http://schemas.microsoft.com/office/drawing/2014/main" id="{C21C03D2-B95C-4F17-BA73-0F8DCFF2A195}"/>
+                <a16:creationId xmlns:a16="http://schemas.microsoft.com/office/drawing/2014/main" id="{535B91B6-34F2-4BA8-A4F7-1AD6B74BBD14}"/>
               </a:ext>
             </a:extLst>
           </p:cNvPr>
@@ -8270,7 +8140,7 @@
           <p:cNvPr id="7" name="">
             <a:extLst xmlns:a="http://schemas.openxmlformats.org/drawingml/2006/main">
               <a:ext uri="{FF2B5EF4-FFF2-40B4-BE49-F238E27FC236}">
-                <a16:creationId xmlns:a16="http://schemas.microsoft.com/office/drawing/2014/main" id="{2B7DDA25-C522-4DE5-909A-7A3A1917820D}"/>
+                <a16:creationId xmlns:a16="http://schemas.microsoft.com/office/drawing/2014/main" id="{CA153D57-CAF1-41B3-8EC4-940C09AFBA6A}"/>
               </a:ext>
             </a:extLst>
           </p:cNvPr>
@@ -8320,7 +8190,7 @@
           <p:cNvPr id="8" name="">
             <a:extLst xmlns:a="http://schemas.openxmlformats.org/drawingml/2006/main">
               <a:ext uri="{FF2B5EF4-FFF2-40B4-BE49-F238E27FC236}">
-                <a16:creationId xmlns:a16="http://schemas.microsoft.com/office/drawing/2014/main" id="{B2100202-F6EB-4872-84A8-15A3DDDDEB56}"/>
+                <a16:creationId xmlns:a16="http://schemas.microsoft.com/office/drawing/2014/main" id="{7D57BAAE-C165-4745-B7F2-7A67724B9D49}"/>
               </a:ext>
             </a:extLst>
           </p:cNvPr>
@@ -8370,7 +8240,7 @@
           <p:cNvPr id="9" name="">
             <a:extLst xmlns:a="http://schemas.openxmlformats.org/drawingml/2006/main">
               <a:ext uri="{FF2B5EF4-FFF2-40B4-BE49-F238E27FC236}">
-                <a16:creationId xmlns:a16="http://schemas.microsoft.com/office/drawing/2014/main" id="{F91ED8C4-3A04-4EC2-AC12-B266D906DA9A}"/>
+                <a16:creationId xmlns:a16="http://schemas.microsoft.com/office/drawing/2014/main" id="{1B9380AF-4F64-4180-B025-779A66178E17}"/>
               </a:ext>
             </a:extLst>
           </p:cNvPr>
@@ -8424,7 +8294,7 @@
           <p:cNvPr id="10" name="">
             <a:extLst xmlns:a="http://schemas.openxmlformats.org/drawingml/2006/main">
               <a:ext uri="{FF2B5EF4-FFF2-40B4-BE49-F238E27FC236}">
-                <a16:creationId xmlns:a16="http://schemas.microsoft.com/office/drawing/2014/main" id="{3B1672A4-315E-4095-873B-0E2496107112}"/>
+                <a16:creationId xmlns:a16="http://schemas.microsoft.com/office/drawing/2014/main" id="{8204B58A-0590-4CFF-9288-7C57106EFFF3}"/>
               </a:ext>
             </a:extLst>
           </p:cNvPr>
@@ -8474,7 +8344,7 @@
           <p:cNvPr id="11" name="">
             <a:extLst xmlns:a="http://schemas.openxmlformats.org/drawingml/2006/main">
               <a:ext uri="{FF2B5EF4-FFF2-40B4-BE49-F238E27FC236}">
-                <a16:creationId xmlns:a16="http://schemas.microsoft.com/office/drawing/2014/main" id="{ADE4CD87-C9FE-4E31-9464-6CC6CB7AE9EC}"/>
+                <a16:creationId xmlns:a16="http://schemas.microsoft.com/office/drawing/2014/main" id="{ADDF1169-8CF9-4FEC-ACDA-6DB2E4CA0A2A}"/>
               </a:ext>
             </a:extLst>
           </p:cNvPr>
@@ -8524,7 +8394,7 @@
           <p:cNvPr id="12" name="">
             <a:extLst xmlns:a="http://schemas.openxmlformats.org/drawingml/2006/main">
               <a:ext uri="{FF2B5EF4-FFF2-40B4-BE49-F238E27FC236}">
-                <a16:creationId xmlns:a16="http://schemas.microsoft.com/office/drawing/2014/main" id="{D6DAA589-9DEB-444D-A6DE-AF9E63EBB9D3}"/>
+                <a16:creationId xmlns:a16="http://schemas.microsoft.com/office/drawing/2014/main" id="{CE7B98DD-6387-47D9-B257-6268C1360FED}"/>
               </a:ext>
             </a:extLst>
           </p:cNvPr>
@@ -8578,7 +8448,7 @@
           <p:cNvPr id="13" name="">
             <a:extLst xmlns:a="http://schemas.openxmlformats.org/drawingml/2006/main">
               <a:ext uri="{FF2B5EF4-FFF2-40B4-BE49-F238E27FC236}">
-                <a16:creationId xmlns:a16="http://schemas.microsoft.com/office/drawing/2014/main" id="{92645837-2C94-43D9-A62C-5227BAAACD73}"/>
+                <a16:creationId xmlns:a16="http://schemas.microsoft.com/office/drawing/2014/main" id="{7FFCF7BD-0801-4BB5-804E-4005B8BE36E8}"/>
               </a:ext>
             </a:extLst>
           </p:cNvPr>
@@ -8628,7 +8498,7 @@
           <p:cNvPr id="14" name="">
             <a:extLst xmlns:a="http://schemas.openxmlformats.org/drawingml/2006/main">
               <a:ext uri="{FF2B5EF4-FFF2-40B4-BE49-F238E27FC236}">
-                <a16:creationId xmlns:a16="http://schemas.microsoft.com/office/drawing/2014/main" id="{D7CAA340-7F66-40BD-B515-2CD86A686DB4}"/>
+                <a16:creationId xmlns:a16="http://schemas.microsoft.com/office/drawing/2014/main" id="{F00506BA-913D-450C-9E78-9018D994E4AE}"/>
               </a:ext>
             </a:extLst>
           </p:cNvPr>
@@ -8678,7 +8548,7 @@
           <p:cNvPr id="15" name="">
             <a:extLst xmlns:a="http://schemas.openxmlformats.org/drawingml/2006/main">
               <a:ext uri="{FF2B5EF4-FFF2-40B4-BE49-F238E27FC236}">
-                <a16:creationId xmlns:a16="http://schemas.microsoft.com/office/drawing/2014/main" id="{06EE6EFA-336F-43C6-9C57-78D6D8B33833}"/>
+                <a16:creationId xmlns:a16="http://schemas.microsoft.com/office/drawing/2014/main" id="{A5DF3B42-31E1-4AF5-80F3-ECCFF0C80B46}"/>
               </a:ext>
             </a:extLst>
           </p:cNvPr>
@@ -8732,7 +8602,7 @@
           <p:cNvPr id="16" name="">
             <a:extLst xmlns:a="http://schemas.openxmlformats.org/drawingml/2006/main">
               <a:ext uri="{FF2B5EF4-FFF2-40B4-BE49-F238E27FC236}">
-                <a16:creationId xmlns:a16="http://schemas.microsoft.com/office/drawing/2014/main" id="{395FA955-7442-4E4E-BA84-8E8B48EC0626}"/>
+                <a16:creationId xmlns:a16="http://schemas.microsoft.com/office/drawing/2014/main" id="{B1DA61FE-C19C-41B3-8B37-9C3E505715B5}"/>
               </a:ext>
             </a:extLst>
           </p:cNvPr>
@@ -8782,7 +8652,7 @@
           <p:cNvPr id="17" name="">
             <a:extLst xmlns:a="http://schemas.openxmlformats.org/drawingml/2006/main">
               <a:ext uri="{FF2B5EF4-FFF2-40B4-BE49-F238E27FC236}">
-                <a16:creationId xmlns:a16="http://schemas.microsoft.com/office/drawing/2014/main" id="{9D3B50D1-7295-41FD-9035-E8A7B80D43A9}"/>
+                <a16:creationId xmlns:a16="http://schemas.microsoft.com/office/drawing/2014/main" id="{49875AC0-4733-4D62-A846-CF73AFF0C8B9}"/>
               </a:ext>
             </a:extLst>
           </p:cNvPr>
@@ -8832,7 +8702,7 @@
           <p:cNvPr id="18" name="">
             <a:extLst xmlns:a="http://schemas.openxmlformats.org/drawingml/2006/main">
               <a:ext uri="{FF2B5EF4-FFF2-40B4-BE49-F238E27FC236}">
-                <a16:creationId xmlns:a16="http://schemas.microsoft.com/office/drawing/2014/main" id="{0C40C0EC-8C8A-4970-969E-463A7ACC5256}"/>
+                <a16:creationId xmlns:a16="http://schemas.microsoft.com/office/drawing/2014/main" id="{F27EA630-609C-4D96-BB6C-465B10C254D4}"/>
               </a:ext>
             </a:extLst>
           </p:cNvPr>
@@ -8886,7 +8756,7 @@
           <p:cNvPr id="19" name="">
             <a:extLst xmlns:a="http://schemas.openxmlformats.org/drawingml/2006/main">
               <a:ext uri="{FF2B5EF4-FFF2-40B4-BE49-F238E27FC236}">
-                <a16:creationId xmlns:a16="http://schemas.microsoft.com/office/drawing/2014/main" id="{C3E8DB97-D182-4A43-8651-DCD1E4942501}"/>
+                <a16:creationId xmlns:a16="http://schemas.microsoft.com/office/drawing/2014/main" id="{2B24C375-478A-42AC-B977-D904602EFACF}"/>
               </a:ext>
             </a:extLst>
           </p:cNvPr>
@@ -8936,7 +8806,7 @@
           <p:cNvPr id="20" name="">
             <a:extLst xmlns:a="http://schemas.openxmlformats.org/drawingml/2006/main">
               <a:ext uri="{FF2B5EF4-FFF2-40B4-BE49-F238E27FC236}">
-                <a16:creationId xmlns:a16="http://schemas.microsoft.com/office/drawing/2014/main" id="{27B8BFE3-BF93-421D-9B95-1D6972A21985}"/>
+                <a16:creationId xmlns:a16="http://schemas.microsoft.com/office/drawing/2014/main" id="{716F41BE-BD4C-43AE-9691-2F2D9C4724B5}"/>
               </a:ext>
             </a:extLst>
           </p:cNvPr>
@@ -8986,7 +8856,7 @@
           <p:cNvPr id="21" name="">
             <a:extLst xmlns:a="http://schemas.openxmlformats.org/drawingml/2006/main">
               <a:ext uri="{FF2B5EF4-FFF2-40B4-BE49-F238E27FC236}">
-                <a16:creationId xmlns:a16="http://schemas.microsoft.com/office/drawing/2014/main" id="{96CC20AB-F633-4D69-9CE0-264D6C5F00B4}"/>
+                <a16:creationId xmlns:a16="http://schemas.microsoft.com/office/drawing/2014/main" id="{B24A4979-D048-43B7-BCA2-25E3421F13DF}"/>
               </a:ext>
             </a:extLst>
           </p:cNvPr>
@@ -9040,7 +8910,7 @@
           <p:cNvPr id="22" name="">
             <a:extLst xmlns:a="http://schemas.openxmlformats.org/drawingml/2006/main">
               <a:ext uri="{FF2B5EF4-FFF2-40B4-BE49-F238E27FC236}">
-                <a16:creationId xmlns:a16="http://schemas.microsoft.com/office/drawing/2014/main" id="{3172C0DF-246F-4ABD-8E8D-85B127EDC2D0}"/>
+                <a16:creationId xmlns:a16="http://schemas.microsoft.com/office/drawing/2014/main" id="{71BB3C9C-D379-482F-B42F-EDC5190438B4}"/>
               </a:ext>
             </a:extLst>
           </p:cNvPr>
@@ -9090,7 +8960,7 @@
           <p:cNvPr id="23" name="">
             <a:extLst xmlns:a="http://schemas.openxmlformats.org/drawingml/2006/main">
               <a:ext uri="{FF2B5EF4-FFF2-40B4-BE49-F238E27FC236}">
-                <a16:creationId xmlns:a16="http://schemas.microsoft.com/office/drawing/2014/main" id="{86599A1B-7BEB-4A4E-8C83-D72818E1CAEB}"/>
+                <a16:creationId xmlns:a16="http://schemas.microsoft.com/office/drawing/2014/main" id="{EC8A9622-DD4E-4109-985F-40BF25EE6E57}"/>
               </a:ext>
             </a:extLst>
           </p:cNvPr>
@@ -9138,7 +9008,7 @@
     </p:spTree>
     <p:extLst>
       <p:ext uri="{BB962C8B-B14F-4D97-AF65-F5344CB8AC3E}">
-        <p14:creationId xmlns:p14="http://schemas.microsoft.com/office/powerpoint/2010/main" val="28090016"/>
+        <p14:creationId xmlns:p14="http://schemas.microsoft.com/office/powerpoint/2010/main" val="882471360"/>
       </p:ext>
     </p:extLst>
   </p:cSld>
@@ -9169,7 +9039,7 @@
           <p:cNvPr id="21" name="">
             <a:extLst xmlns:a="http://schemas.openxmlformats.org/drawingml/2006/main">
               <a:ext uri="{FF2B5EF4-FFF2-40B4-BE49-F238E27FC236}">
-                <a16:creationId xmlns:a16="http://schemas.microsoft.com/office/drawing/2014/main" id="{742FD129-59DA-4E05-998C-CDDB36D54974}"/>
+                <a16:creationId xmlns:a16="http://schemas.microsoft.com/office/drawing/2014/main" id="{5EB2C549-A467-43A2-A3DA-EF94C337C092}"/>
               </a:ext>
             </a:extLst>
           </p:cNvPr>
@@ -9219,7 +9089,7 @@
           <p:cNvPr id="2" name="">
             <a:extLst xmlns:a="http://schemas.openxmlformats.org/drawingml/2006/main">
               <a:ext uri="{FF2B5EF4-FFF2-40B4-BE49-F238E27FC236}">
-                <a16:creationId xmlns:a16="http://schemas.microsoft.com/office/drawing/2014/main" id="{86E1D618-AA0C-4903-858F-A7DBD998CB3E}"/>
+                <a16:creationId xmlns:a16="http://schemas.microsoft.com/office/drawing/2014/main" id="{623C7B63-EFBE-49AD-9F11-A75E04FFB506}"/>
               </a:ext>
             </a:extLst>
           </p:cNvPr>
@@ -9269,7 +9139,7 @@
           <p:cNvPr id="3" name="">
             <a:extLst xmlns:a="http://schemas.openxmlformats.org/drawingml/2006/main">
               <a:ext uri="{FF2B5EF4-FFF2-40B4-BE49-F238E27FC236}">
-                <a16:creationId xmlns:a16="http://schemas.microsoft.com/office/drawing/2014/main" id="{904E1687-7C6D-4C84-9FF5-E005783C47A8}"/>
+                <a16:creationId xmlns:a16="http://schemas.microsoft.com/office/drawing/2014/main" id="{F0755A52-E0B1-453C-96A6-64FE94F60A01}"/>
               </a:ext>
             </a:extLst>
           </p:cNvPr>
@@ -9300,7 +9170,7 @@
           <p:cNvPr id="4" name="">
             <a:extLst xmlns:a="http://schemas.openxmlformats.org/drawingml/2006/main">
               <a:ext uri="{FF2B5EF4-FFF2-40B4-BE49-F238E27FC236}">
-                <a16:creationId xmlns:a16="http://schemas.microsoft.com/office/drawing/2014/main" id="{198FCA1B-D145-42BA-AF9D-AC2F0BE8BD79}"/>
+                <a16:creationId xmlns:a16="http://schemas.microsoft.com/office/drawing/2014/main" id="{5E033145-A0B6-4294-9BA4-8C97DDDD2D29}"/>
               </a:ext>
             </a:extLst>
           </p:cNvPr>
@@ -9350,7 +9220,7 @@
           <p:cNvPr id="5" name="">
             <a:extLst xmlns:a="http://schemas.openxmlformats.org/drawingml/2006/main">
               <a:ext uri="{FF2B5EF4-FFF2-40B4-BE49-F238E27FC236}">
-                <a16:creationId xmlns:a16="http://schemas.microsoft.com/office/drawing/2014/main" id="{E92F1033-CA86-4DDC-81E0-747855C8EAD7}"/>
+                <a16:creationId xmlns:a16="http://schemas.microsoft.com/office/drawing/2014/main" id="{6FA44CC8-57BF-4656-8EDA-19A554D92D85}"/>
               </a:ext>
             </a:extLst>
           </p:cNvPr>
@@ -9400,7 +9270,7 @@
           <p:cNvPr id="6" name="">
             <a:extLst xmlns:a="http://schemas.openxmlformats.org/drawingml/2006/main">
               <a:ext uri="{FF2B5EF4-FFF2-40B4-BE49-F238E27FC236}">
-                <a16:creationId xmlns:a16="http://schemas.microsoft.com/office/drawing/2014/main" id="{732344E4-5F3B-4AF4-B9A4-016AFAFCA31D}"/>
+                <a16:creationId xmlns:a16="http://schemas.microsoft.com/office/drawing/2014/main" id="{713A1B3B-DF10-4798-9EA8-22E3FE642C63}"/>
               </a:ext>
             </a:extLst>
           </p:cNvPr>
@@ -9450,7 +9320,7 @@
           <p:cNvPr id="7" name="">
             <a:extLst xmlns:a="http://schemas.openxmlformats.org/drawingml/2006/main">
               <a:ext uri="{FF2B5EF4-FFF2-40B4-BE49-F238E27FC236}">
-                <a16:creationId xmlns:a16="http://schemas.microsoft.com/office/drawing/2014/main" id="{8C6E2464-A289-49E2-8CCF-C12424807755}"/>
+                <a16:creationId xmlns:a16="http://schemas.microsoft.com/office/drawing/2014/main" id="{437F567F-C13E-4F35-B187-C2C6389087AF}"/>
               </a:ext>
             </a:extLst>
           </p:cNvPr>
@@ -9504,7 +9374,7 @@
           <p:cNvPr id="8" name="">
             <a:extLst xmlns:a="http://schemas.openxmlformats.org/drawingml/2006/main">
               <a:ext uri="{FF2B5EF4-FFF2-40B4-BE49-F238E27FC236}">
-                <a16:creationId xmlns:a16="http://schemas.microsoft.com/office/drawing/2014/main" id="{2F9A936D-89C3-4984-93D6-4DF5949E90E9}"/>
+                <a16:creationId xmlns:a16="http://schemas.microsoft.com/office/drawing/2014/main" id="{0A29728C-9267-4C66-BA0F-6B77D93C8C9E}"/>
               </a:ext>
             </a:extLst>
           </p:cNvPr>
@@ -9535,7 +9405,7 @@
           <p:cNvPr id="9" name="">
             <a:extLst xmlns:a="http://schemas.openxmlformats.org/drawingml/2006/main">
               <a:ext uri="{FF2B5EF4-FFF2-40B4-BE49-F238E27FC236}">
-                <a16:creationId xmlns:a16="http://schemas.microsoft.com/office/drawing/2014/main" id="{7CE5BD88-F998-44A2-BF57-CFBB578B9C4F}"/>
+                <a16:creationId xmlns:a16="http://schemas.microsoft.com/office/drawing/2014/main" id="{87943A11-2D67-4679-A82E-57D60CAF6C10}"/>
               </a:ext>
             </a:extLst>
           </p:cNvPr>
@@ -9606,7 +9476,7 @@
           <p:cNvPr id="10" name="">
             <a:extLst xmlns:a="http://schemas.openxmlformats.org/drawingml/2006/main">
               <a:ext uri="{FF2B5EF4-FFF2-40B4-BE49-F238E27FC236}">
-                <a16:creationId xmlns:a16="http://schemas.microsoft.com/office/drawing/2014/main" id="{A0761226-B34D-4DD4-9C29-D7386A5469D7}"/>
+                <a16:creationId xmlns:a16="http://schemas.microsoft.com/office/drawing/2014/main" id="{38ACC87B-93DF-49B6-9199-74CA4D7B22E5}"/>
               </a:ext>
             </a:extLst>
           </p:cNvPr>
@@ -9660,7 +9530,7 @@
           <p:cNvPr id="11" name="">
             <a:extLst xmlns:a="http://schemas.openxmlformats.org/drawingml/2006/main">
               <a:ext uri="{FF2B5EF4-FFF2-40B4-BE49-F238E27FC236}">
-                <a16:creationId xmlns:a16="http://schemas.microsoft.com/office/drawing/2014/main" id="{A559A36B-2984-44CE-91A5-8E45FD8A6F9C}"/>
+                <a16:creationId xmlns:a16="http://schemas.microsoft.com/office/drawing/2014/main" id="{83887FCD-4A01-477F-B140-AD075275143E}"/>
               </a:ext>
             </a:extLst>
           </p:cNvPr>
@@ -9710,7 +9580,7 @@
           <p:cNvPr id="12" name="">
             <a:extLst xmlns:a="http://schemas.openxmlformats.org/drawingml/2006/main">
               <a:ext uri="{FF2B5EF4-FFF2-40B4-BE49-F238E27FC236}">
-                <a16:creationId xmlns:a16="http://schemas.microsoft.com/office/drawing/2014/main" id="{341ADF33-DAC1-4696-9754-849A7FC2DABE}"/>
+                <a16:creationId xmlns:a16="http://schemas.microsoft.com/office/drawing/2014/main" id="{77B7216B-4221-4F6C-95BB-1A5EE70FAC89}"/>
               </a:ext>
             </a:extLst>
           </p:cNvPr>
@@ -9760,7 +9630,7 @@
           <p:cNvPr id="13" name="">
             <a:extLst xmlns:a="http://schemas.openxmlformats.org/drawingml/2006/main">
               <a:ext uri="{FF2B5EF4-FFF2-40B4-BE49-F238E27FC236}">
-                <a16:creationId xmlns:a16="http://schemas.microsoft.com/office/drawing/2014/main" id="{6393D0F6-9769-4C39-BD1B-48744AD0D968}"/>
+                <a16:creationId xmlns:a16="http://schemas.microsoft.com/office/drawing/2014/main" id="{28985229-565D-4D89-B69A-4C006AE753E0}"/>
               </a:ext>
             </a:extLst>
           </p:cNvPr>
@@ -9814,7 +9684,7 @@
           <p:cNvPr id="14" name="">
             <a:extLst xmlns:a="http://schemas.openxmlformats.org/drawingml/2006/main">
               <a:ext uri="{FF2B5EF4-FFF2-40B4-BE49-F238E27FC236}">
-                <a16:creationId xmlns:a16="http://schemas.microsoft.com/office/drawing/2014/main" id="{C4FC779E-5F8F-41EC-A585-9BDED28D6821}"/>
+                <a16:creationId xmlns:a16="http://schemas.microsoft.com/office/drawing/2014/main" id="{B6BE3484-3064-41AF-B50C-FB9D4AAF47A4}"/>
               </a:ext>
             </a:extLst>
           </p:cNvPr>
@@ -9864,7 +9734,7 @@
           <p:cNvPr id="15" name="">
             <a:extLst xmlns:a="http://schemas.openxmlformats.org/drawingml/2006/main">
               <a:ext uri="{FF2B5EF4-FFF2-40B4-BE49-F238E27FC236}">
-                <a16:creationId xmlns:a16="http://schemas.microsoft.com/office/drawing/2014/main" id="{1A54EDC9-73DE-46E7-B825-0BBC46299AAA}"/>
+                <a16:creationId xmlns:a16="http://schemas.microsoft.com/office/drawing/2014/main" id="{96F24158-4050-4EB0-A6F4-328D1A75FC91}"/>
               </a:ext>
             </a:extLst>
           </p:cNvPr>
@@ -9895,7 +9765,7 @@
           <p:cNvPr id="16" name="">
             <a:extLst xmlns:a="http://schemas.openxmlformats.org/drawingml/2006/main">
               <a:ext uri="{FF2B5EF4-FFF2-40B4-BE49-F238E27FC236}">
-                <a16:creationId xmlns:a16="http://schemas.microsoft.com/office/drawing/2014/main" id="{50B9EC78-27C8-4F89-9FAD-214C5385E0A6}"/>
+                <a16:creationId xmlns:a16="http://schemas.microsoft.com/office/drawing/2014/main" id="{2EB2D390-170F-4373-A37D-7FF081FFC5D1}"/>
               </a:ext>
             </a:extLst>
           </p:cNvPr>
@@ -9949,7 +9819,7 @@
           <p:cNvPr id="17" name="">
             <a:extLst xmlns:a="http://schemas.openxmlformats.org/drawingml/2006/main">
               <a:ext uri="{FF2B5EF4-FFF2-40B4-BE49-F238E27FC236}">
-                <a16:creationId xmlns:a16="http://schemas.microsoft.com/office/drawing/2014/main" id="{9F80F368-9C9B-4E3A-9261-F54C16BA9866}"/>
+                <a16:creationId xmlns:a16="http://schemas.microsoft.com/office/drawing/2014/main" id="{B0E61AB3-DE7B-4BAE-A807-97D0590EB95D}"/>
               </a:ext>
             </a:extLst>
           </p:cNvPr>
@@ -10003,7 +9873,7 @@
           <p:cNvPr id="18" name="">
             <a:extLst xmlns:a="http://schemas.openxmlformats.org/drawingml/2006/main">
               <a:ext uri="{FF2B5EF4-FFF2-40B4-BE49-F238E27FC236}">
-                <a16:creationId xmlns:a16="http://schemas.microsoft.com/office/drawing/2014/main" id="{A3A1E44E-45F8-4764-9310-34C82718E36A}"/>
+                <a16:creationId xmlns:a16="http://schemas.microsoft.com/office/drawing/2014/main" id="{A4210C39-1EC7-450F-8CD0-611306B5E509}"/>
               </a:ext>
             </a:extLst>
           </p:cNvPr>
@@ -10057,7 +9927,7 @@
           <p:cNvPr id="19" name="">
             <a:extLst xmlns:a="http://schemas.openxmlformats.org/drawingml/2006/main">
               <a:ext uri="{FF2B5EF4-FFF2-40B4-BE49-F238E27FC236}">
-                <a16:creationId xmlns:a16="http://schemas.microsoft.com/office/drawing/2014/main" id="{9C8AF025-9E8D-4140-AFCF-208AC277A716}"/>
+                <a16:creationId xmlns:a16="http://schemas.microsoft.com/office/drawing/2014/main" id="{1246B9EE-D7AA-437B-9382-A8549CB8DB61}"/>
               </a:ext>
             </a:extLst>
           </p:cNvPr>
@@ -10107,7 +9977,7 @@
           <p:cNvPr id="20" name="">
             <a:extLst xmlns:a="http://schemas.openxmlformats.org/drawingml/2006/main">
               <a:ext uri="{FF2B5EF4-FFF2-40B4-BE49-F238E27FC236}">
-                <a16:creationId xmlns:a16="http://schemas.microsoft.com/office/drawing/2014/main" id="{2FD85064-AC20-4FB8-958C-E609813B69CA}"/>
+                <a16:creationId xmlns:a16="http://schemas.microsoft.com/office/drawing/2014/main" id="{942DBC60-12D3-471E-9562-E4800BF85939}"/>
               </a:ext>
             </a:extLst>
           </p:cNvPr>
@@ -10155,7 +10025,7 @@
     </p:spTree>
     <p:extLst>
       <p:ext uri="{BB962C8B-B14F-4D97-AF65-F5344CB8AC3E}">
-        <p14:creationId xmlns:p14="http://schemas.microsoft.com/office/powerpoint/2010/main" val="1780336857"/>
+        <p14:creationId xmlns:p14="http://schemas.microsoft.com/office/powerpoint/2010/main" val="926848525"/>
       </p:ext>
     </p:extLst>
   </p:cSld>
@@ -10186,7 +10056,7 @@
           <p:cNvPr id="25" name="">
             <a:extLst xmlns:a="http://schemas.openxmlformats.org/drawingml/2006/main">
               <a:ext uri="{FF2B5EF4-FFF2-40B4-BE49-F238E27FC236}">
-                <a16:creationId xmlns:a16="http://schemas.microsoft.com/office/drawing/2014/main" id="{2913A86C-BAB3-41B6-B8F2-39B990951D3F}"/>
+                <a16:creationId xmlns:a16="http://schemas.microsoft.com/office/drawing/2014/main" id="{CE2E9421-93D1-424C-BFB0-46F41063E908}"/>
               </a:ext>
             </a:extLst>
           </p:cNvPr>
@@ -10236,7 +10106,7 @@
           <p:cNvPr id="2" name="">
             <a:extLst xmlns:a="http://schemas.openxmlformats.org/drawingml/2006/main">
               <a:ext uri="{FF2B5EF4-FFF2-40B4-BE49-F238E27FC236}">
-                <a16:creationId xmlns:a16="http://schemas.microsoft.com/office/drawing/2014/main" id="{BF8A8FE6-B677-4DAE-A10C-B243C309FA37}"/>
+                <a16:creationId xmlns:a16="http://schemas.microsoft.com/office/drawing/2014/main" id="{29039EDC-EE6A-4870-B117-0B99F5480947}"/>
               </a:ext>
             </a:extLst>
           </p:cNvPr>
@@ -10286,7 +10156,7 @@
           <p:cNvPr id="3" name="">
             <a:extLst xmlns:a="http://schemas.openxmlformats.org/drawingml/2006/main">
               <a:ext uri="{FF2B5EF4-FFF2-40B4-BE49-F238E27FC236}">
-                <a16:creationId xmlns:a16="http://schemas.microsoft.com/office/drawing/2014/main" id="{53FEFAE4-228B-41E5-91E1-E51EED71A365}"/>
+                <a16:creationId xmlns:a16="http://schemas.microsoft.com/office/drawing/2014/main" id="{AAE52995-B841-4D74-AB50-0A26E49FBD6C}"/>
               </a:ext>
             </a:extLst>
           </p:cNvPr>
@@ -10317,7 +10187,7 @@
           <p:cNvPr id="4" name="">
             <a:extLst xmlns:a="http://schemas.openxmlformats.org/drawingml/2006/main">
               <a:ext uri="{FF2B5EF4-FFF2-40B4-BE49-F238E27FC236}">
-                <a16:creationId xmlns:a16="http://schemas.microsoft.com/office/drawing/2014/main" id="{D7A57E63-28AD-48FC-8444-AC9E8F8E5385}"/>
+                <a16:creationId xmlns:a16="http://schemas.microsoft.com/office/drawing/2014/main" id="{CC0FDA5A-446B-4F82-A427-CFD484F56ADD}"/>
               </a:ext>
             </a:extLst>
           </p:cNvPr>
@@ -10367,7 +10237,7 @@
           <p:cNvPr id="5" name="">
             <a:extLst xmlns:a="http://schemas.openxmlformats.org/drawingml/2006/main">
               <a:ext uri="{FF2B5EF4-FFF2-40B4-BE49-F238E27FC236}">
-                <a16:creationId xmlns:a16="http://schemas.microsoft.com/office/drawing/2014/main" id="{B706FC7A-C323-459F-A7B5-3D7063A6DEB4}"/>
+                <a16:creationId xmlns:a16="http://schemas.microsoft.com/office/drawing/2014/main" id="{EAC35674-E19A-491A-B7A4-7E9347A58F0F}"/>
               </a:ext>
             </a:extLst>
           </p:cNvPr>
@@ -10417,7 +10287,7 @@
           <p:cNvPr id="6" name="">
             <a:extLst xmlns:a="http://schemas.openxmlformats.org/drawingml/2006/main">
               <a:ext uri="{FF2B5EF4-FFF2-40B4-BE49-F238E27FC236}">
-                <a16:creationId xmlns:a16="http://schemas.microsoft.com/office/drawing/2014/main" id="{1F2BF44C-7B5E-4D37-A4F0-9FE7273183C8}"/>
+                <a16:creationId xmlns:a16="http://schemas.microsoft.com/office/drawing/2014/main" id="{2FB74804-3043-4DE8-82DF-36AEC0734CBA}"/>
               </a:ext>
             </a:extLst>
           </p:cNvPr>
@@ -10471,7 +10341,7 @@
           <p:cNvPr id="7" name="">
             <a:extLst xmlns:a="http://schemas.openxmlformats.org/drawingml/2006/main">
               <a:ext uri="{FF2B5EF4-FFF2-40B4-BE49-F238E27FC236}">
-                <a16:creationId xmlns:a16="http://schemas.microsoft.com/office/drawing/2014/main" id="{D0D0A7B4-5DEF-4118-8286-F5A800D31C92}"/>
+                <a16:creationId xmlns:a16="http://schemas.microsoft.com/office/drawing/2014/main" id="{B147D319-67F4-4735-86B5-49A793B120FB}"/>
               </a:ext>
             </a:extLst>
           </p:cNvPr>
@@ -10502,7 +10372,7 @@
           <p:cNvPr id="8" name="">
             <a:extLst xmlns:a="http://schemas.openxmlformats.org/drawingml/2006/main">
               <a:ext uri="{FF2B5EF4-FFF2-40B4-BE49-F238E27FC236}">
-                <a16:creationId xmlns:a16="http://schemas.microsoft.com/office/drawing/2014/main" id="{CE37C036-DE00-4BC1-A862-05263E58C73B}"/>
+                <a16:creationId xmlns:a16="http://schemas.microsoft.com/office/drawing/2014/main" id="{B492E6CF-C49E-40F1-A282-424868475001}"/>
               </a:ext>
             </a:extLst>
           </p:cNvPr>
@@ -10556,7 +10426,7 @@
           <p:cNvPr id="9" name="">
             <a:extLst xmlns:a="http://schemas.openxmlformats.org/drawingml/2006/main">
               <a:ext uri="{FF2B5EF4-FFF2-40B4-BE49-F238E27FC236}">
-                <a16:creationId xmlns:a16="http://schemas.microsoft.com/office/drawing/2014/main" id="{C1C9EE22-3EE6-4103-AF88-2F397E905F0F}"/>
+                <a16:creationId xmlns:a16="http://schemas.microsoft.com/office/drawing/2014/main" id="{96EE5C83-75EA-4FD0-B685-29BF1B074B1B}"/>
               </a:ext>
             </a:extLst>
           </p:cNvPr>
@@ -10587,7 +10457,7 @@
           <p:cNvPr id="10" name="">
             <a:extLst xmlns:a="http://schemas.openxmlformats.org/drawingml/2006/main">
               <a:ext uri="{FF2B5EF4-FFF2-40B4-BE49-F238E27FC236}">
-                <a16:creationId xmlns:a16="http://schemas.microsoft.com/office/drawing/2014/main" id="{452461A9-087F-4B68-A4D1-D0FF91D14FBD}"/>
+                <a16:creationId xmlns:a16="http://schemas.microsoft.com/office/drawing/2014/main" id="{64E0DD24-31BE-4CD2-9CB0-4C8590F0C344}"/>
               </a:ext>
             </a:extLst>
           </p:cNvPr>
@@ -10641,7 +10511,7 @@
           <p:cNvPr id="11" name="">
             <a:extLst xmlns:a="http://schemas.openxmlformats.org/drawingml/2006/main">
               <a:ext uri="{FF2B5EF4-FFF2-40B4-BE49-F238E27FC236}">
-                <a16:creationId xmlns:a16="http://schemas.microsoft.com/office/drawing/2014/main" id="{958AA567-E46C-43F3-9CD7-18F17CD473E7}"/>
+                <a16:creationId xmlns:a16="http://schemas.microsoft.com/office/drawing/2014/main" id="{774B3FAB-3204-4237-BDA5-16819F2289FF}"/>
               </a:ext>
             </a:extLst>
           </p:cNvPr>
@@ -10672,7 +10542,7 @@
           <p:cNvPr id="12" name="">
             <a:extLst xmlns:a="http://schemas.openxmlformats.org/drawingml/2006/main">
               <a:ext uri="{FF2B5EF4-FFF2-40B4-BE49-F238E27FC236}">
-                <a16:creationId xmlns:a16="http://schemas.microsoft.com/office/drawing/2014/main" id="{20C1E2B8-3504-4E68-B355-AD5873DD4A9E}"/>
+                <a16:creationId xmlns:a16="http://schemas.microsoft.com/office/drawing/2014/main" id="{5D942765-9724-47DB-A3CE-9E7420672C28}"/>
               </a:ext>
             </a:extLst>
           </p:cNvPr>
@@ -10726,7 +10596,7 @@
           <p:cNvPr id="13" name="">
             <a:extLst xmlns:a="http://schemas.openxmlformats.org/drawingml/2006/main">
               <a:ext uri="{FF2B5EF4-FFF2-40B4-BE49-F238E27FC236}">
-                <a16:creationId xmlns:a16="http://schemas.microsoft.com/office/drawing/2014/main" id="{F30EBFF7-BE06-4540-88B7-8AC442A0FF18}"/>
+                <a16:creationId xmlns:a16="http://schemas.microsoft.com/office/drawing/2014/main" id="{33CA5E23-7F92-4CB2-8C1C-692C803F72CE}"/>
               </a:ext>
             </a:extLst>
           </p:cNvPr>
@@ -10757,7 +10627,7 @@
           <p:cNvPr id="14" name="">
             <a:extLst xmlns:a="http://schemas.openxmlformats.org/drawingml/2006/main">
               <a:ext uri="{FF2B5EF4-FFF2-40B4-BE49-F238E27FC236}">
-                <a16:creationId xmlns:a16="http://schemas.microsoft.com/office/drawing/2014/main" id="{445E0674-9711-4049-A3E8-72643C03DD60}"/>
+                <a16:creationId xmlns:a16="http://schemas.microsoft.com/office/drawing/2014/main" id="{5F6C260A-82A4-4848-A227-262B532B948B}"/>
               </a:ext>
             </a:extLst>
           </p:cNvPr>
@@ -10811,7 +10681,7 @@
           <p:cNvPr id="15" name="">
             <a:extLst xmlns:a="http://schemas.openxmlformats.org/drawingml/2006/main">
               <a:ext uri="{FF2B5EF4-FFF2-40B4-BE49-F238E27FC236}">
-                <a16:creationId xmlns:a16="http://schemas.microsoft.com/office/drawing/2014/main" id="{F0C391DA-8364-41CE-B932-CC6BD9371EF2}"/>
+                <a16:creationId xmlns:a16="http://schemas.microsoft.com/office/drawing/2014/main" id="{95FC3553-4BEF-4ACB-A3B7-2575ED9A1AF0}"/>
               </a:ext>
             </a:extLst>
           </p:cNvPr>
@@ -10842,7 +10712,7 @@
           <p:cNvPr id="16" name="">
             <a:extLst xmlns:a="http://schemas.openxmlformats.org/drawingml/2006/main">
               <a:ext uri="{FF2B5EF4-FFF2-40B4-BE49-F238E27FC236}">
-                <a16:creationId xmlns:a16="http://schemas.microsoft.com/office/drawing/2014/main" id="{A6B083D3-E06B-4EE7-AA59-E086BDE5041D}"/>
+                <a16:creationId xmlns:a16="http://schemas.microsoft.com/office/drawing/2014/main" id="{9A3BE5AF-624E-4CA8-AF72-F7D42461B257}"/>
               </a:ext>
             </a:extLst>
           </p:cNvPr>
@@ -10896,7 +10766,7 @@
           <p:cNvPr id="17" name="">
             <a:extLst xmlns:a="http://schemas.openxmlformats.org/drawingml/2006/main">
               <a:ext uri="{FF2B5EF4-FFF2-40B4-BE49-F238E27FC236}">
-                <a16:creationId xmlns:a16="http://schemas.microsoft.com/office/drawing/2014/main" id="{01E7D386-111E-4C10-8384-7B68629668B1}"/>
+                <a16:creationId xmlns:a16="http://schemas.microsoft.com/office/drawing/2014/main" id="{9854FFD7-E5BD-4DED-8F25-48E1213366B6}"/>
               </a:ext>
             </a:extLst>
           </p:cNvPr>
@@ -10927,7 +10797,7 @@
           <p:cNvPr id="18" name="">
             <a:extLst xmlns:a="http://schemas.openxmlformats.org/drawingml/2006/main">
               <a:ext uri="{FF2B5EF4-FFF2-40B4-BE49-F238E27FC236}">
-                <a16:creationId xmlns:a16="http://schemas.microsoft.com/office/drawing/2014/main" id="{1A605F53-41E0-4FF9-B8B0-1C79447EEA07}"/>
+                <a16:creationId xmlns:a16="http://schemas.microsoft.com/office/drawing/2014/main" id="{763090A1-46AD-47AE-8CC6-429850E32BA9}"/>
               </a:ext>
             </a:extLst>
           </p:cNvPr>
@@ -10981,7 +10851,7 @@
           <p:cNvPr id="19" name="">
             <a:extLst xmlns:a="http://schemas.openxmlformats.org/drawingml/2006/main">
               <a:ext uri="{FF2B5EF4-FFF2-40B4-BE49-F238E27FC236}">
-                <a16:creationId xmlns:a16="http://schemas.microsoft.com/office/drawing/2014/main" id="{2BB8C6E6-66AC-47C2-90CD-3DF58AB04554}"/>
+                <a16:creationId xmlns:a16="http://schemas.microsoft.com/office/drawing/2014/main" id="{E108CBC2-EE8F-43A0-BD6C-3FA647CAE875}"/>
               </a:ext>
             </a:extLst>
           </p:cNvPr>
@@ -11031,7 +10901,7 @@
           <p:cNvPr id="20" name="">
             <a:extLst xmlns:a="http://schemas.openxmlformats.org/drawingml/2006/main">
               <a:ext uri="{FF2B5EF4-FFF2-40B4-BE49-F238E27FC236}">
-                <a16:creationId xmlns:a16="http://schemas.microsoft.com/office/drawing/2014/main" id="{49F57DCE-BA29-4902-A325-1A12A22879F6}"/>
+                <a16:creationId xmlns:a16="http://schemas.microsoft.com/office/drawing/2014/main" id="{3DAAF39D-AF71-441F-8963-1B24E89FD1A5}"/>
               </a:ext>
             </a:extLst>
           </p:cNvPr>
@@ -11081,7 +10951,7 @@
           <p:cNvPr id="21" name="">
             <a:extLst xmlns:a="http://schemas.openxmlformats.org/drawingml/2006/main">
               <a:ext uri="{FF2B5EF4-FFF2-40B4-BE49-F238E27FC236}">
-                <a16:creationId xmlns:a16="http://schemas.microsoft.com/office/drawing/2014/main" id="{EC30E6E0-83F3-47E7-A5EA-19DDAFE3DF47}"/>
+                <a16:creationId xmlns:a16="http://schemas.microsoft.com/office/drawing/2014/main" id="{48BDB7B5-6831-417A-8AD0-EDDF4BD7D522}"/>
               </a:ext>
             </a:extLst>
           </p:cNvPr>
@@ -11116,7 +10986,7 @@
           <p:cNvPr id="22" name="">
             <a:extLst xmlns:a="http://schemas.openxmlformats.org/drawingml/2006/main">
               <a:ext uri="{FF2B5EF4-FFF2-40B4-BE49-F238E27FC236}">
-                <a16:creationId xmlns:a16="http://schemas.microsoft.com/office/drawing/2014/main" id="{A8354A55-6C85-4998-861E-1151BAA850F6}"/>
+                <a16:creationId xmlns:a16="http://schemas.microsoft.com/office/drawing/2014/main" id="{C8A54878-4A2E-4891-B076-173259C14119}"/>
               </a:ext>
             </a:extLst>
           </p:cNvPr>
@@ -11166,7 +11036,7 @@
           <p:cNvPr id="23" name="">
             <a:extLst xmlns:a="http://schemas.openxmlformats.org/drawingml/2006/main">
               <a:ext uri="{FF2B5EF4-FFF2-40B4-BE49-F238E27FC236}">
-                <a16:creationId xmlns:a16="http://schemas.microsoft.com/office/drawing/2014/main" id="{29E94648-A811-4168-8203-3BB21209BF65}"/>
+                <a16:creationId xmlns:a16="http://schemas.microsoft.com/office/drawing/2014/main" id="{E9B18119-104A-4FE2-A0F3-A655040647AE}"/>
               </a:ext>
             </a:extLst>
           </p:cNvPr>
@@ -11201,7 +11071,7 @@
           <p:cNvPr id="24" name="">
             <a:extLst xmlns:a="http://schemas.openxmlformats.org/drawingml/2006/main">
               <a:ext uri="{FF2B5EF4-FFF2-40B4-BE49-F238E27FC236}">
-                <a16:creationId xmlns:a16="http://schemas.microsoft.com/office/drawing/2014/main" id="{329C137B-90F2-4C50-84E9-F1C480918A20}"/>
+                <a16:creationId xmlns:a16="http://schemas.microsoft.com/office/drawing/2014/main" id="{FAC763EC-7C0C-4E08-9BD5-BE272530A900}"/>
               </a:ext>
             </a:extLst>
           </p:cNvPr>
@@ -11249,7 +11119,7 @@
     </p:spTree>
     <p:extLst>
       <p:ext uri="{BB962C8B-B14F-4D97-AF65-F5344CB8AC3E}">
-        <p14:creationId xmlns:p14="http://schemas.microsoft.com/office/powerpoint/2010/main" val="702197805"/>
+        <p14:creationId xmlns:p14="http://schemas.microsoft.com/office/powerpoint/2010/main" val="363844529"/>
       </p:ext>
     </p:extLst>
   </p:cSld>
@@ -11280,7 +11150,7 @@
           <p:cNvPr id="26" name="">
             <a:extLst xmlns:a="http://schemas.openxmlformats.org/drawingml/2006/main">
               <a:ext uri="{FF2B5EF4-FFF2-40B4-BE49-F238E27FC236}">
-                <a16:creationId xmlns:a16="http://schemas.microsoft.com/office/drawing/2014/main" id="{BEB5A46B-7501-4197-9850-A9737EFFBBDE}"/>
+                <a16:creationId xmlns:a16="http://schemas.microsoft.com/office/drawing/2014/main" id="{2A055B9E-8705-4F1A-9613-061B62C52646}"/>
               </a:ext>
             </a:extLst>
           </p:cNvPr>
@@ -11330,7 +11200,7 @@
           <p:cNvPr id="2" name="">
             <a:extLst xmlns:a="http://schemas.openxmlformats.org/drawingml/2006/main">
               <a:ext uri="{FF2B5EF4-FFF2-40B4-BE49-F238E27FC236}">
-                <a16:creationId xmlns:a16="http://schemas.microsoft.com/office/drawing/2014/main" id="{16079B3B-0C48-485C-A727-3683BE067202}"/>
+                <a16:creationId xmlns:a16="http://schemas.microsoft.com/office/drawing/2014/main" id="{7F50F14F-FD73-4DC5-B768-D9C2A73A35B0}"/>
               </a:ext>
             </a:extLst>
           </p:cNvPr>
@@ -11380,7 +11250,7 @@
           <p:cNvPr id="3" name="">
             <a:extLst xmlns:a="http://schemas.openxmlformats.org/drawingml/2006/main">
               <a:ext uri="{FF2B5EF4-FFF2-40B4-BE49-F238E27FC236}">
-                <a16:creationId xmlns:a16="http://schemas.microsoft.com/office/drawing/2014/main" id="{54E54130-700F-40C1-8A82-F56A3CC8278B}"/>
+                <a16:creationId xmlns:a16="http://schemas.microsoft.com/office/drawing/2014/main" id="{8CADB6C0-649C-46B0-824B-967246E3185E}"/>
               </a:ext>
             </a:extLst>
           </p:cNvPr>
@@ -11411,7 +11281,7 @@
           <p:cNvPr id="4" name="">
             <a:extLst xmlns:a="http://schemas.openxmlformats.org/drawingml/2006/main">
               <a:ext uri="{FF2B5EF4-FFF2-40B4-BE49-F238E27FC236}">
-                <a16:creationId xmlns:a16="http://schemas.microsoft.com/office/drawing/2014/main" id="{6841CDEB-F608-455D-8A8B-C3FE4B5BD41E}"/>
+                <a16:creationId xmlns:a16="http://schemas.microsoft.com/office/drawing/2014/main" id="{1C86019F-1D2D-4514-BD04-1C5A76F215DF}"/>
               </a:ext>
             </a:extLst>
           </p:cNvPr>
@@ -11461,7 +11331,7 @@
           <p:cNvPr id="5" name="">
             <a:extLst xmlns:a="http://schemas.openxmlformats.org/drawingml/2006/main">
               <a:ext uri="{FF2B5EF4-FFF2-40B4-BE49-F238E27FC236}">
-                <a16:creationId xmlns:a16="http://schemas.microsoft.com/office/drawing/2014/main" id="{4C0ED877-422C-4246-BE0F-0052FE644173}"/>
+                <a16:creationId xmlns:a16="http://schemas.microsoft.com/office/drawing/2014/main" id="{206F420A-D2B3-4B5B-A2E8-FC7AD2EA37E6}"/>
               </a:ext>
             </a:extLst>
           </p:cNvPr>
@@ -11511,7 +11381,7 @@
           <p:cNvPr id="6" name="">
             <a:extLst xmlns:a="http://schemas.openxmlformats.org/drawingml/2006/main">
               <a:ext uri="{FF2B5EF4-FFF2-40B4-BE49-F238E27FC236}">
-                <a16:creationId xmlns:a16="http://schemas.microsoft.com/office/drawing/2014/main" id="{9C7E56D5-185F-4CA0-B9BD-0747B662D214}"/>
+                <a16:creationId xmlns:a16="http://schemas.microsoft.com/office/drawing/2014/main" id="{3B206341-47B9-41F4-8F50-686C1C106FCD}"/>
               </a:ext>
             </a:extLst>
           </p:cNvPr>
@@ -11561,7 +11431,7 @@
           <p:cNvPr id="7" name="">
             <a:extLst xmlns:a="http://schemas.openxmlformats.org/drawingml/2006/main">
               <a:ext uri="{FF2B5EF4-FFF2-40B4-BE49-F238E27FC236}">
-                <a16:creationId xmlns:a16="http://schemas.microsoft.com/office/drawing/2014/main" id="{64FFBBB2-6FBE-443D-9BD1-C77D51AC486C}"/>
+                <a16:creationId xmlns:a16="http://schemas.microsoft.com/office/drawing/2014/main" id="{4655280A-DEDC-42B1-BF35-B90AEA7F4CC5}"/>
               </a:ext>
             </a:extLst>
           </p:cNvPr>
@@ -11592,7 +11462,7 @@
           <p:cNvPr id="8" name="">
             <a:extLst xmlns:a="http://schemas.openxmlformats.org/drawingml/2006/main">
               <a:ext uri="{FF2B5EF4-FFF2-40B4-BE49-F238E27FC236}">
-                <a16:creationId xmlns:a16="http://schemas.microsoft.com/office/drawing/2014/main" id="{68277E8E-9570-4BDE-8B74-5BD6D20F6D40}"/>
+                <a16:creationId xmlns:a16="http://schemas.microsoft.com/office/drawing/2014/main" id="{31571778-96FD-4E80-A175-06C8B14AE34F}"/>
               </a:ext>
             </a:extLst>
           </p:cNvPr>
@@ -11642,7 +11512,7 @@
           <p:cNvPr id="9" name="">
             <a:extLst xmlns:a="http://schemas.openxmlformats.org/drawingml/2006/main">
               <a:ext uri="{FF2B5EF4-FFF2-40B4-BE49-F238E27FC236}">
-                <a16:creationId xmlns:a16="http://schemas.microsoft.com/office/drawing/2014/main" id="{66F6D724-5103-4C59-A456-1EBF831BB033}"/>
+                <a16:creationId xmlns:a16="http://schemas.microsoft.com/office/drawing/2014/main" id="{2FAB55CA-D51A-4701-89CE-6747ABE14495}"/>
               </a:ext>
             </a:extLst>
           </p:cNvPr>
@@ -11673,7 +11543,7 @@
           <p:cNvPr id="10" name="">
             <a:extLst xmlns:a="http://schemas.openxmlformats.org/drawingml/2006/main">
               <a:ext uri="{FF2B5EF4-FFF2-40B4-BE49-F238E27FC236}">
-                <a16:creationId xmlns:a16="http://schemas.microsoft.com/office/drawing/2014/main" id="{E81E7DDC-CC53-4750-9C4F-FFC6072751A1}"/>
+                <a16:creationId xmlns:a16="http://schemas.microsoft.com/office/drawing/2014/main" id="{9140B4E2-5961-4917-80FC-251596A4A26F}"/>
               </a:ext>
             </a:extLst>
           </p:cNvPr>
@@ -11723,7 +11593,7 @@
           <p:cNvPr id="11" name="">
             <a:extLst xmlns:a="http://schemas.openxmlformats.org/drawingml/2006/main">
               <a:ext uri="{FF2B5EF4-FFF2-40B4-BE49-F238E27FC236}">
-                <a16:creationId xmlns:a16="http://schemas.microsoft.com/office/drawing/2014/main" id="{F27EF02F-8CDE-49E6-8C08-E20D52B48E43}"/>
+                <a16:creationId xmlns:a16="http://schemas.microsoft.com/office/drawing/2014/main" id="{B8273558-DD1C-42D6-B675-D17A7B74ED5D}"/>
               </a:ext>
             </a:extLst>
           </p:cNvPr>
@@ -11754,7 +11624,7 @@
           <p:cNvPr id="12" name="">
             <a:extLst xmlns:a="http://schemas.openxmlformats.org/drawingml/2006/main">
               <a:ext uri="{FF2B5EF4-FFF2-40B4-BE49-F238E27FC236}">
-                <a16:creationId xmlns:a16="http://schemas.microsoft.com/office/drawing/2014/main" id="{A59EBDAD-235E-4C1F-88BC-4417F2E7078A}"/>
+                <a16:creationId xmlns:a16="http://schemas.microsoft.com/office/drawing/2014/main" id="{0D64F435-2B3D-44AF-8C19-702BBDBB253A}"/>
               </a:ext>
             </a:extLst>
           </p:cNvPr>
@@ -11804,7 +11674,7 @@
           <p:cNvPr id="13" name="">
             <a:extLst xmlns:a="http://schemas.openxmlformats.org/drawingml/2006/main">
               <a:ext uri="{FF2B5EF4-FFF2-40B4-BE49-F238E27FC236}">
-                <a16:creationId xmlns:a16="http://schemas.microsoft.com/office/drawing/2014/main" id="{FB288FC1-6334-467F-8097-2DAD990C25D4}"/>
+                <a16:creationId xmlns:a16="http://schemas.microsoft.com/office/drawing/2014/main" id="{B0ECDF3B-5C4B-4520-AD37-0AE5A78575AA}"/>
               </a:ext>
             </a:extLst>
           </p:cNvPr>
@@ -11835,7 +11705,7 @@
           <p:cNvPr id="14" name="">
             <a:extLst xmlns:a="http://schemas.openxmlformats.org/drawingml/2006/main">
               <a:ext uri="{FF2B5EF4-FFF2-40B4-BE49-F238E27FC236}">
-                <a16:creationId xmlns:a16="http://schemas.microsoft.com/office/drawing/2014/main" id="{321468F7-D355-4DEE-9F26-5DE7DC0C4306}"/>
+                <a16:creationId xmlns:a16="http://schemas.microsoft.com/office/drawing/2014/main" id="{BD297067-DEE0-4F33-8169-BDC4D0828A72}"/>
               </a:ext>
             </a:extLst>
           </p:cNvPr>
@@ -11885,7 +11755,7 @@
           <p:cNvPr id="15" name="">
             <a:extLst xmlns:a="http://schemas.openxmlformats.org/drawingml/2006/main">
               <a:ext uri="{FF2B5EF4-FFF2-40B4-BE49-F238E27FC236}">
-                <a16:creationId xmlns:a16="http://schemas.microsoft.com/office/drawing/2014/main" id="{06BAD2FC-0D78-47E5-AD6B-C4119937D81E}"/>
+                <a16:creationId xmlns:a16="http://schemas.microsoft.com/office/drawing/2014/main" id="{658E9924-5BBB-4D28-BB51-11349D3DC243}"/>
               </a:ext>
             </a:extLst>
           </p:cNvPr>
@@ -11935,7 +11805,7 @@
           <p:cNvPr id="16" name="">
             <a:extLst xmlns:a="http://schemas.openxmlformats.org/drawingml/2006/main">
               <a:ext uri="{FF2B5EF4-FFF2-40B4-BE49-F238E27FC236}">
-                <a16:creationId xmlns:a16="http://schemas.microsoft.com/office/drawing/2014/main" id="{C1322557-4A88-4D1C-80B2-9671BC1E4568}"/>
+                <a16:creationId xmlns:a16="http://schemas.microsoft.com/office/drawing/2014/main" id="{C7313809-48DB-4618-9606-923171579549}"/>
               </a:ext>
             </a:extLst>
           </p:cNvPr>
@@ -11966,7 +11836,7 @@
           <p:cNvPr id="17" name="">
             <a:extLst xmlns:a="http://schemas.openxmlformats.org/drawingml/2006/main">
               <a:ext uri="{FF2B5EF4-FFF2-40B4-BE49-F238E27FC236}">
-                <a16:creationId xmlns:a16="http://schemas.microsoft.com/office/drawing/2014/main" id="{E31CC52A-EAAF-4A26-A61B-BC78E587BF94}"/>
+                <a16:creationId xmlns:a16="http://schemas.microsoft.com/office/drawing/2014/main" id="{F95B06CA-4547-40D7-A192-656386C465C2}"/>
               </a:ext>
             </a:extLst>
           </p:cNvPr>
@@ -12016,7 +11886,7 @@
           <p:cNvPr id="18" name="">
             <a:extLst xmlns:a="http://schemas.openxmlformats.org/drawingml/2006/main">
               <a:ext uri="{FF2B5EF4-FFF2-40B4-BE49-F238E27FC236}">
-                <a16:creationId xmlns:a16="http://schemas.microsoft.com/office/drawing/2014/main" id="{BC14C35B-791A-48C9-8C8F-BA60CD518E41}"/>
+                <a16:creationId xmlns:a16="http://schemas.microsoft.com/office/drawing/2014/main" id="{41B4EE56-9A62-4BF2-8DF7-AE297BAAD032}"/>
               </a:ext>
             </a:extLst>
           </p:cNvPr>
@@ -12047,7 +11917,7 @@
           <p:cNvPr id="19" name="">
             <a:extLst xmlns:a="http://schemas.openxmlformats.org/drawingml/2006/main">
               <a:ext uri="{FF2B5EF4-FFF2-40B4-BE49-F238E27FC236}">
-                <a16:creationId xmlns:a16="http://schemas.microsoft.com/office/drawing/2014/main" id="{D112A882-9D98-49A1-B6EB-95DB200896F6}"/>
+                <a16:creationId xmlns:a16="http://schemas.microsoft.com/office/drawing/2014/main" id="{D3E51BD8-4BA0-4103-A41D-C009B1600C64}"/>
               </a:ext>
             </a:extLst>
           </p:cNvPr>
@@ -12097,7 +11967,7 @@
           <p:cNvPr id="20" name="">
             <a:extLst xmlns:a="http://schemas.openxmlformats.org/drawingml/2006/main">
               <a:ext uri="{FF2B5EF4-FFF2-40B4-BE49-F238E27FC236}">
-                <a16:creationId xmlns:a16="http://schemas.microsoft.com/office/drawing/2014/main" id="{F2453FD1-894D-4FCD-892B-B7368B939234}"/>
+                <a16:creationId xmlns:a16="http://schemas.microsoft.com/office/drawing/2014/main" id="{C3146B67-52BB-4D4C-B75C-5D6AA4486B2A}"/>
               </a:ext>
             </a:extLst>
           </p:cNvPr>
@@ -12128,7 +11998,7 @@
           <p:cNvPr id="21" name="">
             <a:extLst xmlns:a="http://schemas.openxmlformats.org/drawingml/2006/main">
               <a:ext uri="{FF2B5EF4-FFF2-40B4-BE49-F238E27FC236}">
-                <a16:creationId xmlns:a16="http://schemas.microsoft.com/office/drawing/2014/main" id="{979065CD-02F0-458F-BB15-A75AC165620D}"/>
+                <a16:creationId xmlns:a16="http://schemas.microsoft.com/office/drawing/2014/main" id="{902F77FE-29E7-4FBF-B80A-89E010429477}"/>
               </a:ext>
             </a:extLst>
           </p:cNvPr>
@@ -12178,7 +12048,7 @@
           <p:cNvPr id="22" name="">
             <a:extLst xmlns:a="http://schemas.openxmlformats.org/drawingml/2006/main">
               <a:ext uri="{FF2B5EF4-FFF2-40B4-BE49-F238E27FC236}">
-                <a16:creationId xmlns:a16="http://schemas.microsoft.com/office/drawing/2014/main" id="{5C22EEC1-B2D0-4F3F-A414-B090489A0815}"/>
+                <a16:creationId xmlns:a16="http://schemas.microsoft.com/office/drawing/2014/main" id="{B89F29B4-3F5C-4C9E-AFE4-767446DAC363}"/>
               </a:ext>
             </a:extLst>
           </p:cNvPr>
@@ -12209,7 +12079,7 @@
           <p:cNvPr id="23" name="">
             <a:extLst xmlns:a="http://schemas.openxmlformats.org/drawingml/2006/main">
               <a:ext uri="{FF2B5EF4-FFF2-40B4-BE49-F238E27FC236}">
-                <a16:creationId xmlns:a16="http://schemas.microsoft.com/office/drawing/2014/main" id="{7869B474-4C4B-4D08-9E54-FA32A82417AD}"/>
+                <a16:creationId xmlns:a16="http://schemas.microsoft.com/office/drawing/2014/main" id="{5AF70FEE-5CF9-4DC3-8A64-EED50A3D9BBA}"/>
               </a:ext>
             </a:extLst>
           </p:cNvPr>
@@ -12259,7 +12129,7 @@
           <p:cNvPr id="24" name="">
             <a:extLst xmlns:a="http://schemas.openxmlformats.org/drawingml/2006/main">
               <a:ext uri="{FF2B5EF4-FFF2-40B4-BE49-F238E27FC236}">
-                <a16:creationId xmlns:a16="http://schemas.microsoft.com/office/drawing/2014/main" id="{40D4CDCF-7BD4-4452-BA84-291ABD4A6C50}"/>
+                <a16:creationId xmlns:a16="http://schemas.microsoft.com/office/drawing/2014/main" id="{45954792-2730-4DB8-BB63-9A1F34C00605}"/>
               </a:ext>
             </a:extLst>
           </p:cNvPr>
@@ -12294,7 +12164,7 @@
           <p:cNvPr id="25" name="">
             <a:extLst xmlns:a="http://schemas.openxmlformats.org/drawingml/2006/main">
               <a:ext uri="{FF2B5EF4-FFF2-40B4-BE49-F238E27FC236}">
-                <a16:creationId xmlns:a16="http://schemas.microsoft.com/office/drawing/2014/main" id="{0C851429-D937-43BC-AD86-7B727AC2F6CC}"/>
+                <a16:creationId xmlns:a16="http://schemas.microsoft.com/office/drawing/2014/main" id="{8B22944B-5F63-44E8-89AD-A51C1E95E6FA}"/>
               </a:ext>
             </a:extLst>
           </p:cNvPr>
@@ -12342,7 +12212,7 @@
     </p:spTree>
     <p:extLst>
       <p:ext uri="{BB962C8B-B14F-4D97-AF65-F5344CB8AC3E}">
-        <p14:creationId xmlns:p14="http://schemas.microsoft.com/office/powerpoint/2010/main" val="1577960250"/>
+        <p14:creationId xmlns:p14="http://schemas.microsoft.com/office/powerpoint/2010/main" val="1609224698"/>
       </p:ext>
     </p:extLst>
   </p:cSld>
@@ -12373,7 +12243,7 @@
           <p:cNvPr id="18" name="">
             <a:extLst xmlns:a="http://schemas.openxmlformats.org/drawingml/2006/main">
               <a:ext uri="{FF2B5EF4-FFF2-40B4-BE49-F238E27FC236}">
-                <a16:creationId xmlns:a16="http://schemas.microsoft.com/office/drawing/2014/main" id="{A7411AE1-A4F1-4641-9D09-9D3585FC769F}"/>
+                <a16:creationId xmlns:a16="http://schemas.microsoft.com/office/drawing/2014/main" id="{5FF9E99B-E7FF-4936-8778-912A11569455}"/>
               </a:ext>
             </a:extLst>
           </p:cNvPr>
@@ -12423,7 +12293,7 @@
           <p:cNvPr id="2" name="">
             <a:extLst xmlns:a="http://schemas.openxmlformats.org/drawingml/2006/main">
               <a:ext uri="{FF2B5EF4-FFF2-40B4-BE49-F238E27FC236}">
-                <a16:creationId xmlns:a16="http://schemas.microsoft.com/office/drawing/2014/main" id="{D37BBA03-11EC-4302-B93D-D6BCAFEAB664}"/>
+                <a16:creationId xmlns:a16="http://schemas.microsoft.com/office/drawing/2014/main" id="{48877324-C07C-418E-A11F-E994E1C63615}"/>
               </a:ext>
             </a:extLst>
           </p:cNvPr>
@@ -12473,7 +12343,7 @@
           <p:cNvPr id="3" name="">
             <a:extLst xmlns:a="http://schemas.openxmlformats.org/drawingml/2006/main">
               <a:ext uri="{FF2B5EF4-FFF2-40B4-BE49-F238E27FC236}">
-                <a16:creationId xmlns:a16="http://schemas.microsoft.com/office/drawing/2014/main" id="{A18AD5D6-C5E5-4C59-A472-2A98BFBA0F08}"/>
+                <a16:creationId xmlns:a16="http://schemas.microsoft.com/office/drawing/2014/main" id="{07AE507E-7C56-4289-8FC2-0EF285838731}"/>
               </a:ext>
             </a:extLst>
           </p:cNvPr>
@@ -12504,7 +12374,7 @@
           <p:cNvPr id="4" name="">
             <a:extLst xmlns:a="http://schemas.openxmlformats.org/drawingml/2006/main">
               <a:ext uri="{FF2B5EF4-FFF2-40B4-BE49-F238E27FC236}">
-                <a16:creationId xmlns:a16="http://schemas.microsoft.com/office/drawing/2014/main" id="{409A87C1-E867-4538-8AE9-36515ED1C4A7}"/>
+                <a16:creationId xmlns:a16="http://schemas.microsoft.com/office/drawing/2014/main" id="{B5CC5974-7CBD-437A-BEE9-6BE1EE697D81}"/>
               </a:ext>
             </a:extLst>
           </p:cNvPr>
@@ -12554,7 +12424,7 @@
           <p:cNvPr id="5" name="">
             <a:extLst xmlns:a="http://schemas.openxmlformats.org/drawingml/2006/main">
               <a:ext uri="{FF2B5EF4-FFF2-40B4-BE49-F238E27FC236}">
-                <a16:creationId xmlns:a16="http://schemas.microsoft.com/office/drawing/2014/main" id="{26315679-BC8D-4F4C-ABEB-2F6A5B8AB69F}"/>
+                <a16:creationId xmlns:a16="http://schemas.microsoft.com/office/drawing/2014/main" id="{B2E9121B-4AAE-4334-AE48-57193964C4F0}"/>
               </a:ext>
             </a:extLst>
           </p:cNvPr>
@@ -12604,7 +12474,7 @@
           <p:cNvPr id="6" name="">
             <a:extLst xmlns:a="http://schemas.openxmlformats.org/drawingml/2006/main">
               <a:ext uri="{FF2B5EF4-FFF2-40B4-BE49-F238E27FC236}">
-                <a16:creationId xmlns:a16="http://schemas.microsoft.com/office/drawing/2014/main" id="{E88BEF5B-3B81-4C63-B7C6-929C69EE9DD0}"/>
+                <a16:creationId xmlns:a16="http://schemas.microsoft.com/office/drawing/2014/main" id="{23F8ABC9-892A-488B-813A-1EBFA9BB5D03}"/>
               </a:ext>
             </a:extLst>
           </p:cNvPr>
@@ -12654,7 +12524,7 @@
           <p:cNvPr id="7" name="">
             <a:extLst xmlns:a="http://schemas.openxmlformats.org/drawingml/2006/main">
               <a:ext uri="{FF2B5EF4-FFF2-40B4-BE49-F238E27FC236}">
-                <a16:creationId xmlns:a16="http://schemas.microsoft.com/office/drawing/2014/main" id="{CAC319B4-AC6A-4DEA-B627-F9F3688A7951}"/>
+                <a16:creationId xmlns:a16="http://schemas.microsoft.com/office/drawing/2014/main" id="{A30A06B2-2AFC-40AB-812C-A10A0AF50B05}"/>
               </a:ext>
             </a:extLst>
           </p:cNvPr>
@@ -12704,7 +12574,7 @@
           <p:cNvPr id="8" name="">
             <a:extLst xmlns:a="http://schemas.openxmlformats.org/drawingml/2006/main">
               <a:ext uri="{FF2B5EF4-FFF2-40B4-BE49-F238E27FC236}">
-                <a16:creationId xmlns:a16="http://schemas.microsoft.com/office/drawing/2014/main" id="{7400E408-B29A-4023-A34F-7A3B03D0B78D}"/>
+                <a16:creationId xmlns:a16="http://schemas.microsoft.com/office/drawing/2014/main" id="{327C5825-CBB1-44EE-A4DD-946BECB36074}"/>
               </a:ext>
             </a:extLst>
           </p:cNvPr>
@@ -12735,7 +12605,7 @@
           <p:cNvPr id="9" name="">
             <a:extLst xmlns:a="http://schemas.openxmlformats.org/drawingml/2006/main">
               <a:ext uri="{FF2B5EF4-FFF2-40B4-BE49-F238E27FC236}">
-                <a16:creationId xmlns:a16="http://schemas.microsoft.com/office/drawing/2014/main" id="{628362C0-F989-45A3-AC3A-3A4ADB478210}"/>
+                <a16:creationId xmlns:a16="http://schemas.microsoft.com/office/drawing/2014/main" id="{642295F9-D299-4309-86A0-B628E532938A}"/>
               </a:ext>
             </a:extLst>
           </p:cNvPr>
@@ -12785,7 +12655,7 @@
           <p:cNvPr id="10" name="">
             <a:extLst xmlns:a="http://schemas.openxmlformats.org/drawingml/2006/main">
               <a:ext uri="{FF2B5EF4-FFF2-40B4-BE49-F238E27FC236}">
-                <a16:creationId xmlns:a16="http://schemas.microsoft.com/office/drawing/2014/main" id="{49523408-7A53-4A61-A73A-92A07CDFB4FF}"/>
+                <a16:creationId xmlns:a16="http://schemas.microsoft.com/office/drawing/2014/main" id="{E6683215-E088-41A3-B072-4480069C6B3F}"/>
               </a:ext>
             </a:extLst>
           </p:cNvPr>
@@ -12835,7 +12705,7 @@
           <p:cNvPr id="11" name="">
             <a:extLst xmlns:a="http://schemas.openxmlformats.org/drawingml/2006/main">
               <a:ext uri="{FF2B5EF4-FFF2-40B4-BE49-F238E27FC236}">
-                <a16:creationId xmlns:a16="http://schemas.microsoft.com/office/drawing/2014/main" id="{AB8E389A-E67B-42C3-AAB2-B8A6B8055E86}"/>
+                <a16:creationId xmlns:a16="http://schemas.microsoft.com/office/drawing/2014/main" id="{6EE94D6D-80B0-4611-A5E7-E641CC0153A6}"/>
               </a:ext>
             </a:extLst>
           </p:cNvPr>
@@ -12866,7 +12736,7 @@
           <p:cNvPr id="12" name="">
             <a:extLst xmlns:a="http://schemas.openxmlformats.org/drawingml/2006/main">
               <a:ext uri="{FF2B5EF4-FFF2-40B4-BE49-F238E27FC236}">
-                <a16:creationId xmlns:a16="http://schemas.microsoft.com/office/drawing/2014/main" id="{977477E5-E7B2-43C7-ACA9-B6422EB8D0FF}"/>
+                <a16:creationId xmlns:a16="http://schemas.microsoft.com/office/drawing/2014/main" id="{5571AE3F-3EB2-493E-A907-35A31094F27A}"/>
               </a:ext>
             </a:extLst>
           </p:cNvPr>
@@ -12916,7 +12786,7 @@
           <p:cNvPr id="13" name="">
             <a:extLst xmlns:a="http://schemas.openxmlformats.org/drawingml/2006/main">
               <a:ext uri="{FF2B5EF4-FFF2-40B4-BE49-F238E27FC236}">
-                <a16:creationId xmlns:a16="http://schemas.microsoft.com/office/drawing/2014/main" id="{7704D348-8ADD-45B0-B466-B8DEA292F189}"/>
+                <a16:creationId xmlns:a16="http://schemas.microsoft.com/office/drawing/2014/main" id="{E91E83B1-C666-4FA8-B34C-A9B0260E076E}"/>
               </a:ext>
             </a:extLst>
           </p:cNvPr>
@@ -12966,7 +12836,7 @@
           <p:cNvPr id="14" name="">
             <a:extLst xmlns:a="http://schemas.openxmlformats.org/drawingml/2006/main">
               <a:ext uri="{FF2B5EF4-FFF2-40B4-BE49-F238E27FC236}">
-                <a16:creationId xmlns:a16="http://schemas.microsoft.com/office/drawing/2014/main" id="{3D32FEA1-8F72-474C-B048-34ADE9C5C4C4}"/>
+                <a16:creationId xmlns:a16="http://schemas.microsoft.com/office/drawing/2014/main" id="{F3FE0533-64C0-45B3-877F-5A3271B141A8}"/>
               </a:ext>
             </a:extLst>
           </p:cNvPr>
@@ -12997,7 +12867,7 @@
           <p:cNvPr id="15" name="">
             <a:extLst xmlns:a="http://schemas.openxmlformats.org/drawingml/2006/main">
               <a:ext uri="{FF2B5EF4-FFF2-40B4-BE49-F238E27FC236}">
-                <a16:creationId xmlns:a16="http://schemas.microsoft.com/office/drawing/2014/main" id="{57D06FCC-6DA0-4B41-AE77-D82F606DD27E}"/>
+                <a16:creationId xmlns:a16="http://schemas.microsoft.com/office/drawing/2014/main" id="{004FA66B-C763-4588-BE3A-11A91B41103B}"/>
               </a:ext>
             </a:extLst>
           </p:cNvPr>
@@ -13047,7 +12917,7 @@
           <p:cNvPr id="16" name="">
             <a:extLst xmlns:a="http://schemas.openxmlformats.org/drawingml/2006/main">
               <a:ext uri="{FF2B5EF4-FFF2-40B4-BE49-F238E27FC236}">
-                <a16:creationId xmlns:a16="http://schemas.microsoft.com/office/drawing/2014/main" id="{94F17100-62D8-40CF-8D07-342D179D8588}"/>
+                <a16:creationId xmlns:a16="http://schemas.microsoft.com/office/drawing/2014/main" id="{2C52FE9A-9322-47C3-8E14-CC8EAE49EA2E}"/>
               </a:ext>
             </a:extLst>
           </p:cNvPr>
@@ -13097,7 +12967,7 @@
           <p:cNvPr id="17" name="">
             <a:extLst xmlns:a="http://schemas.openxmlformats.org/drawingml/2006/main">
               <a:ext uri="{FF2B5EF4-FFF2-40B4-BE49-F238E27FC236}">
-                <a16:creationId xmlns:a16="http://schemas.microsoft.com/office/drawing/2014/main" id="{324E82F3-67C8-4A95-8C55-B225D7C31C3F}"/>
+                <a16:creationId xmlns:a16="http://schemas.microsoft.com/office/drawing/2014/main" id="{0DF90655-8F48-4BCE-AE79-0150979253D7}"/>
               </a:ext>
             </a:extLst>
           </p:cNvPr>
@@ -13126,7 +12996,7 @@
     </p:spTree>
     <p:extLst>
       <p:ext uri="{BB962C8B-B14F-4D97-AF65-F5344CB8AC3E}">
-        <p14:creationId xmlns:p14="http://schemas.microsoft.com/office/powerpoint/2010/main" val="1222785405"/>
+        <p14:creationId xmlns:p14="http://schemas.microsoft.com/office/powerpoint/2010/main" val="771921096"/>
       </p:ext>
     </p:extLst>
   </p:cSld>
@@ -13157,7 +13027,7 @@
           <p:cNvPr id="15" name="">
             <a:extLst xmlns:a="http://schemas.openxmlformats.org/drawingml/2006/main">
               <a:ext uri="{FF2B5EF4-FFF2-40B4-BE49-F238E27FC236}">
-                <a16:creationId xmlns:a16="http://schemas.microsoft.com/office/drawing/2014/main" id="{EF5BD4DD-1E3D-4169-8C25-2C56FCFF01B5}"/>
+                <a16:creationId xmlns:a16="http://schemas.microsoft.com/office/drawing/2014/main" id="{FDF78410-2C86-4691-812E-54B64B77AD2E}"/>
               </a:ext>
             </a:extLst>
           </p:cNvPr>
@@ -13207,7 +13077,7 @@
           <p:cNvPr id="2" name="">
             <a:extLst xmlns:a="http://schemas.openxmlformats.org/drawingml/2006/main">
               <a:ext uri="{FF2B5EF4-FFF2-40B4-BE49-F238E27FC236}">
-                <a16:creationId xmlns:a16="http://schemas.microsoft.com/office/drawing/2014/main" id="{775797EE-8279-457E-BDE4-A30E073A84D3}"/>
+                <a16:creationId xmlns:a16="http://schemas.microsoft.com/office/drawing/2014/main" id="{CAA53D22-23A6-4556-AF79-EDD3FF7738A8}"/>
               </a:ext>
             </a:extLst>
           </p:cNvPr>
@@ -13257,7 +13127,7 @@
           <p:cNvPr id="3" name="">
             <a:extLst xmlns:a="http://schemas.openxmlformats.org/drawingml/2006/main">
               <a:ext uri="{FF2B5EF4-FFF2-40B4-BE49-F238E27FC236}">
-                <a16:creationId xmlns:a16="http://schemas.microsoft.com/office/drawing/2014/main" id="{A5F23820-C8F3-4FA6-A6AB-1CAC98510529}"/>
+                <a16:creationId xmlns:a16="http://schemas.microsoft.com/office/drawing/2014/main" id="{5F53EBF6-966C-4717-B38A-D472AE5C64BA}"/>
               </a:ext>
             </a:extLst>
           </p:cNvPr>
@@ -13288,7 +13158,7 @@
           <p:cNvPr id="4" name="">
             <a:extLst xmlns:a="http://schemas.openxmlformats.org/drawingml/2006/main">
               <a:ext uri="{FF2B5EF4-FFF2-40B4-BE49-F238E27FC236}">
-                <a16:creationId xmlns:a16="http://schemas.microsoft.com/office/drawing/2014/main" id="{023402F3-A8A8-4FD3-B1B4-7EE534555DFF}"/>
+                <a16:creationId xmlns:a16="http://schemas.microsoft.com/office/drawing/2014/main" id="{D7AD9EC4-0EDB-4F5A-BB3D-F2785CE7B38C}"/>
               </a:ext>
             </a:extLst>
           </p:cNvPr>
@@ -13338,7 +13208,7 @@
           <p:cNvPr id="5" name="">
             <a:extLst xmlns:a="http://schemas.openxmlformats.org/drawingml/2006/main">
               <a:ext uri="{FF2B5EF4-FFF2-40B4-BE49-F238E27FC236}">
-                <a16:creationId xmlns:a16="http://schemas.microsoft.com/office/drawing/2014/main" id="{AF0CB2C1-57F2-45C7-9D77-69CEF6AC55E8}"/>
+                <a16:creationId xmlns:a16="http://schemas.microsoft.com/office/drawing/2014/main" id="{0371F636-1A07-4D62-BFE9-E260D857D77B}"/>
               </a:ext>
             </a:extLst>
           </p:cNvPr>
@@ -13388,7 +13258,7 @@
           <p:cNvPr id="6" name="">
             <a:extLst xmlns:a="http://schemas.openxmlformats.org/drawingml/2006/main">
               <a:ext uri="{FF2B5EF4-FFF2-40B4-BE49-F238E27FC236}">
-                <a16:creationId xmlns:a16="http://schemas.microsoft.com/office/drawing/2014/main" id="{3DDECF0E-DFA9-41AB-9A1B-7BA91FD9647C}"/>
+                <a16:creationId xmlns:a16="http://schemas.microsoft.com/office/drawing/2014/main" id="{1F00C2EA-9174-44AA-A334-3EBBFC9FDC31}"/>
               </a:ext>
             </a:extLst>
           </p:cNvPr>
@@ -13442,7 +13312,7 @@
           <p:cNvPr id="7" name="">
             <a:extLst xmlns:a="http://schemas.openxmlformats.org/drawingml/2006/main">
               <a:ext uri="{FF2B5EF4-FFF2-40B4-BE49-F238E27FC236}">
-                <a16:creationId xmlns:a16="http://schemas.microsoft.com/office/drawing/2014/main" id="{9734C16D-D7EB-42AE-8C6F-538795BCA930}"/>
+                <a16:creationId xmlns:a16="http://schemas.microsoft.com/office/drawing/2014/main" id="{1E1A78B5-40D6-4708-8929-A5DB638C6994}"/>
               </a:ext>
             </a:extLst>
           </p:cNvPr>
@@ -13473,7 +13343,7 @@
           <p:cNvPr id="8" name="">
             <a:extLst xmlns:a="http://schemas.openxmlformats.org/drawingml/2006/main">
               <a:ext uri="{FF2B5EF4-FFF2-40B4-BE49-F238E27FC236}">
-                <a16:creationId xmlns:a16="http://schemas.microsoft.com/office/drawing/2014/main" id="{94002394-F933-4C6D-8EE8-E7A03CDC3CEE}"/>
+                <a16:creationId xmlns:a16="http://schemas.microsoft.com/office/drawing/2014/main" id="{241BB544-11A0-4061-B541-05A7EA990F15}"/>
               </a:ext>
             </a:extLst>
           </p:cNvPr>
@@ -13527,7 +13397,7 @@
           <p:cNvPr id="9" name="">
             <a:extLst xmlns:a="http://schemas.openxmlformats.org/drawingml/2006/main">
               <a:ext uri="{FF2B5EF4-FFF2-40B4-BE49-F238E27FC236}">
-                <a16:creationId xmlns:a16="http://schemas.microsoft.com/office/drawing/2014/main" id="{3DF0ACA7-F4D1-46F7-A9B4-F27D671C256A}"/>
+                <a16:creationId xmlns:a16="http://schemas.microsoft.com/office/drawing/2014/main" id="{BF7E2251-86D7-4EE6-BBB2-DBF9D60419BD}"/>
               </a:ext>
             </a:extLst>
           </p:cNvPr>
@@ -13581,7 +13451,7 @@
           <p:cNvPr id="10" name="">
             <a:extLst xmlns:a="http://schemas.openxmlformats.org/drawingml/2006/main">
               <a:ext uri="{FF2B5EF4-FFF2-40B4-BE49-F238E27FC236}">
-                <a16:creationId xmlns:a16="http://schemas.microsoft.com/office/drawing/2014/main" id="{CFD4A9DF-EFB2-40CE-BA2B-544B940737ED}"/>
+                <a16:creationId xmlns:a16="http://schemas.microsoft.com/office/drawing/2014/main" id="{CCF84937-40D0-4CDD-BD06-D15B7412B7B9}"/>
               </a:ext>
             </a:extLst>
           </p:cNvPr>
@@ -13635,7 +13505,7 @@
           <p:cNvPr id="11" name="">
             <a:extLst xmlns:a="http://schemas.openxmlformats.org/drawingml/2006/main">
               <a:ext uri="{FF2B5EF4-FFF2-40B4-BE49-F238E27FC236}">
-                <a16:creationId xmlns:a16="http://schemas.microsoft.com/office/drawing/2014/main" id="{2E47A1C9-C031-4CD2-A114-AD28108323C1}"/>
+                <a16:creationId xmlns:a16="http://schemas.microsoft.com/office/drawing/2014/main" id="{476793FE-E1DF-44B8-BAE9-91216DB5AA2F}"/>
               </a:ext>
             </a:extLst>
           </p:cNvPr>
@@ -13685,7 +13555,7 @@
           <p:cNvPr id="12" name="">
             <a:extLst xmlns:a="http://schemas.openxmlformats.org/drawingml/2006/main">
               <a:ext uri="{FF2B5EF4-FFF2-40B4-BE49-F238E27FC236}">
-                <a16:creationId xmlns:a16="http://schemas.microsoft.com/office/drawing/2014/main" id="{26F19B05-4C05-4626-B9F9-E9B73AAE1CAD}"/>
+                <a16:creationId xmlns:a16="http://schemas.microsoft.com/office/drawing/2014/main" id="{935E39AE-E841-4F2F-AF61-52F4FDC52F59}"/>
               </a:ext>
             </a:extLst>
           </p:cNvPr>
@@ -13720,7 +13590,7 @@
           <p:cNvPr id="13" name="">
             <a:extLst xmlns:a="http://schemas.openxmlformats.org/drawingml/2006/main">
               <a:ext uri="{FF2B5EF4-FFF2-40B4-BE49-F238E27FC236}">
-                <a16:creationId xmlns:a16="http://schemas.microsoft.com/office/drawing/2014/main" id="{E476FCB7-9A5E-49E5-887E-49511A4B0A4B}"/>
+                <a16:creationId xmlns:a16="http://schemas.microsoft.com/office/drawing/2014/main" id="{AD3396E3-AF2F-4453-AAFC-436A4DA091EB}"/>
               </a:ext>
             </a:extLst>
           </p:cNvPr>
@@ -13770,7 +13640,7 @@
           <p:cNvPr id="14" name="">
             <a:extLst xmlns:a="http://schemas.openxmlformats.org/drawingml/2006/main">
               <a:ext uri="{FF2B5EF4-FFF2-40B4-BE49-F238E27FC236}">
-                <a16:creationId xmlns:a16="http://schemas.microsoft.com/office/drawing/2014/main" id="{64A7B3AA-8D68-42DF-BB23-1C2EA8AE9997}"/>
+                <a16:creationId xmlns:a16="http://schemas.microsoft.com/office/drawing/2014/main" id="{EE24D8A4-A27A-4EC2-B7DB-976EB613BBC7}"/>
               </a:ext>
             </a:extLst>
           </p:cNvPr>
@@ -13862,7 +13732,7 @@
     </p:spTree>
     <p:extLst>
       <p:ext uri="{BB962C8B-B14F-4D97-AF65-F5344CB8AC3E}">
-        <p14:creationId xmlns:p14="http://schemas.microsoft.com/office/powerpoint/2010/main" val="1310553521"/>
+        <p14:creationId xmlns:p14="http://schemas.microsoft.com/office/powerpoint/2010/main" val="1035946648"/>
       </p:ext>
     </p:extLst>
   </p:cSld>
@@ -13893,7 +13763,7 @@
           <p:cNvPr id="15" name="">
             <a:extLst xmlns:a="http://schemas.openxmlformats.org/drawingml/2006/main">
               <a:ext uri="{FF2B5EF4-FFF2-40B4-BE49-F238E27FC236}">
-                <a16:creationId xmlns:a16="http://schemas.microsoft.com/office/drawing/2014/main" id="{EE62EFA5-A8F2-4434-9D2C-038FD014D12F}"/>
+                <a16:creationId xmlns:a16="http://schemas.microsoft.com/office/drawing/2014/main" id="{88E15D1F-80EC-441D-95E4-541DC3F2F637}"/>
               </a:ext>
             </a:extLst>
           </p:cNvPr>
@@ -13943,7 +13813,7 @@
           <p:cNvPr id="2" name="">
             <a:extLst xmlns:a="http://schemas.openxmlformats.org/drawingml/2006/main">
               <a:ext uri="{FF2B5EF4-FFF2-40B4-BE49-F238E27FC236}">
-                <a16:creationId xmlns:a16="http://schemas.microsoft.com/office/drawing/2014/main" id="{B54A6872-82D1-4B49-BDB7-29D46A579541}"/>
+                <a16:creationId xmlns:a16="http://schemas.microsoft.com/office/drawing/2014/main" id="{B0A69956-C0CD-4488-A556-34DFC5513302}"/>
               </a:ext>
             </a:extLst>
           </p:cNvPr>
@@ -13993,7 +13863,7 @@
           <p:cNvPr id="3" name="">
             <a:extLst xmlns:a="http://schemas.openxmlformats.org/drawingml/2006/main">
               <a:ext uri="{FF2B5EF4-FFF2-40B4-BE49-F238E27FC236}">
-                <a16:creationId xmlns:a16="http://schemas.microsoft.com/office/drawing/2014/main" id="{EC987A52-C957-4D37-9B52-E42DA087E3BD}"/>
+                <a16:creationId xmlns:a16="http://schemas.microsoft.com/office/drawing/2014/main" id="{1DF8E5D0-8F1C-48BD-8483-1B1D96EAA32F}"/>
               </a:ext>
             </a:extLst>
           </p:cNvPr>
@@ -14024,7 +13894,7 @@
           <p:cNvPr id="4" name="">
             <a:extLst xmlns:a="http://schemas.openxmlformats.org/drawingml/2006/main">
               <a:ext uri="{FF2B5EF4-FFF2-40B4-BE49-F238E27FC236}">
-                <a16:creationId xmlns:a16="http://schemas.microsoft.com/office/drawing/2014/main" id="{B37E6F12-5982-4D0A-A762-CAB690450A6D}"/>
+                <a16:creationId xmlns:a16="http://schemas.microsoft.com/office/drawing/2014/main" id="{4E7D8D72-A3A3-4EAA-96EE-21664BE7D17B}"/>
               </a:ext>
             </a:extLst>
           </p:cNvPr>
@@ -14074,7 +13944,7 @@
           <p:cNvPr id="5" name="">
             <a:extLst xmlns:a="http://schemas.openxmlformats.org/drawingml/2006/main">
               <a:ext uri="{FF2B5EF4-FFF2-40B4-BE49-F238E27FC236}">
-                <a16:creationId xmlns:a16="http://schemas.microsoft.com/office/drawing/2014/main" id="{11F176B6-320B-41CD-B6BD-D0EEB5A8EE7A}"/>
+                <a16:creationId xmlns:a16="http://schemas.microsoft.com/office/drawing/2014/main" id="{0242781C-034B-443B-9A60-3D4D4D2016E0}"/>
               </a:ext>
             </a:extLst>
           </p:cNvPr>
@@ -14124,7 +13994,7 @@
           <p:cNvPr id="6" name="">
             <a:extLst xmlns:a="http://schemas.openxmlformats.org/drawingml/2006/main">
               <a:ext uri="{FF2B5EF4-FFF2-40B4-BE49-F238E27FC236}">
-                <a16:creationId xmlns:a16="http://schemas.microsoft.com/office/drawing/2014/main" id="{DB8C8C97-7C1F-4523-9FAB-28F6170131F4}"/>
+                <a16:creationId xmlns:a16="http://schemas.microsoft.com/office/drawing/2014/main" id="{A95A45FF-8FF5-4FD5-B239-5432857CDDAF}"/>
               </a:ext>
             </a:extLst>
           </p:cNvPr>
@@ -14159,7 +14029,7 @@
           <p:cNvPr id="7" name="">
             <a:extLst xmlns:a="http://schemas.openxmlformats.org/drawingml/2006/main">
               <a:ext uri="{FF2B5EF4-FFF2-40B4-BE49-F238E27FC236}">
-                <a16:creationId xmlns:a16="http://schemas.microsoft.com/office/drawing/2014/main" id="{582E768C-1604-47E7-95EA-22F131D81228}"/>
+                <a16:creationId xmlns:a16="http://schemas.microsoft.com/office/drawing/2014/main" id="{1A169258-6B59-43FB-9F37-EB689C860866}"/>
               </a:ext>
             </a:extLst>
           </p:cNvPr>
@@ -14209,7 +14079,7 @@
           <p:cNvPr id="8" name="">
             <a:extLst xmlns:a="http://schemas.openxmlformats.org/drawingml/2006/main">
               <a:ext uri="{FF2B5EF4-FFF2-40B4-BE49-F238E27FC236}">
-                <a16:creationId xmlns:a16="http://schemas.microsoft.com/office/drawing/2014/main" id="{4181BC70-BF1C-446B-8467-49EDCEDF8C20}"/>
+                <a16:creationId xmlns:a16="http://schemas.microsoft.com/office/drawing/2014/main" id="{408A084C-CDF3-4D11-B7D5-D37A2C3A15C0}"/>
               </a:ext>
             </a:extLst>
           </p:cNvPr>
@@ -14327,7 +14197,7 @@
           <p:cNvPr id="9" name="">
             <a:extLst xmlns:a="http://schemas.openxmlformats.org/drawingml/2006/main">
               <a:ext uri="{FF2B5EF4-FFF2-40B4-BE49-F238E27FC236}">
-                <a16:creationId xmlns:a16="http://schemas.microsoft.com/office/drawing/2014/main" id="{13A5BBDB-8558-4C4F-BA13-73E9E77DBEEE}"/>
+                <a16:creationId xmlns:a16="http://schemas.microsoft.com/office/drawing/2014/main" id="{1394977C-5E1E-431B-A91D-EE9BF0B08924}"/>
               </a:ext>
             </a:extLst>
           </p:cNvPr>
@@ -14377,7 +14247,7 @@
           <p:cNvPr id="10" name="">
             <a:extLst xmlns:a="http://schemas.openxmlformats.org/drawingml/2006/main">
               <a:ext uri="{FF2B5EF4-FFF2-40B4-BE49-F238E27FC236}">
-                <a16:creationId xmlns:a16="http://schemas.microsoft.com/office/drawing/2014/main" id="{8E8F9140-AB02-45B8-BD69-62467554B4D6}"/>
+                <a16:creationId xmlns:a16="http://schemas.microsoft.com/office/drawing/2014/main" id="{32E1C59F-D6C1-45FB-B856-515E26E8EB13}"/>
               </a:ext>
             </a:extLst>
           </p:cNvPr>
@@ -14427,7 +14297,7 @@
           <p:cNvPr id="11" name="">
             <a:extLst xmlns:a="http://schemas.openxmlformats.org/drawingml/2006/main">
               <a:ext uri="{FF2B5EF4-FFF2-40B4-BE49-F238E27FC236}">
-                <a16:creationId xmlns:a16="http://schemas.microsoft.com/office/drawing/2014/main" id="{97DCC08D-F7D6-41DB-BE9E-9B4788B68963}"/>
+                <a16:creationId xmlns:a16="http://schemas.microsoft.com/office/drawing/2014/main" id="{EC1BA739-774E-4062-AD77-E3F33F166C6D}"/>
               </a:ext>
             </a:extLst>
           </p:cNvPr>
@@ -14462,7 +14332,7 @@
           <p:cNvPr id="12" name="">
             <a:extLst xmlns:a="http://schemas.openxmlformats.org/drawingml/2006/main">
               <a:ext uri="{FF2B5EF4-FFF2-40B4-BE49-F238E27FC236}">
-                <a16:creationId xmlns:a16="http://schemas.microsoft.com/office/drawing/2014/main" id="{24AB667D-D414-443E-B473-633D918D1CE6}"/>
+                <a16:creationId xmlns:a16="http://schemas.microsoft.com/office/drawing/2014/main" id="{9D271F66-A166-4656-A407-4A717F612DDA}"/>
               </a:ext>
             </a:extLst>
           </p:cNvPr>
@@ -14512,7 +14382,7 @@
           <p:cNvPr id="13" name="">
             <a:extLst xmlns:a="http://schemas.openxmlformats.org/drawingml/2006/main">
               <a:ext uri="{FF2B5EF4-FFF2-40B4-BE49-F238E27FC236}">
-                <a16:creationId xmlns:a16="http://schemas.microsoft.com/office/drawing/2014/main" id="{23F2FD71-ACBD-460A-8AC0-1DB331ABAFA7}"/>
+                <a16:creationId xmlns:a16="http://schemas.microsoft.com/office/drawing/2014/main" id="{9BDBF354-44C7-479E-9848-E51222D4198B}"/>
               </a:ext>
             </a:extLst>
           </p:cNvPr>
@@ -14698,7 +14568,7 @@
           <p:cNvPr id="14" name="">
             <a:extLst xmlns:a="http://schemas.openxmlformats.org/drawingml/2006/main">
               <a:ext uri="{FF2B5EF4-FFF2-40B4-BE49-F238E27FC236}">
-                <a16:creationId xmlns:a16="http://schemas.microsoft.com/office/drawing/2014/main" id="{220A5E78-30B3-4AA2-8BF0-0ABCCA3C6659}"/>
+                <a16:creationId xmlns:a16="http://schemas.microsoft.com/office/drawing/2014/main" id="{19FF18E0-3808-4B6B-B61C-5234E5EBE707}"/>
               </a:ext>
             </a:extLst>
           </p:cNvPr>
@@ -14746,7 +14616,7 @@
     </p:spTree>
     <p:extLst>
       <p:ext uri="{BB962C8B-B14F-4D97-AF65-F5344CB8AC3E}">
-        <p14:creationId xmlns:p14="http://schemas.microsoft.com/office/powerpoint/2010/main" val="2065415418"/>
+        <p14:creationId xmlns:p14="http://schemas.microsoft.com/office/powerpoint/2010/main" val="1072462424"/>
       </p:ext>
     </p:extLst>
   </p:cSld>
@@ -14777,7 +14647,7 @@
           <p:cNvPr id="13" name="">
             <a:extLst xmlns:a="http://schemas.openxmlformats.org/drawingml/2006/main">
               <a:ext uri="{FF2B5EF4-FFF2-40B4-BE49-F238E27FC236}">
-                <a16:creationId xmlns:a16="http://schemas.microsoft.com/office/drawing/2014/main" id="{9FD0D935-9E6B-4003-A089-A3CC494CFEB6}"/>
+                <a16:creationId xmlns:a16="http://schemas.microsoft.com/office/drawing/2014/main" id="{C88A8993-24B8-40C7-9758-9C92C09EC6FF}"/>
               </a:ext>
             </a:extLst>
           </p:cNvPr>
@@ -14827,7 +14697,7 @@
           <p:cNvPr id="2" name="">
             <a:extLst xmlns:a="http://schemas.openxmlformats.org/drawingml/2006/main">
               <a:ext uri="{FF2B5EF4-FFF2-40B4-BE49-F238E27FC236}">
-                <a16:creationId xmlns:a16="http://schemas.microsoft.com/office/drawing/2014/main" id="{4FC4495D-C6B9-4607-9E08-DFBABFB8281B}"/>
+                <a16:creationId xmlns:a16="http://schemas.microsoft.com/office/drawing/2014/main" id="{916B1273-1193-44E4-8411-8468226B5948}"/>
               </a:ext>
             </a:extLst>
           </p:cNvPr>
@@ -14877,7 +14747,7 @@
           <p:cNvPr id="3" name="">
             <a:extLst xmlns:a="http://schemas.openxmlformats.org/drawingml/2006/main">
               <a:ext uri="{FF2B5EF4-FFF2-40B4-BE49-F238E27FC236}">
-                <a16:creationId xmlns:a16="http://schemas.microsoft.com/office/drawing/2014/main" id="{F5418B78-F897-4DC6-8DA5-DE638203AC3D}"/>
+                <a16:creationId xmlns:a16="http://schemas.microsoft.com/office/drawing/2014/main" id="{375E54FD-1C3F-4FFC-8AD1-F52737CCDF14}"/>
               </a:ext>
             </a:extLst>
           </p:cNvPr>
@@ -14908,7 +14778,7 @@
           <p:cNvPr id="4" name="">
             <a:extLst xmlns:a="http://schemas.openxmlformats.org/drawingml/2006/main">
               <a:ext uri="{FF2B5EF4-FFF2-40B4-BE49-F238E27FC236}">
-                <a16:creationId xmlns:a16="http://schemas.microsoft.com/office/drawing/2014/main" id="{5FD4C568-A08C-4FC8-AF10-6EC9E7D6017A}"/>
+                <a16:creationId xmlns:a16="http://schemas.microsoft.com/office/drawing/2014/main" id="{DE32C35C-452C-43CC-8287-DF2D56834D0C}"/>
               </a:ext>
             </a:extLst>
           </p:cNvPr>
@@ -14958,7 +14828,7 @@
           <p:cNvPr id="5" name="">
             <a:extLst xmlns:a="http://schemas.openxmlformats.org/drawingml/2006/main">
               <a:ext uri="{FF2B5EF4-FFF2-40B4-BE49-F238E27FC236}">
-                <a16:creationId xmlns:a16="http://schemas.microsoft.com/office/drawing/2014/main" id="{3C4E3D85-5A81-42F1-9E61-588A98642241}"/>
+                <a16:creationId xmlns:a16="http://schemas.microsoft.com/office/drawing/2014/main" id="{00AED735-D877-42C3-B860-6EF792A33785}"/>
               </a:ext>
             </a:extLst>
           </p:cNvPr>
@@ -15008,7 +14878,7 @@
           <p:cNvPr id="6" name="">
             <a:extLst xmlns:a="http://schemas.openxmlformats.org/drawingml/2006/main">
               <a:ext uri="{FF2B5EF4-FFF2-40B4-BE49-F238E27FC236}">
-                <a16:creationId xmlns:a16="http://schemas.microsoft.com/office/drawing/2014/main" id="{0E288EBB-7F8C-4E5B-925B-53EB15A5075D}"/>
+                <a16:creationId xmlns:a16="http://schemas.microsoft.com/office/drawing/2014/main" id="{B68BA7FB-0C3F-4D37-89AC-1FC701AC28AD}"/>
               </a:ext>
             </a:extLst>
           </p:cNvPr>
@@ -15043,7 +14913,7 @@
           <p:cNvPr id="7" name="">
             <a:extLst xmlns:a="http://schemas.openxmlformats.org/drawingml/2006/main">
               <a:ext uri="{FF2B5EF4-FFF2-40B4-BE49-F238E27FC236}">
-                <a16:creationId xmlns:a16="http://schemas.microsoft.com/office/drawing/2014/main" id="{C68B51C3-AF9A-4247-9388-D21BC2B42D2F}"/>
+                <a16:creationId xmlns:a16="http://schemas.microsoft.com/office/drawing/2014/main" id="{9037B7A2-5B77-4387-9F2C-D3A4A1CD6917}"/>
               </a:ext>
             </a:extLst>
           </p:cNvPr>
@@ -15093,7 +14963,7 @@
           <p:cNvPr id="8" name="">
             <a:extLst xmlns:a="http://schemas.openxmlformats.org/drawingml/2006/main">
               <a:ext uri="{FF2B5EF4-FFF2-40B4-BE49-F238E27FC236}">
-                <a16:creationId xmlns:a16="http://schemas.microsoft.com/office/drawing/2014/main" id="{49721059-2C28-4D35-9082-2F74DDE698D1}"/>
+                <a16:creationId xmlns:a16="http://schemas.microsoft.com/office/drawing/2014/main" id="{9F78051D-39D2-4D83-A33D-AFAAA17F7807}"/>
               </a:ext>
             </a:extLst>
           </p:cNvPr>
@@ -15245,7 +15115,7 @@
           <p:cNvPr id="9" name="">
             <a:extLst xmlns:a="http://schemas.openxmlformats.org/drawingml/2006/main">
               <a:ext uri="{FF2B5EF4-FFF2-40B4-BE49-F238E27FC236}">
-                <a16:creationId xmlns:a16="http://schemas.microsoft.com/office/drawing/2014/main" id="{236A8CDB-58D9-412D-808A-B756D071CD90}"/>
+                <a16:creationId xmlns:a16="http://schemas.microsoft.com/office/drawing/2014/main" id="{FC23C7E8-1D39-43EB-A204-7E4E4095BE36}"/>
               </a:ext>
             </a:extLst>
           </p:cNvPr>
@@ -15280,7 +15150,7 @@
           <p:cNvPr id="10" name="">
             <a:extLst xmlns:a="http://schemas.openxmlformats.org/drawingml/2006/main">
               <a:ext uri="{FF2B5EF4-FFF2-40B4-BE49-F238E27FC236}">
-                <a16:creationId xmlns:a16="http://schemas.microsoft.com/office/drawing/2014/main" id="{B95D084C-104A-4735-A68D-702702A415BF}"/>
+                <a16:creationId xmlns:a16="http://schemas.microsoft.com/office/drawing/2014/main" id="{5DE62386-DE03-450D-A0C1-F4AA7949E2BC}"/>
               </a:ext>
             </a:extLst>
           </p:cNvPr>
@@ -15330,7 +15200,7 @@
           <p:cNvPr id="11" name="">
             <a:extLst xmlns:a="http://schemas.openxmlformats.org/drawingml/2006/main">
               <a:ext uri="{FF2B5EF4-FFF2-40B4-BE49-F238E27FC236}">
-                <a16:creationId xmlns:a16="http://schemas.microsoft.com/office/drawing/2014/main" id="{38213982-5AFB-4595-93E5-89D48B533FE9}"/>
+                <a16:creationId xmlns:a16="http://schemas.microsoft.com/office/drawing/2014/main" id="{31B7D450-DA01-486E-98DC-8C75E536FCA9}"/>
               </a:ext>
             </a:extLst>
           </p:cNvPr>
@@ -15475,7 +15345,7 @@
           <p:cNvPr id="12" name="">
             <a:extLst xmlns:a="http://schemas.openxmlformats.org/drawingml/2006/main">
               <a:ext uri="{FF2B5EF4-FFF2-40B4-BE49-F238E27FC236}">
-                <a16:creationId xmlns:a16="http://schemas.microsoft.com/office/drawing/2014/main" id="{5D47F0D0-39FB-4EBB-81FB-8D0E8048C106}"/>
+                <a16:creationId xmlns:a16="http://schemas.microsoft.com/office/drawing/2014/main" id="{BB3D5176-93D9-4225-B5CE-8510B76B3797}"/>
               </a:ext>
             </a:extLst>
           </p:cNvPr>
@@ -15523,7 +15393,7 @@
     </p:spTree>
     <p:extLst>
       <p:ext uri="{BB962C8B-B14F-4D97-AF65-F5344CB8AC3E}">
-        <p14:creationId xmlns:p14="http://schemas.microsoft.com/office/powerpoint/2010/main" val="98100833"/>
+        <p14:creationId xmlns:p14="http://schemas.microsoft.com/office/powerpoint/2010/main" val="1593998777"/>
       </p:ext>
     </p:extLst>
   </p:cSld>
@@ -15554,7 +15424,7 @@
           <p:cNvPr id="18" name="">
             <a:extLst xmlns:a="http://schemas.openxmlformats.org/drawingml/2006/main">
               <a:ext uri="{FF2B5EF4-FFF2-40B4-BE49-F238E27FC236}">
-                <a16:creationId xmlns:a16="http://schemas.microsoft.com/office/drawing/2014/main" id="{095C4E9F-ACBE-4375-8BD9-62A68D56E102}"/>
+                <a16:creationId xmlns:a16="http://schemas.microsoft.com/office/drawing/2014/main" id="{779E1E14-CBB8-4FEA-88D9-2990AD70553E}"/>
               </a:ext>
             </a:extLst>
           </p:cNvPr>
@@ -15604,7 +15474,7 @@
           <p:cNvPr id="2" name="">
             <a:extLst xmlns:a="http://schemas.openxmlformats.org/drawingml/2006/main">
               <a:ext uri="{FF2B5EF4-FFF2-40B4-BE49-F238E27FC236}">
-                <a16:creationId xmlns:a16="http://schemas.microsoft.com/office/drawing/2014/main" id="{2D366130-CBBD-44D0-A4F8-22707317C57E}"/>
+                <a16:creationId xmlns:a16="http://schemas.microsoft.com/office/drawing/2014/main" id="{D8981406-F0F9-432A-AC2C-7EBFCD5EDB46}"/>
               </a:ext>
             </a:extLst>
           </p:cNvPr>
@@ -15654,7 +15524,7 @@
           <p:cNvPr id="3" name="">
             <a:extLst xmlns:a="http://schemas.openxmlformats.org/drawingml/2006/main">
               <a:ext uri="{FF2B5EF4-FFF2-40B4-BE49-F238E27FC236}">
-                <a16:creationId xmlns:a16="http://schemas.microsoft.com/office/drawing/2014/main" id="{5AF1B499-3677-4D81-8AB7-7FE425865802}"/>
+                <a16:creationId xmlns:a16="http://schemas.microsoft.com/office/drawing/2014/main" id="{CBD324D2-B5DB-4422-9320-A6EC204DCDCA}"/>
               </a:ext>
             </a:extLst>
           </p:cNvPr>
@@ -15685,7 +15555,7 @@
           <p:cNvPr id="4" name="">
             <a:extLst xmlns:a="http://schemas.openxmlformats.org/drawingml/2006/main">
               <a:ext uri="{FF2B5EF4-FFF2-40B4-BE49-F238E27FC236}">
-                <a16:creationId xmlns:a16="http://schemas.microsoft.com/office/drawing/2014/main" id="{575FFE23-9477-4559-8D81-6B376DE712E1}"/>
+                <a16:creationId xmlns:a16="http://schemas.microsoft.com/office/drawing/2014/main" id="{BDE41383-B796-4F62-9B28-E860B93B786B}"/>
               </a:ext>
             </a:extLst>
           </p:cNvPr>
@@ -15735,7 +15605,7 @@
           <p:cNvPr id="5" name="">
             <a:extLst xmlns:a="http://schemas.openxmlformats.org/drawingml/2006/main">
               <a:ext uri="{FF2B5EF4-FFF2-40B4-BE49-F238E27FC236}">
-                <a16:creationId xmlns:a16="http://schemas.microsoft.com/office/drawing/2014/main" id="{24690FEF-C706-40F0-BEF2-08FC1880A8C3}"/>
+                <a16:creationId xmlns:a16="http://schemas.microsoft.com/office/drawing/2014/main" id="{62EC4424-43BE-47D8-8733-70AE202A4181}"/>
               </a:ext>
             </a:extLst>
           </p:cNvPr>
@@ -15785,7 +15655,7 @@
           <p:cNvPr id="6" name="">
             <a:extLst xmlns:a="http://schemas.openxmlformats.org/drawingml/2006/main">
               <a:ext uri="{FF2B5EF4-FFF2-40B4-BE49-F238E27FC236}">
-                <a16:creationId xmlns:a16="http://schemas.microsoft.com/office/drawing/2014/main" id="{A7A04B3F-BECC-42E3-AB07-1A29F18B7B59}"/>
+                <a16:creationId xmlns:a16="http://schemas.microsoft.com/office/drawing/2014/main" id="{08515353-D445-475A-880D-10C65AD9DE7D}"/>
               </a:ext>
             </a:extLst>
           </p:cNvPr>
@@ -15820,7 +15690,7 @@
           <p:cNvPr id="7" name="">
             <a:extLst xmlns:a="http://schemas.openxmlformats.org/drawingml/2006/main">
               <a:ext uri="{FF2B5EF4-FFF2-40B4-BE49-F238E27FC236}">
-                <a16:creationId xmlns:a16="http://schemas.microsoft.com/office/drawing/2014/main" id="{218900F5-A1B9-4F62-9D1C-957D43968C85}"/>
+                <a16:creationId xmlns:a16="http://schemas.microsoft.com/office/drawing/2014/main" id="{2D8DB265-ECF7-4ACC-985E-D33503EA0A53}"/>
               </a:ext>
             </a:extLst>
           </p:cNvPr>
@@ -15870,7 +15740,7 @@
           <p:cNvPr id="8" name="">
             <a:extLst xmlns:a="http://schemas.openxmlformats.org/drawingml/2006/main">
               <a:ext uri="{FF2B5EF4-FFF2-40B4-BE49-F238E27FC236}">
-                <a16:creationId xmlns:a16="http://schemas.microsoft.com/office/drawing/2014/main" id="{AEB01907-5E09-46D6-B948-3317F9C4A850}"/>
+                <a16:creationId xmlns:a16="http://schemas.microsoft.com/office/drawing/2014/main" id="{D1A94442-24D0-4061-AAFC-52B5135CC99B}"/>
               </a:ext>
             </a:extLst>
           </p:cNvPr>
@@ -15920,7 +15790,7 @@
           <p:cNvPr id="9" name="">
             <a:extLst xmlns:a="http://schemas.openxmlformats.org/drawingml/2006/main">
               <a:ext uri="{FF2B5EF4-FFF2-40B4-BE49-F238E27FC236}">
-                <a16:creationId xmlns:a16="http://schemas.microsoft.com/office/drawing/2014/main" id="{89A960DF-303D-47B1-889F-09FA3514C269}"/>
+                <a16:creationId xmlns:a16="http://schemas.microsoft.com/office/drawing/2014/main" id="{1B4373A3-854C-4773-88D8-52F1C94473BC}"/>
               </a:ext>
             </a:extLst>
           </p:cNvPr>
@@ -15955,7 +15825,7 @@
           <p:cNvPr id="10" name="">
             <a:extLst xmlns:a="http://schemas.openxmlformats.org/drawingml/2006/main">
               <a:ext uri="{FF2B5EF4-FFF2-40B4-BE49-F238E27FC236}">
-                <a16:creationId xmlns:a16="http://schemas.microsoft.com/office/drawing/2014/main" id="{98A7F775-DE01-4555-A81E-01CECCAC615F}"/>
+                <a16:creationId xmlns:a16="http://schemas.microsoft.com/office/drawing/2014/main" id="{1156FDD0-C0F3-420A-92EF-40B46DA406DD}"/>
               </a:ext>
             </a:extLst>
           </p:cNvPr>
@@ -16005,7 +15875,7 @@
           <p:cNvPr id="11" name="">
             <a:extLst xmlns:a="http://schemas.openxmlformats.org/drawingml/2006/main">
               <a:ext uri="{FF2B5EF4-FFF2-40B4-BE49-F238E27FC236}">
-                <a16:creationId xmlns:a16="http://schemas.microsoft.com/office/drawing/2014/main" id="{9686BB2D-9144-43DA-93A9-61906E1340DE}"/>
+                <a16:creationId xmlns:a16="http://schemas.microsoft.com/office/drawing/2014/main" id="{A0E81078-4DE9-403E-9D17-F42B4007CB50}"/>
               </a:ext>
             </a:extLst>
           </p:cNvPr>
@@ -16055,7 +15925,7 @@
           <p:cNvPr id="12" name="">
             <a:extLst xmlns:a="http://schemas.openxmlformats.org/drawingml/2006/main">
               <a:ext uri="{FF2B5EF4-FFF2-40B4-BE49-F238E27FC236}">
-                <a16:creationId xmlns:a16="http://schemas.microsoft.com/office/drawing/2014/main" id="{B2F89CDB-77FC-4A47-A30E-308AFF095E57}"/>
+                <a16:creationId xmlns:a16="http://schemas.microsoft.com/office/drawing/2014/main" id="{EDD3B221-42E9-4B9E-BEB3-8FBF10C9D216}"/>
               </a:ext>
             </a:extLst>
           </p:cNvPr>
@@ -16090,7 +15960,7 @@
           <p:cNvPr id="13" name="">
             <a:extLst xmlns:a="http://schemas.openxmlformats.org/drawingml/2006/main">
               <a:ext uri="{FF2B5EF4-FFF2-40B4-BE49-F238E27FC236}">
-                <a16:creationId xmlns:a16="http://schemas.microsoft.com/office/drawing/2014/main" id="{2FB32EAD-60AD-4BEF-85B8-297FDA6401C5}"/>
+                <a16:creationId xmlns:a16="http://schemas.microsoft.com/office/drawing/2014/main" id="{7921C5BD-EF6F-4B14-9C76-D2F01B693102}"/>
               </a:ext>
             </a:extLst>
           </p:cNvPr>
@@ -16140,7 +16010,7 @@
           <p:cNvPr id="14" name="">
             <a:extLst xmlns:a="http://schemas.openxmlformats.org/drawingml/2006/main">
               <a:ext uri="{FF2B5EF4-FFF2-40B4-BE49-F238E27FC236}">
-                <a16:creationId xmlns:a16="http://schemas.microsoft.com/office/drawing/2014/main" id="{AE9F072E-D304-462F-983A-A80C10E4FFAF}"/>
+                <a16:creationId xmlns:a16="http://schemas.microsoft.com/office/drawing/2014/main" id="{348BD829-4250-4140-A9D3-C20014E41820}"/>
               </a:ext>
             </a:extLst>
           </p:cNvPr>
@@ -16190,7 +16060,7 @@
           <p:cNvPr id="15" name="">
             <a:extLst xmlns:a="http://schemas.openxmlformats.org/drawingml/2006/main">
               <a:ext uri="{FF2B5EF4-FFF2-40B4-BE49-F238E27FC236}">
-                <a16:creationId xmlns:a16="http://schemas.microsoft.com/office/drawing/2014/main" id="{7C45682C-425C-4B3B-86B8-1FC82D76BB01}"/>
+                <a16:creationId xmlns:a16="http://schemas.microsoft.com/office/drawing/2014/main" id="{6D6F7E54-C75C-4530-8843-D1C499ED8532}"/>
               </a:ext>
             </a:extLst>
           </p:cNvPr>
@@ -16225,7 +16095,7 @@
           <p:cNvPr id="16" name="">
             <a:extLst xmlns:a="http://schemas.openxmlformats.org/drawingml/2006/main">
               <a:ext uri="{FF2B5EF4-FFF2-40B4-BE49-F238E27FC236}">
-                <a16:creationId xmlns:a16="http://schemas.microsoft.com/office/drawing/2014/main" id="{7CC51171-C5D8-4E19-BB24-8CD1A4BDBA07}"/>
+                <a16:creationId xmlns:a16="http://schemas.microsoft.com/office/drawing/2014/main" id="{DF2A14A5-524C-45C2-98B8-022394E41343}"/>
               </a:ext>
             </a:extLst>
           </p:cNvPr>
@@ -16275,7 +16145,7 @@
           <p:cNvPr id="17" name="">
             <a:extLst xmlns:a="http://schemas.openxmlformats.org/drawingml/2006/main">
               <a:ext uri="{FF2B5EF4-FFF2-40B4-BE49-F238E27FC236}">
-                <a16:creationId xmlns:a16="http://schemas.microsoft.com/office/drawing/2014/main" id="{8F7C3DF3-9C36-420A-8AB6-7D81CB91634C}"/>
+                <a16:creationId xmlns:a16="http://schemas.microsoft.com/office/drawing/2014/main" id="{AAE7C3BC-E8F4-452D-BF27-F0AA08ADDBB5}"/>
               </a:ext>
             </a:extLst>
           </p:cNvPr>
@@ -16323,7 +16193,7 @@
     </p:spTree>
     <p:extLst>
       <p:ext uri="{BB962C8B-B14F-4D97-AF65-F5344CB8AC3E}">
-        <p14:creationId xmlns:p14="http://schemas.microsoft.com/office/powerpoint/2010/main" val="1149608308"/>
+        <p14:creationId xmlns:p14="http://schemas.microsoft.com/office/powerpoint/2010/main" val="1671428358"/>
       </p:ext>
     </p:extLst>
   </p:cSld>

</xml_diff>